<commit_message>
Remove accent-stripe/underline motifs, swap cream bg for neutral gray
pptx skill flags title underlines and edge stripes as a known AI-slide tell;
removed them from titleBar/sectionLabel/title/conclusion slides and the ISO
callout box, and replaced the warm-paper background with a neutral
near-white so white cards read with proper contrast.
</commit_message>
<xml_diff>
--- a/수복치과재료학실험/수복치과재료학실험_DentalCements_20260922.pptx
+++ b/수복치과재료학실험/수복치과재료학실험_DentalCements_20260922.pptx
@@ -2643,7 +2643,7 @@
     <p:bg>
       <p:bgPr>
         <a:solidFill>
-          <a:srgbClr val="FBF8F3"/>
+          <a:srgbClr val="F5F6F5"/>
         </a:solidFill>
       </p:bgPr>
     </p:bg>
@@ -2820,27 +2820,7 @@
       </p:sp>
       <p:sp>
         <p:nvSpPr>
-          <p:cNvPr id="7" name="Shape 5"/>
-          <p:cNvSpPr/>
-          <p:nvPr/>
-        </p:nvSpPr>
-        <p:spPr>
-          <a:xfrm>
-            <a:off x="822960" y="2697480"/>
-            <a:ext cx="640080" cy="54864"/>
-          </a:xfrm>
-          <a:prstGeom prst="rect">
-            <a:avLst/>
-          </a:prstGeom>
-          <a:solidFill>
-            <a:srgbClr val="F2704A"/>
-          </a:solidFill>
-          <a:ln/>
-        </p:spPr>
-      </p:sp>
-      <p:sp>
-        <p:nvSpPr>
-          <p:cNvPr id="8" name="Text 6"/>
+          <p:cNvPr id="7" name="Text 5"/>
           <p:cNvSpPr txBox="1"/>
           <p:nvPr/>
         </p:nvSpPr>
@@ -2952,7 +2932,7 @@
       </p:sp>
       <p:sp>
         <p:nvSpPr>
-          <p:cNvPr id="9" name="Text 7"/>
+          <p:cNvPr id="8" name="Text 6"/>
           <p:cNvSpPr txBox="1"/>
           <p:nvPr/>
         </p:nvSpPr>
@@ -3003,7 +2983,7 @@
     <p:bg>
       <p:bgPr>
         <a:solidFill>
-          <a:srgbClr val="FBF8F3"/>
+          <a:srgbClr val="F5F6F5"/>
         </a:solidFill>
       </p:bgPr>
     </p:bg>
@@ -3102,26 +3082,6 @@
       <p:sp>
         <p:nvSpPr>
           <p:cNvPr id="4" name="Shape 2"/>
-          <p:cNvSpPr/>
-          <p:nvPr/>
-        </p:nvSpPr>
-        <p:spPr>
-          <a:xfrm>
-            <a:off x="640080" y="1207008"/>
-            <a:ext cx="502920" cy="45720"/>
-          </a:xfrm>
-          <a:prstGeom prst="rect">
-            <a:avLst/>
-          </a:prstGeom>
-          <a:solidFill>
-            <a:srgbClr val="F2704A"/>
-          </a:solidFill>
-          <a:ln/>
-        </p:spPr>
-      </p:sp>
-      <p:sp>
-        <p:nvSpPr>
-          <p:cNvPr id="5" name="Shape 3"/>
           <p:cNvSpPr/>
           <p:nvPr/>
         </p:nvSpPr>
@@ -3150,7 +3110,7 @@
       </p:sp>
       <p:graphicFrame>
         <p:nvGraphicFramePr>
-          <p:cNvPr id="6" name="Chart 0" descr=""/>
+          <p:cNvPr id="5" name="Chart 0" descr=""/>
           <p:cNvGraphicFramePr/>
           <p:nvPr/>
         </p:nvGraphicFramePr>
@@ -3166,7 +3126,7 @@
       </p:graphicFrame>
       <p:sp>
         <p:nvSpPr>
-          <p:cNvPr id="7" name="Text 4"/>
+          <p:cNvPr id="6" name="Text 3"/>
           <p:cNvSpPr txBox="1"/>
           <p:nvPr/>
         </p:nvSpPr>
@@ -3205,7 +3165,7 @@
       </p:sp>
       <p:sp>
         <p:nvSpPr>
-          <p:cNvPr id="8" name="Shape 5"/>
+          <p:cNvPr id="7" name="Shape 4"/>
           <p:cNvSpPr/>
           <p:nvPr/>
         </p:nvSpPr>
@@ -3234,7 +3194,7 @@
       </p:sp>
       <p:graphicFrame>
         <p:nvGraphicFramePr>
-          <p:cNvPr id="9" name="Chart 1" descr=""/>
+          <p:cNvPr id="8" name="Chart 1" descr=""/>
           <p:cNvGraphicFramePr/>
           <p:nvPr/>
         </p:nvGraphicFramePr>
@@ -3250,7 +3210,7 @@
       </p:graphicFrame>
       <p:sp>
         <p:nvSpPr>
-          <p:cNvPr id="10" name="Text 6"/>
+          <p:cNvPr id="9" name="Text 5"/>
           <p:cNvSpPr txBox="1"/>
           <p:nvPr/>
         </p:nvSpPr>
@@ -3292,7 +3252,7 @@
       </p:sp>
       <p:sp>
         <p:nvSpPr>
-          <p:cNvPr id="11" name="Text 7"/>
+          <p:cNvPr id="10" name="Text 6"/>
           <p:cNvSpPr txBox="1"/>
           <p:nvPr/>
         </p:nvSpPr>
@@ -3343,7 +3303,7 @@
     <p:bg>
       <p:bgPr>
         <a:solidFill>
-          <a:srgbClr val="FBF8F3"/>
+          <a:srgbClr val="F5F6F5"/>
         </a:solidFill>
       </p:bgPr>
     </p:bg>
@@ -3441,27 +3401,7 @@
       </p:sp>
       <p:sp>
         <p:nvSpPr>
-          <p:cNvPr id="4" name="Shape 2"/>
-          <p:cNvSpPr/>
-          <p:nvPr/>
-        </p:nvSpPr>
-        <p:spPr>
-          <a:xfrm>
-            <a:off x="640080" y="1207008"/>
-            <a:ext cx="502920" cy="45720"/>
-          </a:xfrm>
-          <a:prstGeom prst="rect">
-            <a:avLst/>
-          </a:prstGeom>
-          <a:solidFill>
-            <a:srgbClr val="F2704A"/>
-          </a:solidFill>
-          <a:ln/>
-        </p:spPr>
-      </p:sp>
-      <p:sp>
-        <p:nvSpPr>
-          <p:cNvPr id="5" name="Text 3"/>
+          <p:cNvPr id="4" name="Text 2"/>
           <p:cNvSpPr txBox="1"/>
           <p:nvPr/>
         </p:nvSpPr>
@@ -3500,27 +3440,7 @@
       </p:sp>
       <p:sp>
         <p:nvSpPr>
-          <p:cNvPr id="6" name="Shape 4"/>
-          <p:cNvSpPr/>
-          <p:nvPr/>
-        </p:nvSpPr>
-        <p:spPr>
-          <a:xfrm>
-            <a:off x="640080" y="1865376"/>
-            <a:ext cx="320040" cy="32004"/>
-          </a:xfrm>
-          <a:prstGeom prst="rect">
-            <a:avLst/>
-          </a:prstGeom>
-          <a:solidFill>
-            <a:srgbClr val="F2704A"/>
-          </a:solidFill>
-          <a:ln/>
-        </p:spPr>
-      </p:sp>
-      <p:sp>
-        <p:nvSpPr>
-          <p:cNvPr id="7" name="Text 5"/>
+          <p:cNvPr id="5" name="Text 3"/>
           <p:cNvSpPr txBox="1"/>
           <p:nvPr/>
         </p:nvSpPr>
@@ -3582,7 +3502,7 @@
       </p:sp>
       <p:sp>
         <p:nvSpPr>
-          <p:cNvPr id="8" name="Text 6"/>
+          <p:cNvPr id="6" name="Text 4"/>
           <p:cNvSpPr txBox="1"/>
           <p:nvPr/>
         </p:nvSpPr>
@@ -3621,27 +3541,7 @@
       </p:sp>
       <p:sp>
         <p:nvSpPr>
-          <p:cNvPr id="9" name="Shape 7"/>
-          <p:cNvSpPr/>
-          <p:nvPr/>
-        </p:nvSpPr>
-        <p:spPr>
-          <a:xfrm>
-            <a:off x="640080" y="3739896"/>
-            <a:ext cx="320040" cy="32004"/>
-          </a:xfrm>
-          <a:prstGeom prst="rect">
-            <a:avLst/>
-          </a:prstGeom>
-          <a:solidFill>
-            <a:srgbClr val="F2704A"/>
-          </a:solidFill>
-          <a:ln/>
-        </p:spPr>
-      </p:sp>
-      <p:sp>
-        <p:nvSpPr>
-          <p:cNvPr id="10" name="Text 8"/>
+          <p:cNvPr id="7" name="Text 5"/>
           <p:cNvSpPr txBox="1"/>
           <p:nvPr/>
         </p:nvSpPr>
@@ -3703,7 +3603,7 @@
       </p:sp>
       <p:sp>
         <p:nvSpPr>
-          <p:cNvPr id="11" name="Text 9"/>
+          <p:cNvPr id="8" name="Text 6"/>
           <p:cNvSpPr txBox="1"/>
           <p:nvPr/>
         </p:nvSpPr>
@@ -3742,27 +3642,7 @@
       </p:sp>
       <p:sp>
         <p:nvSpPr>
-          <p:cNvPr id="12" name="Shape 10"/>
-          <p:cNvSpPr/>
-          <p:nvPr/>
-        </p:nvSpPr>
-        <p:spPr>
-          <a:xfrm>
-            <a:off x="640080" y="5522976"/>
-            <a:ext cx="320040" cy="32004"/>
-          </a:xfrm>
-          <a:prstGeom prst="rect">
-            <a:avLst/>
-          </a:prstGeom>
-          <a:solidFill>
-            <a:srgbClr val="F2704A"/>
-          </a:solidFill>
-          <a:ln/>
-        </p:spPr>
-      </p:sp>
-      <p:sp>
-        <p:nvSpPr>
-          <p:cNvPr id="13" name="Text 11"/>
+          <p:cNvPr id="9" name="Text 7"/>
           <p:cNvSpPr txBox="1"/>
           <p:nvPr/>
         </p:nvSpPr>
@@ -3824,7 +3704,7 @@
       </p:sp>
       <p:sp>
         <p:nvSpPr>
-          <p:cNvPr id="14" name="Text 12"/>
+          <p:cNvPr id="10" name="Text 8"/>
           <p:cNvSpPr txBox="1"/>
           <p:nvPr/>
         </p:nvSpPr>
@@ -3875,7 +3755,7 @@
     <p:bg>
       <p:bgPr>
         <a:solidFill>
-          <a:srgbClr val="FBF8F3"/>
+          <a:srgbClr val="F5F6F5"/>
         </a:solidFill>
       </p:bgPr>
     </p:bg>
@@ -4149,7 +4029,7 @@
     <p:bg>
       <p:bgPr>
         <a:solidFill>
-          <a:srgbClr val="FBF8F3"/>
+          <a:srgbClr val="F5F6F5"/>
         </a:solidFill>
       </p:bgPr>
     </p:bg>
@@ -4247,27 +4127,7 @@
       </p:sp>
       <p:sp>
         <p:nvSpPr>
-          <p:cNvPr id="4" name="Shape 2"/>
-          <p:cNvSpPr/>
-          <p:nvPr/>
-        </p:nvSpPr>
-        <p:spPr>
-          <a:xfrm>
-            <a:off x="640080" y="1207008"/>
-            <a:ext cx="502920" cy="45720"/>
-          </a:xfrm>
-          <a:prstGeom prst="rect">
-            <a:avLst/>
-          </a:prstGeom>
-          <a:solidFill>
-            <a:srgbClr val="F2704A"/>
-          </a:solidFill>
-          <a:ln/>
-        </p:spPr>
-      </p:sp>
-      <p:sp>
-        <p:nvSpPr>
-          <p:cNvPr id="5" name="Text 3"/>
+          <p:cNvPr id="4" name="Text 2"/>
           <p:cNvSpPr txBox="1"/>
           <p:nvPr/>
         </p:nvSpPr>
@@ -4369,7 +4229,7 @@
       </p:sp>
       <p:sp>
         <p:nvSpPr>
-          <p:cNvPr id="6" name="Text 4"/>
+          <p:cNvPr id="5" name="Text 3"/>
           <p:cNvSpPr txBox="1"/>
           <p:nvPr/>
         </p:nvSpPr>
@@ -4420,7 +4280,7 @@
     <p:bg>
       <p:bgPr>
         <a:solidFill>
-          <a:srgbClr val="FBF8F3"/>
+          <a:srgbClr val="F5F6F5"/>
         </a:solidFill>
       </p:bgPr>
     </p:bg>
@@ -4524,26 +4384,6 @@
         </p:nvSpPr>
         <p:spPr>
           <a:xfrm>
-            <a:off x="640080" y="1207008"/>
-            <a:ext cx="502920" cy="45720"/>
-          </a:xfrm>
-          <a:prstGeom prst="rect">
-            <a:avLst/>
-          </a:prstGeom>
-          <a:solidFill>
-            <a:srgbClr val="F2704A"/>
-          </a:solidFill>
-          <a:ln/>
-        </p:spPr>
-      </p:sp>
-      <p:sp>
-        <p:nvSpPr>
-          <p:cNvPr id="5" name="Shape 3"/>
-          <p:cNvSpPr/>
-          <p:nvPr/>
-        </p:nvSpPr>
-        <p:spPr>
-          <a:xfrm>
             <a:off x="822960" y="1828800"/>
             <a:ext cx="502920" cy="502920"/>
           </a:xfrm>
@@ -4560,7 +4400,7 @@
       </p:sp>
       <p:sp>
         <p:nvSpPr>
-          <p:cNvPr id="6" name="Text 4"/>
+          <p:cNvPr id="5" name="Text 3"/>
           <p:cNvSpPr txBox="1"/>
           <p:nvPr/>
         </p:nvSpPr>
@@ -4599,7 +4439,7 @@
       </p:sp>
       <p:sp>
         <p:nvSpPr>
-          <p:cNvPr id="7" name="Text 5"/>
+          <p:cNvPr id="6" name="Text 4"/>
           <p:cNvSpPr txBox="1"/>
           <p:nvPr/>
         </p:nvSpPr>
@@ -4638,7 +4478,7 @@
       </p:sp>
       <p:sp>
         <p:nvSpPr>
-          <p:cNvPr id="8" name="Shape 6"/>
+          <p:cNvPr id="7" name="Shape 5"/>
           <p:cNvSpPr/>
           <p:nvPr/>
         </p:nvSpPr>
@@ -4660,7 +4500,7 @@
       </p:sp>
       <p:sp>
         <p:nvSpPr>
-          <p:cNvPr id="9" name="Text 7"/>
+          <p:cNvPr id="8" name="Text 6"/>
           <p:cNvSpPr txBox="1"/>
           <p:nvPr/>
         </p:nvSpPr>
@@ -4699,7 +4539,7 @@
       </p:sp>
       <p:sp>
         <p:nvSpPr>
-          <p:cNvPr id="10" name="Text 8"/>
+          <p:cNvPr id="9" name="Text 7"/>
           <p:cNvSpPr txBox="1"/>
           <p:nvPr/>
         </p:nvSpPr>
@@ -4738,7 +4578,7 @@
       </p:sp>
       <p:sp>
         <p:nvSpPr>
-          <p:cNvPr id="11" name="Shape 9"/>
+          <p:cNvPr id="10" name="Shape 8"/>
           <p:cNvSpPr/>
           <p:nvPr/>
         </p:nvSpPr>
@@ -4760,7 +4600,7 @@
       </p:sp>
       <p:sp>
         <p:nvSpPr>
-          <p:cNvPr id="12" name="Text 10"/>
+          <p:cNvPr id="11" name="Text 9"/>
           <p:cNvSpPr txBox="1"/>
           <p:nvPr/>
         </p:nvSpPr>
@@ -4799,7 +4639,7 @@
       </p:sp>
       <p:sp>
         <p:nvSpPr>
-          <p:cNvPr id="13" name="Text 11"/>
+          <p:cNvPr id="12" name="Text 10"/>
           <p:cNvSpPr txBox="1"/>
           <p:nvPr/>
         </p:nvSpPr>
@@ -4838,7 +4678,7 @@
       </p:sp>
       <p:sp>
         <p:nvSpPr>
-          <p:cNvPr id="14" name="Shape 12"/>
+          <p:cNvPr id="13" name="Shape 11"/>
           <p:cNvSpPr/>
           <p:nvPr/>
         </p:nvSpPr>
@@ -4860,7 +4700,7 @@
       </p:sp>
       <p:sp>
         <p:nvSpPr>
-          <p:cNvPr id="15" name="Text 13"/>
+          <p:cNvPr id="14" name="Text 12"/>
           <p:cNvSpPr txBox="1"/>
           <p:nvPr/>
         </p:nvSpPr>
@@ -4899,7 +4739,7 @@
       </p:sp>
       <p:sp>
         <p:nvSpPr>
-          <p:cNvPr id="16" name="Text 14"/>
+          <p:cNvPr id="15" name="Text 13"/>
           <p:cNvSpPr txBox="1"/>
           <p:nvPr/>
         </p:nvSpPr>
@@ -4938,7 +4778,7 @@
       </p:sp>
       <p:sp>
         <p:nvSpPr>
-          <p:cNvPr id="17" name="Shape 15"/>
+          <p:cNvPr id="16" name="Shape 14"/>
           <p:cNvSpPr/>
           <p:nvPr/>
         </p:nvSpPr>
@@ -4960,7 +4800,7 @@
       </p:sp>
       <p:sp>
         <p:nvSpPr>
-          <p:cNvPr id="18" name="Text 16"/>
+          <p:cNvPr id="17" name="Text 15"/>
           <p:cNvSpPr txBox="1"/>
           <p:nvPr/>
         </p:nvSpPr>
@@ -4999,7 +4839,7 @@
       </p:sp>
       <p:sp>
         <p:nvSpPr>
-          <p:cNvPr id="19" name="Text 17"/>
+          <p:cNvPr id="18" name="Text 16"/>
           <p:cNvSpPr txBox="1"/>
           <p:nvPr/>
         </p:nvSpPr>
@@ -5038,7 +4878,7 @@
       </p:sp>
       <p:sp>
         <p:nvSpPr>
-          <p:cNvPr id="20" name="Text 18"/>
+          <p:cNvPr id="19" name="Text 17"/>
           <p:cNvSpPr txBox="1"/>
           <p:nvPr/>
         </p:nvSpPr>
@@ -5089,7 +4929,7 @@
     <p:bg>
       <p:bgPr>
         <a:solidFill>
-          <a:srgbClr val="FBF8F3"/>
+          <a:srgbClr val="F5F6F5"/>
         </a:solidFill>
       </p:bgPr>
     </p:bg>
@@ -5187,27 +5027,7 @@
       </p:sp>
       <p:sp>
         <p:nvSpPr>
-          <p:cNvPr id="4" name="Shape 2"/>
-          <p:cNvSpPr/>
-          <p:nvPr/>
-        </p:nvSpPr>
-        <p:spPr>
-          <a:xfrm>
-            <a:off x="640080" y="1207008"/>
-            <a:ext cx="502920" cy="45720"/>
-          </a:xfrm>
-          <a:prstGeom prst="rect">
-            <a:avLst/>
-          </a:prstGeom>
-          <a:solidFill>
-            <a:srgbClr val="F2704A"/>
-          </a:solidFill>
-          <a:ln/>
-        </p:spPr>
-      </p:sp>
-      <p:sp>
-        <p:nvSpPr>
-          <p:cNvPr id="5" name="Text 3"/>
+          <p:cNvPr id="4" name="Text 2"/>
           <p:cNvSpPr txBox="1"/>
           <p:nvPr/>
         </p:nvSpPr>
@@ -5246,27 +5066,7 @@
       </p:sp>
       <p:sp>
         <p:nvSpPr>
-          <p:cNvPr id="6" name="Shape 4"/>
-          <p:cNvSpPr/>
-          <p:nvPr/>
-        </p:nvSpPr>
-        <p:spPr>
-          <a:xfrm>
-            <a:off x="640080" y="1865376"/>
-            <a:ext cx="320040" cy="32004"/>
-          </a:xfrm>
-          <a:prstGeom prst="rect">
-            <a:avLst/>
-          </a:prstGeom>
-          <a:solidFill>
-            <a:srgbClr val="F2704A"/>
-          </a:solidFill>
-          <a:ln/>
-        </p:spPr>
-      </p:sp>
-      <p:sp>
-        <p:nvSpPr>
-          <p:cNvPr id="7" name="Shape 5"/>
+          <p:cNvPr id="5" name="Shape 3"/>
           <p:cNvSpPr/>
           <p:nvPr/>
         </p:nvSpPr>
@@ -5288,7 +5088,7 @@
       </p:sp>
       <p:sp>
         <p:nvSpPr>
-          <p:cNvPr id="8" name="Text 6"/>
+          <p:cNvPr id="6" name="Text 4"/>
           <p:cNvSpPr txBox="1"/>
           <p:nvPr/>
         </p:nvSpPr>
@@ -5327,7 +5127,7 @@
       </p:sp>
       <p:sp>
         <p:nvSpPr>
-          <p:cNvPr id="9" name="Text 7"/>
+          <p:cNvPr id="7" name="Text 5"/>
           <p:cNvSpPr txBox="1"/>
           <p:nvPr/>
         </p:nvSpPr>
@@ -5369,7 +5169,7 @@
       </p:sp>
       <p:sp>
         <p:nvSpPr>
-          <p:cNvPr id="10" name="Shape 8"/>
+          <p:cNvPr id="8" name="Shape 6"/>
           <p:cNvSpPr/>
           <p:nvPr/>
         </p:nvSpPr>
@@ -5391,7 +5191,7 @@
       </p:sp>
       <p:sp>
         <p:nvSpPr>
-          <p:cNvPr id="11" name="Text 9"/>
+          <p:cNvPr id="9" name="Text 7"/>
           <p:cNvSpPr txBox="1"/>
           <p:nvPr/>
         </p:nvSpPr>
@@ -5430,7 +5230,7 @@
       </p:sp>
       <p:sp>
         <p:nvSpPr>
-          <p:cNvPr id="12" name="Text 10"/>
+          <p:cNvPr id="10" name="Text 8"/>
           <p:cNvSpPr txBox="1"/>
           <p:nvPr/>
         </p:nvSpPr>
@@ -5472,7 +5272,7 @@
       </p:sp>
       <p:sp>
         <p:nvSpPr>
-          <p:cNvPr id="13" name="Shape 11"/>
+          <p:cNvPr id="11" name="Shape 9"/>
           <p:cNvSpPr/>
           <p:nvPr/>
         </p:nvSpPr>
@@ -5494,7 +5294,7 @@
       </p:sp>
       <p:sp>
         <p:nvSpPr>
-          <p:cNvPr id="14" name="Text 12"/>
+          <p:cNvPr id="12" name="Text 10"/>
           <p:cNvSpPr txBox="1"/>
           <p:nvPr/>
         </p:nvSpPr>
@@ -5533,7 +5333,7 @@
       </p:sp>
       <p:sp>
         <p:nvSpPr>
-          <p:cNvPr id="15" name="Text 13"/>
+          <p:cNvPr id="13" name="Text 11"/>
           <p:cNvSpPr txBox="1"/>
           <p:nvPr/>
         </p:nvSpPr>
@@ -5575,7 +5375,7 @@
       </p:sp>
       <p:sp>
         <p:nvSpPr>
-          <p:cNvPr id="16" name="Shape 14"/>
+          <p:cNvPr id="14" name="Shape 12"/>
           <p:cNvSpPr/>
           <p:nvPr/>
         </p:nvSpPr>
@@ -5597,7 +5397,7 @@
       </p:sp>
       <p:sp>
         <p:nvSpPr>
-          <p:cNvPr id="17" name="Text 15"/>
+          <p:cNvPr id="15" name="Text 13"/>
           <p:cNvSpPr txBox="1"/>
           <p:nvPr/>
         </p:nvSpPr>
@@ -5636,7 +5436,7 @@
       </p:sp>
       <p:sp>
         <p:nvSpPr>
-          <p:cNvPr id="18" name="Text 16"/>
+          <p:cNvPr id="16" name="Text 14"/>
           <p:cNvSpPr txBox="1"/>
           <p:nvPr/>
         </p:nvSpPr>
@@ -5678,7 +5478,7 @@
       </p:sp>
       <p:sp>
         <p:nvSpPr>
-          <p:cNvPr id="19" name="Text 17"/>
+          <p:cNvPr id="17" name="Text 15"/>
           <p:cNvSpPr txBox="1"/>
           <p:nvPr/>
         </p:nvSpPr>
@@ -5717,27 +5517,7 @@
       </p:sp>
       <p:sp>
         <p:nvSpPr>
-          <p:cNvPr id="20" name="Shape 18"/>
-          <p:cNvSpPr/>
-          <p:nvPr/>
-        </p:nvSpPr>
-        <p:spPr>
-          <a:xfrm>
-            <a:off x="6217920" y="1865376"/>
-            <a:ext cx="320040" cy="32004"/>
-          </a:xfrm>
-          <a:prstGeom prst="rect">
-            <a:avLst/>
-          </a:prstGeom>
-          <a:solidFill>
-            <a:srgbClr val="F2704A"/>
-          </a:solidFill>
-          <a:ln/>
-        </p:spPr>
-      </p:sp>
-      <p:sp>
-        <p:nvSpPr>
-          <p:cNvPr id="21" name="Shape 19"/>
+          <p:cNvPr id="18" name="Shape 16"/>
           <p:cNvSpPr/>
           <p:nvPr/>
         </p:nvSpPr>
@@ -5759,7 +5539,7 @@
       </p:sp>
       <p:sp>
         <p:nvSpPr>
-          <p:cNvPr id="22" name="Text 20"/>
+          <p:cNvPr id="19" name="Text 17"/>
           <p:cNvSpPr txBox="1"/>
           <p:nvPr/>
         </p:nvSpPr>
@@ -5798,7 +5578,7 @@
       </p:sp>
       <p:sp>
         <p:nvSpPr>
-          <p:cNvPr id="23" name="Text 21"/>
+          <p:cNvPr id="20" name="Text 18"/>
           <p:cNvSpPr txBox="1"/>
           <p:nvPr/>
         </p:nvSpPr>
@@ -5840,7 +5620,7 @@
       </p:sp>
       <p:sp>
         <p:nvSpPr>
-          <p:cNvPr id="24" name="Shape 22"/>
+          <p:cNvPr id="21" name="Shape 19"/>
           <p:cNvSpPr/>
           <p:nvPr/>
         </p:nvSpPr>
@@ -5862,7 +5642,7 @@
       </p:sp>
       <p:sp>
         <p:nvSpPr>
-          <p:cNvPr id="25" name="Text 23"/>
+          <p:cNvPr id="22" name="Text 20"/>
           <p:cNvSpPr txBox="1"/>
           <p:nvPr/>
         </p:nvSpPr>
@@ -5901,7 +5681,7 @@
       </p:sp>
       <p:sp>
         <p:nvSpPr>
-          <p:cNvPr id="26" name="Text 24"/>
+          <p:cNvPr id="23" name="Text 21"/>
           <p:cNvSpPr txBox="1"/>
           <p:nvPr/>
         </p:nvSpPr>
@@ -5943,7 +5723,7 @@
       </p:sp>
       <p:sp>
         <p:nvSpPr>
-          <p:cNvPr id="27" name="Shape 25"/>
+          <p:cNvPr id="24" name="Shape 22"/>
           <p:cNvSpPr/>
           <p:nvPr/>
         </p:nvSpPr>
@@ -5965,7 +5745,7 @@
       </p:sp>
       <p:sp>
         <p:nvSpPr>
-          <p:cNvPr id="28" name="Text 26"/>
+          <p:cNvPr id="25" name="Text 23"/>
           <p:cNvSpPr txBox="1"/>
           <p:nvPr/>
         </p:nvSpPr>
@@ -6004,7 +5784,7 @@
       </p:sp>
       <p:sp>
         <p:nvSpPr>
-          <p:cNvPr id="29" name="Text 27"/>
+          <p:cNvPr id="26" name="Text 24"/>
           <p:cNvSpPr txBox="1"/>
           <p:nvPr/>
         </p:nvSpPr>
@@ -6046,7 +5826,7 @@
       </p:sp>
       <p:sp>
         <p:nvSpPr>
-          <p:cNvPr id="30" name="Shape 28"/>
+          <p:cNvPr id="27" name="Shape 25"/>
           <p:cNvSpPr/>
           <p:nvPr/>
         </p:nvSpPr>
@@ -6068,7 +5848,7 @@
       </p:sp>
       <p:sp>
         <p:nvSpPr>
-          <p:cNvPr id="31" name="Text 29"/>
+          <p:cNvPr id="28" name="Text 26"/>
           <p:cNvSpPr txBox="1"/>
           <p:nvPr/>
         </p:nvSpPr>
@@ -6107,7 +5887,7 @@
       </p:sp>
       <p:sp>
         <p:nvSpPr>
-          <p:cNvPr id="32" name="Text 30"/>
+          <p:cNvPr id="29" name="Text 27"/>
           <p:cNvSpPr txBox="1"/>
           <p:nvPr/>
         </p:nvSpPr>
@@ -6149,7 +5929,7 @@
       </p:sp>
       <p:sp>
         <p:nvSpPr>
-          <p:cNvPr id="33" name="Text 31"/>
+          <p:cNvPr id="30" name="Text 28"/>
           <p:cNvSpPr txBox="1"/>
           <p:nvPr/>
         </p:nvSpPr>
@@ -6188,27 +5968,7 @@
       </p:sp>
       <p:sp>
         <p:nvSpPr>
-          <p:cNvPr id="34" name="Shape 32"/>
-          <p:cNvSpPr/>
-          <p:nvPr/>
-        </p:nvSpPr>
-        <p:spPr>
-          <a:xfrm>
-            <a:off x="640080" y="5157216"/>
-            <a:ext cx="320040" cy="32004"/>
-          </a:xfrm>
-          <a:prstGeom prst="rect">
-            <a:avLst/>
-          </a:prstGeom>
-          <a:solidFill>
-            <a:srgbClr val="F2704A"/>
-          </a:solidFill>
-          <a:ln/>
-        </p:spPr>
-      </p:sp>
-      <p:sp>
-        <p:nvSpPr>
-          <p:cNvPr id="35" name="Shape 33"/>
+          <p:cNvPr id="31" name="Shape 29"/>
           <p:cNvSpPr/>
           <p:nvPr/>
         </p:nvSpPr>
@@ -6237,7 +5997,7 @@
       </p:sp>
       <p:sp>
         <p:nvSpPr>
-          <p:cNvPr id="36" name="Shape 34"/>
+          <p:cNvPr id="32" name="Shape 30"/>
           <p:cNvSpPr/>
           <p:nvPr/>
         </p:nvSpPr>
@@ -6259,7 +6019,7 @@
       </p:sp>
       <p:sp>
         <p:nvSpPr>
-          <p:cNvPr id="37" name="Text 35"/>
+          <p:cNvPr id="33" name="Text 31"/>
           <p:cNvSpPr txBox="1"/>
           <p:nvPr/>
         </p:nvSpPr>
@@ -6298,7 +6058,7 @@
       </p:sp>
       <p:sp>
         <p:nvSpPr>
-          <p:cNvPr id="38" name="Text 36"/>
+          <p:cNvPr id="34" name="Text 32"/>
           <p:cNvSpPr txBox="1"/>
           <p:nvPr/>
         </p:nvSpPr>
@@ -6337,7 +6097,7 @@
       </p:sp>
       <p:sp>
         <p:nvSpPr>
-          <p:cNvPr id="39" name="Text 37"/>
+          <p:cNvPr id="35" name="Text 33"/>
           <p:cNvSpPr txBox="1"/>
           <p:nvPr/>
         </p:nvSpPr>
@@ -6399,7 +6159,7 @@
       </p:sp>
       <p:sp>
         <p:nvSpPr>
-          <p:cNvPr id="40" name="Shape 38"/>
+          <p:cNvPr id="36" name="Shape 34"/>
           <p:cNvSpPr/>
           <p:nvPr/>
         </p:nvSpPr>
@@ -6428,7 +6188,7 @@
       </p:sp>
       <p:sp>
         <p:nvSpPr>
-          <p:cNvPr id="41" name="Shape 39"/>
+          <p:cNvPr id="37" name="Shape 35"/>
           <p:cNvSpPr/>
           <p:nvPr/>
         </p:nvSpPr>
@@ -6450,7 +6210,7 @@
       </p:sp>
       <p:sp>
         <p:nvSpPr>
-          <p:cNvPr id="42" name="Text 40"/>
+          <p:cNvPr id="38" name="Text 36"/>
           <p:cNvSpPr txBox="1"/>
           <p:nvPr/>
         </p:nvSpPr>
@@ -6489,7 +6249,7 @@
       </p:sp>
       <p:sp>
         <p:nvSpPr>
-          <p:cNvPr id="43" name="Text 41"/>
+          <p:cNvPr id="39" name="Text 37"/>
           <p:cNvSpPr txBox="1"/>
           <p:nvPr/>
         </p:nvSpPr>
@@ -6528,7 +6288,7 @@
       </p:sp>
       <p:sp>
         <p:nvSpPr>
-          <p:cNvPr id="44" name="Text 42"/>
+          <p:cNvPr id="40" name="Text 38"/>
           <p:cNvSpPr txBox="1"/>
           <p:nvPr/>
         </p:nvSpPr>
@@ -6590,7 +6350,7 @@
       </p:sp>
       <p:sp>
         <p:nvSpPr>
-          <p:cNvPr id="45" name="Shape 43"/>
+          <p:cNvPr id="41" name="Shape 39"/>
           <p:cNvSpPr/>
           <p:nvPr/>
         </p:nvSpPr>
@@ -6619,7 +6379,7 @@
       </p:sp>
       <p:sp>
         <p:nvSpPr>
-          <p:cNvPr id="46" name="Shape 44"/>
+          <p:cNvPr id="42" name="Shape 40"/>
           <p:cNvSpPr/>
           <p:nvPr/>
         </p:nvSpPr>
@@ -6641,7 +6401,7 @@
       </p:sp>
       <p:sp>
         <p:nvSpPr>
-          <p:cNvPr id="47" name="Text 45"/>
+          <p:cNvPr id="43" name="Text 41"/>
           <p:cNvSpPr txBox="1"/>
           <p:nvPr/>
         </p:nvSpPr>
@@ -6680,7 +6440,7 @@
       </p:sp>
       <p:sp>
         <p:nvSpPr>
-          <p:cNvPr id="48" name="Text 46"/>
+          <p:cNvPr id="44" name="Text 42"/>
           <p:cNvSpPr txBox="1"/>
           <p:nvPr/>
         </p:nvSpPr>
@@ -6719,7 +6479,7 @@
       </p:sp>
       <p:sp>
         <p:nvSpPr>
-          <p:cNvPr id="49" name="Text 47"/>
+          <p:cNvPr id="45" name="Text 43"/>
           <p:cNvSpPr txBox="1"/>
           <p:nvPr/>
         </p:nvSpPr>
@@ -6781,7 +6541,7 @@
       </p:sp>
       <p:sp>
         <p:nvSpPr>
-          <p:cNvPr id="50" name="Shape 48"/>
+          <p:cNvPr id="46" name="Shape 44"/>
           <p:cNvSpPr/>
           <p:nvPr/>
         </p:nvSpPr>
@@ -6810,7 +6570,7 @@
       </p:sp>
       <p:sp>
         <p:nvSpPr>
-          <p:cNvPr id="51" name="Shape 49"/>
+          <p:cNvPr id="47" name="Shape 45"/>
           <p:cNvSpPr/>
           <p:nvPr/>
         </p:nvSpPr>
@@ -6832,7 +6592,7 @@
       </p:sp>
       <p:sp>
         <p:nvSpPr>
-          <p:cNvPr id="52" name="Text 50"/>
+          <p:cNvPr id="48" name="Text 46"/>
           <p:cNvSpPr txBox="1"/>
           <p:nvPr/>
         </p:nvSpPr>
@@ -6871,7 +6631,7 @@
       </p:sp>
       <p:sp>
         <p:nvSpPr>
-          <p:cNvPr id="53" name="Text 51"/>
+          <p:cNvPr id="49" name="Text 47"/>
           <p:cNvSpPr txBox="1"/>
           <p:nvPr/>
         </p:nvSpPr>
@@ -6910,7 +6670,7 @@
       </p:sp>
       <p:sp>
         <p:nvSpPr>
-          <p:cNvPr id="54" name="Text 52"/>
+          <p:cNvPr id="50" name="Text 48"/>
           <p:cNvSpPr txBox="1"/>
           <p:nvPr/>
         </p:nvSpPr>
@@ -6972,7 +6732,7 @@
       </p:sp>
       <p:sp>
         <p:nvSpPr>
-          <p:cNvPr id="55" name="Text 53"/>
+          <p:cNvPr id="51" name="Text 49"/>
           <p:cNvSpPr txBox="1"/>
           <p:nvPr/>
         </p:nvSpPr>
@@ -7023,7 +6783,7 @@
     <p:bg>
       <p:bgPr>
         <a:solidFill>
-          <a:srgbClr val="FBF8F3"/>
+          <a:srgbClr val="F5F6F5"/>
         </a:solidFill>
       </p:bgPr>
     </p:bg>
@@ -7122,26 +6882,6 @@
       <p:sp>
         <p:nvSpPr>
           <p:cNvPr id="4" name="Shape 2"/>
-          <p:cNvSpPr/>
-          <p:nvPr/>
-        </p:nvSpPr>
-        <p:spPr>
-          <a:xfrm>
-            <a:off x="640080" y="1207008"/>
-            <a:ext cx="502920" cy="45720"/>
-          </a:xfrm>
-          <a:prstGeom prst="rect">
-            <a:avLst/>
-          </a:prstGeom>
-          <a:solidFill>
-            <a:srgbClr val="F2704A"/>
-          </a:solidFill>
-          <a:ln/>
-        </p:spPr>
-      </p:sp>
-      <p:sp>
-        <p:nvSpPr>
-          <p:cNvPr id="5" name="Shape 3"/>
           <p:cNvSpPr/>
           <p:nvPr/>
         </p:nvSpPr>
@@ -7170,7 +6910,7 @@
       </p:sp>
       <p:sp>
         <p:nvSpPr>
-          <p:cNvPr id="6" name="Shape 4"/>
+          <p:cNvPr id="5" name="Shape 3"/>
           <p:cNvSpPr/>
           <p:nvPr/>
         </p:nvSpPr>
@@ -7192,7 +6932,7 @@
       </p:sp>
       <p:sp>
         <p:nvSpPr>
-          <p:cNvPr id="7" name="Text 5"/>
+          <p:cNvPr id="6" name="Text 4"/>
           <p:cNvSpPr txBox="1"/>
           <p:nvPr/>
         </p:nvSpPr>
@@ -7231,7 +6971,7 @@
       </p:sp>
       <p:sp>
         <p:nvSpPr>
-          <p:cNvPr id="8" name="Text 6"/>
+          <p:cNvPr id="7" name="Text 5"/>
           <p:cNvSpPr txBox="1"/>
           <p:nvPr/>
         </p:nvSpPr>
@@ -7270,7 +7010,7 @@
       </p:sp>
       <p:sp>
         <p:nvSpPr>
-          <p:cNvPr id="9" name="Text 7"/>
+          <p:cNvPr id="8" name="Text 6"/>
           <p:cNvSpPr txBox="1"/>
           <p:nvPr/>
         </p:nvSpPr>
@@ -7404,7 +7144,7 @@
       </p:sp>
       <p:sp>
         <p:nvSpPr>
-          <p:cNvPr id="10" name="Shape 8"/>
+          <p:cNvPr id="9" name="Shape 7"/>
           <p:cNvSpPr/>
           <p:nvPr/>
         </p:nvSpPr>
@@ -7433,7 +7173,7 @@
       </p:sp>
       <p:sp>
         <p:nvSpPr>
-          <p:cNvPr id="11" name="Shape 9"/>
+          <p:cNvPr id="10" name="Shape 8"/>
           <p:cNvSpPr/>
           <p:nvPr/>
         </p:nvSpPr>
@@ -7455,7 +7195,7 @@
       </p:sp>
       <p:sp>
         <p:nvSpPr>
-          <p:cNvPr id="12" name="Text 10"/>
+          <p:cNvPr id="11" name="Text 9"/>
           <p:cNvSpPr txBox="1"/>
           <p:nvPr/>
         </p:nvSpPr>
@@ -7494,7 +7234,7 @@
       </p:sp>
       <p:sp>
         <p:nvSpPr>
-          <p:cNvPr id="13" name="Text 11"/>
+          <p:cNvPr id="12" name="Text 10"/>
           <p:cNvSpPr txBox="1"/>
           <p:nvPr/>
         </p:nvSpPr>
@@ -7533,7 +7273,7 @@
       </p:sp>
       <p:pic>
         <p:nvPicPr>
-          <p:cNvPr id="14" name="Image 0" descr="/home/user/-/수복치과재료학실험/dental_photos/insert/photo_09.jpg">    </p:cNvPr>
+          <p:cNvPr id="13" name="Image 0" descr="/home/user/-/수복치과재료학실험/dental_photos/insert/photo_09.jpg">    </p:cNvPr>
           <p:cNvPicPr>
             <a:picLocks noChangeAspect="1"/>
           </p:cNvPicPr>
@@ -7556,7 +7296,7 @@
       </p:pic>
       <p:sp>
         <p:nvSpPr>
-          <p:cNvPr id="15" name="Shape 12"/>
+          <p:cNvPr id="14" name="Shape 11"/>
           <p:cNvSpPr/>
           <p:nvPr/>
         </p:nvSpPr>
@@ -7578,7 +7318,7 @@
       </p:sp>
       <p:sp>
         <p:nvSpPr>
-          <p:cNvPr id="16" name="Text 13"/>
+          <p:cNvPr id="15" name="Text 12"/>
           <p:cNvSpPr txBox="1"/>
           <p:nvPr/>
         </p:nvSpPr>
@@ -7617,7 +7357,7 @@
       </p:sp>
       <p:sp>
         <p:nvSpPr>
-          <p:cNvPr id="17" name="Text 14"/>
+          <p:cNvPr id="16" name="Text 13"/>
           <p:cNvSpPr txBox="1"/>
           <p:nvPr/>
         </p:nvSpPr>
@@ -7751,7 +7491,7 @@
       </p:sp>
       <p:sp>
         <p:nvSpPr>
-          <p:cNvPr id="18" name="Shape 15"/>
+          <p:cNvPr id="17" name="Shape 14"/>
           <p:cNvSpPr/>
           <p:nvPr/>
         </p:nvSpPr>
@@ -7780,7 +7520,7 @@
       </p:sp>
       <p:sp>
         <p:nvSpPr>
-          <p:cNvPr id="19" name="Shape 16"/>
+          <p:cNvPr id="18" name="Shape 15"/>
           <p:cNvSpPr/>
           <p:nvPr/>
         </p:nvSpPr>
@@ -7802,7 +7542,7 @@
       </p:sp>
       <p:sp>
         <p:nvSpPr>
-          <p:cNvPr id="20" name="Text 17"/>
+          <p:cNvPr id="19" name="Text 16"/>
           <p:cNvSpPr txBox="1"/>
           <p:nvPr/>
         </p:nvSpPr>
@@ -7841,7 +7581,7 @@
       </p:sp>
       <p:sp>
         <p:nvSpPr>
-          <p:cNvPr id="21" name="Text 18"/>
+          <p:cNvPr id="20" name="Text 17"/>
           <p:cNvSpPr txBox="1"/>
           <p:nvPr/>
         </p:nvSpPr>
@@ -7880,7 +7620,7 @@
       </p:sp>
       <p:pic>
         <p:nvPicPr>
-          <p:cNvPr id="22" name="Image 1" descr="/home/user/-/수복치과재료학실험/dental_photos/insert/photo_10.jpg">    </p:cNvPr>
+          <p:cNvPr id="21" name="Image 1" descr="/home/user/-/수복치과재료학실험/dental_photos/insert/photo_10.jpg">    </p:cNvPr>
           <p:cNvPicPr>
             <a:picLocks noChangeAspect="1"/>
           </p:cNvPicPr>
@@ -7903,7 +7643,7 @@
       </p:pic>
       <p:sp>
         <p:nvSpPr>
-          <p:cNvPr id="23" name="Shape 19"/>
+          <p:cNvPr id="22" name="Shape 18"/>
           <p:cNvSpPr/>
           <p:nvPr/>
         </p:nvSpPr>
@@ -7925,7 +7665,7 @@
       </p:sp>
       <p:sp>
         <p:nvSpPr>
-          <p:cNvPr id="24" name="Text 20"/>
+          <p:cNvPr id="23" name="Text 19"/>
           <p:cNvSpPr txBox="1"/>
           <p:nvPr/>
         </p:nvSpPr>
@@ -7964,7 +7704,7 @@
       </p:sp>
       <p:sp>
         <p:nvSpPr>
-          <p:cNvPr id="25" name="Text 21"/>
+          <p:cNvPr id="24" name="Text 20"/>
           <p:cNvSpPr txBox="1"/>
           <p:nvPr/>
         </p:nvSpPr>
@@ -8098,7 +7838,7 @@
       </p:sp>
       <p:sp>
         <p:nvSpPr>
-          <p:cNvPr id="26" name="Shape 22"/>
+          <p:cNvPr id="25" name="Shape 21"/>
           <p:cNvSpPr/>
           <p:nvPr/>
         </p:nvSpPr>
@@ -8120,7 +7860,7 @@
       </p:sp>
       <p:sp>
         <p:nvSpPr>
-          <p:cNvPr id="27" name="Text 23"/>
+          <p:cNvPr id="26" name="Text 22"/>
           <p:cNvSpPr txBox="1"/>
           <p:nvPr/>
         </p:nvSpPr>
@@ -8214,7 +7954,7 @@
       </p:sp>
       <p:sp>
         <p:nvSpPr>
-          <p:cNvPr id="28" name="Text 24"/>
+          <p:cNvPr id="27" name="Text 23"/>
           <p:cNvSpPr txBox="1"/>
           <p:nvPr/>
         </p:nvSpPr>
@@ -8265,7 +8005,7 @@
     <p:bg>
       <p:bgPr>
         <a:solidFill>
-          <a:srgbClr val="FBF8F3"/>
+          <a:srgbClr val="F5F6F5"/>
         </a:solidFill>
       </p:bgPr>
     </p:bg>
@@ -8363,27 +8103,7 @@
       </p:sp>
       <p:sp>
         <p:nvSpPr>
-          <p:cNvPr id="4" name="Shape 2"/>
-          <p:cNvSpPr/>
-          <p:nvPr/>
-        </p:nvSpPr>
-        <p:spPr>
-          <a:xfrm>
-            <a:off x="640080" y="1207008"/>
-            <a:ext cx="502920" cy="45720"/>
-          </a:xfrm>
-          <a:prstGeom prst="rect">
-            <a:avLst/>
-          </a:prstGeom>
-          <a:solidFill>
-            <a:srgbClr val="F2704A"/>
-          </a:solidFill>
-          <a:ln/>
-        </p:spPr>
-      </p:sp>
-      <p:sp>
-        <p:nvSpPr>
-          <p:cNvPr id="5" name="Text 3"/>
+          <p:cNvPr id="4" name="Text 2"/>
           <p:cNvSpPr txBox="1"/>
           <p:nvPr/>
         </p:nvSpPr>
@@ -8422,27 +8142,7 @@
       </p:sp>
       <p:sp>
         <p:nvSpPr>
-          <p:cNvPr id="6" name="Shape 4"/>
-          <p:cNvSpPr/>
-          <p:nvPr/>
-        </p:nvSpPr>
-        <p:spPr>
-          <a:xfrm>
-            <a:off x="640080" y="1819656"/>
-            <a:ext cx="320040" cy="32004"/>
-          </a:xfrm>
-          <a:prstGeom prst="rect">
-            <a:avLst/>
-          </a:prstGeom>
-          <a:solidFill>
-            <a:srgbClr val="F2704A"/>
-          </a:solidFill>
-          <a:ln/>
-        </p:spPr>
-      </p:sp>
-      <p:sp>
-        <p:nvSpPr>
-          <p:cNvPr id="7" name="Text 5"/>
+          <p:cNvPr id="5" name="Text 3"/>
           <p:cNvSpPr txBox="1"/>
           <p:nvPr/>
         </p:nvSpPr>
@@ -8524,7 +8224,7 @@
       </p:sp>
       <p:sp>
         <p:nvSpPr>
-          <p:cNvPr id="8" name="Text 6"/>
+          <p:cNvPr id="6" name="Text 4"/>
           <p:cNvSpPr txBox="1"/>
           <p:nvPr/>
         </p:nvSpPr>
@@ -8563,27 +8263,7 @@
       </p:sp>
       <p:sp>
         <p:nvSpPr>
-          <p:cNvPr id="9" name="Shape 7"/>
-          <p:cNvSpPr/>
-          <p:nvPr/>
-        </p:nvSpPr>
-        <p:spPr>
-          <a:xfrm>
-            <a:off x="640080" y="3694176"/>
-            <a:ext cx="320040" cy="32004"/>
-          </a:xfrm>
-          <a:prstGeom prst="rect">
-            <a:avLst/>
-          </a:prstGeom>
-          <a:solidFill>
-            <a:srgbClr val="F2704A"/>
-          </a:solidFill>
-          <a:ln/>
-        </p:spPr>
-      </p:sp>
-      <p:sp>
-        <p:nvSpPr>
-          <p:cNvPr id="10" name="Text 8"/>
+          <p:cNvPr id="7" name="Text 5"/>
           <p:cNvSpPr txBox="1"/>
           <p:nvPr/>
         </p:nvSpPr>
@@ -8685,7 +8365,7 @@
       </p:sp>
       <p:sp>
         <p:nvSpPr>
-          <p:cNvPr id="11" name="Shape 9"/>
+          <p:cNvPr id="8" name="Shape 6"/>
           <p:cNvSpPr/>
           <p:nvPr/>
         </p:nvSpPr>
@@ -8714,7 +8394,7 @@
       </p:sp>
       <p:sp>
         <p:nvSpPr>
-          <p:cNvPr id="12" name="Text 10"/>
+          <p:cNvPr id="9" name="Text 7"/>
           <p:cNvSpPr txBox="1"/>
           <p:nvPr/>
         </p:nvSpPr>
@@ -10373,7 +10053,7 @@
       </p:graphicFrame>
       <p:sp>
         <p:nvSpPr>
-          <p:cNvPr id="14" name="Text 11"/>
+          <p:cNvPr id="11" name="Text 8"/>
           <p:cNvSpPr txBox="1"/>
           <p:nvPr/>
         </p:nvSpPr>
@@ -10415,7 +10095,7 @@
       </p:sp>
       <p:sp>
         <p:nvSpPr>
-          <p:cNvPr id="15" name="Shape 12"/>
+          <p:cNvPr id="12" name="Shape 9"/>
           <p:cNvSpPr/>
           <p:nvPr/>
         </p:nvSpPr>
@@ -10430,34 +10110,14 @@
             </a:avLst>
           </a:prstGeom>
           <a:solidFill>
-            <a:srgbClr val="FFFFFF"/>
+            <a:srgbClr val="EAF2EE"/>
           </a:solidFill>
           <a:ln/>
         </p:spPr>
       </p:sp>
       <p:sp>
         <p:nvSpPr>
-          <p:cNvPr id="16" name="Shape 13"/>
-          <p:cNvSpPr/>
-          <p:nvPr/>
-        </p:nvSpPr>
-        <p:spPr>
-          <a:xfrm>
-            <a:off x="640080" y="5532120"/>
-            <a:ext cx="73152" cy="868680"/>
-          </a:xfrm>
-          <a:prstGeom prst="rect">
-            <a:avLst/>
-          </a:prstGeom>
-          <a:solidFill>
-            <a:srgbClr val="F2704A"/>
-          </a:solidFill>
-          <a:ln/>
-        </p:spPr>
-      </p:sp>
-      <p:sp>
-        <p:nvSpPr>
-          <p:cNvPr id="17" name="Text 14"/>
+          <p:cNvPr id="13" name="Text 10"/>
           <p:cNvSpPr txBox="1"/>
           <p:nvPr/>
         </p:nvSpPr>
@@ -10516,7 +10176,7 @@
       </p:sp>
       <p:sp>
         <p:nvSpPr>
-          <p:cNvPr id="18" name="Text 15"/>
+          <p:cNvPr id="14" name="Text 11"/>
           <p:cNvSpPr txBox="1"/>
           <p:nvPr/>
         </p:nvSpPr>
@@ -10567,7 +10227,7 @@
     <p:bg>
       <p:bgPr>
         <a:solidFill>
-          <a:srgbClr val="FBF8F3"/>
+          <a:srgbClr val="F5F6F5"/>
         </a:solidFill>
       </p:bgPr>
     </p:bg>
@@ -10665,27 +10325,7 @@
       </p:sp>
       <p:sp>
         <p:nvSpPr>
-          <p:cNvPr id="4" name="Shape 2"/>
-          <p:cNvSpPr/>
-          <p:nvPr/>
-        </p:nvSpPr>
-        <p:spPr>
-          <a:xfrm>
-            <a:off x="640080" y="1207008"/>
-            <a:ext cx="502920" cy="45720"/>
-          </a:xfrm>
-          <a:prstGeom prst="rect">
-            <a:avLst/>
-          </a:prstGeom>
-          <a:solidFill>
-            <a:srgbClr val="F2704A"/>
-          </a:solidFill>
-          <a:ln/>
-        </p:spPr>
-      </p:sp>
-      <p:sp>
-        <p:nvSpPr>
-          <p:cNvPr id="5" name="Text 3"/>
+          <p:cNvPr id="4" name="Text 2"/>
           <p:cNvSpPr txBox="1"/>
           <p:nvPr/>
         </p:nvSpPr>
@@ -10724,27 +10364,7 @@
       </p:sp>
       <p:sp>
         <p:nvSpPr>
-          <p:cNvPr id="6" name="Shape 4"/>
-          <p:cNvSpPr/>
-          <p:nvPr/>
-        </p:nvSpPr>
-        <p:spPr>
-          <a:xfrm>
-            <a:off x="640080" y="1819656"/>
-            <a:ext cx="320040" cy="32004"/>
-          </a:xfrm>
-          <a:prstGeom prst="rect">
-            <a:avLst/>
-          </a:prstGeom>
-          <a:solidFill>
-            <a:srgbClr val="F2704A"/>
-          </a:solidFill>
-          <a:ln/>
-        </p:spPr>
-      </p:sp>
-      <p:sp>
-        <p:nvSpPr>
-          <p:cNvPr id="7" name="Text 5"/>
+          <p:cNvPr id="5" name="Text 3"/>
           <p:cNvSpPr txBox="1"/>
           <p:nvPr/>
         </p:nvSpPr>
@@ -12008,7 +11628,7 @@
       </p:graphicFrame>
       <p:sp>
         <p:nvSpPr>
-          <p:cNvPr id="9" name="Text 6"/>
+          <p:cNvPr id="7" name="Text 4"/>
           <p:cNvSpPr txBox="1"/>
           <p:nvPr/>
         </p:nvSpPr>
@@ -12047,27 +11667,7 @@
       </p:sp>
       <p:sp>
         <p:nvSpPr>
-          <p:cNvPr id="10" name="Shape 7"/>
-          <p:cNvSpPr/>
-          <p:nvPr/>
-        </p:nvSpPr>
-        <p:spPr>
-          <a:xfrm>
-            <a:off x="640080" y="4654296"/>
-            <a:ext cx="320040" cy="32004"/>
-          </a:xfrm>
-          <a:prstGeom prst="rect">
-            <a:avLst/>
-          </a:prstGeom>
-          <a:solidFill>
-            <a:srgbClr val="F2704A"/>
-          </a:solidFill>
-          <a:ln/>
-        </p:spPr>
-      </p:sp>
-      <p:sp>
-        <p:nvSpPr>
-          <p:cNvPr id="11" name="Text 8"/>
+          <p:cNvPr id="8" name="Text 5"/>
           <p:cNvSpPr txBox="1"/>
           <p:nvPr/>
         </p:nvSpPr>
@@ -12149,7 +11749,7 @@
       </p:sp>
       <p:sp>
         <p:nvSpPr>
-          <p:cNvPr id="12" name="Text 9"/>
+          <p:cNvPr id="9" name="Text 6"/>
           <p:cNvSpPr txBox="1"/>
           <p:nvPr/>
         </p:nvSpPr>
@@ -12231,7 +11831,7 @@
       </p:sp>
       <p:sp>
         <p:nvSpPr>
-          <p:cNvPr id="13" name="Text 10"/>
+          <p:cNvPr id="10" name="Text 7"/>
           <p:cNvSpPr txBox="1"/>
           <p:nvPr/>
         </p:nvSpPr>
@@ -12270,27 +11870,7 @@
       </p:sp>
       <p:sp>
         <p:nvSpPr>
-          <p:cNvPr id="14" name="Shape 11"/>
-          <p:cNvSpPr/>
-          <p:nvPr/>
-        </p:nvSpPr>
-        <p:spPr>
-          <a:xfrm>
-            <a:off x="640080" y="6071616"/>
-            <a:ext cx="320040" cy="32004"/>
-          </a:xfrm>
-          <a:prstGeom prst="rect">
-            <a:avLst/>
-          </a:prstGeom>
-          <a:solidFill>
-            <a:srgbClr val="F2704A"/>
-          </a:solidFill>
-          <a:ln/>
-        </p:spPr>
-      </p:sp>
-      <p:sp>
-        <p:nvSpPr>
-          <p:cNvPr id="15" name="Text 12"/>
+          <p:cNvPr id="11" name="Text 8"/>
           <p:cNvSpPr txBox="1"/>
           <p:nvPr/>
         </p:nvSpPr>
@@ -12332,7 +11912,7 @@
       </p:sp>
       <p:sp>
         <p:nvSpPr>
-          <p:cNvPr id="16" name="Text 13"/>
+          <p:cNvPr id="12" name="Text 9"/>
           <p:cNvSpPr txBox="1"/>
           <p:nvPr/>
         </p:nvSpPr>
@@ -12383,7 +11963,7 @@
     <p:bg>
       <p:bgPr>
         <a:solidFill>
-          <a:srgbClr val="FBF8F3"/>
+          <a:srgbClr val="F5F6F5"/>
         </a:solidFill>
       </p:bgPr>
     </p:bg>
@@ -12482,26 +12062,6 @@
       <p:sp>
         <p:nvSpPr>
           <p:cNvPr id="4" name="Shape 2"/>
-          <p:cNvSpPr/>
-          <p:nvPr/>
-        </p:nvSpPr>
-        <p:spPr>
-          <a:xfrm>
-            <a:off x="640080" y="1207008"/>
-            <a:ext cx="502920" cy="45720"/>
-          </a:xfrm>
-          <a:prstGeom prst="rect">
-            <a:avLst/>
-          </a:prstGeom>
-          <a:solidFill>
-            <a:srgbClr val="F2704A"/>
-          </a:solidFill>
-          <a:ln/>
-        </p:spPr>
-      </p:sp>
-      <p:sp>
-        <p:nvSpPr>
-          <p:cNvPr id="5" name="Shape 3"/>
           <p:cNvSpPr/>
           <p:nvPr/>
         </p:nvSpPr>
@@ -12530,7 +12090,7 @@
       </p:sp>
       <p:sp>
         <p:nvSpPr>
-          <p:cNvPr id="6" name="Text 4"/>
+          <p:cNvPr id="5" name="Text 3"/>
           <p:cNvSpPr txBox="1"/>
           <p:nvPr/>
         </p:nvSpPr>
@@ -12569,7 +12129,7 @@
       </p:sp>
       <p:sp>
         <p:nvSpPr>
-          <p:cNvPr id="7" name="Text 5"/>
+          <p:cNvPr id="6" name="Text 4"/>
           <p:cNvSpPr txBox="1"/>
           <p:nvPr/>
         </p:nvSpPr>
@@ -12691,7 +12251,7 @@
       </p:sp>
       <p:pic>
         <p:nvPicPr>
-          <p:cNvPr id="8" name="Image 0" descr="/home/user/-/수복치과재료학실험/dental_photos/insert/photo_06.jpg">    </p:cNvPr>
+          <p:cNvPr id="7" name="Image 0" descr="/home/user/-/수복치과재료학실험/dental_photos/insert/photo_06.jpg">    </p:cNvPr>
           <p:cNvPicPr>
             <a:picLocks noChangeAspect="1"/>
           </p:cNvPicPr>
@@ -12714,7 +12274,7 @@
       </p:pic>
       <p:sp>
         <p:nvSpPr>
-          <p:cNvPr id="9" name="Shape 6"/>
+          <p:cNvPr id="8" name="Shape 5"/>
           <p:cNvSpPr/>
           <p:nvPr/>
         </p:nvSpPr>
@@ -12736,7 +12296,7 @@
       </p:sp>
       <p:sp>
         <p:nvSpPr>
-          <p:cNvPr id="10" name="Text 7"/>
+          <p:cNvPr id="9" name="Text 6"/>
           <p:cNvSpPr txBox="1"/>
           <p:nvPr/>
         </p:nvSpPr>
@@ -12778,7 +12338,7 @@
       </p:sp>
       <p:pic>
         <p:nvPicPr>
-          <p:cNvPr id="11" name="Image 1" descr="/home/user/-/수복치과재료학실험/dental_photos/insert/photo_07.jpg">    </p:cNvPr>
+          <p:cNvPr id="10" name="Image 1" descr="/home/user/-/수복치과재료학실험/dental_photos/insert/photo_07.jpg">    </p:cNvPr>
           <p:cNvPicPr>
             <a:picLocks noChangeAspect="1"/>
           </p:cNvPicPr>
@@ -12801,7 +12361,7 @@
       </p:pic>
       <p:sp>
         <p:nvSpPr>
-          <p:cNvPr id="12" name="Shape 8"/>
+          <p:cNvPr id="11" name="Shape 7"/>
           <p:cNvSpPr/>
           <p:nvPr/>
         </p:nvSpPr>
@@ -12823,7 +12383,7 @@
       </p:sp>
       <p:sp>
         <p:nvSpPr>
-          <p:cNvPr id="13" name="Text 9"/>
+          <p:cNvPr id="12" name="Text 8"/>
           <p:cNvSpPr txBox="1"/>
           <p:nvPr/>
         </p:nvSpPr>
@@ -12865,7 +12425,7 @@
       </p:sp>
       <p:sp>
         <p:nvSpPr>
-          <p:cNvPr id="14" name="Shape 10"/>
+          <p:cNvPr id="13" name="Shape 9"/>
           <p:cNvSpPr/>
           <p:nvPr/>
         </p:nvSpPr>
@@ -12894,7 +12454,7 @@
       </p:sp>
       <p:sp>
         <p:nvSpPr>
-          <p:cNvPr id="15" name="Text 11"/>
+          <p:cNvPr id="14" name="Text 10"/>
           <p:cNvSpPr txBox="1"/>
           <p:nvPr/>
         </p:nvSpPr>
@@ -12933,7 +12493,7 @@
       </p:sp>
       <p:sp>
         <p:nvSpPr>
-          <p:cNvPr id="16" name="Text 12"/>
+          <p:cNvPr id="15" name="Text 11"/>
           <p:cNvSpPr txBox="1"/>
           <p:nvPr/>
         </p:nvSpPr>
@@ -13055,7 +12615,7 @@
       </p:sp>
       <p:pic>
         <p:nvPicPr>
-          <p:cNvPr id="17" name="Image 2" descr="/home/user/-/수복치과재료학실험/dental_photos/insert/photo_05.jpg">    </p:cNvPr>
+          <p:cNvPr id="16" name="Image 2" descr="/home/user/-/수복치과재료학실험/dental_photos/insert/photo_05.jpg">    </p:cNvPr>
           <p:cNvPicPr>
             <a:picLocks noChangeAspect="1"/>
           </p:cNvPicPr>
@@ -13078,7 +12638,7 @@
       </p:pic>
       <p:sp>
         <p:nvSpPr>
-          <p:cNvPr id="18" name="Shape 13"/>
+          <p:cNvPr id="17" name="Shape 12"/>
           <p:cNvSpPr/>
           <p:nvPr/>
         </p:nvSpPr>
@@ -13100,7 +12660,7 @@
       </p:sp>
       <p:sp>
         <p:nvSpPr>
-          <p:cNvPr id="19" name="Text 14"/>
+          <p:cNvPr id="18" name="Text 13"/>
           <p:cNvSpPr txBox="1"/>
           <p:nvPr/>
         </p:nvSpPr>
@@ -13142,7 +12702,7 @@
       </p:sp>
       <p:sp>
         <p:nvSpPr>
-          <p:cNvPr id="20" name="Text 15"/>
+          <p:cNvPr id="19" name="Text 14"/>
           <p:cNvSpPr txBox="1"/>
           <p:nvPr/>
         </p:nvSpPr>
@@ -13193,7 +12753,7 @@
     <p:bg>
       <p:bgPr>
         <a:solidFill>
-          <a:srgbClr val="FBF8F3"/>
+          <a:srgbClr val="F5F6F5"/>
         </a:solidFill>
       </p:bgPr>
     </p:bg>
@@ -13291,27 +12851,7 @@
       </p:sp>
       <p:sp>
         <p:nvSpPr>
-          <p:cNvPr id="4" name="Shape 2"/>
-          <p:cNvSpPr/>
-          <p:nvPr/>
-        </p:nvSpPr>
-        <p:spPr>
-          <a:xfrm>
-            <a:off x="640080" y="1207008"/>
-            <a:ext cx="502920" cy="45720"/>
-          </a:xfrm>
-          <a:prstGeom prst="rect">
-            <a:avLst/>
-          </a:prstGeom>
-          <a:solidFill>
-            <a:srgbClr val="F2704A"/>
-          </a:solidFill>
-          <a:ln/>
-        </p:spPr>
-      </p:sp>
-      <p:sp>
-        <p:nvSpPr>
-          <p:cNvPr id="5" name="Text 3"/>
+          <p:cNvPr id="4" name="Text 2"/>
           <p:cNvSpPr txBox="1"/>
           <p:nvPr/>
         </p:nvSpPr>
@@ -13347,26 +12887,6 @@
             <a:endParaRPr lang="en-US" sz="1450" dirty="0"/>
           </a:p>
         </p:txBody>
-      </p:sp>
-      <p:sp>
-        <p:nvSpPr>
-          <p:cNvPr id="6" name="Shape 4"/>
-          <p:cNvSpPr/>
-          <p:nvPr/>
-        </p:nvSpPr>
-        <p:spPr>
-          <a:xfrm>
-            <a:off x="640080" y="1819656"/>
-            <a:ext cx="320040" cy="32004"/>
-          </a:xfrm>
-          <a:prstGeom prst="rect">
-            <a:avLst/>
-          </a:prstGeom>
-          <a:solidFill>
-            <a:srgbClr val="F2704A"/>
-          </a:solidFill>
-          <a:ln/>
-        </p:spPr>
       </p:sp>
       <p:graphicFrame>
         <p:nvGraphicFramePr>
@@ -14986,7 +14506,7 @@
       </p:graphicFrame>
       <p:sp>
         <p:nvSpPr>
-          <p:cNvPr id="8" name="Text 5"/>
+          <p:cNvPr id="6" name="Text 3"/>
           <p:cNvSpPr txBox="1"/>
           <p:nvPr/>
         </p:nvSpPr>
@@ -15025,27 +14545,7 @@
       </p:sp>
       <p:sp>
         <p:nvSpPr>
-          <p:cNvPr id="9" name="Shape 6"/>
-          <p:cNvSpPr/>
-          <p:nvPr/>
-        </p:nvSpPr>
-        <p:spPr>
-          <a:xfrm>
-            <a:off x="6492240" y="1819656"/>
-            <a:ext cx="320040" cy="32004"/>
-          </a:xfrm>
-          <a:prstGeom prst="rect">
-            <a:avLst/>
-          </a:prstGeom>
-          <a:solidFill>
-            <a:srgbClr val="F2704A"/>
-          </a:solidFill>
-          <a:ln/>
-        </p:spPr>
-      </p:sp>
-      <p:sp>
-        <p:nvSpPr>
-          <p:cNvPr id="10" name="Text 7"/>
+          <p:cNvPr id="7" name="Text 4"/>
           <p:cNvSpPr txBox="1"/>
           <p:nvPr/>
         </p:nvSpPr>
@@ -15167,7 +14667,7 @@
       </p:sp>
       <p:pic>
         <p:nvPicPr>
-          <p:cNvPr id="11" name="Image 0" descr="/home/user/-/수복치과재료학실험/dental_photos/insert/photo_04.jpg">    </p:cNvPr>
+          <p:cNvPr id="8" name="Image 0" descr="/home/user/-/수복치과재료학실험/dental_photos/insert/photo_04.jpg">    </p:cNvPr>
           <p:cNvPicPr>
             <a:picLocks noChangeAspect="1"/>
           </p:cNvPicPr>
@@ -15190,7 +14690,7 @@
       </p:pic>
       <p:sp>
         <p:nvSpPr>
-          <p:cNvPr id="12" name="Shape 8"/>
+          <p:cNvPr id="9" name="Shape 5"/>
           <p:cNvSpPr/>
           <p:nvPr/>
         </p:nvSpPr>
@@ -15212,7 +14712,7 @@
       </p:sp>
       <p:sp>
         <p:nvSpPr>
-          <p:cNvPr id="13" name="Text 9"/>
+          <p:cNvPr id="10" name="Text 6"/>
           <p:cNvSpPr txBox="1"/>
           <p:nvPr/>
         </p:nvSpPr>
@@ -15254,27 +14754,7 @@
       </p:sp>
       <p:sp>
         <p:nvSpPr>
-          <p:cNvPr id="14" name="Shape 10"/>
-          <p:cNvSpPr/>
-          <p:nvPr/>
-        </p:nvSpPr>
-        <p:spPr>
-          <a:xfrm>
-            <a:off x="640080" y="4828032"/>
-            <a:ext cx="10908792" cy="27432"/>
-          </a:xfrm>
-          <a:prstGeom prst="rect">
-            <a:avLst/>
-          </a:prstGeom>
-          <a:solidFill>
-            <a:srgbClr val="E4DED2"/>
-          </a:solidFill>
-          <a:ln/>
-        </p:spPr>
-      </p:sp>
-      <p:sp>
-        <p:nvSpPr>
-          <p:cNvPr id="15" name="Text 11"/>
+          <p:cNvPr id="11" name="Text 7"/>
           <p:cNvSpPr txBox="1"/>
           <p:nvPr/>
         </p:nvSpPr>
@@ -15313,27 +14793,7 @@
       </p:sp>
       <p:sp>
         <p:nvSpPr>
-          <p:cNvPr id="16" name="Shape 12"/>
-          <p:cNvSpPr/>
-          <p:nvPr/>
-        </p:nvSpPr>
-        <p:spPr>
-          <a:xfrm>
-            <a:off x="640080" y="5266944"/>
-            <a:ext cx="320040" cy="32004"/>
-          </a:xfrm>
-          <a:prstGeom prst="rect">
-            <a:avLst/>
-          </a:prstGeom>
-          <a:solidFill>
-            <a:srgbClr val="F2704A"/>
-          </a:solidFill>
-          <a:ln/>
-        </p:spPr>
-      </p:sp>
-      <p:sp>
-        <p:nvSpPr>
-          <p:cNvPr id="17" name="Text 13"/>
+          <p:cNvPr id="12" name="Text 8"/>
           <p:cNvSpPr txBox="1"/>
           <p:nvPr/>
         </p:nvSpPr>
@@ -15395,7 +14855,7 @@
       </p:sp>
       <p:sp>
         <p:nvSpPr>
-          <p:cNvPr id="18" name="Text 14"/>
+          <p:cNvPr id="13" name="Text 9"/>
           <p:cNvSpPr txBox="1"/>
           <p:nvPr/>
         </p:nvSpPr>
@@ -15437,7 +14897,7 @@
       </p:sp>
       <p:pic>
         <p:nvPicPr>
-          <p:cNvPr id="19" name="Image 1" descr="/home/user/-/수복치과재료학실험/dental_photos/insert/photo_02.jpg">    </p:cNvPr>
+          <p:cNvPr id="14" name="Image 1" descr="/home/user/-/수복치과재료학실험/dental_photos/insert/photo_02.jpg">    </p:cNvPr>
           <p:cNvPicPr>
             <a:picLocks noChangeAspect="1"/>
           </p:cNvPicPr>
@@ -15460,7 +14920,7 @@
       </p:pic>
       <p:sp>
         <p:nvSpPr>
-          <p:cNvPr id="20" name="Shape 15"/>
+          <p:cNvPr id="15" name="Shape 10"/>
           <p:cNvSpPr/>
           <p:nvPr/>
         </p:nvSpPr>
@@ -15482,7 +14942,7 @@
       </p:sp>
       <p:sp>
         <p:nvSpPr>
-          <p:cNvPr id="21" name="Text 16"/>
+          <p:cNvPr id="16" name="Text 11"/>
           <p:cNvSpPr txBox="1"/>
           <p:nvPr/>
         </p:nvSpPr>
@@ -15524,7 +14984,7 @@
       </p:sp>
       <p:sp>
         <p:nvSpPr>
-          <p:cNvPr id="22" name="Text 17"/>
+          <p:cNvPr id="17" name="Text 12"/>
           <p:cNvSpPr txBox="1"/>
           <p:nvPr/>
         </p:nvSpPr>
@@ -15575,7 +15035,7 @@
     <p:bg>
       <p:bgPr>
         <a:solidFill>
-          <a:srgbClr val="FBF8F3"/>
+          <a:srgbClr val="F5F6F5"/>
         </a:solidFill>
       </p:bgPr>
     </p:bg>
@@ -15670,26 +15130,6 @@
             <a:endParaRPr lang="en-US" sz="2400" dirty="0"/>
           </a:p>
         </p:txBody>
-      </p:sp>
-      <p:sp>
-        <p:nvSpPr>
-          <p:cNvPr id="4" name="Shape 2"/>
-          <p:cNvSpPr/>
-          <p:nvPr/>
-        </p:nvSpPr>
-        <p:spPr>
-          <a:xfrm>
-            <a:off x="640080" y="1207008"/>
-            <a:ext cx="502920" cy="45720"/>
-          </a:xfrm>
-          <a:prstGeom prst="rect">
-            <a:avLst/>
-          </a:prstGeom>
-          <a:solidFill>
-            <a:srgbClr val="F2704A"/>
-          </a:solidFill>
-          <a:ln/>
-        </p:spPr>
       </p:sp>
       <p:graphicFrame>
         <p:nvGraphicFramePr>
@@ -20451,7 +19891,7 @@
       </p:graphicFrame>
       <p:sp>
         <p:nvSpPr>
-          <p:cNvPr id="6" name="Text 3"/>
+          <p:cNvPr id="5" name="Text 2"/>
           <p:cNvSpPr txBox="1"/>
           <p:nvPr/>
         </p:nvSpPr>
@@ -20493,7 +19933,7 @@
       </p:sp>
       <p:sp>
         <p:nvSpPr>
-          <p:cNvPr id="7" name="Shape 4"/>
+          <p:cNvPr id="6" name="Shape 3"/>
           <p:cNvSpPr/>
           <p:nvPr/>
         </p:nvSpPr>
@@ -20515,7 +19955,7 @@
       </p:sp>
       <p:sp>
         <p:nvSpPr>
-          <p:cNvPr id="8" name="Text 5"/>
+          <p:cNvPr id="7" name="Text 4"/>
           <p:cNvSpPr txBox="1"/>
           <p:nvPr/>
         </p:nvSpPr>
@@ -20554,7 +19994,7 @@
       </p:sp>
       <p:sp>
         <p:nvSpPr>
-          <p:cNvPr id="9" name="Text 6"/>
+          <p:cNvPr id="8" name="Text 5"/>
           <p:cNvSpPr txBox="1"/>
           <p:nvPr/>
         </p:nvSpPr>

</xml_diff>

<commit_message>
Add real SD error bars + class-trend/A2-comparison slide from Results.xlsx
pptxgenjs has no native error-bar support, so scripts/add_errorbars.py
post-processes the generated chart XML to inject custom symmetric SD
error bars (per the pptx skill's OOXML-patch guidance). Recomputed the
setting-time means/SDs directly from the team's Results.xlsx raw data
(6 groups, mixed mm:ss/decimal formats normalized by hand — the
spreadsheet's own AVERAGE/STDEV formulas were erroring out with #NAME?
on the mixed formats). Added a new slide comparing our group's values
against the class-wide trend, in SD-multiple terms, following the format
of the referenced A2 composite-resin deck's "Group vs Overall Average"
style.
</commit_message>
<xml_diff>
--- a/수복치과재료학실험/수복치과재료학실험_DentalCements_20260922.pptx
+++ b/수복치과재료학실험/수복치과재료학실험_DentalCements_20260922.pptx
@@ -18,9 +18,10 @@
     <p:sldId id="266" r:id="rId12"/>
     <p:sldId id="267" r:id="rId13"/>
     <p:sldId id="268" r:id="rId14"/>
+    <p:sldId id="269" r:id="rId15"/>
   </p:sldIdLst>
   <p:notesMasterIdLst>
-    <p:notesMasterId r:id="rId15"/>
+    <p:notesMasterId r:id="rId16"/>
   </p:notesMasterIdLst>
   <p:sldSz cx="12192000" cy="6858000"/>
   <p:notesSz cx="6858000" cy="12192000"/>
@@ -282,6 +283,72 @@
               <a:effectLst/>
             </c:spPr>
           </c:dPt>
+          <c:errBars>
+            <c:errBarType val="both"/>
+            <c:errValType val="cust"/>
+            <c:noEndCap val="0"/>
+            <c:plus>
+              <c:numLit>
+                <c:formatCode>General</c:formatCode>
+                <c:ptCount val="7"/>
+                <c:pt idx="0">
+                  <c:v>4.02</c:v>
+                </c:pt>
+                <c:pt idx="1">
+                  <c:v>3.85</c:v>
+                </c:pt>
+                <c:pt idx="2">
+                  <c:v>2.73</c:v>
+                </c:pt>
+                <c:pt idx="3">
+                  <c:v>2.17</c:v>
+                </c:pt>
+                <c:pt idx="4">
+                  <c:v>4.04</c:v>
+                </c:pt>
+                <c:pt idx="5">
+                  <c:v>1.58</c:v>
+                </c:pt>
+                <c:pt idx="6">
+                  <c:v>0</c:v>
+                </c:pt>
+              </c:numLit>
+            </c:plus>
+            <c:minus>
+              <c:numLit>
+                <c:formatCode>General</c:formatCode>
+                <c:ptCount val="7"/>
+                <c:pt idx="0">
+                  <c:v>4.02</c:v>
+                </c:pt>
+                <c:pt idx="1">
+                  <c:v>3.85</c:v>
+                </c:pt>
+                <c:pt idx="2">
+                  <c:v>2.73</c:v>
+                </c:pt>
+                <c:pt idx="3">
+                  <c:v>2.17</c:v>
+                </c:pt>
+                <c:pt idx="4">
+                  <c:v>4.04</c:v>
+                </c:pt>
+                <c:pt idx="5">
+                  <c:v>1.58</c:v>
+                </c:pt>
+                <c:pt idx="6">
+                  <c:v>0</c:v>
+                </c:pt>
+              </c:numLit>
+            </c:minus>
+            <c:spPr>
+              <a:ln w="9525">
+                <a:solidFill>
+                  <a:srgbClr val="5B6B7A"/>
+                </a:solidFill>
+              </a:ln>
+            </c:spPr>
+          </c:errBars>
           <c:cat>
             <c:multiLvlStrRef>
               <c:f>Sheet1!$A$2:$A$8</c:f>
@@ -326,22 +393,22 @@
                 <c:formatCode>General</c:formatCode>
                 <c:ptCount val="7"/>
                 <c:pt idx="0">
-                  <c:v>13.13</c:v>
+                  <c:v>13.21</c:v>
                 </c:pt>
                 <c:pt idx="1">
-                  <c:v>11.2</c:v>
+                  <c:v>11.22</c:v>
                 </c:pt>
                 <c:pt idx="2">
-                  <c:v>7.63</c:v>
+                  <c:v>7.67</c:v>
                 </c:pt>
                 <c:pt idx="3">
-                  <c:v>10.08</c:v>
+                  <c:v>10.12</c:v>
                 </c:pt>
                 <c:pt idx="4">
                   <c:v>10.29</c:v>
                 </c:pt>
                 <c:pt idx="5">
-                  <c:v>6.03</c:v>
+                  <c:v>6.08</c:v>
                 </c:pt>
                 <c:pt idx="6">
                   <c:v>6.4</c:v>
@@ -425,6 +492,7 @@
         <c:axId val="2094734552"/>
         <c:scaling>
           <c:orientation val="minMax"/>
+          <c:max val="18"/>
           <c:min val="0"/>
         </c:scaling>
         <c:delete val="0"/>
@@ -637,6 +705,60 @@
               <a:effectLst/>
             </c:spPr>
           </c:dPt>
+          <c:errBars>
+            <c:errBarType val="both"/>
+            <c:errValType val="cust"/>
+            <c:noEndCap val="0"/>
+            <c:plus>
+              <c:numLit>
+                <c:formatCode>General</c:formatCode>
+                <c:ptCount val="5"/>
+                <c:pt idx="0">
+                  <c:v>0.0433</c:v>
+                </c:pt>
+                <c:pt idx="1">
+                  <c:v>0.0531</c:v>
+                </c:pt>
+                <c:pt idx="2">
+                  <c:v>0.0727</c:v>
+                </c:pt>
+                <c:pt idx="3">
+                  <c:v>0.0072</c:v>
+                </c:pt>
+                <c:pt idx="4">
+                  <c:v>0.004</c:v>
+                </c:pt>
+              </c:numLit>
+            </c:plus>
+            <c:minus>
+              <c:numLit>
+                <c:formatCode>General</c:formatCode>
+                <c:ptCount val="5"/>
+                <c:pt idx="0">
+                  <c:v>0.0433</c:v>
+                </c:pt>
+                <c:pt idx="1">
+                  <c:v>0.0531</c:v>
+                </c:pt>
+                <c:pt idx="2">
+                  <c:v>0.0727</c:v>
+                </c:pt>
+                <c:pt idx="3">
+                  <c:v>0.0072</c:v>
+                </c:pt>
+                <c:pt idx="4">
+                  <c:v>0.004</c:v>
+                </c:pt>
+              </c:numLit>
+            </c:minus>
+            <c:spPr>
+              <a:ln w="9525">
+                <a:solidFill>
+                  <a:srgbClr val="5B6B7A"/>
+                </a:solidFill>
+              </a:ln>
+            </c:spPr>
+          </c:errBars>
           <c:cat>
             <c:multiLvlStrRef>
               <c:f>Sheet1!$A$2:$A$6</c:f>
@@ -766,6 +888,7 @@
         <c:axId val="2094734552"/>
         <c:scaling>
           <c:orientation val="minMax"/>
+          <c:max val="0.13"/>
           <c:min val="0"/>
         </c:scaling>
         <c:delete val="0"/>
@@ -1320,7 +1443,7 @@
           <a:p>
             <a:r>
               <a:rPr lang="en-US" dirty="0"/>
-              <a:t>출처: 반 전체 취합 데이터(6개 조, A1~A6). Notion 9.22 수업일지의 '보고서: 전체조 데이터 평균/비교' 지시에 따라 구성. 시간 단위 해석에 가정이 포함되어 있으므로 발표 전 원본 스프레드시트로 재확인 필요.</a:t>
+              <a:t>출처: Results.xlsx(반 전체 취합 데이터, 6개 조 A1~A6, 9/29 최종본). Notion 9.22 수업일지의 '보고서: 전체조 데이터 평균/비교' 지시에 따라 구성. 오차 막대(에러바)는 표준편차 1개 폭.</a:t>
             </a:r>
             <a:endParaRPr lang="en-US" dirty="0"/>
           </a:p>
@@ -1408,7 +1531,7 @@
           <a:p>
             <a:r>
               <a:rPr lang="en-US" dirty="0"/>
-              <a:t>참고 PPT(박수진 외, A반 5조) 고찰 구조를 참고해 재구성 — 다만 수치·조건은 오늘 A반 본인 실측 기준으로 새로 정리한 것.</a:t>
+              <a:t>SD 배수 = (A2 값 − 전체 평균) ÷ 표준편차. 일반적으로 ±1 SD 이내면 정상 범위, 그 밖이면 눈에 띄는 편차로 해석. ZPC 15%↑·GIC 두 조건에서 A2가 유독 느린 이유는 Q&amp;A에서 나올 수 있으니, 혼합 균질도·indentor 판정 시점 등 슬라이드 12(결과 해석)의 오차 요인과 연결지어 답변할 것.</a:t>
             </a:r>
             <a:endParaRPr lang="en-US" dirty="0"/>
           </a:p>
@@ -1496,7 +1619,7 @@
           <a:p>
             <a:r>
               <a:rPr lang="en-US" dirty="0"/>
-              <a:t/>
+              <a:t>참고 PPT(박수진 외, A반 5조) 고찰 구조를 참고해 재구성 — 다만 수치·조건은 오늘 A반 본인 실측 기준으로 새로 정리한 것.</a:t>
             </a:r>
             <a:endParaRPr lang="en-US" dirty="0"/>
           </a:p>
@@ -1608,6 +1731,94 @@
             <a:fld id="{F7021451-1387-4CA6-816F-3879F97B5CBC}" type="slidenum">
               <a:rPr lang="en-US"/>
               <a:t>13</a:t>
+            </a:fld>
+            <a:endParaRPr lang="en-US"/>
+          </a:p>
+        </p:txBody>
+      </p:sp>
+    </p:spTree>
+    <p:extLst>
+      <p:ext uri="{BB962C8B-B14F-4D97-AF65-F5344CB8AC3E}">
+        <p14:creationId xmlns:p14="http://schemas.microsoft.com/office/powerpoint/2010/main" val="1024086991"/>
+      </p:ext>
+    </p:extLst>
+  </p:cSld>
+  <p:clrMapOvr>
+    <a:masterClrMapping/>
+  </p:clrMapOvr>
+</p:notes>
+</file>
+
+<file path=ppt/notesSlides/notesSlide14.xml><?xml version="1.0" encoding="utf-8"?>
+<p:notes xmlns:a="http://schemas.openxmlformats.org/drawingml/2006/main" xmlns:r="http://schemas.openxmlformats.org/officeDocument/2006/relationships" xmlns:p="http://schemas.openxmlformats.org/presentationml/2006/main">
+  <p:cSld>
+    <p:spTree>
+      <p:nvGrpSpPr>
+        <p:cNvPr id="1" name=""/>
+        <p:cNvGrpSpPr/>
+        <p:nvPr/>
+      </p:nvGrpSpPr>
+      <p:grpSpPr>
+        <a:xfrm>
+          <a:off x="0" y="0"/>
+          <a:ext cx="0" cy="0"/>
+          <a:chOff x="0" y="0"/>
+          <a:chExt cx="0" cy="0"/>
+        </a:xfrm>
+      </p:grpSpPr>
+      <p:sp>
+        <p:nvSpPr>
+          <p:cNvPr id="2" name="Slide Image Placeholder 1"/>
+          <p:cNvSpPr>
+            <a:spLocks noGrp="1" noRot="1" noChangeAspect="1"/>
+          </p:cNvSpPr>
+          <p:nvPr>
+            <p:ph type="sldImg"/>
+          </p:nvPr>
+        </p:nvSpPr>
+        <p:spPr/>
+      </p:sp>
+      <p:sp>
+        <p:nvSpPr>
+          <p:cNvPr id="3" name="Notes Placeholder 2"/>
+          <p:cNvSpPr>
+            <a:spLocks noGrp="1"/>
+          </p:cNvSpPr>
+          <p:nvPr>
+            <p:ph type="body" idx="1"/>
+          </p:nvPr>
+        </p:nvSpPr>
+        <p:spPr/>
+        <p:txBody>
+          <a:bodyPr/>
+          <a:lstStyle/>
+          <a:p>
+            <a:r>
+              <a:rPr lang="en-US" dirty="0"/>
+              <a:t/>
+            </a:r>
+            <a:endParaRPr lang="en-US" dirty="0"/>
+          </a:p>
+        </p:txBody>
+      </p:sp>
+      <p:sp>
+        <p:nvSpPr>
+          <p:cNvPr id="4" name="Slide Number Placeholder 3"/>
+          <p:cNvSpPr>
+            <a:spLocks noGrp="1"/>
+          </p:cNvSpPr>
+          <p:nvPr>
+            <p:ph type="sldNum" sz="quarter" idx="10"/>
+          </p:nvPr>
+        </p:nvSpPr>
+        <p:spPr/>
+        <p:txBody>
+          <a:bodyPr/>
+          <a:lstStyle/>
+          <a:p>
+            <a:fld id="{F7021451-1387-4CA6-816F-3879F97B5CBC}" type="slidenum">
+              <a:rPr lang="en-US"/>
+              <a:t>14</a:t>
             </a:fld>
             <a:endParaRPr lang="en-US"/>
           </a:p>
@@ -3157,7 +3368,7 @@
                 <a:ea typeface="맑은 고딕" pitchFamily="34" charset="-122"/>
                 <a:cs typeface="맑은 고딕" pitchFamily="34" charset="-120"/>
               </a:rPr>
-              <a:t>ZPC 15%↓: 13:08   ·   ZPC 정상: 11:12   ·   ZPC 15%↑: 7:38   ·   ZPC 15%↑+냉각판: 10:05   ·   PC 정상: 10:17   ·   GIC 정상: 6:02   ·   RMGI: 6:24*   (* RMGI는 취합 표에 setting time 항목 자체가 없어 A2조 단독 값)</a:t>
+              <a:t>ZPC 15%↓: 13:13   ·   ZPC 정상: 11:13   ·   ZPC 15%↑: 7:40   ·   ZPC 15%↑+냉각판: 10:07   ·   PC 정상: 10:17   ·   GIC 정상: 6:05   ·   RMGI: 6:24*   (* RMGI는 취합 표에 setting time 항목 자체가 없어 A2조 단독 값)</a:t>
             </a:r>
             <a:endParaRPr lang="en-US" sz="850" dirty="0"/>
           </a:p>
@@ -3244,7 +3455,7 @@
                 <a:ea typeface="맑은 고딕" pitchFamily="34" charset="-122"/>
                 <a:cs typeface="맑은 고딕" pitchFamily="34" charset="-120"/>
               </a:rPr>
-              <a:t>※ 9/28 A1~A6 전체 취합 raw data 기준 재계산(본인 조 A2는 원 노트 mm:ss 표기, 나머지 조는 소수점 표기 — 자릿수가 60을 넘는 사례를 근거로 "분 단위 소수"로 환산, 콜론(:)으로 명확히 표기된 값은 그대로 사용). ⚠️ ZPC 15%↓·정상·15%↑ 세 조건 모두 한 조(A3)의 Film thickness 값이 다른 조 대비 3~10배 높게 나와(0.117/0.153/0.196) 평균을 끌어올림 — 같은 조의 냉각판 조건 값은 정상 범위인 점을 볼 때 측정·단위 오류 가능성 있음, 발표 전 해당 조에 재확인 권장. RMGI Setting time은 취합 표 자체에 항목이 없어 A2조 단독 값(6:24)만 반영.</a:t>
+              <a:t>※ Results.xlsx(9/29, A1~A6 6개조 원자료) 기준 재계산 — 오차 막대는 표준편차(SD) 1개. 막대가 길수록 조별 편차가 크다는 뜻. ZPC 15%↓·정상·15%↑ 세 조건의 Film thickness SD가 특히 큰 것은 한 조(A3)의 값이 다른 조 대비 3~10배 높게 나온 영향(0.117/0.153/0.196) — 같은 조의 냉각판 조건 값은 정상 범위라 측정·단위 오류 가능성 있음, 발표 전 해당 조에 재확인 권장. RMGI Setting time은 취합 표 자체에 항목이 없어 A2조 단독 값(6:24)만 반영, 오차 막대 없음.</a:t>
             </a:r>
             <a:endParaRPr lang="en-US" sz="950" dirty="0"/>
           </a:p>
@@ -3300,6 +3511,2235 @@
 <file path=ppt/slides/slide11.xml><?xml version="1.0" encoding="utf-8"?>
 <p:sld xmlns:a="http://schemas.openxmlformats.org/drawingml/2006/main" xmlns:r="http://schemas.openxmlformats.org/officeDocument/2006/relationships" xmlns:p="http://schemas.openxmlformats.org/presentationml/2006/main">
   <p:cSld name="Slide 11">
+    <p:bg>
+      <p:bgPr>
+        <a:solidFill>
+          <a:srgbClr val="F5F6F5"/>
+        </a:solidFill>
+      </p:bgPr>
+    </p:bg>
+    <p:spTree>
+      <p:nvGrpSpPr>
+        <p:cNvPr id="1" name=""/>
+        <p:cNvGrpSpPr/>
+        <p:nvPr/>
+      </p:nvGrpSpPr>
+      <p:grpSpPr>
+        <a:xfrm>
+          <a:off x="0" y="0"/>
+          <a:ext cx="0" cy="0"/>
+          <a:chOff x="0" y="0"/>
+          <a:chExt cx="0" cy="0"/>
+        </a:xfrm>
+      </p:grpSpPr>
+      <p:sp>
+        <p:nvSpPr>
+          <p:cNvPr id="2" name="Text 0"/>
+          <p:cNvSpPr txBox="1"/>
+          <p:nvPr/>
+        </p:nvSpPr>
+        <p:spPr>
+          <a:xfrm>
+            <a:off x="640080" y="365760"/>
+            <a:ext cx="10908792" cy="292608"/>
+          </a:xfrm>
+          <a:prstGeom prst="rect">
+            <a:avLst/>
+          </a:prstGeom>
+          <a:noFill/>
+          <a:ln/>
+        </p:spPr>
+        <p:txBody>
+          <a:bodyPr wrap="square" lIns="0" tIns="0" rIns="0" bIns="0" rtlCol="0" anchor="ctr"/>
+          <a:lstStyle/>
+          <a:p>
+            <a:pPr indent="0" marL="0">
+              <a:buNone/>
+            </a:pPr>
+            <a:r>
+              <a:rPr lang="en-US" sz="1200" b="1" spc="100" kern="0" dirty="0">
+                <a:solidFill>
+                  <a:srgbClr val="F2704A"/>
+                </a:solidFill>
+                <a:latin typeface="맑은 고딕" pitchFamily="34" charset="0"/>
+                <a:ea typeface="맑은 고딕" pitchFamily="34" charset="-122"/>
+                <a:cs typeface="맑은 고딕" pitchFamily="34" charset="-120"/>
+              </a:rPr>
+              <a:t>실험 결과 · 03</a:t>
+            </a:r>
+            <a:endParaRPr lang="en-US" sz="1200" dirty="0"/>
+          </a:p>
+        </p:txBody>
+      </p:sp>
+      <p:sp>
+        <p:nvSpPr>
+          <p:cNvPr id="3" name="Text 1"/>
+          <p:cNvSpPr txBox="1"/>
+          <p:nvPr/>
+        </p:nvSpPr>
+        <p:spPr>
+          <a:xfrm>
+            <a:off x="640080" y="640080"/>
+            <a:ext cx="10908792" cy="548640"/>
+          </a:xfrm>
+          <a:prstGeom prst="rect">
+            <a:avLst/>
+          </a:prstGeom>
+          <a:noFill/>
+          <a:ln/>
+        </p:spPr>
+        <p:txBody>
+          <a:bodyPr wrap="square" lIns="0" tIns="0" rIns="0" bIns="0" rtlCol="0" anchor="ctr"/>
+          <a:lstStyle/>
+          <a:p>
+            <a:pPr indent="0" marL="0">
+              <a:buNone/>
+            </a:pPr>
+            <a:r>
+              <a:rPr lang="en-US" sz="2400" b="1" dirty="0">
+                <a:solidFill>
+                  <a:srgbClr val="114B3F"/>
+                </a:solidFill>
+                <a:latin typeface="맑은 고딕" pitchFamily="34" charset="0"/>
+                <a:ea typeface="맑은 고딕" pitchFamily="34" charset="-122"/>
+                <a:cs typeface="맑은 고딕" pitchFamily="34" charset="-120"/>
+              </a:rPr>
+              <a:t>조별 경향성 &amp; 우리 조(A2) 위치</a:t>
+            </a:r>
+            <a:endParaRPr lang="en-US" sz="2400" dirty="0"/>
+          </a:p>
+        </p:txBody>
+      </p:sp>
+      <p:sp>
+        <p:nvSpPr>
+          <p:cNvPr id="4" name="Text 2"/>
+          <p:cNvSpPr txBox="1"/>
+          <p:nvPr/>
+        </p:nvSpPr>
+        <p:spPr>
+          <a:xfrm>
+            <a:off x="640080" y="1463040"/>
+            <a:ext cx="10908792" cy="347472"/>
+          </a:xfrm>
+          <a:prstGeom prst="rect">
+            <a:avLst/>
+          </a:prstGeom>
+          <a:noFill/>
+          <a:ln/>
+        </p:spPr>
+        <p:txBody>
+          <a:bodyPr wrap="square" lIns="0" tIns="0" rIns="0" bIns="0" rtlCol="0" anchor="ctr"/>
+          <a:lstStyle/>
+          <a:p>
+            <a:pPr indent="0" marL="0">
+              <a:buNone/>
+            </a:pPr>
+            <a:r>
+              <a:rPr lang="en-US" sz="1450" b="1" dirty="0">
+                <a:solidFill>
+                  <a:srgbClr val="114B3F"/>
+                </a:solidFill>
+                <a:latin typeface="맑은 고딕" pitchFamily="34" charset="0"/>
+                <a:ea typeface="맑은 고딕" pitchFamily="34" charset="-122"/>
+                <a:cs typeface="맑은 고딕" pitchFamily="34" charset="-120"/>
+              </a:rPr>
+              <a:t>전체 조 경향성 (Setting time, 6개 조 평균)</a:t>
+            </a:r>
+            <a:endParaRPr lang="en-US" sz="1450" dirty="0"/>
+          </a:p>
+        </p:txBody>
+      </p:sp>
+      <p:sp>
+        <p:nvSpPr>
+          <p:cNvPr id="5" name="Text 3"/>
+          <p:cNvSpPr txBox="1"/>
+          <p:nvPr/>
+        </p:nvSpPr>
+        <p:spPr>
+          <a:xfrm>
+            <a:off x="640080" y="1810512"/>
+            <a:ext cx="10908792" cy="1143000"/>
+          </a:xfrm>
+          <a:prstGeom prst="rect">
+            <a:avLst/>
+          </a:prstGeom>
+          <a:noFill/>
+          <a:ln/>
+        </p:spPr>
+        <p:txBody>
+          <a:bodyPr wrap="square" lIns="0" tIns="0" rIns="0" bIns="0" rtlCol="0" anchor="t"/>
+          <a:lstStyle/>
+          <a:p>
+            <a:pPr indent="0" marL="0">
+              <a:lnSpc>
+                <a:spcPct val="140000"/>
+              </a:lnSpc>
+              <a:buNone/>
+            </a:pPr>
+            <a:r>
+              <a:rPr lang="en-US" sz="1250" dirty="0">
+                <a:solidFill>
+                  <a:srgbClr val="1C2321"/>
+                </a:solidFill>
+                <a:latin typeface="맑은 고딕" pitchFamily="34" charset="0"/>
+                <a:ea typeface="맑은 고딕" pitchFamily="34" charset="-122"/>
+                <a:cs typeface="맑은 고딕" pitchFamily="34" charset="-120"/>
+              </a:rPr>
+              <a:t>•  분액비(P/L ratio)가 높을수록(15%↑) 평균 7:40으로 가장 빠르고, 낮을수록(15%↓) 13:13으로 가장 느림 — high &lt; normal &lt; low 순으로 느려질 것이라는 이론적 예측이 반 전체 데이터에서도 일관되게 확인됨</a:t>
+            </a:r>
+            <a:endParaRPr lang="en-US" sz="1250" dirty="0"/>
+          </a:p>
+          <a:p>
+            <a:pPr indent="0" marL="0">
+              <a:lnSpc>
+                <a:spcPct val="140000"/>
+              </a:lnSpc>
+              <a:buNone/>
+            </a:pPr>
+            <a:r>
+              <a:rPr lang="en-US" sz="1250" dirty="0">
+                <a:solidFill>
+                  <a:srgbClr val="1C2321"/>
+                </a:solidFill>
+                <a:latin typeface="맑은 고딕" pitchFamily="34" charset="0"/>
+                <a:ea typeface="맑은 고딕" pitchFamily="34" charset="-122"/>
+                <a:cs typeface="맑은 고딕" pitchFamily="34" charset="-120"/>
+              </a:rPr>
+              <a:t>•  재료 간 경향도 일관됨: GIC(6:05)·RMGI(6:24)가 가장 빠르고, ZPC 계열이 전반적으로 가장 느림 — 재료 자체의 반응 속도 차이가 조건 차이보다 더 크게 작용</a:t>
+            </a:r>
+            <a:endParaRPr lang="en-US" sz="1250" dirty="0"/>
+          </a:p>
+        </p:txBody>
+      </p:sp>
+      <p:sp>
+        <p:nvSpPr>
+          <p:cNvPr id="6" name="Text 4"/>
+          <p:cNvSpPr txBox="1"/>
+          <p:nvPr/>
+        </p:nvSpPr>
+        <p:spPr>
+          <a:xfrm>
+            <a:off x="640080" y="3017520"/>
+            <a:ext cx="10908792" cy="347472"/>
+          </a:xfrm>
+          <a:prstGeom prst="rect">
+            <a:avLst/>
+          </a:prstGeom>
+          <a:noFill/>
+          <a:ln/>
+        </p:spPr>
+        <p:txBody>
+          <a:bodyPr wrap="square" lIns="0" tIns="0" rIns="0" bIns="0" rtlCol="0" anchor="ctr"/>
+          <a:lstStyle/>
+          <a:p>
+            <a:pPr indent="0" marL="0">
+              <a:buNone/>
+            </a:pPr>
+            <a:r>
+              <a:rPr lang="en-US" sz="1450" b="1" dirty="0">
+                <a:solidFill>
+                  <a:srgbClr val="114B3F"/>
+                </a:solidFill>
+                <a:latin typeface="맑은 고딕" pitchFamily="34" charset="0"/>
+                <a:ea typeface="맑은 고딕" pitchFamily="34" charset="-122"/>
+                <a:cs typeface="맑은 고딕" pitchFamily="34" charset="-120"/>
+              </a:rPr>
+              <a:t>우리 조(A2)는 전체 평균 대비 어디에 위치하는가</a:t>
+            </a:r>
+            <a:endParaRPr lang="en-US" sz="1450" dirty="0"/>
+          </a:p>
+        </p:txBody>
+      </p:sp>
+      <p:sp>
+        <p:nvSpPr>
+          <p:cNvPr id="7" name="Text 5"/>
+          <p:cNvSpPr txBox="1"/>
+          <p:nvPr/>
+        </p:nvSpPr>
+        <p:spPr>
+          <a:xfrm>
+            <a:off x="640080" y="3364992"/>
+            <a:ext cx="10908792" cy="1005840"/>
+          </a:xfrm>
+          <a:prstGeom prst="rect">
+            <a:avLst/>
+          </a:prstGeom>
+          <a:noFill/>
+          <a:ln/>
+        </p:spPr>
+        <p:txBody>
+          <a:bodyPr wrap="square" lIns="0" tIns="0" rIns="0" bIns="0" rtlCol="0" anchor="t"/>
+          <a:lstStyle/>
+          <a:p>
+            <a:pPr indent="0" marL="0">
+              <a:lnSpc>
+                <a:spcPct val="140000"/>
+              </a:lnSpc>
+              <a:buNone/>
+            </a:pPr>
+            <a:r>
+              <a:rPr lang="en-US" sz="1250" dirty="0">
+                <a:solidFill>
+                  <a:srgbClr val="1C2321"/>
+                </a:solidFill>
+                <a:latin typeface="맑은 고딕" pitchFamily="34" charset="0"/>
+                <a:ea typeface="맑은 고딕" pitchFamily="34" charset="-122"/>
+                <a:cs typeface="맑은 고딕" pitchFamily="34" charset="-120"/>
+              </a:rPr>
+              <a:t>•  6개 조건 중 5개에서 전체 평균보다 느리게 경화 — 유일하게 PC 정상 조건만 평균과 거의 같음(평균 대비 −0.2 SD)</a:t>
+            </a:r>
+            <a:endParaRPr lang="en-US" sz="1250" dirty="0"/>
+          </a:p>
+          <a:p>
+            <a:pPr indent="0" marL="0">
+              <a:lnSpc>
+                <a:spcPct val="140000"/>
+              </a:lnSpc>
+              <a:buNone/>
+            </a:pPr>
+            <a:r>
+              <a:rPr lang="en-US" sz="1250" dirty="0">
+                <a:solidFill>
+                  <a:srgbClr val="1C2321"/>
+                </a:solidFill>
+                <a:latin typeface="맑은 고딕" pitchFamily="34" charset="0"/>
+                <a:ea typeface="맑은 고딕" pitchFamily="34" charset="-122"/>
+                <a:cs typeface="맑은 고딕" pitchFamily="34" charset="-120"/>
+              </a:rPr>
+              <a:t>•  편차가 가장 큰 조건은 ZPC 15%↑(+1.9 SD)와 GIC(+1.7 SD) — 우리 조가 indentor 판정 기준을 다른 조보다 보수적으로(늦게 경화로 판단) 적용했거나, 혼합 속도가 상대적으로 느렸을 가능성을 시사</a:t>
+            </a:r>
+            <a:endParaRPr lang="en-US" sz="1250" dirty="0"/>
+          </a:p>
+        </p:txBody>
+      </p:sp>
+      <p:graphicFrame>
+        <p:nvGraphicFramePr>
+          <p:cNvPr id="12" name="Table 0"/>
+          <p:cNvGraphicFramePr>
+            <a:graphicFrameLocks noGrp="1"/>
+          </p:cNvGraphicFramePr>
+          <p:nvPr>
+            <p:extLst>
+              <p:ext uri="{D42A27DB-BD31-4B8C-83A1-F6EECF244321}">
+                <p14:modId xmlns:p14="http://schemas.microsoft.com/office/powerpoint/2010/main" val="1579011935"/>
+              </p:ext>
+            </p:extLst>
+          </p:nvPr>
+        </p:nvGraphicFramePr>
+        <p:xfrm>
+          <a:off x="640080" y="4526280"/>
+          <a:ext cx="10908792" cy="1828800"/>
+        </p:xfrm>
+        <a:graphic>
+          <a:graphicData uri="http://schemas.openxmlformats.org/drawingml/2006/table">
+            <a:tbl>
+              <a:tblPr/>
+              <a:tblGrid>
+                <a:gridCol w="3200400"/>
+                <a:gridCol w="2569464"/>
+                <a:gridCol w="2569464"/>
+                <a:gridCol w="2569464"/>
+              </a:tblGrid>
+              <a:tr h="292608">
+                <a:tc>
+                  <a:txBody>
+                    <a:bodyPr/>
+                    <a:lstStyle/>
+                    <a:p>
+                      <a:pPr algn="ctr" indent="0" marL="0">
+                        <a:buNone/>
+                      </a:pPr>
+                      <a:r>
+                        <a:rPr lang="en-US" sz="1100" b="1" dirty="0">
+                          <a:solidFill>
+                            <a:srgbClr val="FFFFFF"/>
+                          </a:solidFill>
+                          <a:latin typeface="맑은 고딕" pitchFamily="34" charset="0"/>
+                          <a:ea typeface="맑은 고딕" pitchFamily="34" charset="-122"/>
+                          <a:cs typeface="맑은 고딕" pitchFamily="34" charset="-120"/>
+                        </a:rPr>
+                        <a:t>조건</a:t>
+                      </a:r>
+                      <a:endParaRPr lang="en-US" sz="1100" dirty="0">
+                        <a:latin typeface="맑은 고딕" charset="0"/>
+                        <a:ea typeface="맑은 고딕" charset="0"/>
+                        <a:cs typeface="맑은 고딕" charset="0"/>
+                      </a:endParaRPr>
+                    </a:p>
+                  </a:txBody>
+                  <a:tcPr marL="82296" marR="82296" marT="54864" marB="54864" anchor="ctr">
+                    <a:lnL w="6350" cap="flat" cmpd="sng" algn="ctr">
+                      <a:solidFill>
+                        <a:srgbClr val="E4DED2"/>
+                      </a:solidFill>
+                      <a:prstDash val="solid"/>
+                      <a:round/>
+                      <a:headEnd type="none" w="med" len="med"/>
+                      <a:tailEnd type="none" w="med" len="med"/>
+                    </a:lnL>
+                    <a:lnR w="6350" cap="flat" cmpd="sng" algn="ctr">
+                      <a:solidFill>
+                        <a:srgbClr val="E4DED2"/>
+                      </a:solidFill>
+                      <a:prstDash val="solid"/>
+                      <a:round/>
+                      <a:headEnd type="none" w="med" len="med"/>
+                      <a:tailEnd type="none" w="med" len="med"/>
+                    </a:lnR>
+                    <a:lnT w="6350" cap="flat" cmpd="sng" algn="ctr">
+                      <a:solidFill>
+                        <a:srgbClr val="E4DED2"/>
+                      </a:solidFill>
+                      <a:prstDash val="solid"/>
+                      <a:round/>
+                      <a:headEnd type="none" w="med" len="med"/>
+                      <a:tailEnd type="none" w="med" len="med"/>
+                    </a:lnT>
+                    <a:lnB w="6350" cap="flat" cmpd="sng" algn="ctr">
+                      <a:solidFill>
+                        <a:srgbClr val="E4DED2"/>
+                      </a:solidFill>
+                      <a:prstDash val="solid"/>
+                      <a:round/>
+                      <a:headEnd type="none" w="med" len="med"/>
+                      <a:tailEnd type="none" w="med" len="med"/>
+                    </a:lnB>
+                    <a:solidFill>
+                      <a:srgbClr val="114B3F"/>
+                    </a:solidFill>
+                  </a:tcPr>
+                </a:tc>
+                <a:tc>
+                  <a:txBody>
+                    <a:bodyPr/>
+                    <a:lstStyle/>
+                    <a:p>
+                      <a:pPr algn="ctr" indent="0" marL="0">
+                        <a:buNone/>
+                      </a:pPr>
+                      <a:r>
+                        <a:rPr lang="en-US" sz="1100" b="1" dirty="0">
+                          <a:solidFill>
+                            <a:srgbClr val="FFFFFF"/>
+                          </a:solidFill>
+                          <a:latin typeface="맑은 고딕" pitchFamily="34" charset="0"/>
+                          <a:ea typeface="맑은 고딕" pitchFamily="34" charset="-122"/>
+                          <a:cs typeface="맑은 고딕" pitchFamily="34" charset="-120"/>
+                        </a:rPr>
+                        <a:t>전체 평균</a:t>
+                      </a:r>
+                      <a:endParaRPr lang="en-US" sz="1100" dirty="0">
+                        <a:latin typeface="맑은 고딕" charset="0"/>
+                        <a:ea typeface="맑은 고딕" charset="0"/>
+                        <a:cs typeface="맑은 고딕" charset="0"/>
+                      </a:endParaRPr>
+                    </a:p>
+                  </a:txBody>
+                  <a:tcPr marL="82296" marR="82296" marT="54864" marB="54864" anchor="ctr">
+                    <a:lnL w="6350" cap="flat" cmpd="sng" algn="ctr">
+                      <a:solidFill>
+                        <a:srgbClr val="E4DED2"/>
+                      </a:solidFill>
+                      <a:prstDash val="solid"/>
+                      <a:round/>
+                      <a:headEnd type="none" w="med" len="med"/>
+                      <a:tailEnd type="none" w="med" len="med"/>
+                    </a:lnL>
+                    <a:lnR w="6350" cap="flat" cmpd="sng" algn="ctr">
+                      <a:solidFill>
+                        <a:srgbClr val="E4DED2"/>
+                      </a:solidFill>
+                      <a:prstDash val="solid"/>
+                      <a:round/>
+                      <a:headEnd type="none" w="med" len="med"/>
+                      <a:tailEnd type="none" w="med" len="med"/>
+                    </a:lnR>
+                    <a:lnT w="6350" cap="flat" cmpd="sng" algn="ctr">
+                      <a:solidFill>
+                        <a:srgbClr val="E4DED2"/>
+                      </a:solidFill>
+                      <a:prstDash val="solid"/>
+                      <a:round/>
+                      <a:headEnd type="none" w="med" len="med"/>
+                      <a:tailEnd type="none" w="med" len="med"/>
+                    </a:lnT>
+                    <a:lnB w="6350" cap="flat" cmpd="sng" algn="ctr">
+                      <a:solidFill>
+                        <a:srgbClr val="E4DED2"/>
+                      </a:solidFill>
+                      <a:prstDash val="solid"/>
+                      <a:round/>
+                      <a:headEnd type="none" w="med" len="med"/>
+                      <a:tailEnd type="none" w="med" len="med"/>
+                    </a:lnB>
+                    <a:solidFill>
+                      <a:srgbClr val="114B3F"/>
+                    </a:solidFill>
+                  </a:tcPr>
+                </a:tc>
+                <a:tc>
+                  <a:txBody>
+                    <a:bodyPr/>
+                    <a:lstStyle/>
+                    <a:p>
+                      <a:pPr algn="ctr" indent="0" marL="0">
+                        <a:buNone/>
+                      </a:pPr>
+                      <a:r>
+                        <a:rPr lang="en-US" sz="1100" b="1" dirty="0">
+                          <a:solidFill>
+                            <a:srgbClr val="FFFFFF"/>
+                          </a:solidFill>
+                          <a:latin typeface="맑은 고딕" pitchFamily="34" charset="0"/>
+                          <a:ea typeface="맑은 고딕" pitchFamily="34" charset="-122"/>
+                          <a:cs typeface="맑은 고딕" pitchFamily="34" charset="-120"/>
+                        </a:rPr>
+                        <a:t>우리 조(A2)</a:t>
+                      </a:r>
+                      <a:endParaRPr lang="en-US" sz="1100" dirty="0">
+                        <a:latin typeface="맑은 고딕" charset="0"/>
+                        <a:ea typeface="맑은 고딕" charset="0"/>
+                        <a:cs typeface="맑은 고딕" charset="0"/>
+                      </a:endParaRPr>
+                    </a:p>
+                  </a:txBody>
+                  <a:tcPr marL="82296" marR="82296" marT="54864" marB="54864" anchor="ctr">
+                    <a:lnL w="6350" cap="flat" cmpd="sng" algn="ctr">
+                      <a:solidFill>
+                        <a:srgbClr val="E4DED2"/>
+                      </a:solidFill>
+                      <a:prstDash val="solid"/>
+                      <a:round/>
+                      <a:headEnd type="none" w="med" len="med"/>
+                      <a:tailEnd type="none" w="med" len="med"/>
+                    </a:lnL>
+                    <a:lnR w="6350" cap="flat" cmpd="sng" algn="ctr">
+                      <a:solidFill>
+                        <a:srgbClr val="E4DED2"/>
+                      </a:solidFill>
+                      <a:prstDash val="solid"/>
+                      <a:round/>
+                      <a:headEnd type="none" w="med" len="med"/>
+                      <a:tailEnd type="none" w="med" len="med"/>
+                    </a:lnR>
+                    <a:lnT w="6350" cap="flat" cmpd="sng" algn="ctr">
+                      <a:solidFill>
+                        <a:srgbClr val="E4DED2"/>
+                      </a:solidFill>
+                      <a:prstDash val="solid"/>
+                      <a:round/>
+                      <a:headEnd type="none" w="med" len="med"/>
+                      <a:tailEnd type="none" w="med" len="med"/>
+                    </a:lnT>
+                    <a:lnB w="6350" cap="flat" cmpd="sng" algn="ctr">
+                      <a:solidFill>
+                        <a:srgbClr val="E4DED2"/>
+                      </a:solidFill>
+                      <a:prstDash val="solid"/>
+                      <a:round/>
+                      <a:headEnd type="none" w="med" len="med"/>
+                      <a:tailEnd type="none" w="med" len="med"/>
+                    </a:lnB>
+                    <a:solidFill>
+                      <a:srgbClr val="114B3F"/>
+                    </a:solidFill>
+                  </a:tcPr>
+                </a:tc>
+                <a:tc>
+                  <a:txBody>
+                    <a:bodyPr/>
+                    <a:lstStyle/>
+                    <a:p>
+                      <a:pPr algn="ctr" indent="0" marL="0">
+                        <a:buNone/>
+                      </a:pPr>
+                      <a:r>
+                        <a:rPr lang="en-US" sz="1100" b="1" dirty="0">
+                          <a:solidFill>
+                            <a:srgbClr val="FFFFFF"/>
+                          </a:solidFill>
+                          <a:latin typeface="맑은 고딕" pitchFamily="34" charset="0"/>
+                          <a:ea typeface="맑은 고딕" pitchFamily="34" charset="-122"/>
+                          <a:cs typeface="맑은 고딕" pitchFamily="34" charset="-120"/>
+                        </a:rPr>
+                        <a:t>차이(SD 배수)</a:t>
+                      </a:r>
+                      <a:endParaRPr lang="en-US" sz="1100" dirty="0">
+                        <a:latin typeface="맑은 고딕" charset="0"/>
+                        <a:ea typeface="맑은 고딕" charset="0"/>
+                        <a:cs typeface="맑은 고딕" charset="0"/>
+                      </a:endParaRPr>
+                    </a:p>
+                  </a:txBody>
+                  <a:tcPr marL="82296" marR="82296" marT="54864" marB="54864" anchor="ctr">
+                    <a:lnL w="6350" cap="flat" cmpd="sng" algn="ctr">
+                      <a:solidFill>
+                        <a:srgbClr val="E4DED2"/>
+                      </a:solidFill>
+                      <a:prstDash val="solid"/>
+                      <a:round/>
+                      <a:headEnd type="none" w="med" len="med"/>
+                      <a:tailEnd type="none" w="med" len="med"/>
+                    </a:lnL>
+                    <a:lnR w="6350" cap="flat" cmpd="sng" algn="ctr">
+                      <a:solidFill>
+                        <a:srgbClr val="E4DED2"/>
+                      </a:solidFill>
+                      <a:prstDash val="solid"/>
+                      <a:round/>
+                      <a:headEnd type="none" w="med" len="med"/>
+                      <a:tailEnd type="none" w="med" len="med"/>
+                    </a:lnR>
+                    <a:lnT w="6350" cap="flat" cmpd="sng" algn="ctr">
+                      <a:solidFill>
+                        <a:srgbClr val="E4DED2"/>
+                      </a:solidFill>
+                      <a:prstDash val="solid"/>
+                      <a:round/>
+                      <a:headEnd type="none" w="med" len="med"/>
+                      <a:tailEnd type="none" w="med" len="med"/>
+                    </a:lnT>
+                    <a:lnB w="6350" cap="flat" cmpd="sng" algn="ctr">
+                      <a:solidFill>
+                        <a:srgbClr val="E4DED2"/>
+                      </a:solidFill>
+                      <a:prstDash val="solid"/>
+                      <a:round/>
+                      <a:headEnd type="none" w="med" len="med"/>
+                      <a:tailEnd type="none" w="med" len="med"/>
+                    </a:lnB>
+                    <a:solidFill>
+                      <a:srgbClr val="114B3F"/>
+                    </a:solidFill>
+                  </a:tcPr>
+                </a:tc>
+              </a:tr>
+              <a:tr h="256032">
+                <a:tc>
+                  <a:txBody>
+                    <a:bodyPr/>
+                    <a:lstStyle/>
+                    <a:p>
+                      <a:pPr algn="ctr" indent="0" marL="0">
+                        <a:buNone/>
+                      </a:pPr>
+                      <a:r>
+                        <a:rPr lang="en-US" sz="1100" dirty="0">
+                          <a:solidFill>
+                            <a:srgbClr val="1C2321"/>
+                          </a:solidFill>
+                          <a:latin typeface="맑은 고딕" pitchFamily="34" charset="0"/>
+                          <a:ea typeface="맑은 고딕" pitchFamily="34" charset="-122"/>
+                          <a:cs typeface="맑은 고딕" pitchFamily="34" charset="-120"/>
+                        </a:rPr>
+                        <a:t>ZPC 15%↓</a:t>
+                      </a:r>
+                      <a:endParaRPr lang="en-US" sz="1100" dirty="0">
+                        <a:latin typeface="맑은 고딕" charset="0"/>
+                        <a:ea typeface="맑은 고딕" charset="0"/>
+                        <a:cs typeface="맑은 고딕" charset="0"/>
+                      </a:endParaRPr>
+                    </a:p>
+                  </a:txBody>
+                  <a:tcPr marL="82296" marR="82296" marT="54864" marB="54864" anchor="ctr">
+                    <a:lnL w="6350" cap="flat" cmpd="sng" algn="ctr">
+                      <a:solidFill>
+                        <a:srgbClr val="E4DED2"/>
+                      </a:solidFill>
+                      <a:prstDash val="solid"/>
+                      <a:round/>
+                      <a:headEnd type="none" w="med" len="med"/>
+                      <a:tailEnd type="none" w="med" len="med"/>
+                    </a:lnL>
+                    <a:lnR w="6350" cap="flat" cmpd="sng" algn="ctr">
+                      <a:solidFill>
+                        <a:srgbClr val="E4DED2"/>
+                      </a:solidFill>
+                      <a:prstDash val="solid"/>
+                      <a:round/>
+                      <a:headEnd type="none" w="med" len="med"/>
+                      <a:tailEnd type="none" w="med" len="med"/>
+                    </a:lnR>
+                    <a:lnT w="6350" cap="flat" cmpd="sng" algn="ctr">
+                      <a:solidFill>
+                        <a:srgbClr val="E4DED2"/>
+                      </a:solidFill>
+                      <a:prstDash val="solid"/>
+                      <a:round/>
+                      <a:headEnd type="none" w="med" len="med"/>
+                      <a:tailEnd type="none" w="med" len="med"/>
+                    </a:lnT>
+                    <a:lnB w="6350" cap="flat" cmpd="sng" algn="ctr">
+                      <a:solidFill>
+                        <a:srgbClr val="E4DED2"/>
+                      </a:solidFill>
+                      <a:prstDash val="solid"/>
+                      <a:round/>
+                      <a:headEnd type="none" w="med" len="med"/>
+                      <a:tailEnd type="none" w="med" len="med"/>
+                    </a:lnB>
+                  </a:tcPr>
+                </a:tc>
+                <a:tc>
+                  <a:txBody>
+                    <a:bodyPr/>
+                    <a:lstStyle/>
+                    <a:p>
+                      <a:pPr algn="ctr" indent="0" marL="0">
+                        <a:buNone/>
+                      </a:pPr>
+                      <a:r>
+                        <a:rPr lang="en-US" sz="1100" dirty="0">
+                          <a:solidFill>
+                            <a:srgbClr val="1C2321"/>
+                          </a:solidFill>
+                          <a:latin typeface="맑은 고딕" pitchFamily="34" charset="0"/>
+                          <a:ea typeface="맑은 고딕" pitchFamily="34" charset="-122"/>
+                          <a:cs typeface="맑은 고딕" pitchFamily="34" charset="-120"/>
+                        </a:rPr>
+                        <a:t>13:13</a:t>
+                      </a:r>
+                      <a:endParaRPr lang="en-US" sz="1100" dirty="0">
+                        <a:latin typeface="맑은 고딕" charset="0"/>
+                        <a:ea typeface="맑은 고딕" charset="0"/>
+                        <a:cs typeface="맑은 고딕" charset="0"/>
+                      </a:endParaRPr>
+                    </a:p>
+                  </a:txBody>
+                  <a:tcPr marL="82296" marR="82296" marT="54864" marB="54864" anchor="ctr">
+                    <a:lnL w="6350" cap="flat" cmpd="sng" algn="ctr">
+                      <a:solidFill>
+                        <a:srgbClr val="E4DED2"/>
+                      </a:solidFill>
+                      <a:prstDash val="solid"/>
+                      <a:round/>
+                      <a:headEnd type="none" w="med" len="med"/>
+                      <a:tailEnd type="none" w="med" len="med"/>
+                    </a:lnL>
+                    <a:lnR w="6350" cap="flat" cmpd="sng" algn="ctr">
+                      <a:solidFill>
+                        <a:srgbClr val="E4DED2"/>
+                      </a:solidFill>
+                      <a:prstDash val="solid"/>
+                      <a:round/>
+                      <a:headEnd type="none" w="med" len="med"/>
+                      <a:tailEnd type="none" w="med" len="med"/>
+                    </a:lnR>
+                    <a:lnT w="6350" cap="flat" cmpd="sng" algn="ctr">
+                      <a:solidFill>
+                        <a:srgbClr val="E4DED2"/>
+                      </a:solidFill>
+                      <a:prstDash val="solid"/>
+                      <a:round/>
+                      <a:headEnd type="none" w="med" len="med"/>
+                      <a:tailEnd type="none" w="med" len="med"/>
+                    </a:lnT>
+                    <a:lnB w="6350" cap="flat" cmpd="sng" algn="ctr">
+                      <a:solidFill>
+                        <a:srgbClr val="E4DED2"/>
+                      </a:solidFill>
+                      <a:prstDash val="solid"/>
+                      <a:round/>
+                      <a:headEnd type="none" w="med" len="med"/>
+                      <a:tailEnd type="none" w="med" len="med"/>
+                    </a:lnB>
+                  </a:tcPr>
+                </a:tc>
+                <a:tc>
+                  <a:txBody>
+                    <a:bodyPr/>
+                    <a:lstStyle/>
+                    <a:p>
+                      <a:pPr algn="ctr" indent="0" marL="0">
+                        <a:buNone/>
+                      </a:pPr>
+                      <a:r>
+                        <a:rPr lang="en-US" sz="1100" dirty="0">
+                          <a:solidFill>
+                            <a:srgbClr val="1C2321"/>
+                          </a:solidFill>
+                          <a:latin typeface="맑은 고딕" pitchFamily="34" charset="0"/>
+                          <a:ea typeface="맑은 고딕" pitchFamily="34" charset="-122"/>
+                          <a:cs typeface="맑은 고딕" pitchFamily="34" charset="-120"/>
+                        </a:rPr>
+                        <a:t>16:46</a:t>
+                      </a:r>
+                      <a:endParaRPr lang="en-US" sz="1100" dirty="0">
+                        <a:latin typeface="맑은 고딕" charset="0"/>
+                        <a:ea typeface="맑은 고딕" charset="0"/>
+                        <a:cs typeface="맑은 고딕" charset="0"/>
+                      </a:endParaRPr>
+                    </a:p>
+                  </a:txBody>
+                  <a:tcPr marL="82296" marR="82296" marT="54864" marB="54864" anchor="ctr">
+                    <a:lnL w="6350" cap="flat" cmpd="sng" algn="ctr">
+                      <a:solidFill>
+                        <a:srgbClr val="E4DED2"/>
+                      </a:solidFill>
+                      <a:prstDash val="solid"/>
+                      <a:round/>
+                      <a:headEnd type="none" w="med" len="med"/>
+                      <a:tailEnd type="none" w="med" len="med"/>
+                    </a:lnL>
+                    <a:lnR w="6350" cap="flat" cmpd="sng" algn="ctr">
+                      <a:solidFill>
+                        <a:srgbClr val="E4DED2"/>
+                      </a:solidFill>
+                      <a:prstDash val="solid"/>
+                      <a:round/>
+                      <a:headEnd type="none" w="med" len="med"/>
+                      <a:tailEnd type="none" w="med" len="med"/>
+                    </a:lnR>
+                    <a:lnT w="6350" cap="flat" cmpd="sng" algn="ctr">
+                      <a:solidFill>
+                        <a:srgbClr val="E4DED2"/>
+                      </a:solidFill>
+                      <a:prstDash val="solid"/>
+                      <a:round/>
+                      <a:headEnd type="none" w="med" len="med"/>
+                      <a:tailEnd type="none" w="med" len="med"/>
+                    </a:lnT>
+                    <a:lnB w="6350" cap="flat" cmpd="sng" algn="ctr">
+                      <a:solidFill>
+                        <a:srgbClr val="E4DED2"/>
+                      </a:solidFill>
+                      <a:prstDash val="solid"/>
+                      <a:round/>
+                      <a:headEnd type="none" w="med" len="med"/>
+                      <a:tailEnd type="none" w="med" len="med"/>
+                    </a:lnB>
+                  </a:tcPr>
+                </a:tc>
+                <a:tc>
+                  <a:txBody>
+                    <a:bodyPr/>
+                    <a:lstStyle/>
+                    <a:p>
+                      <a:pPr algn="ctr" indent="0" marL="0">
+                        <a:buNone/>
+                      </a:pPr>
+                      <a:r>
+                        <a:rPr lang="en-US" sz="1100" dirty="0">
+                          <a:solidFill>
+                            <a:srgbClr val="1C2321"/>
+                          </a:solidFill>
+                          <a:latin typeface="맑은 고딕" pitchFamily="34" charset="0"/>
+                          <a:ea typeface="맑은 고딕" pitchFamily="34" charset="-122"/>
+                          <a:cs typeface="맑은 고딕" pitchFamily="34" charset="-120"/>
+                        </a:rPr>
+                        <a:t>+0.9 SD</a:t>
+                      </a:r>
+                      <a:endParaRPr lang="en-US" sz="1100" dirty="0">
+                        <a:latin typeface="맑은 고딕" charset="0"/>
+                        <a:ea typeface="맑은 고딕" charset="0"/>
+                        <a:cs typeface="맑은 고딕" charset="0"/>
+                      </a:endParaRPr>
+                    </a:p>
+                  </a:txBody>
+                  <a:tcPr marL="82296" marR="82296" marT="54864" marB="54864" anchor="ctr">
+                    <a:lnL w="6350" cap="flat" cmpd="sng" algn="ctr">
+                      <a:solidFill>
+                        <a:srgbClr val="E4DED2"/>
+                      </a:solidFill>
+                      <a:prstDash val="solid"/>
+                      <a:round/>
+                      <a:headEnd type="none" w="med" len="med"/>
+                      <a:tailEnd type="none" w="med" len="med"/>
+                    </a:lnL>
+                    <a:lnR w="6350" cap="flat" cmpd="sng" algn="ctr">
+                      <a:solidFill>
+                        <a:srgbClr val="E4DED2"/>
+                      </a:solidFill>
+                      <a:prstDash val="solid"/>
+                      <a:round/>
+                      <a:headEnd type="none" w="med" len="med"/>
+                      <a:tailEnd type="none" w="med" len="med"/>
+                    </a:lnR>
+                    <a:lnT w="6350" cap="flat" cmpd="sng" algn="ctr">
+                      <a:solidFill>
+                        <a:srgbClr val="E4DED2"/>
+                      </a:solidFill>
+                      <a:prstDash val="solid"/>
+                      <a:round/>
+                      <a:headEnd type="none" w="med" len="med"/>
+                      <a:tailEnd type="none" w="med" len="med"/>
+                    </a:lnT>
+                    <a:lnB w="6350" cap="flat" cmpd="sng" algn="ctr">
+                      <a:solidFill>
+                        <a:srgbClr val="E4DED2"/>
+                      </a:solidFill>
+                      <a:prstDash val="solid"/>
+                      <a:round/>
+                      <a:headEnd type="none" w="med" len="med"/>
+                      <a:tailEnd type="none" w="med" len="med"/>
+                    </a:lnB>
+                  </a:tcPr>
+                </a:tc>
+              </a:tr>
+              <a:tr h="256032">
+                <a:tc>
+                  <a:txBody>
+                    <a:bodyPr/>
+                    <a:lstStyle/>
+                    <a:p>
+                      <a:pPr algn="ctr" indent="0" marL="0">
+                        <a:buNone/>
+                      </a:pPr>
+                      <a:r>
+                        <a:rPr lang="en-US" sz="1100" dirty="0">
+                          <a:solidFill>
+                            <a:srgbClr val="1C2321"/>
+                          </a:solidFill>
+                          <a:latin typeface="맑은 고딕" pitchFamily="34" charset="0"/>
+                          <a:ea typeface="맑은 고딕" pitchFamily="34" charset="-122"/>
+                          <a:cs typeface="맑은 고딕" pitchFamily="34" charset="-120"/>
+                        </a:rPr>
+                        <a:t>ZPC 정상</a:t>
+                      </a:r>
+                      <a:endParaRPr lang="en-US" sz="1100" dirty="0">
+                        <a:latin typeface="맑은 고딕" charset="0"/>
+                        <a:ea typeface="맑은 고딕" charset="0"/>
+                        <a:cs typeface="맑은 고딕" charset="0"/>
+                      </a:endParaRPr>
+                    </a:p>
+                  </a:txBody>
+                  <a:tcPr marL="82296" marR="82296" marT="54864" marB="54864" anchor="ctr">
+                    <a:lnL w="6350" cap="flat" cmpd="sng" algn="ctr">
+                      <a:solidFill>
+                        <a:srgbClr val="E4DED2"/>
+                      </a:solidFill>
+                      <a:prstDash val="solid"/>
+                      <a:round/>
+                      <a:headEnd type="none" w="med" len="med"/>
+                      <a:tailEnd type="none" w="med" len="med"/>
+                    </a:lnL>
+                    <a:lnR w="6350" cap="flat" cmpd="sng" algn="ctr">
+                      <a:solidFill>
+                        <a:srgbClr val="E4DED2"/>
+                      </a:solidFill>
+                      <a:prstDash val="solid"/>
+                      <a:round/>
+                      <a:headEnd type="none" w="med" len="med"/>
+                      <a:tailEnd type="none" w="med" len="med"/>
+                    </a:lnR>
+                    <a:lnT w="6350" cap="flat" cmpd="sng" algn="ctr">
+                      <a:solidFill>
+                        <a:srgbClr val="E4DED2"/>
+                      </a:solidFill>
+                      <a:prstDash val="solid"/>
+                      <a:round/>
+                      <a:headEnd type="none" w="med" len="med"/>
+                      <a:tailEnd type="none" w="med" len="med"/>
+                    </a:lnT>
+                    <a:lnB w="6350" cap="flat" cmpd="sng" algn="ctr">
+                      <a:solidFill>
+                        <a:srgbClr val="E4DED2"/>
+                      </a:solidFill>
+                      <a:prstDash val="solid"/>
+                      <a:round/>
+                      <a:headEnd type="none" w="med" len="med"/>
+                      <a:tailEnd type="none" w="med" len="med"/>
+                    </a:lnB>
+                  </a:tcPr>
+                </a:tc>
+                <a:tc>
+                  <a:txBody>
+                    <a:bodyPr/>
+                    <a:lstStyle/>
+                    <a:p>
+                      <a:pPr algn="ctr" indent="0" marL="0">
+                        <a:buNone/>
+                      </a:pPr>
+                      <a:r>
+                        <a:rPr lang="en-US" sz="1100" dirty="0">
+                          <a:solidFill>
+                            <a:srgbClr val="1C2321"/>
+                          </a:solidFill>
+                          <a:latin typeface="맑은 고딕" pitchFamily="34" charset="0"/>
+                          <a:ea typeface="맑은 고딕" pitchFamily="34" charset="-122"/>
+                          <a:cs typeface="맑은 고딕" pitchFamily="34" charset="-120"/>
+                        </a:rPr>
+                        <a:t>11:13</a:t>
+                      </a:r>
+                      <a:endParaRPr lang="en-US" sz="1100" dirty="0">
+                        <a:latin typeface="맑은 고딕" charset="0"/>
+                        <a:ea typeface="맑은 고딕" charset="0"/>
+                        <a:cs typeface="맑은 고딕" charset="0"/>
+                      </a:endParaRPr>
+                    </a:p>
+                  </a:txBody>
+                  <a:tcPr marL="82296" marR="82296" marT="54864" marB="54864" anchor="ctr">
+                    <a:lnL w="6350" cap="flat" cmpd="sng" algn="ctr">
+                      <a:solidFill>
+                        <a:srgbClr val="E4DED2"/>
+                      </a:solidFill>
+                      <a:prstDash val="solid"/>
+                      <a:round/>
+                      <a:headEnd type="none" w="med" len="med"/>
+                      <a:tailEnd type="none" w="med" len="med"/>
+                    </a:lnL>
+                    <a:lnR w="6350" cap="flat" cmpd="sng" algn="ctr">
+                      <a:solidFill>
+                        <a:srgbClr val="E4DED2"/>
+                      </a:solidFill>
+                      <a:prstDash val="solid"/>
+                      <a:round/>
+                      <a:headEnd type="none" w="med" len="med"/>
+                      <a:tailEnd type="none" w="med" len="med"/>
+                    </a:lnR>
+                    <a:lnT w="6350" cap="flat" cmpd="sng" algn="ctr">
+                      <a:solidFill>
+                        <a:srgbClr val="E4DED2"/>
+                      </a:solidFill>
+                      <a:prstDash val="solid"/>
+                      <a:round/>
+                      <a:headEnd type="none" w="med" len="med"/>
+                      <a:tailEnd type="none" w="med" len="med"/>
+                    </a:lnT>
+                    <a:lnB w="6350" cap="flat" cmpd="sng" algn="ctr">
+                      <a:solidFill>
+                        <a:srgbClr val="E4DED2"/>
+                      </a:solidFill>
+                      <a:prstDash val="solid"/>
+                      <a:round/>
+                      <a:headEnd type="none" w="med" len="med"/>
+                      <a:tailEnd type="none" w="med" len="med"/>
+                    </a:lnB>
+                  </a:tcPr>
+                </a:tc>
+                <a:tc>
+                  <a:txBody>
+                    <a:bodyPr/>
+                    <a:lstStyle/>
+                    <a:p>
+                      <a:pPr algn="ctr" indent="0" marL="0">
+                        <a:buNone/>
+                      </a:pPr>
+                      <a:r>
+                        <a:rPr lang="en-US" sz="1100" dirty="0">
+                          <a:solidFill>
+                            <a:srgbClr val="1C2321"/>
+                          </a:solidFill>
+                          <a:latin typeface="맑은 고딕" pitchFamily="34" charset="0"/>
+                          <a:ea typeface="맑은 고딕" pitchFamily="34" charset="-122"/>
+                          <a:cs typeface="맑은 고딕" pitchFamily="34" charset="-120"/>
+                        </a:rPr>
+                        <a:t>16:20</a:t>
+                      </a:r>
+                      <a:endParaRPr lang="en-US" sz="1100" dirty="0">
+                        <a:latin typeface="맑은 고딕" charset="0"/>
+                        <a:ea typeface="맑은 고딕" charset="0"/>
+                        <a:cs typeface="맑은 고딕" charset="0"/>
+                      </a:endParaRPr>
+                    </a:p>
+                  </a:txBody>
+                  <a:tcPr marL="82296" marR="82296" marT="54864" marB="54864" anchor="ctr">
+                    <a:lnL w="6350" cap="flat" cmpd="sng" algn="ctr">
+                      <a:solidFill>
+                        <a:srgbClr val="E4DED2"/>
+                      </a:solidFill>
+                      <a:prstDash val="solid"/>
+                      <a:round/>
+                      <a:headEnd type="none" w="med" len="med"/>
+                      <a:tailEnd type="none" w="med" len="med"/>
+                    </a:lnL>
+                    <a:lnR w="6350" cap="flat" cmpd="sng" algn="ctr">
+                      <a:solidFill>
+                        <a:srgbClr val="E4DED2"/>
+                      </a:solidFill>
+                      <a:prstDash val="solid"/>
+                      <a:round/>
+                      <a:headEnd type="none" w="med" len="med"/>
+                      <a:tailEnd type="none" w="med" len="med"/>
+                    </a:lnR>
+                    <a:lnT w="6350" cap="flat" cmpd="sng" algn="ctr">
+                      <a:solidFill>
+                        <a:srgbClr val="E4DED2"/>
+                      </a:solidFill>
+                      <a:prstDash val="solid"/>
+                      <a:round/>
+                      <a:headEnd type="none" w="med" len="med"/>
+                      <a:tailEnd type="none" w="med" len="med"/>
+                    </a:lnT>
+                    <a:lnB w="6350" cap="flat" cmpd="sng" algn="ctr">
+                      <a:solidFill>
+                        <a:srgbClr val="E4DED2"/>
+                      </a:solidFill>
+                      <a:prstDash val="solid"/>
+                      <a:round/>
+                      <a:headEnd type="none" w="med" len="med"/>
+                      <a:tailEnd type="none" w="med" len="med"/>
+                    </a:lnB>
+                  </a:tcPr>
+                </a:tc>
+                <a:tc>
+                  <a:txBody>
+                    <a:bodyPr/>
+                    <a:lstStyle/>
+                    <a:p>
+                      <a:pPr algn="ctr" indent="0" marL="0">
+                        <a:buNone/>
+                      </a:pPr>
+                      <a:r>
+                        <a:rPr lang="en-US" sz="1100" dirty="0">
+                          <a:solidFill>
+                            <a:srgbClr val="1C2321"/>
+                          </a:solidFill>
+                          <a:latin typeface="맑은 고딕" pitchFamily="34" charset="0"/>
+                          <a:ea typeface="맑은 고딕" pitchFamily="34" charset="-122"/>
+                          <a:cs typeface="맑은 고딕" pitchFamily="34" charset="-120"/>
+                        </a:rPr>
+                        <a:t>+1.3 SD</a:t>
+                      </a:r>
+                      <a:endParaRPr lang="en-US" sz="1100" dirty="0">
+                        <a:latin typeface="맑은 고딕" charset="0"/>
+                        <a:ea typeface="맑은 고딕" charset="0"/>
+                        <a:cs typeface="맑은 고딕" charset="0"/>
+                      </a:endParaRPr>
+                    </a:p>
+                  </a:txBody>
+                  <a:tcPr marL="82296" marR="82296" marT="54864" marB="54864" anchor="ctr">
+                    <a:lnL w="6350" cap="flat" cmpd="sng" algn="ctr">
+                      <a:solidFill>
+                        <a:srgbClr val="E4DED2"/>
+                      </a:solidFill>
+                      <a:prstDash val="solid"/>
+                      <a:round/>
+                      <a:headEnd type="none" w="med" len="med"/>
+                      <a:tailEnd type="none" w="med" len="med"/>
+                    </a:lnL>
+                    <a:lnR w="6350" cap="flat" cmpd="sng" algn="ctr">
+                      <a:solidFill>
+                        <a:srgbClr val="E4DED2"/>
+                      </a:solidFill>
+                      <a:prstDash val="solid"/>
+                      <a:round/>
+                      <a:headEnd type="none" w="med" len="med"/>
+                      <a:tailEnd type="none" w="med" len="med"/>
+                    </a:lnR>
+                    <a:lnT w="6350" cap="flat" cmpd="sng" algn="ctr">
+                      <a:solidFill>
+                        <a:srgbClr val="E4DED2"/>
+                      </a:solidFill>
+                      <a:prstDash val="solid"/>
+                      <a:round/>
+                      <a:headEnd type="none" w="med" len="med"/>
+                      <a:tailEnd type="none" w="med" len="med"/>
+                    </a:lnT>
+                    <a:lnB w="6350" cap="flat" cmpd="sng" algn="ctr">
+                      <a:solidFill>
+                        <a:srgbClr val="E4DED2"/>
+                      </a:solidFill>
+                      <a:prstDash val="solid"/>
+                      <a:round/>
+                      <a:headEnd type="none" w="med" len="med"/>
+                      <a:tailEnd type="none" w="med" len="med"/>
+                    </a:lnB>
+                  </a:tcPr>
+                </a:tc>
+              </a:tr>
+              <a:tr h="256032">
+                <a:tc>
+                  <a:txBody>
+                    <a:bodyPr/>
+                    <a:lstStyle/>
+                    <a:p>
+                      <a:pPr algn="ctr" indent="0" marL="0">
+                        <a:buNone/>
+                      </a:pPr>
+                      <a:r>
+                        <a:rPr lang="en-US" sz="1100" dirty="0">
+                          <a:solidFill>
+                            <a:srgbClr val="1C2321"/>
+                          </a:solidFill>
+                          <a:latin typeface="맑은 고딕" pitchFamily="34" charset="0"/>
+                          <a:ea typeface="맑은 고딕" pitchFamily="34" charset="-122"/>
+                          <a:cs typeface="맑은 고딕" pitchFamily="34" charset="-120"/>
+                        </a:rPr>
+                        <a:t>ZPC 15%↑</a:t>
+                      </a:r>
+                      <a:endParaRPr lang="en-US" sz="1100" dirty="0">
+                        <a:latin typeface="맑은 고딕" charset="0"/>
+                        <a:ea typeface="맑은 고딕" charset="0"/>
+                        <a:cs typeface="맑은 고딕" charset="0"/>
+                      </a:endParaRPr>
+                    </a:p>
+                  </a:txBody>
+                  <a:tcPr marL="82296" marR="82296" marT="54864" marB="54864" anchor="ctr">
+                    <a:lnL w="6350" cap="flat" cmpd="sng" algn="ctr">
+                      <a:solidFill>
+                        <a:srgbClr val="E4DED2"/>
+                      </a:solidFill>
+                      <a:prstDash val="solid"/>
+                      <a:round/>
+                      <a:headEnd type="none" w="med" len="med"/>
+                      <a:tailEnd type="none" w="med" len="med"/>
+                    </a:lnL>
+                    <a:lnR w="6350" cap="flat" cmpd="sng" algn="ctr">
+                      <a:solidFill>
+                        <a:srgbClr val="E4DED2"/>
+                      </a:solidFill>
+                      <a:prstDash val="solid"/>
+                      <a:round/>
+                      <a:headEnd type="none" w="med" len="med"/>
+                      <a:tailEnd type="none" w="med" len="med"/>
+                    </a:lnR>
+                    <a:lnT w="6350" cap="flat" cmpd="sng" algn="ctr">
+                      <a:solidFill>
+                        <a:srgbClr val="E4DED2"/>
+                      </a:solidFill>
+                      <a:prstDash val="solid"/>
+                      <a:round/>
+                      <a:headEnd type="none" w="med" len="med"/>
+                      <a:tailEnd type="none" w="med" len="med"/>
+                    </a:lnT>
+                    <a:lnB w="6350" cap="flat" cmpd="sng" algn="ctr">
+                      <a:solidFill>
+                        <a:srgbClr val="E4DED2"/>
+                      </a:solidFill>
+                      <a:prstDash val="solid"/>
+                      <a:round/>
+                      <a:headEnd type="none" w="med" len="med"/>
+                      <a:tailEnd type="none" w="med" len="med"/>
+                    </a:lnB>
+                  </a:tcPr>
+                </a:tc>
+                <a:tc>
+                  <a:txBody>
+                    <a:bodyPr/>
+                    <a:lstStyle/>
+                    <a:p>
+                      <a:pPr algn="ctr" indent="0" marL="0">
+                        <a:buNone/>
+                      </a:pPr>
+                      <a:r>
+                        <a:rPr lang="en-US" sz="1100" dirty="0">
+                          <a:solidFill>
+                            <a:srgbClr val="1C2321"/>
+                          </a:solidFill>
+                          <a:latin typeface="맑은 고딕" pitchFamily="34" charset="0"/>
+                          <a:ea typeface="맑은 고딕" pitchFamily="34" charset="-122"/>
+                          <a:cs typeface="맑은 고딕" pitchFamily="34" charset="-120"/>
+                        </a:rPr>
+                        <a:t>7:40</a:t>
+                      </a:r>
+                      <a:endParaRPr lang="en-US" sz="1100" dirty="0">
+                        <a:latin typeface="맑은 고딕" charset="0"/>
+                        <a:ea typeface="맑은 고딕" charset="0"/>
+                        <a:cs typeface="맑은 고딕" charset="0"/>
+                      </a:endParaRPr>
+                    </a:p>
+                  </a:txBody>
+                  <a:tcPr marL="82296" marR="82296" marT="54864" marB="54864" anchor="ctr">
+                    <a:lnL w="6350" cap="flat" cmpd="sng" algn="ctr">
+                      <a:solidFill>
+                        <a:srgbClr val="E4DED2"/>
+                      </a:solidFill>
+                      <a:prstDash val="solid"/>
+                      <a:round/>
+                      <a:headEnd type="none" w="med" len="med"/>
+                      <a:tailEnd type="none" w="med" len="med"/>
+                    </a:lnL>
+                    <a:lnR w="6350" cap="flat" cmpd="sng" algn="ctr">
+                      <a:solidFill>
+                        <a:srgbClr val="E4DED2"/>
+                      </a:solidFill>
+                      <a:prstDash val="solid"/>
+                      <a:round/>
+                      <a:headEnd type="none" w="med" len="med"/>
+                      <a:tailEnd type="none" w="med" len="med"/>
+                    </a:lnR>
+                    <a:lnT w="6350" cap="flat" cmpd="sng" algn="ctr">
+                      <a:solidFill>
+                        <a:srgbClr val="E4DED2"/>
+                      </a:solidFill>
+                      <a:prstDash val="solid"/>
+                      <a:round/>
+                      <a:headEnd type="none" w="med" len="med"/>
+                      <a:tailEnd type="none" w="med" len="med"/>
+                    </a:lnT>
+                    <a:lnB w="6350" cap="flat" cmpd="sng" algn="ctr">
+                      <a:solidFill>
+                        <a:srgbClr val="E4DED2"/>
+                      </a:solidFill>
+                      <a:prstDash val="solid"/>
+                      <a:round/>
+                      <a:headEnd type="none" w="med" len="med"/>
+                      <a:tailEnd type="none" w="med" len="med"/>
+                    </a:lnB>
+                  </a:tcPr>
+                </a:tc>
+                <a:tc>
+                  <a:txBody>
+                    <a:bodyPr/>
+                    <a:lstStyle/>
+                    <a:p>
+                      <a:pPr algn="ctr" indent="0" marL="0">
+                        <a:buNone/>
+                      </a:pPr>
+                      <a:r>
+                        <a:rPr lang="en-US" sz="1100" dirty="0">
+                          <a:solidFill>
+                            <a:srgbClr val="1C2321"/>
+                          </a:solidFill>
+                          <a:latin typeface="맑은 고딕" pitchFamily="34" charset="0"/>
+                          <a:ea typeface="맑은 고딕" pitchFamily="34" charset="-122"/>
+                          <a:cs typeface="맑은 고딕" pitchFamily="34" charset="-120"/>
+                        </a:rPr>
+                        <a:t>12:45</a:t>
+                      </a:r>
+                      <a:endParaRPr lang="en-US" sz="1100" dirty="0">
+                        <a:latin typeface="맑은 고딕" charset="0"/>
+                        <a:ea typeface="맑은 고딕" charset="0"/>
+                        <a:cs typeface="맑은 고딕" charset="0"/>
+                      </a:endParaRPr>
+                    </a:p>
+                  </a:txBody>
+                  <a:tcPr marL="82296" marR="82296" marT="54864" marB="54864" anchor="ctr">
+                    <a:lnL w="6350" cap="flat" cmpd="sng" algn="ctr">
+                      <a:solidFill>
+                        <a:srgbClr val="E4DED2"/>
+                      </a:solidFill>
+                      <a:prstDash val="solid"/>
+                      <a:round/>
+                      <a:headEnd type="none" w="med" len="med"/>
+                      <a:tailEnd type="none" w="med" len="med"/>
+                    </a:lnL>
+                    <a:lnR w="6350" cap="flat" cmpd="sng" algn="ctr">
+                      <a:solidFill>
+                        <a:srgbClr val="E4DED2"/>
+                      </a:solidFill>
+                      <a:prstDash val="solid"/>
+                      <a:round/>
+                      <a:headEnd type="none" w="med" len="med"/>
+                      <a:tailEnd type="none" w="med" len="med"/>
+                    </a:lnR>
+                    <a:lnT w="6350" cap="flat" cmpd="sng" algn="ctr">
+                      <a:solidFill>
+                        <a:srgbClr val="E4DED2"/>
+                      </a:solidFill>
+                      <a:prstDash val="solid"/>
+                      <a:round/>
+                      <a:headEnd type="none" w="med" len="med"/>
+                      <a:tailEnd type="none" w="med" len="med"/>
+                    </a:lnT>
+                    <a:lnB w="6350" cap="flat" cmpd="sng" algn="ctr">
+                      <a:solidFill>
+                        <a:srgbClr val="E4DED2"/>
+                      </a:solidFill>
+                      <a:prstDash val="solid"/>
+                      <a:round/>
+                      <a:headEnd type="none" w="med" len="med"/>
+                      <a:tailEnd type="none" w="med" len="med"/>
+                    </a:lnB>
+                  </a:tcPr>
+                </a:tc>
+                <a:tc>
+                  <a:txBody>
+                    <a:bodyPr/>
+                    <a:lstStyle/>
+                    <a:p>
+                      <a:pPr algn="ctr" indent="0" marL="0">
+                        <a:buNone/>
+                      </a:pPr>
+                      <a:r>
+                        <a:rPr lang="en-US" sz="1100" dirty="0">
+                          <a:solidFill>
+                            <a:srgbClr val="1C2321"/>
+                          </a:solidFill>
+                          <a:latin typeface="맑은 고딕" pitchFamily="34" charset="0"/>
+                          <a:ea typeface="맑은 고딕" pitchFamily="34" charset="-122"/>
+                          <a:cs typeface="맑은 고딕" pitchFamily="34" charset="-120"/>
+                        </a:rPr>
+                        <a:t>+1.9 SD</a:t>
+                      </a:r>
+                      <a:endParaRPr lang="en-US" sz="1100" dirty="0">
+                        <a:latin typeface="맑은 고딕" charset="0"/>
+                        <a:ea typeface="맑은 고딕" charset="0"/>
+                        <a:cs typeface="맑은 고딕" charset="0"/>
+                      </a:endParaRPr>
+                    </a:p>
+                  </a:txBody>
+                  <a:tcPr marL="82296" marR="82296" marT="54864" marB="54864" anchor="ctr">
+                    <a:lnL w="6350" cap="flat" cmpd="sng" algn="ctr">
+                      <a:solidFill>
+                        <a:srgbClr val="E4DED2"/>
+                      </a:solidFill>
+                      <a:prstDash val="solid"/>
+                      <a:round/>
+                      <a:headEnd type="none" w="med" len="med"/>
+                      <a:tailEnd type="none" w="med" len="med"/>
+                    </a:lnL>
+                    <a:lnR w="6350" cap="flat" cmpd="sng" algn="ctr">
+                      <a:solidFill>
+                        <a:srgbClr val="E4DED2"/>
+                      </a:solidFill>
+                      <a:prstDash val="solid"/>
+                      <a:round/>
+                      <a:headEnd type="none" w="med" len="med"/>
+                      <a:tailEnd type="none" w="med" len="med"/>
+                    </a:lnR>
+                    <a:lnT w="6350" cap="flat" cmpd="sng" algn="ctr">
+                      <a:solidFill>
+                        <a:srgbClr val="E4DED2"/>
+                      </a:solidFill>
+                      <a:prstDash val="solid"/>
+                      <a:round/>
+                      <a:headEnd type="none" w="med" len="med"/>
+                      <a:tailEnd type="none" w="med" len="med"/>
+                    </a:lnT>
+                    <a:lnB w="6350" cap="flat" cmpd="sng" algn="ctr">
+                      <a:solidFill>
+                        <a:srgbClr val="E4DED2"/>
+                      </a:solidFill>
+                      <a:prstDash val="solid"/>
+                      <a:round/>
+                      <a:headEnd type="none" w="med" len="med"/>
+                      <a:tailEnd type="none" w="med" len="med"/>
+                    </a:lnB>
+                  </a:tcPr>
+                </a:tc>
+              </a:tr>
+              <a:tr h="256032">
+                <a:tc>
+                  <a:txBody>
+                    <a:bodyPr/>
+                    <a:lstStyle/>
+                    <a:p>
+                      <a:pPr algn="ctr" indent="0" marL="0">
+                        <a:buNone/>
+                      </a:pPr>
+                      <a:r>
+                        <a:rPr lang="en-US" sz="1100" dirty="0">
+                          <a:solidFill>
+                            <a:srgbClr val="1C2321"/>
+                          </a:solidFill>
+                          <a:latin typeface="맑은 고딕" pitchFamily="34" charset="0"/>
+                          <a:ea typeface="맑은 고딕" pitchFamily="34" charset="-122"/>
+                          <a:cs typeface="맑은 고딕" pitchFamily="34" charset="-120"/>
+                        </a:rPr>
+                        <a:t>ZPC 15%↑+냉각판</a:t>
+                      </a:r>
+                      <a:endParaRPr lang="en-US" sz="1100" dirty="0">
+                        <a:latin typeface="맑은 고딕" charset="0"/>
+                        <a:ea typeface="맑은 고딕" charset="0"/>
+                        <a:cs typeface="맑은 고딕" charset="0"/>
+                      </a:endParaRPr>
+                    </a:p>
+                  </a:txBody>
+                  <a:tcPr marL="82296" marR="82296" marT="54864" marB="54864" anchor="ctr">
+                    <a:lnL w="6350" cap="flat" cmpd="sng" algn="ctr">
+                      <a:solidFill>
+                        <a:srgbClr val="E4DED2"/>
+                      </a:solidFill>
+                      <a:prstDash val="solid"/>
+                      <a:round/>
+                      <a:headEnd type="none" w="med" len="med"/>
+                      <a:tailEnd type="none" w="med" len="med"/>
+                    </a:lnL>
+                    <a:lnR w="6350" cap="flat" cmpd="sng" algn="ctr">
+                      <a:solidFill>
+                        <a:srgbClr val="E4DED2"/>
+                      </a:solidFill>
+                      <a:prstDash val="solid"/>
+                      <a:round/>
+                      <a:headEnd type="none" w="med" len="med"/>
+                      <a:tailEnd type="none" w="med" len="med"/>
+                    </a:lnR>
+                    <a:lnT w="6350" cap="flat" cmpd="sng" algn="ctr">
+                      <a:solidFill>
+                        <a:srgbClr val="E4DED2"/>
+                      </a:solidFill>
+                      <a:prstDash val="solid"/>
+                      <a:round/>
+                      <a:headEnd type="none" w="med" len="med"/>
+                      <a:tailEnd type="none" w="med" len="med"/>
+                    </a:lnT>
+                    <a:lnB w="6350" cap="flat" cmpd="sng" algn="ctr">
+                      <a:solidFill>
+                        <a:srgbClr val="E4DED2"/>
+                      </a:solidFill>
+                      <a:prstDash val="solid"/>
+                      <a:round/>
+                      <a:headEnd type="none" w="med" len="med"/>
+                      <a:tailEnd type="none" w="med" len="med"/>
+                    </a:lnB>
+                  </a:tcPr>
+                </a:tc>
+                <a:tc>
+                  <a:txBody>
+                    <a:bodyPr/>
+                    <a:lstStyle/>
+                    <a:p>
+                      <a:pPr algn="ctr" indent="0" marL="0">
+                        <a:buNone/>
+                      </a:pPr>
+                      <a:r>
+                        <a:rPr lang="en-US" sz="1100" dirty="0">
+                          <a:solidFill>
+                            <a:srgbClr val="1C2321"/>
+                          </a:solidFill>
+                          <a:latin typeface="맑은 고딕" pitchFamily="34" charset="0"/>
+                          <a:ea typeface="맑은 고딕" pitchFamily="34" charset="-122"/>
+                          <a:cs typeface="맑은 고딕" pitchFamily="34" charset="-120"/>
+                        </a:rPr>
+                        <a:t>10:07</a:t>
+                      </a:r>
+                      <a:endParaRPr lang="en-US" sz="1100" dirty="0">
+                        <a:latin typeface="맑은 고딕" charset="0"/>
+                        <a:ea typeface="맑은 고딕" charset="0"/>
+                        <a:cs typeface="맑은 고딕" charset="0"/>
+                      </a:endParaRPr>
+                    </a:p>
+                  </a:txBody>
+                  <a:tcPr marL="82296" marR="82296" marT="54864" marB="54864" anchor="ctr">
+                    <a:lnL w="6350" cap="flat" cmpd="sng" algn="ctr">
+                      <a:solidFill>
+                        <a:srgbClr val="E4DED2"/>
+                      </a:solidFill>
+                      <a:prstDash val="solid"/>
+                      <a:round/>
+                      <a:headEnd type="none" w="med" len="med"/>
+                      <a:tailEnd type="none" w="med" len="med"/>
+                    </a:lnL>
+                    <a:lnR w="6350" cap="flat" cmpd="sng" algn="ctr">
+                      <a:solidFill>
+                        <a:srgbClr val="E4DED2"/>
+                      </a:solidFill>
+                      <a:prstDash val="solid"/>
+                      <a:round/>
+                      <a:headEnd type="none" w="med" len="med"/>
+                      <a:tailEnd type="none" w="med" len="med"/>
+                    </a:lnR>
+                    <a:lnT w="6350" cap="flat" cmpd="sng" algn="ctr">
+                      <a:solidFill>
+                        <a:srgbClr val="E4DED2"/>
+                      </a:solidFill>
+                      <a:prstDash val="solid"/>
+                      <a:round/>
+                      <a:headEnd type="none" w="med" len="med"/>
+                      <a:tailEnd type="none" w="med" len="med"/>
+                    </a:lnT>
+                    <a:lnB w="6350" cap="flat" cmpd="sng" algn="ctr">
+                      <a:solidFill>
+                        <a:srgbClr val="E4DED2"/>
+                      </a:solidFill>
+                      <a:prstDash val="solid"/>
+                      <a:round/>
+                      <a:headEnd type="none" w="med" len="med"/>
+                      <a:tailEnd type="none" w="med" len="med"/>
+                    </a:lnB>
+                  </a:tcPr>
+                </a:tc>
+                <a:tc>
+                  <a:txBody>
+                    <a:bodyPr/>
+                    <a:lstStyle/>
+                    <a:p>
+                      <a:pPr algn="ctr" indent="0" marL="0">
+                        <a:buNone/>
+                      </a:pPr>
+                      <a:r>
+                        <a:rPr lang="en-US" sz="1100" dirty="0">
+                          <a:solidFill>
+                            <a:srgbClr val="1C2321"/>
+                          </a:solidFill>
+                          <a:latin typeface="맑은 고딕" pitchFamily="34" charset="0"/>
+                          <a:ea typeface="맑은 고딕" pitchFamily="34" charset="-122"/>
+                          <a:cs typeface="맑은 고딕" pitchFamily="34" charset="-120"/>
+                        </a:rPr>
+                        <a:t>12:03</a:t>
+                      </a:r>
+                      <a:endParaRPr lang="en-US" sz="1100" dirty="0">
+                        <a:latin typeface="맑은 고딕" charset="0"/>
+                        <a:ea typeface="맑은 고딕" charset="0"/>
+                        <a:cs typeface="맑은 고딕" charset="0"/>
+                      </a:endParaRPr>
+                    </a:p>
+                  </a:txBody>
+                  <a:tcPr marL="82296" marR="82296" marT="54864" marB="54864" anchor="ctr">
+                    <a:lnL w="6350" cap="flat" cmpd="sng" algn="ctr">
+                      <a:solidFill>
+                        <a:srgbClr val="E4DED2"/>
+                      </a:solidFill>
+                      <a:prstDash val="solid"/>
+                      <a:round/>
+                      <a:headEnd type="none" w="med" len="med"/>
+                      <a:tailEnd type="none" w="med" len="med"/>
+                    </a:lnL>
+                    <a:lnR w="6350" cap="flat" cmpd="sng" algn="ctr">
+                      <a:solidFill>
+                        <a:srgbClr val="E4DED2"/>
+                      </a:solidFill>
+                      <a:prstDash val="solid"/>
+                      <a:round/>
+                      <a:headEnd type="none" w="med" len="med"/>
+                      <a:tailEnd type="none" w="med" len="med"/>
+                    </a:lnR>
+                    <a:lnT w="6350" cap="flat" cmpd="sng" algn="ctr">
+                      <a:solidFill>
+                        <a:srgbClr val="E4DED2"/>
+                      </a:solidFill>
+                      <a:prstDash val="solid"/>
+                      <a:round/>
+                      <a:headEnd type="none" w="med" len="med"/>
+                      <a:tailEnd type="none" w="med" len="med"/>
+                    </a:lnT>
+                    <a:lnB w="6350" cap="flat" cmpd="sng" algn="ctr">
+                      <a:solidFill>
+                        <a:srgbClr val="E4DED2"/>
+                      </a:solidFill>
+                      <a:prstDash val="solid"/>
+                      <a:round/>
+                      <a:headEnd type="none" w="med" len="med"/>
+                      <a:tailEnd type="none" w="med" len="med"/>
+                    </a:lnB>
+                  </a:tcPr>
+                </a:tc>
+                <a:tc>
+                  <a:txBody>
+                    <a:bodyPr/>
+                    <a:lstStyle/>
+                    <a:p>
+                      <a:pPr algn="ctr" indent="0" marL="0">
+                        <a:buNone/>
+                      </a:pPr>
+                      <a:r>
+                        <a:rPr lang="en-US" sz="1100" dirty="0">
+                          <a:solidFill>
+                            <a:srgbClr val="1C2321"/>
+                          </a:solidFill>
+                          <a:latin typeface="맑은 고딕" pitchFamily="34" charset="0"/>
+                          <a:ea typeface="맑은 고딕" pitchFamily="34" charset="-122"/>
+                          <a:cs typeface="맑은 고딕" pitchFamily="34" charset="-120"/>
+                        </a:rPr>
+                        <a:t>+0.9 SD</a:t>
+                      </a:r>
+                      <a:endParaRPr lang="en-US" sz="1100" dirty="0">
+                        <a:latin typeface="맑은 고딕" charset="0"/>
+                        <a:ea typeface="맑은 고딕" charset="0"/>
+                        <a:cs typeface="맑은 고딕" charset="0"/>
+                      </a:endParaRPr>
+                    </a:p>
+                  </a:txBody>
+                  <a:tcPr marL="82296" marR="82296" marT="54864" marB="54864" anchor="ctr">
+                    <a:lnL w="6350" cap="flat" cmpd="sng" algn="ctr">
+                      <a:solidFill>
+                        <a:srgbClr val="E4DED2"/>
+                      </a:solidFill>
+                      <a:prstDash val="solid"/>
+                      <a:round/>
+                      <a:headEnd type="none" w="med" len="med"/>
+                      <a:tailEnd type="none" w="med" len="med"/>
+                    </a:lnL>
+                    <a:lnR w="6350" cap="flat" cmpd="sng" algn="ctr">
+                      <a:solidFill>
+                        <a:srgbClr val="E4DED2"/>
+                      </a:solidFill>
+                      <a:prstDash val="solid"/>
+                      <a:round/>
+                      <a:headEnd type="none" w="med" len="med"/>
+                      <a:tailEnd type="none" w="med" len="med"/>
+                    </a:lnR>
+                    <a:lnT w="6350" cap="flat" cmpd="sng" algn="ctr">
+                      <a:solidFill>
+                        <a:srgbClr val="E4DED2"/>
+                      </a:solidFill>
+                      <a:prstDash val="solid"/>
+                      <a:round/>
+                      <a:headEnd type="none" w="med" len="med"/>
+                      <a:tailEnd type="none" w="med" len="med"/>
+                    </a:lnT>
+                    <a:lnB w="6350" cap="flat" cmpd="sng" algn="ctr">
+                      <a:solidFill>
+                        <a:srgbClr val="E4DED2"/>
+                      </a:solidFill>
+                      <a:prstDash val="solid"/>
+                      <a:round/>
+                      <a:headEnd type="none" w="med" len="med"/>
+                      <a:tailEnd type="none" w="med" len="med"/>
+                    </a:lnB>
+                  </a:tcPr>
+                </a:tc>
+              </a:tr>
+              <a:tr h="256032">
+                <a:tc>
+                  <a:txBody>
+                    <a:bodyPr/>
+                    <a:lstStyle/>
+                    <a:p>
+                      <a:pPr algn="ctr" indent="0" marL="0">
+                        <a:buNone/>
+                      </a:pPr>
+                      <a:r>
+                        <a:rPr lang="en-US" sz="1100" dirty="0">
+                          <a:solidFill>
+                            <a:srgbClr val="1C2321"/>
+                          </a:solidFill>
+                          <a:latin typeface="맑은 고딕" pitchFamily="34" charset="0"/>
+                          <a:ea typeface="맑은 고딕" pitchFamily="34" charset="-122"/>
+                          <a:cs typeface="맑은 고딕" pitchFamily="34" charset="-120"/>
+                        </a:rPr>
+                        <a:t>PC 정상</a:t>
+                      </a:r>
+                      <a:endParaRPr lang="en-US" sz="1100" dirty="0">
+                        <a:latin typeface="맑은 고딕" charset="0"/>
+                        <a:ea typeface="맑은 고딕" charset="0"/>
+                        <a:cs typeface="맑은 고딕" charset="0"/>
+                      </a:endParaRPr>
+                    </a:p>
+                  </a:txBody>
+                  <a:tcPr marL="82296" marR="82296" marT="54864" marB="54864" anchor="ctr">
+                    <a:lnL w="6350" cap="flat" cmpd="sng" algn="ctr">
+                      <a:solidFill>
+                        <a:srgbClr val="E4DED2"/>
+                      </a:solidFill>
+                      <a:prstDash val="solid"/>
+                      <a:round/>
+                      <a:headEnd type="none" w="med" len="med"/>
+                      <a:tailEnd type="none" w="med" len="med"/>
+                    </a:lnL>
+                    <a:lnR w="6350" cap="flat" cmpd="sng" algn="ctr">
+                      <a:solidFill>
+                        <a:srgbClr val="E4DED2"/>
+                      </a:solidFill>
+                      <a:prstDash val="solid"/>
+                      <a:round/>
+                      <a:headEnd type="none" w="med" len="med"/>
+                      <a:tailEnd type="none" w="med" len="med"/>
+                    </a:lnR>
+                    <a:lnT w="6350" cap="flat" cmpd="sng" algn="ctr">
+                      <a:solidFill>
+                        <a:srgbClr val="E4DED2"/>
+                      </a:solidFill>
+                      <a:prstDash val="solid"/>
+                      <a:round/>
+                      <a:headEnd type="none" w="med" len="med"/>
+                      <a:tailEnd type="none" w="med" len="med"/>
+                    </a:lnT>
+                    <a:lnB w="6350" cap="flat" cmpd="sng" algn="ctr">
+                      <a:solidFill>
+                        <a:srgbClr val="E4DED2"/>
+                      </a:solidFill>
+                      <a:prstDash val="solid"/>
+                      <a:round/>
+                      <a:headEnd type="none" w="med" len="med"/>
+                      <a:tailEnd type="none" w="med" len="med"/>
+                    </a:lnB>
+                  </a:tcPr>
+                </a:tc>
+                <a:tc>
+                  <a:txBody>
+                    <a:bodyPr/>
+                    <a:lstStyle/>
+                    <a:p>
+                      <a:pPr algn="ctr" indent="0" marL="0">
+                        <a:buNone/>
+                      </a:pPr>
+                      <a:r>
+                        <a:rPr lang="en-US" sz="1100" dirty="0">
+                          <a:solidFill>
+                            <a:srgbClr val="1C2321"/>
+                          </a:solidFill>
+                          <a:latin typeface="맑은 고딕" pitchFamily="34" charset="0"/>
+                          <a:ea typeface="맑은 고딕" pitchFamily="34" charset="-122"/>
+                          <a:cs typeface="맑은 고딕" pitchFamily="34" charset="-120"/>
+                        </a:rPr>
+                        <a:t>10:17</a:t>
+                      </a:r>
+                      <a:endParaRPr lang="en-US" sz="1100" dirty="0">
+                        <a:latin typeface="맑은 고딕" charset="0"/>
+                        <a:ea typeface="맑은 고딕" charset="0"/>
+                        <a:cs typeface="맑은 고딕" charset="0"/>
+                      </a:endParaRPr>
+                    </a:p>
+                  </a:txBody>
+                  <a:tcPr marL="82296" marR="82296" marT="54864" marB="54864" anchor="ctr">
+                    <a:lnL w="6350" cap="flat" cmpd="sng" algn="ctr">
+                      <a:solidFill>
+                        <a:srgbClr val="E4DED2"/>
+                      </a:solidFill>
+                      <a:prstDash val="solid"/>
+                      <a:round/>
+                      <a:headEnd type="none" w="med" len="med"/>
+                      <a:tailEnd type="none" w="med" len="med"/>
+                    </a:lnL>
+                    <a:lnR w="6350" cap="flat" cmpd="sng" algn="ctr">
+                      <a:solidFill>
+                        <a:srgbClr val="E4DED2"/>
+                      </a:solidFill>
+                      <a:prstDash val="solid"/>
+                      <a:round/>
+                      <a:headEnd type="none" w="med" len="med"/>
+                      <a:tailEnd type="none" w="med" len="med"/>
+                    </a:lnR>
+                    <a:lnT w="6350" cap="flat" cmpd="sng" algn="ctr">
+                      <a:solidFill>
+                        <a:srgbClr val="E4DED2"/>
+                      </a:solidFill>
+                      <a:prstDash val="solid"/>
+                      <a:round/>
+                      <a:headEnd type="none" w="med" len="med"/>
+                      <a:tailEnd type="none" w="med" len="med"/>
+                    </a:lnT>
+                    <a:lnB w="6350" cap="flat" cmpd="sng" algn="ctr">
+                      <a:solidFill>
+                        <a:srgbClr val="E4DED2"/>
+                      </a:solidFill>
+                      <a:prstDash val="solid"/>
+                      <a:round/>
+                      <a:headEnd type="none" w="med" len="med"/>
+                      <a:tailEnd type="none" w="med" len="med"/>
+                    </a:lnB>
+                  </a:tcPr>
+                </a:tc>
+                <a:tc>
+                  <a:txBody>
+                    <a:bodyPr/>
+                    <a:lstStyle/>
+                    <a:p>
+                      <a:pPr algn="ctr" indent="0" marL="0">
+                        <a:buNone/>
+                      </a:pPr>
+                      <a:r>
+                        <a:rPr lang="en-US" sz="1100" dirty="0">
+                          <a:solidFill>
+                            <a:srgbClr val="1C2321"/>
+                          </a:solidFill>
+                          <a:latin typeface="맑은 고딕" pitchFamily="34" charset="0"/>
+                          <a:ea typeface="맑은 고딕" pitchFamily="34" charset="-122"/>
+                          <a:cs typeface="맑은 고딕" pitchFamily="34" charset="-120"/>
+                        </a:rPr>
+                        <a:t>9:41</a:t>
+                      </a:r>
+                      <a:endParaRPr lang="en-US" sz="1100" dirty="0">
+                        <a:latin typeface="맑은 고딕" charset="0"/>
+                        <a:ea typeface="맑은 고딕" charset="0"/>
+                        <a:cs typeface="맑은 고딕" charset="0"/>
+                      </a:endParaRPr>
+                    </a:p>
+                  </a:txBody>
+                  <a:tcPr marL="82296" marR="82296" marT="54864" marB="54864" anchor="ctr">
+                    <a:lnL w="6350" cap="flat" cmpd="sng" algn="ctr">
+                      <a:solidFill>
+                        <a:srgbClr val="E4DED2"/>
+                      </a:solidFill>
+                      <a:prstDash val="solid"/>
+                      <a:round/>
+                      <a:headEnd type="none" w="med" len="med"/>
+                      <a:tailEnd type="none" w="med" len="med"/>
+                    </a:lnL>
+                    <a:lnR w="6350" cap="flat" cmpd="sng" algn="ctr">
+                      <a:solidFill>
+                        <a:srgbClr val="E4DED2"/>
+                      </a:solidFill>
+                      <a:prstDash val="solid"/>
+                      <a:round/>
+                      <a:headEnd type="none" w="med" len="med"/>
+                      <a:tailEnd type="none" w="med" len="med"/>
+                    </a:lnR>
+                    <a:lnT w="6350" cap="flat" cmpd="sng" algn="ctr">
+                      <a:solidFill>
+                        <a:srgbClr val="E4DED2"/>
+                      </a:solidFill>
+                      <a:prstDash val="solid"/>
+                      <a:round/>
+                      <a:headEnd type="none" w="med" len="med"/>
+                      <a:tailEnd type="none" w="med" len="med"/>
+                    </a:lnT>
+                    <a:lnB w="6350" cap="flat" cmpd="sng" algn="ctr">
+                      <a:solidFill>
+                        <a:srgbClr val="E4DED2"/>
+                      </a:solidFill>
+                      <a:prstDash val="solid"/>
+                      <a:round/>
+                      <a:headEnd type="none" w="med" len="med"/>
+                      <a:tailEnd type="none" w="med" len="med"/>
+                    </a:lnB>
+                  </a:tcPr>
+                </a:tc>
+                <a:tc>
+                  <a:txBody>
+                    <a:bodyPr/>
+                    <a:lstStyle/>
+                    <a:p>
+                      <a:pPr algn="ctr" indent="0" marL="0">
+                        <a:buNone/>
+                      </a:pPr>
+                      <a:r>
+                        <a:rPr lang="en-US" sz="1100" dirty="0">
+                          <a:solidFill>
+                            <a:srgbClr val="1C2321"/>
+                          </a:solidFill>
+                          <a:latin typeface="맑은 고딕" pitchFamily="34" charset="0"/>
+                          <a:ea typeface="맑은 고딕" pitchFamily="34" charset="-122"/>
+                          <a:cs typeface="맑은 고딕" pitchFamily="34" charset="-120"/>
+                        </a:rPr>
+                        <a:t>−0.2 SD</a:t>
+                      </a:r>
+                      <a:endParaRPr lang="en-US" sz="1100" dirty="0">
+                        <a:latin typeface="맑은 고딕" charset="0"/>
+                        <a:ea typeface="맑은 고딕" charset="0"/>
+                        <a:cs typeface="맑은 고딕" charset="0"/>
+                      </a:endParaRPr>
+                    </a:p>
+                  </a:txBody>
+                  <a:tcPr marL="82296" marR="82296" marT="54864" marB="54864" anchor="ctr">
+                    <a:lnL w="6350" cap="flat" cmpd="sng" algn="ctr">
+                      <a:solidFill>
+                        <a:srgbClr val="E4DED2"/>
+                      </a:solidFill>
+                      <a:prstDash val="solid"/>
+                      <a:round/>
+                      <a:headEnd type="none" w="med" len="med"/>
+                      <a:tailEnd type="none" w="med" len="med"/>
+                    </a:lnL>
+                    <a:lnR w="6350" cap="flat" cmpd="sng" algn="ctr">
+                      <a:solidFill>
+                        <a:srgbClr val="E4DED2"/>
+                      </a:solidFill>
+                      <a:prstDash val="solid"/>
+                      <a:round/>
+                      <a:headEnd type="none" w="med" len="med"/>
+                      <a:tailEnd type="none" w="med" len="med"/>
+                    </a:lnR>
+                    <a:lnT w="6350" cap="flat" cmpd="sng" algn="ctr">
+                      <a:solidFill>
+                        <a:srgbClr val="E4DED2"/>
+                      </a:solidFill>
+                      <a:prstDash val="solid"/>
+                      <a:round/>
+                      <a:headEnd type="none" w="med" len="med"/>
+                      <a:tailEnd type="none" w="med" len="med"/>
+                    </a:lnT>
+                    <a:lnB w="6350" cap="flat" cmpd="sng" algn="ctr">
+                      <a:solidFill>
+                        <a:srgbClr val="E4DED2"/>
+                      </a:solidFill>
+                      <a:prstDash val="solid"/>
+                      <a:round/>
+                      <a:headEnd type="none" w="med" len="med"/>
+                      <a:tailEnd type="none" w="med" len="med"/>
+                    </a:lnB>
+                  </a:tcPr>
+                </a:tc>
+              </a:tr>
+              <a:tr h="256032">
+                <a:tc>
+                  <a:txBody>
+                    <a:bodyPr/>
+                    <a:lstStyle/>
+                    <a:p>
+                      <a:pPr algn="ctr" indent="0" marL="0">
+                        <a:buNone/>
+                      </a:pPr>
+                      <a:r>
+                        <a:rPr lang="en-US" sz="1100" dirty="0">
+                          <a:solidFill>
+                            <a:srgbClr val="1C2321"/>
+                          </a:solidFill>
+                          <a:latin typeface="맑은 고딕" pitchFamily="34" charset="0"/>
+                          <a:ea typeface="맑은 고딕" pitchFamily="34" charset="-122"/>
+                          <a:cs typeface="맑은 고딕" pitchFamily="34" charset="-120"/>
+                        </a:rPr>
+                        <a:t>GIC 정상</a:t>
+                      </a:r>
+                      <a:endParaRPr lang="en-US" sz="1100" dirty="0">
+                        <a:latin typeface="맑은 고딕" charset="0"/>
+                        <a:ea typeface="맑은 고딕" charset="0"/>
+                        <a:cs typeface="맑은 고딕" charset="0"/>
+                      </a:endParaRPr>
+                    </a:p>
+                  </a:txBody>
+                  <a:tcPr marL="82296" marR="82296" marT="54864" marB="54864" anchor="ctr">
+                    <a:lnL w="6350" cap="flat" cmpd="sng" algn="ctr">
+                      <a:solidFill>
+                        <a:srgbClr val="E4DED2"/>
+                      </a:solidFill>
+                      <a:prstDash val="solid"/>
+                      <a:round/>
+                      <a:headEnd type="none" w="med" len="med"/>
+                      <a:tailEnd type="none" w="med" len="med"/>
+                    </a:lnL>
+                    <a:lnR w="6350" cap="flat" cmpd="sng" algn="ctr">
+                      <a:solidFill>
+                        <a:srgbClr val="E4DED2"/>
+                      </a:solidFill>
+                      <a:prstDash val="solid"/>
+                      <a:round/>
+                      <a:headEnd type="none" w="med" len="med"/>
+                      <a:tailEnd type="none" w="med" len="med"/>
+                    </a:lnR>
+                    <a:lnT w="6350" cap="flat" cmpd="sng" algn="ctr">
+                      <a:solidFill>
+                        <a:srgbClr val="E4DED2"/>
+                      </a:solidFill>
+                      <a:prstDash val="solid"/>
+                      <a:round/>
+                      <a:headEnd type="none" w="med" len="med"/>
+                      <a:tailEnd type="none" w="med" len="med"/>
+                    </a:lnT>
+                    <a:lnB w="6350" cap="flat" cmpd="sng" algn="ctr">
+                      <a:solidFill>
+                        <a:srgbClr val="E4DED2"/>
+                      </a:solidFill>
+                      <a:prstDash val="solid"/>
+                      <a:round/>
+                      <a:headEnd type="none" w="med" len="med"/>
+                      <a:tailEnd type="none" w="med" len="med"/>
+                    </a:lnB>
+                  </a:tcPr>
+                </a:tc>
+                <a:tc>
+                  <a:txBody>
+                    <a:bodyPr/>
+                    <a:lstStyle/>
+                    <a:p>
+                      <a:pPr algn="ctr" indent="0" marL="0">
+                        <a:buNone/>
+                      </a:pPr>
+                      <a:r>
+                        <a:rPr lang="en-US" sz="1100" dirty="0">
+                          <a:solidFill>
+                            <a:srgbClr val="1C2321"/>
+                          </a:solidFill>
+                          <a:latin typeface="맑은 고딕" pitchFamily="34" charset="0"/>
+                          <a:ea typeface="맑은 고딕" pitchFamily="34" charset="-122"/>
+                          <a:cs typeface="맑은 고딕" pitchFamily="34" charset="-120"/>
+                        </a:rPr>
+                        <a:t>6:05</a:t>
+                      </a:r>
+                      <a:endParaRPr lang="en-US" sz="1100" dirty="0">
+                        <a:latin typeface="맑은 고딕" charset="0"/>
+                        <a:ea typeface="맑은 고딕" charset="0"/>
+                        <a:cs typeface="맑은 고딕" charset="0"/>
+                      </a:endParaRPr>
+                    </a:p>
+                  </a:txBody>
+                  <a:tcPr marL="82296" marR="82296" marT="54864" marB="54864" anchor="ctr">
+                    <a:lnL w="6350" cap="flat" cmpd="sng" algn="ctr">
+                      <a:solidFill>
+                        <a:srgbClr val="E4DED2"/>
+                      </a:solidFill>
+                      <a:prstDash val="solid"/>
+                      <a:round/>
+                      <a:headEnd type="none" w="med" len="med"/>
+                      <a:tailEnd type="none" w="med" len="med"/>
+                    </a:lnL>
+                    <a:lnR w="6350" cap="flat" cmpd="sng" algn="ctr">
+                      <a:solidFill>
+                        <a:srgbClr val="E4DED2"/>
+                      </a:solidFill>
+                      <a:prstDash val="solid"/>
+                      <a:round/>
+                      <a:headEnd type="none" w="med" len="med"/>
+                      <a:tailEnd type="none" w="med" len="med"/>
+                    </a:lnR>
+                    <a:lnT w="6350" cap="flat" cmpd="sng" algn="ctr">
+                      <a:solidFill>
+                        <a:srgbClr val="E4DED2"/>
+                      </a:solidFill>
+                      <a:prstDash val="solid"/>
+                      <a:round/>
+                      <a:headEnd type="none" w="med" len="med"/>
+                      <a:tailEnd type="none" w="med" len="med"/>
+                    </a:lnT>
+                    <a:lnB w="6350" cap="flat" cmpd="sng" algn="ctr">
+                      <a:solidFill>
+                        <a:srgbClr val="E4DED2"/>
+                      </a:solidFill>
+                      <a:prstDash val="solid"/>
+                      <a:round/>
+                      <a:headEnd type="none" w="med" len="med"/>
+                      <a:tailEnd type="none" w="med" len="med"/>
+                    </a:lnB>
+                  </a:tcPr>
+                </a:tc>
+                <a:tc>
+                  <a:txBody>
+                    <a:bodyPr/>
+                    <a:lstStyle/>
+                    <a:p>
+                      <a:pPr algn="ctr" indent="0" marL="0">
+                        <a:buNone/>
+                      </a:pPr>
+                      <a:r>
+                        <a:rPr lang="en-US" sz="1100" dirty="0">
+                          <a:solidFill>
+                            <a:srgbClr val="1C2321"/>
+                          </a:solidFill>
+                          <a:latin typeface="맑은 고딕" pitchFamily="34" charset="0"/>
+                          <a:ea typeface="맑은 고딕" pitchFamily="34" charset="-122"/>
+                          <a:cs typeface="맑은 고딕" pitchFamily="34" charset="-120"/>
+                        </a:rPr>
+                        <a:t>8:43</a:t>
+                      </a:r>
+                      <a:endParaRPr lang="en-US" sz="1100" dirty="0">
+                        <a:latin typeface="맑은 고딕" charset="0"/>
+                        <a:ea typeface="맑은 고딕" charset="0"/>
+                        <a:cs typeface="맑은 고딕" charset="0"/>
+                      </a:endParaRPr>
+                    </a:p>
+                  </a:txBody>
+                  <a:tcPr marL="82296" marR="82296" marT="54864" marB="54864" anchor="ctr">
+                    <a:lnL w="6350" cap="flat" cmpd="sng" algn="ctr">
+                      <a:solidFill>
+                        <a:srgbClr val="E4DED2"/>
+                      </a:solidFill>
+                      <a:prstDash val="solid"/>
+                      <a:round/>
+                      <a:headEnd type="none" w="med" len="med"/>
+                      <a:tailEnd type="none" w="med" len="med"/>
+                    </a:lnL>
+                    <a:lnR w="6350" cap="flat" cmpd="sng" algn="ctr">
+                      <a:solidFill>
+                        <a:srgbClr val="E4DED2"/>
+                      </a:solidFill>
+                      <a:prstDash val="solid"/>
+                      <a:round/>
+                      <a:headEnd type="none" w="med" len="med"/>
+                      <a:tailEnd type="none" w="med" len="med"/>
+                    </a:lnR>
+                    <a:lnT w="6350" cap="flat" cmpd="sng" algn="ctr">
+                      <a:solidFill>
+                        <a:srgbClr val="E4DED2"/>
+                      </a:solidFill>
+                      <a:prstDash val="solid"/>
+                      <a:round/>
+                      <a:headEnd type="none" w="med" len="med"/>
+                      <a:tailEnd type="none" w="med" len="med"/>
+                    </a:lnT>
+                    <a:lnB w="6350" cap="flat" cmpd="sng" algn="ctr">
+                      <a:solidFill>
+                        <a:srgbClr val="E4DED2"/>
+                      </a:solidFill>
+                      <a:prstDash val="solid"/>
+                      <a:round/>
+                      <a:headEnd type="none" w="med" len="med"/>
+                      <a:tailEnd type="none" w="med" len="med"/>
+                    </a:lnB>
+                  </a:tcPr>
+                </a:tc>
+                <a:tc>
+                  <a:txBody>
+                    <a:bodyPr/>
+                    <a:lstStyle/>
+                    <a:p>
+                      <a:pPr algn="ctr" indent="0" marL="0">
+                        <a:buNone/>
+                      </a:pPr>
+                      <a:r>
+                        <a:rPr lang="en-US" sz="1100" dirty="0">
+                          <a:solidFill>
+                            <a:srgbClr val="1C2321"/>
+                          </a:solidFill>
+                          <a:latin typeface="맑은 고딕" pitchFamily="34" charset="0"/>
+                          <a:ea typeface="맑은 고딕" pitchFamily="34" charset="-122"/>
+                          <a:cs typeface="맑은 고딕" pitchFamily="34" charset="-120"/>
+                        </a:rPr>
+                        <a:t>+1.7 SD</a:t>
+                      </a:r>
+                      <a:endParaRPr lang="en-US" sz="1100" dirty="0">
+                        <a:latin typeface="맑은 고딕" charset="0"/>
+                        <a:ea typeface="맑은 고딕" charset="0"/>
+                        <a:cs typeface="맑은 고딕" charset="0"/>
+                      </a:endParaRPr>
+                    </a:p>
+                  </a:txBody>
+                  <a:tcPr marL="82296" marR="82296" marT="54864" marB="54864" anchor="ctr">
+                    <a:lnL w="6350" cap="flat" cmpd="sng" algn="ctr">
+                      <a:solidFill>
+                        <a:srgbClr val="E4DED2"/>
+                      </a:solidFill>
+                      <a:prstDash val="solid"/>
+                      <a:round/>
+                      <a:headEnd type="none" w="med" len="med"/>
+                      <a:tailEnd type="none" w="med" len="med"/>
+                    </a:lnL>
+                    <a:lnR w="6350" cap="flat" cmpd="sng" algn="ctr">
+                      <a:solidFill>
+                        <a:srgbClr val="E4DED2"/>
+                      </a:solidFill>
+                      <a:prstDash val="solid"/>
+                      <a:round/>
+                      <a:headEnd type="none" w="med" len="med"/>
+                      <a:tailEnd type="none" w="med" len="med"/>
+                    </a:lnR>
+                    <a:lnT w="6350" cap="flat" cmpd="sng" algn="ctr">
+                      <a:solidFill>
+                        <a:srgbClr val="E4DED2"/>
+                      </a:solidFill>
+                      <a:prstDash val="solid"/>
+                      <a:round/>
+                      <a:headEnd type="none" w="med" len="med"/>
+                      <a:tailEnd type="none" w="med" len="med"/>
+                    </a:lnT>
+                    <a:lnB w="6350" cap="flat" cmpd="sng" algn="ctr">
+                      <a:solidFill>
+                        <a:srgbClr val="E4DED2"/>
+                      </a:solidFill>
+                      <a:prstDash val="solid"/>
+                      <a:round/>
+                      <a:headEnd type="none" w="med" len="med"/>
+                      <a:tailEnd type="none" w="med" len="med"/>
+                    </a:lnB>
+                  </a:tcPr>
+                </a:tc>
+              </a:tr>
+            </a:tbl>
+          </a:graphicData>
+        </a:graphic>
+      </p:graphicFrame>
+      <p:sp>
+        <p:nvSpPr>
+          <p:cNvPr id="9" name="Text 6"/>
+          <p:cNvSpPr txBox="1"/>
+          <p:nvPr/>
+        </p:nvSpPr>
+        <p:spPr>
+          <a:xfrm>
+            <a:off x="11365992" y="6400800"/>
+            <a:ext cx="457200" cy="320040"/>
+          </a:xfrm>
+          <a:prstGeom prst="rect">
+            <a:avLst/>
+          </a:prstGeom>
+          <a:noFill/>
+          <a:ln/>
+        </p:spPr>
+        <p:txBody>
+          <a:bodyPr wrap="square" lIns="0" tIns="0" rIns="0" bIns="0" rtlCol="0" anchor="ctr"/>
+          <a:lstStyle/>
+          <a:p>
+            <a:pPr algn="r" indent="0" marL="0">
+              <a:buNone/>
+            </a:pPr>
+            <a:r>
+              <a:rPr lang="en-US" sz="1100" dirty="0">
+                <a:solidFill>
+                  <a:srgbClr val="6B7568"/>
+                </a:solidFill>
+                <a:latin typeface="Cambria" pitchFamily="34" charset="0"/>
+                <a:ea typeface="Cambria" pitchFamily="34" charset="-122"/>
+                <a:cs typeface="Cambria" pitchFamily="34" charset="-120"/>
+              </a:rPr>
+              <a:t>11</a:t>
+            </a:r>
+            <a:endParaRPr lang="en-US" sz="1100" dirty="0"/>
+          </a:p>
+        </p:txBody>
+      </p:sp>
+    </p:spTree>
+  </p:cSld>
+  <p:clrMapOvr>
+    <a:masterClrMapping/>
+  </p:clrMapOvr>
+</p:sld>
+</file>
+
+<file path=ppt/slides/slide12.xml><?xml version="1.0" encoding="utf-8"?>
+<p:sld xmlns:a="http://schemas.openxmlformats.org/drawingml/2006/main" xmlns:r="http://schemas.openxmlformats.org/officeDocument/2006/relationships" xmlns:p="http://schemas.openxmlformats.org/presentationml/2006/main">
+  <p:cSld name="Slide 12">
     <p:bg>
       <p:bgPr>
         <a:solidFill>
@@ -3735,7 +6175,7 @@
                 <a:ea typeface="Cambria" pitchFamily="34" charset="-122"/>
                 <a:cs typeface="Cambria" pitchFamily="34" charset="-120"/>
               </a:rPr>
-              <a:t>11</a:t>
+              <a:t>12</a:t>
             </a:r>
             <a:endParaRPr lang="en-US" sz="1100" dirty="0"/>
           </a:p>
@@ -3749,9 +6189,9 @@
 </p:sld>
 </file>
 
-<file path=ppt/slides/slide12.xml><?xml version="1.0" encoding="utf-8"?>
+<file path=ppt/slides/slide13.xml><?xml version="1.0" encoding="utf-8"?>
 <p:sld xmlns:a="http://schemas.openxmlformats.org/drawingml/2006/main" xmlns:r="http://schemas.openxmlformats.org/officeDocument/2006/relationships" xmlns:p="http://schemas.openxmlformats.org/presentationml/2006/main">
-  <p:cSld name="Slide 12">
+  <p:cSld name="Slide 13">
     <p:bg>
       <p:bgPr>
         <a:solidFill>
@@ -4009,7 +6449,7 @@
                 <a:ea typeface="Cambria" pitchFamily="34" charset="-122"/>
                 <a:cs typeface="Cambria" pitchFamily="34" charset="-120"/>
               </a:rPr>
-              <a:t>12</a:t>
+              <a:t>13</a:t>
             </a:r>
             <a:endParaRPr lang="en-US" sz="1100" dirty="0"/>
           </a:p>
@@ -4023,9 +6463,9 @@
 </p:sld>
 </file>
 
-<file path=ppt/slides/slide13.xml><?xml version="1.0" encoding="utf-8"?>
+<file path=ppt/slides/slide14.xml><?xml version="1.0" encoding="utf-8"?>
 <p:sld xmlns:a="http://schemas.openxmlformats.org/drawingml/2006/main" xmlns:r="http://schemas.openxmlformats.org/officeDocument/2006/relationships" xmlns:p="http://schemas.openxmlformats.org/presentationml/2006/main">
-  <p:cSld name="Slide 13">
+  <p:cSld name="Slide 14">
     <p:bg>
       <p:bgPr>
         <a:solidFill>
@@ -4260,7 +6700,7 @@
                 <a:ea typeface="Cambria" pitchFamily="34" charset="-122"/>
                 <a:cs typeface="Cambria" pitchFamily="34" charset="-120"/>
               </a:rPr>
-              <a:t>13</a:t>
+              <a:t>14</a:t>
             </a:r>
             <a:endParaRPr lang="en-US" sz="1100" dirty="0"/>
           </a:p>

</xml_diff>

<commit_message>
Merge full speaker script into slide notes for both decks
Both PPTs now carry the complete spoken script (from 발표대본.md) as
native slide notes, per-slide, alongside the existing production tips
(marked [발표 팁]). Verified every slide in both decks has non-empty
notes and re-validated + re-rendered both after the merge — no visual
regressions, error bars on the cement deck's charts still intact.
</commit_message>
<xml_diff>
--- a/수복치과재료학실험/수복치과재료학실험_DentalCements_20260922.pptx
+++ b/수복치과재료학실험/수복치과재료학실험_DentalCements_20260922.pptx
@@ -1355,7 +1355,8 @@
           <a:p>
             <a:r>
               <a:rPr lang="en-US" dirty="0"/>
-              <a:t/>
+              <a:t>[대본 0:00~0:20]
+안녕하세요, A2조 발표를 맡은 [이름]입니다. 오늘은 9월 22일에 진행한 Dental Cements 실습, setting time과 film thickness 측정 결과를 정리해서 발표하겠습니다.</a:t>
             </a:r>
             <a:endParaRPr lang="en-US" dirty="0"/>
           </a:p>
@@ -1443,7 +1444,10 @@
           <a:p>
             <a:r>
               <a:rPr lang="en-US" dirty="0"/>
-              <a:t>출처: Results.xlsx(반 전체 취합 데이터, 6개 조 A1~A6, 9/29 최종본). Notion 9.22 수업일지의 '보고서: 전체조 데이터 평균/비교' 지시에 따라 구성. 오차 막대(에러바)는 표준편차 1개 폭.</a:t>
+              <a:t>[대본 7:00~8:00]
+이건 저희 조만이 아니라 A반 6개 조 데이터를 다 모아서 평균 낸 결과입니다. setting time 그래프를 보면 ZPC는 분액비가 높을수록(15%↑) 빨리 굳고 낮을수록(15%↓) 느리게 굳는 경향이 반 전체 평균에서도 비슷하게 나타났습니다. 막대 위에 그려진 세로선은 표준편차, 그러니까 조별로 값이 얼마나 흩어져 있는지를 보여주는 오차 막대입니다.
+film thickness 그래프를 보면 ZPC 세 조건 모두 오차 막대가 유독 긴 걸 볼 수 있는데요, 한 조(A3)의 값이 다른 조보다 3~10배 높게 나온 영향입니다. 같은 조의 냉각판 조건 값은 정상 범위였던 걸 보면 측정이나 단위 표기 과정에서 오류가 있었을 가능성이 있어 보이고, 이 부분은 참고용으로만 봐주시면 좋겠습니다.
+[발표 팁] 출처: Results.xlsx(반 전체 취합 데이터, 6개 조 A1~A6, 9/29 최종본). Notion 9.22 수업일지의 '보고서: 전체조 데이터 평균/비교' 지시에 따라 구성. 오차 막대(에러바)는 표준편차 1개 폭.</a:t>
             </a:r>
             <a:endParaRPr lang="en-US" dirty="0"/>
           </a:p>
@@ -1531,7 +1535,10 @@
           <a:p>
             <a:r>
               <a:rPr lang="en-US" dirty="0"/>
-              <a:t>SD 배수 = (A2 값 − 전체 평균) ÷ 표준편차. 일반적으로 ±1 SD 이내면 정상 범위, 그 밖이면 눈에 띄는 편차로 해석. ZPC 15%↑·GIC 두 조건에서 A2가 유독 느린 이유는 Q&amp;A에서 나올 수 있으니, 혼합 균질도·indentor 판정 시점 등 슬라이드 12(결과 해석)의 오차 요인과 연결지어 답변할 것.</a:t>
+              <a:t>[대본 8:00~8:50]
+이번엔 저희 조가 전체 평균과 비교해서 어디쯤 있는지를 짚어보겠습니다. 저희 조는 6개 조건 중 5개에서 전체 평균보다 느리게 경화됐습니다. 유일하게 PC 정상 조건만 평균과 거의 비슷했고요.
+특히 ZPC 15% 높음 조건과 GIC에서 편차가 가장 컸는데, 표준편차 기준으로 각각 1.9배, 1.7배 정도 평균에서 벗어나 있습니다. 저희가 indentor로 경화 여부를 판단할 때 다른 조보다 좀 더 보수적으로, 그러니까 조금 더 늦게 "다 굳었다"고 판단했거나, 혼합 속도 자체가 상대적으로 느렸을 가능성이 있다고 봅니다.
+[발표 팁] SD 배수 = (A2 값 − 전체 평균) ÷ 표준편차. 일반적으로 ±1 SD 이내면 정상 범위, 그 밖이면 눈에 띄는 편차로 해석. ZPC 15%↑·GIC 두 조건에서 A2가 유독 느린 이유는 Q&amp;A에서 나올 수 있으니, 혼합 균질도·indentor 판정 시점 등 슬라이드 12(결과 해석)의 오차 요인과 연결지어 답변할 것.</a:t>
             </a:r>
             <a:endParaRPr lang="en-US" dirty="0"/>
           </a:p>
@@ -1619,7 +1626,11 @@
           <a:p>
             <a:r>
               <a:rPr lang="en-US" dirty="0"/>
-              <a:t>참고 PPT(박수진 외, A반 5조) 고찰 구조를 참고해 재구성 — 다만 수치·조건은 오늘 A반 본인 실측 기준으로 새로 정리한 것.</a:t>
+              <a:t>[대본 8:50~9:45]
+먼저 분액비와 경화시간 관계를 보면, 이론상으로는 분액비가 높을수록 반응할 산화아연이 많아져서 빨리 굳어야 하는데, 저희 실측도 15% 높음이 정상보다 빠르게 나와서 이론과 대체로 맞았습니다. 다만 정상 조건 자체가 예상보다 오래 걸린 건, 혼합 균질도나 실험실 온습도, indentor 판정 시점의 주관성 같은 요인이 작용했을 것으로 봅니다.
+냉각판 효과는 저희 예상과 반대로 나왔는데요, 온도가 낮으면 반응이 느려져서 경화도 늦어질 거라 생각했지만, 실측은 오히려 상온보다 짧게 나왔습니다. 다만 저희가 작업시간을 따로 측정하지 못해서 경화시간만으로 비교한 한계가 있습니다.
+마지막으로 제조사 공식 값과 비교하면 전반적으로 실측이 1.9배에서 2.4배 정도 느린데, 이건 ISO 표준 조건인 37도가 아니라 상온에서 실습했기 때문으로 보입니다.
+[발표 팁] 참고 PPT(박수진 외, A반 5조) 고찰 구조를 참고해 재구성 — 다만 수치·조건은 오늘 A반 본인 실측 기준으로 새로 정리한 것.</a:t>
             </a:r>
             <a:endParaRPr lang="en-US" dirty="0"/>
           </a:p>
@@ -1707,7 +1718,9 @@
           <a:p>
             <a:r>
               <a:rPr lang="en-US" dirty="0"/>
-              <a:t/>
+              <a:t>[대본 9:45~10:00]
+정리하면, 분액비와 혼합 온도, 재료 종류 모두 dental cement의 경화시간과 피막도에 유의한 영향을 줍니다. 임상에서는 이 특성을 이용해서, 빠른 경화가 필요하면 분액비를 높게, 여유 있는 작업시간이 필요하면 낮은 분액비나 냉각판을 활용하는 식으로 조절해서 쓸 수 있겠습니다.
+이상으로 발표를 마치겠습니다. 감사합니다.</a:t>
             </a:r>
             <a:endParaRPr lang="en-US" dirty="0"/>
           </a:p>
@@ -1795,7 +1808,15 @@
           <a:p>
             <a:r>
               <a:rPr lang="en-US" dirty="0"/>
-              <a:t/>
+              <a:t>[예상 질문 메모]
+Q. 조별 취합 데이터에서 film thickness 값이 이상하게 튄 조(A3)는 어떻게 처리했나?
+→ 평균에는 그대로 반영했지만, 슬라이드 10에 측정·단위 오류 가능성이 있다고 명시해뒀다고 답하면 됩니다. 발표 전 실제로 해당 조에 값을 한 번 더 확인해두면 더 좋습니다.
+Q. 실측값이 제조사 공식 값보다 훨씬 느린 이유는 온도 하나뿐인가?
+→ 온도(37°C vs 23°C)가 가장 크지만, 습도(90% vs 통제 없음)도 함께 작용했을 가능성이 있고, indentor 판정 시점의 주관성, 개인별 혼합 속도 차이도 오차 요인으로 볼 수 있다고 답하면 됩니다.
+Q. 냉각판 조건이 이론과 반대로 나온 것을 어떻게 설명할 것인가?
+→ 작업시간(working time)을 따로 측정하지 못해 경화시간만으로 판단한 한계라고 솔직히 인정하는 게 가장 무난합니다. 냉각판은 분액비를 높게 쓰면서도 여유 있는 작업시간을 확보하기 위한 방법이라, 경화시간 자체보다 작업시간 지표로 봐야 더 정확한 비교가 될 것 같다고 덧붙이면 좋습니다.
+Q. 우리 조만 유독 느리게 나온 이유가 뭐라고 생각하는가?
+→ 가장 그럴듯한 설명은 indentor 판정 기준입니다. "완전한 원형 압흔이 안 남는 시점"이라는 기준 자체가 다소 주관적이라, 저희 조가 다른 조보다 조금 더 보수적으로(늦게) 판단했을 가능성이 있습니다. 혼합 속도나 실험실 내 위치별 온도 차이도 부차적 요인으로 들 수 있습니다.</a:t>
             </a:r>
             <a:endParaRPr lang="en-US" dirty="0"/>
           </a:p>
@@ -1883,7 +1904,8 @@
           <a:p>
             <a:r>
               <a:rPr lang="en-US" dirty="0"/>
-              <a:t/>
+              <a:t>[대본 0:20~0:35]
+발표는 이론적 배경, 실험 목적, 실험 재료·방법, 실험 결과, 마지막으로 결과 해석 순으로 진행하겠습니다.</a:t>
             </a:r>
             <a:endParaRPr lang="en-US" dirty="0"/>
           </a:p>
@@ -1971,7 +1993,11 @@
           <a:p>
             <a:r>
               <a:rPr lang="en-US" dirty="0"/>
-              <a:t>출처: 치과재료학(제9판), 한국치과재료학교수협의회 / Dental Cements 강의PPT 2026S(수복치과재료학 이론 교안, 9/22).</a:t>
+              <a:t>[대본 0:35~1:30]
+먼저 dental cement가 임상에서 쓰이는 용도부터 보면, 크게 네 가지입니다. 인레이나 금관 같은 수복물을 합착·고정하는 luting agent, 치수를 보호하는 base, 와동을 직접 채우는 restorative material, 그리고 수술용 드레싱재로 쓰입니다.
+cement가 잘 유지되려면 피막도가 작을수록 좋고, 기계적 성질이 우수해야 하며, 경화되는 동안 부피 변화가 작아야 하고, 치아 조직과 화학적으로 결합할 수 있으면 더 유리합니다.
+결합 기전으로 분류하면 인산염계인 ZPC, 페놀염계인 ZOE, 폴리카복실레이트계인 PC·GIC, 그리고 레진계인 레진 시멘트·RMGI로 나뉩니다. 오늘 저희가 다룬 건 이 중 ZPC, PC, GIC, RMGI 네 가지입니다.
+[발표 팁] 출처: 치과재료학(제9판), 한국치과재료학교수협의회 / Dental Cements 강의PPT 2026S(수복치과재료학 이론 교안, 9/22).</a:t>
             </a:r>
             <a:endParaRPr lang="en-US" dirty="0"/>
           </a:p>
@@ -2059,7 +2085,9 @@
           <a:p>
             <a:r>
               <a:rPr lang="en-US" dirty="0"/>
-              <a:t/>
+              <a:t>[대본 1:30~2:30]
+ZPC는 분말이 산화아연, 용액이 인산인 구조로, 간접 수복물을 영구 합착하거나 고강도 베이스로 씁니다. PC는 폴리아크릴산 용액을 쓰는 게 ZPC와 다른 점이고, GIC는 불소·알루미늄 실리케이트 글라스 분말을 씁니다.
+한 가지 짚고 넘어갈 부분이 냉각판 혼합법인데요, 냉동고에 보관해 둔 유리판 위에서 혼합하는 방식으로, 분액비를 15% 높게 쓸 때 함께 적용합니다. 작업시간은 늘리면서 경화시간은 줄이는 효과를 노린 방법입니다. RMGI는 GIC를 레진으로 개량한 재료로, 오늘은 1:1 auto-mixing tip으로 혼합했습니다.</a:t>
             </a:r>
             <a:endParaRPr lang="en-US" dirty="0"/>
           </a:p>
@@ -2147,7 +2175,10 @@
           <a:p>
             <a:r>
               <a:rPr lang="en-US" dirty="0"/>
-              <a:t>출처: ISO 9917-1:2007 규격 원문(강의 자료 인용) 및 각 제품 설명서(Elite Cement 100 / Hy-Bond Carbo Plus / GC Fuji I, 첨부 설명서 원문 기준).</a:t>
+              <a:t>[대본 2:30~3:30]
+측정 기준이 된 ISO 9917-1:2007 규격을 보면, setting time은 400±5g 무게의 indentor로 압입해서 완전한 원형 압흔이 안 남는 시점까지의 시간입니다. film thickness는 유리판 사이에 시멘트를 끼우고 150N 하중을 10분간 가한 뒤 두께 변화를 재는 방식이고요.
+오른쪽 표는 제조사가 공식적으로 제시한 값인데, 저희 실측값과 비교해 보면 꽤 차이가 큽니다. 이유는 아래 박스에 정리했듯이, ISO 규격은 37도·습도 90%를 기준으로 하는데 저희 실습실은 상온 23도 정도였거든요. 온도가 낮으면 반응이 느려지니까, 이게 실측이 더 느리게 나온 주된 이유로 보입니다.
+[발표 팁] 출처: ISO 9917-1:2007 규격 원문(강의 자료 인용) 및 각 제품 설명서(Elite Cement 100 / Hy-Bond Carbo Plus / GC Fuji I, 첨부 설명서 원문 기준).</a:t>
             </a:r>
             <a:endParaRPr lang="en-US" dirty="0"/>
           </a:p>
@@ -2235,7 +2266,10 @@
           <a:p>
             <a:r>
               <a:rPr lang="en-US" dirty="0"/>
-              <a:t>출처: Notion 수업일지 9.22 (수복치과재료학실험) + 강의 슬라이드 「Aims of experiment」 원문. 수업 초반 하이브리드 콤포짓 Q&amp;A는 지난 주 복습 성격이라 요약에서 제외, 오늘의 재료실험 파트만 정리함.</a:t>
+              <a:t>[대본 3:30~4:15]
+오늘 실습은 ZPC를 중심으로 분액비를 정상, 15% 높게, 15% 낮게, 그리고 냉각판까지 네 조건으로 바꿔가며 setting time을 재고, 같은 재료로 film thickness도 측정했습니다. PC·GIC·RMGI는 정상 조건에서 setting time만 쟀고, ZOE는 시연만 진행했습니다.
+수업에서 제시된 실험 목적은 혼합 방법·점도 차이, 분액비가 경화시간에 미치는 영향, 냉각판의 의미, 그리고 재료별 특성을 확인하는 것이었습니다.
+[발표 팁] 출처: Notion 수업일지 9.22 (수복치과재료학실험) + 강의 슬라이드 「Aims of experiment」 원문. 수업 초반 하이브리드 콤포짓 Q&amp;A는 지난 주 복습 성격이라 요약에서 제외, 오늘의 재료실험 파트만 정리함.</a:t>
             </a:r>
             <a:endParaRPr lang="en-US" dirty="0"/>
           </a:p>
@@ -2323,7 +2357,8 @@
           <a:p>
             <a:r>
               <a:rPr lang="en-US" dirty="0"/>
-              <a:t/>
+              <a:t>[대본 4:15~4:45]
+재료는 이렇게 구성했습니다. setting time 쪽은 시멘트 다섯 종류와 유리판, 스파툴라, 금속 몰드, indentor를 썼고, film thickness 쪽은 슬라이드글라스 두 장과 마이크로미터, 그리고 150N 하중을 가하는 장치를 사용했습니다.</a:t>
             </a:r>
             <a:endParaRPr lang="en-US" dirty="0"/>
           </a:p>
@@ -2411,7 +2446,9 @@
           <a:p>
             <a:r>
               <a:rPr lang="en-US" dirty="0"/>
-              <a:t/>
+              <a:t>[대본 4:45~6:00]
+분액비 조건은 표에 정리한 대로 scoop·drop 비율을 조정했고, 혼합은 분말을 먼저 덜어놓고 액체를 한 곳에 모은 뒤 나눠 넣는 순서로 진행했습니다.
+측정은, setting time의 경우 혼합 종료 90초 뒤부터 indentor로 30초 간격으로 눌러보다가 경화가 임박하면 10초 간격으로 좁혀서 완전한 원형 압흔이 안 남는 시점을 기록했고, film thickness는 유리판 두께를 먼저 재고(A) 시멘트를 끼운 뒤 150N을 10분간 가한 상태에서 다시 재서(B) 그 차이를 피막도로 계산했습니다.</a:t>
             </a:r>
             <a:endParaRPr lang="en-US" dirty="0"/>
           </a:p>
@@ -2499,7 +2536,8 @@
           <a:p>
             <a:r>
               <a:rPr lang="en-US" dirty="0"/>
-              <a:t/>
+              <a:t>[대본 6:00~7:00]
+저희 조 실측 결과입니다. setting time이 빠른 순으로 보면 RMGI가 6분 24초로 가장 빨랐고, 그다음이 GIC, PC 순이었습니다. ZPC 네 조건 중에서는 15% 높음이 가장 빨랐고, 15% 낮음이 가장 느렸습니다.</a:t>
             </a:r>
             <a:endParaRPr lang="en-US" dirty="0"/>
           </a:p>

</xml_diff>

<commit_message>
Fix table header word-wrap on slide 5 (ISO spec/manufacturer values)
Full 15-slide visual + content QA re-audit: rendered every slide to PNG
and inspected each one, verified notes/발표대본.md sync (all 15 slides
have notes, all match verbatim), verified 슬라이드 N cross-references
and pageNum/comment numbering are consistent, verified class-average vs
own-group data consistency, and confirmed error-bar injection still
targets the correct chart XML files.

Only issue found: the manufacturer-spec table on slide 5 had column
widths too narrow for their headers, so "Working" and "Setting" broke
mid-word ("Worki/ng", "Settin/g"). Rebalanced colW so every header
fits on one line without shrinking the data columns into a second
overflow issue.

Co-Authored-By: Claude Sonnet 5 <noreply@anthropic.com>
Claude-Session: https://claude.ai/code/session_014ok8p4xZCZLzhCuM2RAuEa
</commit_message>
<xml_diff>
--- a/수복치과재료학실험/수복치과재료학실험_DentalCements_20260922.pptx
+++ b/수복치과재료학실험/수복치과재료학실험_DentalCements_20260922.pptx
@@ -14850,7 +14850,7 @@
       </p:sp>
       <p:pic>
         <p:nvPicPr>
-          <p:cNvPr id="13" name="Image 0" descr="/home/user/-/수복치과재료학실험/dental_photos/insert/photo_09.jpg">    </p:cNvPr>
+          <p:cNvPr id="13" name="Image 0" descr="/home/user/-/.claude/worktrees/agent-a33c37b000189e92f/수복치과재료학실험/dental_photos/insert/photo_09.jpg">    </p:cNvPr>
           <p:cNvPicPr>
             <a:picLocks noChangeAspect="1"/>
           </p:cNvPicPr>
@@ -15197,7 +15197,7 @@
       </p:sp>
       <p:pic>
         <p:nvPicPr>
-          <p:cNvPr id="21" name="Image 1" descr="/home/user/-/수복치과재료학실험/dental_photos/insert/photo_10.jpg">    </p:cNvPr>
+          <p:cNvPr id="21" name="Image 1" descr="/home/user/-/.claude/worktrees/agent-a33c37b000189e92f/수복치과재료학실험/dental_photos/insert/photo_10.jpg">    </p:cNvPr>
           <p:cNvPicPr>
             <a:picLocks noChangeAspect="1"/>
           </p:cNvPicPr>
@@ -16031,12 +16031,12 @@
             <a:tbl>
               <a:tblPr/>
               <a:tblGrid>
-                <a:gridCol w="502920"/>
-                <a:gridCol w="1417320"/>
-                <a:gridCol w="868680"/>
-                <a:gridCol w="685800"/>
-                <a:gridCol w="594360"/>
-                <a:gridCol w="594360"/>
+                <a:gridCol w="457200"/>
+                <a:gridCol w="1188720"/>
+                <a:gridCol w="777240"/>
+                <a:gridCol w="731520"/>
+                <a:gridCol w="777240"/>
+                <a:gridCol w="731520"/>
               </a:tblGrid>
               <a:tr h="548640">
                 <a:tc>
@@ -19828,7 +19828,7 @@
       </p:sp>
       <p:pic>
         <p:nvPicPr>
-          <p:cNvPr id="7" name="Image 0" descr="/home/user/-/수복치과재료학실험/dental_photos/insert/photo_06.jpg">    </p:cNvPr>
+          <p:cNvPr id="7" name="Image 0" descr="/home/user/-/.claude/worktrees/agent-a33c37b000189e92f/수복치과재료학실험/dental_photos/insert/photo_06.jpg">    </p:cNvPr>
           <p:cNvPicPr>
             <a:picLocks noChangeAspect="1"/>
           </p:cNvPicPr>
@@ -19915,7 +19915,7 @@
       </p:sp>
       <p:pic>
         <p:nvPicPr>
-          <p:cNvPr id="10" name="Image 1" descr="/home/user/-/수복치과재료학실험/dental_photos/insert/photo_07.jpg">    </p:cNvPr>
+          <p:cNvPr id="10" name="Image 1" descr="/home/user/-/.claude/worktrees/agent-a33c37b000189e92f/수복치과재료학실험/dental_photos/insert/photo_07.jpg">    </p:cNvPr>
           <p:cNvPicPr>
             <a:picLocks noChangeAspect="1"/>
           </p:cNvPicPr>
@@ -20192,7 +20192,7 @@
       </p:sp>
       <p:pic>
         <p:nvPicPr>
-          <p:cNvPr id="16" name="Image 2" descr="/home/user/-/수복치과재료학실험/dental_photos/insert/photo_05.jpg">    </p:cNvPr>
+          <p:cNvPr id="16" name="Image 2" descr="/home/user/-/.claude/worktrees/agent-a33c37b000189e92f/수복치과재료학실험/dental_photos/insert/photo_05.jpg">    </p:cNvPr>
           <p:cNvPicPr>
             <a:picLocks noChangeAspect="1"/>
           </p:cNvPicPr>
@@ -22244,7 +22244,7 @@
       </p:sp>
       <p:pic>
         <p:nvPicPr>
-          <p:cNvPr id="8" name="Image 0" descr="/home/user/-/수복치과재료학실험/dental_photos/insert/photo_04.jpg">    </p:cNvPr>
+          <p:cNvPr id="8" name="Image 0" descr="/home/user/-/.claude/worktrees/agent-a33c37b000189e92f/수복치과재료학실험/dental_photos/insert/photo_04.jpg">    </p:cNvPr>
           <p:cNvPicPr>
             <a:picLocks noChangeAspect="1"/>
           </p:cNvPicPr>
@@ -22642,7 +22642,7 @@
       </p:sp>
       <p:pic>
         <p:nvPicPr>
-          <p:cNvPr id="8" name="Image 0" descr="/home/user/-/수복치과재료학실험/dental_photos/insert/photo_02.jpg">    </p:cNvPr>
+          <p:cNvPr id="8" name="Image 0" descr="/home/user/-/.claude/worktrees/agent-a33c37b000189e92f/수복치과재료학실험/dental_photos/insert/photo_02.jpg">    </p:cNvPr>
           <p:cNvPicPr>
             <a:picLocks noChangeAspect="1"/>
           </p:cNvPicPr>

</xml_diff>

<commit_message>
Add comparison chart to slide 12; sync content edits from user's PPT
- Slide 12: added a clustered bar chart (전체 평균 vs 우리 조(A2), matching
  slide 11's style — error bars = SD of the class-wide mean) plus a
  compact caption line with exact figures, replacing the plain
  table. scripts/add_errorbars.py updated to inject into this third
  chart (chart3.xml), error bars applied only to the "전체 평균" series.
- Ported the user's direct PowerPoint edits (proofreading + content
  fixes) back into build.js as the source of truth: title formatting,
  "경화시간"→"경화 시간" spacing throughout, several caption/wording
  rewrites (slides 4,5,6,7,8,9,10,11,13,14), and filling in the
  ZPC 15%↑+냉각판 Scoop/Drop value (was "-", now "3 / 13") on slide 8.
  Speaker notes / 발표대본.md were left untouched since the user's
  edits were only to visible slide text, not narration.
</commit_message>
<xml_diff>
--- a/수복치과재료학실험/수복치과재료학실험_DentalCements_20260922.pptx
+++ b/수복치과재료학실험/수복치과재료학실험_DentalCements_20260922.pptx
@@ -945,6 +945,486 @@
         <a:effectLst/>
       </c:spPr>
     </c:plotArea>
+    <c:plotVisOnly val="1"/>
+    <c:dispBlanksAs val="span"/>
+  </c:chart>
+  <c:spPr>
+    <a:noFill/>
+    <a:ln>
+      <a:noFill/>
+    </a:ln>
+    <a:effectLst/>
+  </c:spPr>
+  <c:externalData r:id="rId1">
+    <c:autoUpdate val="0"/>
+  </c:externalData>
+</c:chartSpace>
+</file>
+
+<file path=ppt/charts/chart3.xml><?xml version="1.0" encoding="utf-8"?>
+<c:chartSpace xmlns:c="http://schemas.openxmlformats.org/drawingml/2006/chart" xmlns:a="http://schemas.openxmlformats.org/drawingml/2006/main" xmlns:r="http://schemas.openxmlformats.org/officeDocument/2006/relationships">
+  <c:date1904 val="0"/>
+  <c:roundedCorners val="1"/>
+  <c:chart>
+    <c:title>
+      <c:tx>
+        <c:rich>
+          <a:bodyPr/>
+          <a:lstStyle/>
+          <a:p>
+            <a:pPr>
+              <a:defRPr sz="1200" b="0" i="0" u="none" strike="noStrike">
+                <a:solidFill>
+                  <a:srgbClr val="1B3A5C"/>
+                </a:solidFill>
+                <a:latin typeface="맑은 고딕"/>
+              </a:defRPr>
+            </a:pPr>
+            <a:r>
+              <a:rPr sz="1200" b="0" i="0" u="none" strike="noStrike">
+                <a:solidFill>
+                  <a:srgbClr val="1B3A5C"/>
+                </a:solidFill>
+                <a:latin typeface="맑은 고딕"/>
+              </a:rPr>
+              <a:t>Setting time — 전체 평균 vs 우리 조(A2)</a:t>
+            </a:r>
+          </a:p>
+        </c:rich>
+      </c:tx>
+      <c:layout/>
+      <c:overlay val="0"/>
+    </c:title>
+    <c:autoTitleDeleted val="0"/>
+    <c:plotArea>
+      <c:layout/>
+      <c:barChart>
+        <c:barDir val="col"/>
+        <c:grouping val="clustered"/>
+        <c:varyColors val="0"/>
+        <c:ser>
+          <c:idx val="0"/>
+          <c:order val="0"/>
+          <c:tx>
+            <c:strRef>
+              <c:f>Sheet1!$B$1</c:f>
+              <c:strCache>
+                <c:ptCount val="1"/>
+                <c:pt idx="0">
+                  <c:v>전체 평균</c:v>
+                </c:pt>
+              </c:strCache>
+            </c:strRef>
+          </c:tx>
+          <c:spPr>
+            <a:solidFill>
+              <a:srgbClr val="1B3A5C"/>
+            </a:solidFill>
+            <a:effectLst/>
+          </c:spPr>
+          <c:invertIfNegative val="0"/>
+          <c:dLbls>
+            <c:numFmt formatCode="0.0" sourceLinked="0"/>
+            <c:txPr>
+              <a:bodyPr/>
+              <a:lstStyle/>
+              <a:p>
+                <a:pPr>
+                  <a:defRPr b="0" i="0" strike="noStrike" sz="850" u="none">
+                    <a:solidFill>
+                      <a:srgbClr val="1C2733"/>
+                    </a:solidFill>
+                    <a:latin typeface="Arial"/>
+                  </a:defRPr>
+                </a:pPr>
+              </a:p>
+            </c:txPr>
+            <c:showLegendKey val="0"/>
+            <c:showVal val="1"/>
+            <c:showCatName val="0"/>
+            <c:showSerName val="0"/>
+            <c:showPercent val="0"/>
+            <c:showBubbleSize val="0"/>
+            <c:showLeaderLines val="0"/>
+          </c:dLbls>
+          <c:errBars>
+            <c:errBarType val="both"/>
+            <c:errValType val="cust"/>
+            <c:noEndCap val="0"/>
+            <c:plus>
+              <c:numLit>
+                <c:formatCode>General</c:formatCode>
+                <c:ptCount val="6"/>
+                <c:pt idx="0">
+                  <c:v>4.02</c:v>
+                </c:pt>
+                <c:pt idx="1">
+                  <c:v>3.85</c:v>
+                </c:pt>
+                <c:pt idx="2">
+                  <c:v>2.73</c:v>
+                </c:pt>
+                <c:pt idx="3">
+                  <c:v>2.17</c:v>
+                </c:pt>
+                <c:pt idx="4">
+                  <c:v>4.04</c:v>
+                </c:pt>
+                <c:pt idx="5">
+                  <c:v>1.58</c:v>
+                </c:pt>
+              </c:numLit>
+            </c:plus>
+            <c:minus>
+              <c:numLit>
+                <c:formatCode>General</c:formatCode>
+                <c:ptCount val="6"/>
+                <c:pt idx="0">
+                  <c:v>4.02</c:v>
+                </c:pt>
+                <c:pt idx="1">
+                  <c:v>3.85</c:v>
+                </c:pt>
+                <c:pt idx="2">
+                  <c:v>2.73</c:v>
+                </c:pt>
+                <c:pt idx="3">
+                  <c:v>2.17</c:v>
+                </c:pt>
+                <c:pt idx="4">
+                  <c:v>4.04</c:v>
+                </c:pt>
+                <c:pt idx="5">
+                  <c:v>1.58</c:v>
+                </c:pt>
+              </c:numLit>
+            </c:minus>
+            <c:spPr>
+              <a:ln w="9525">
+                <a:solidFill>
+                  <a:srgbClr val="5B6B7A"/>
+                </a:solidFill>
+              </a:ln>
+            </c:spPr>
+          </c:errBars>
+          <c:cat>
+            <c:multiLvlStrRef>
+              <c:f>Sheet1!$A$2:$A$7</c:f>
+              <c:multiLvlStrCache>
+                <c:ptCount val="6"/>
+                <c:lvl>
+                  <c:pt idx="0">
+                    <c:v>ZPC
+15%↓</c:v>
+                  </c:pt>
+                  <c:pt idx="1">
+                    <c:v>ZPC
+정상</c:v>
+                  </c:pt>
+                  <c:pt idx="2">
+                    <c:v>ZPC
+15%↑</c:v>
+                  </c:pt>
+                  <c:pt idx="3">
+                    <c:v>ZPC
+15%↑+냉각판</c:v>
+                  </c:pt>
+                  <c:pt idx="4">
+                    <c:v>PC
+정상</c:v>
+                  </c:pt>
+                  <c:pt idx="5">
+                    <c:v>GIC
+정상</c:v>
+                  </c:pt>
+                </c:lvl>
+              </c:multiLvlStrCache>
+            </c:multiLvlStrRef>
+          </c:cat>
+          <c:val>
+            <c:numRef>
+              <c:f>Sheet1!$B$2:$B$7</c:f>
+              <c:numCache>
+                <c:formatCode>General</c:formatCode>
+                <c:ptCount val="6"/>
+                <c:pt idx="0">
+                  <c:v>13.21</c:v>
+                </c:pt>
+                <c:pt idx="1">
+                  <c:v>11.22</c:v>
+                </c:pt>
+                <c:pt idx="2">
+                  <c:v>7.67</c:v>
+                </c:pt>
+                <c:pt idx="3">
+                  <c:v>10.12</c:v>
+                </c:pt>
+                <c:pt idx="4">
+                  <c:v>10.29</c:v>
+                </c:pt>
+                <c:pt idx="5">
+                  <c:v>6.08</c:v>
+                </c:pt>
+              </c:numCache>
+            </c:numRef>
+          </c:val>
+        </c:ser>
+        <c:ser>
+          <c:idx val="1"/>
+          <c:order val="1"/>
+          <c:tx>
+            <c:strRef>
+              <c:f>Sheet1!$C$1</c:f>
+              <c:strCache>
+                <c:ptCount val="1"/>
+                <c:pt idx="0">
+                  <c:v>우리 조(A2)</c:v>
+                </c:pt>
+              </c:strCache>
+            </c:strRef>
+          </c:tx>
+          <c:spPr>
+            <a:solidFill>
+              <a:srgbClr val="4A90C2"/>
+            </a:solidFill>
+            <a:effectLst/>
+          </c:spPr>
+          <c:invertIfNegative val="0"/>
+          <c:dLbls>
+            <c:numFmt formatCode="0.0" sourceLinked="0"/>
+            <c:txPr>
+              <a:bodyPr/>
+              <a:lstStyle/>
+              <a:p>
+                <a:pPr>
+                  <a:defRPr b="0" i="0" strike="noStrike" sz="850" u="none">
+                    <a:solidFill>
+                      <a:srgbClr val="1C2733"/>
+                    </a:solidFill>
+                    <a:latin typeface="Arial"/>
+                  </a:defRPr>
+                </a:pPr>
+              </a:p>
+            </c:txPr>
+            <c:showLegendKey val="0"/>
+            <c:showVal val="1"/>
+            <c:showCatName val="0"/>
+            <c:showSerName val="0"/>
+            <c:showPercent val="0"/>
+            <c:showBubbleSize val="0"/>
+            <c:showLeaderLines val="0"/>
+          </c:dLbls>
+          <c:cat>
+            <c:multiLvlStrRef>
+              <c:f>Sheet1!$A$2:$A$7</c:f>
+              <c:multiLvlStrCache>
+                <c:ptCount val="6"/>
+                <c:lvl>
+                  <c:pt idx="0">
+                    <c:v>ZPC
+15%↓</c:v>
+                  </c:pt>
+                  <c:pt idx="1">
+                    <c:v>ZPC
+정상</c:v>
+                  </c:pt>
+                  <c:pt idx="2">
+                    <c:v>ZPC
+15%↑</c:v>
+                  </c:pt>
+                  <c:pt idx="3">
+                    <c:v>ZPC
+15%↑+냉각판</c:v>
+                  </c:pt>
+                  <c:pt idx="4">
+                    <c:v>PC
+정상</c:v>
+                  </c:pt>
+                  <c:pt idx="5">
+                    <c:v>GIC
+정상</c:v>
+                  </c:pt>
+                </c:lvl>
+              </c:multiLvlStrCache>
+            </c:multiLvlStrRef>
+          </c:cat>
+          <c:val>
+            <c:numRef>
+              <c:f>Sheet1!$C$2:$C$7</c:f>
+              <c:numCache>
+                <c:formatCode>General</c:formatCode>
+                <c:ptCount val="6"/>
+                <c:pt idx="0">
+                  <c:v>16.77</c:v>
+                </c:pt>
+                <c:pt idx="1">
+                  <c:v>16.33</c:v>
+                </c:pt>
+                <c:pt idx="2">
+                  <c:v>12.75</c:v>
+                </c:pt>
+                <c:pt idx="3">
+                  <c:v>12.05</c:v>
+                </c:pt>
+                <c:pt idx="4">
+                  <c:v>9.68</c:v>
+                </c:pt>
+                <c:pt idx="5">
+                  <c:v>8.72</c:v>
+                </c:pt>
+              </c:numCache>
+            </c:numRef>
+          </c:val>
+        </c:ser>
+        <c:dLbls>
+          <c:numFmt formatCode="0.0" sourceLinked="0"/>
+          <c:txPr>
+            <a:bodyPr/>
+            <a:lstStyle/>
+            <a:p>
+              <a:pPr>
+                <a:defRPr b="0" i="0" strike="noStrike" sz="850" u="none">
+                  <a:solidFill>
+                    <a:srgbClr val="1C2733"/>
+                  </a:solidFill>
+                  <a:latin typeface="Arial"/>
+                </a:defRPr>
+              </a:pPr>
+            </a:p>
+          </c:txPr>
+          <c:showLegendKey val="0"/>
+          <c:showVal val="1"/>
+          <c:showCatName val="0"/>
+          <c:showSerName val="0"/>
+          <c:showPercent val="0"/>
+          <c:showBubbleSize val="0"/>
+          <c:showLeaderLines val="0"/>
+        </c:dLbls>
+        <c:gapWidth val="35"/>
+        <c:overlap val="0"/>
+        <c:axId val="2094734554"/>
+        <c:axId val="2094734552"/>
+        <c:axId val="2094734556"/>
+      </c:barChart>
+      <c:catAx>
+        <c:axId val="2094734554"/>
+        <c:scaling>
+          <c:orientation val="minMax"/>
+        </c:scaling>
+        <c:delete val="0"/>
+        <c:axPos val="b"/>
+        <c:numFmt formatCode="General" sourceLinked="1"/>
+        <c:majorTickMark val="out"/>
+        <c:minorTickMark val="none"/>
+        <c:tickLblPos val="low"/>
+        <c:spPr>
+          <a:ln w="12700" cap="flat">
+            <a:solidFill>
+              <a:srgbClr val="888888"/>
+            </a:solidFill>
+            <a:prstDash val="solid"/>
+            <a:round/>
+          </a:ln>
+        </c:spPr>
+        <c:txPr>
+          <a:bodyPr/>
+          <a:lstStyle/>
+          <a:p>
+            <a:pPr>
+              <a:defRPr sz="900" b="0" i="0" u="none" strike="noStrike">
+                <a:solidFill>
+                  <a:srgbClr val="5B6B7A"/>
+                </a:solidFill>
+                <a:latin typeface="맑은 고딕"/>
+              </a:defRPr>
+            </a:pPr>
+            <a:endParaRPr lang="en-US"/>
+          </a:p>
+        </c:txPr>
+        <c:crossAx val="2094734552"/>
+        <c:crosses val="autoZero"/>
+        <c:auto val="1"/>
+        <c:lblAlgn val="ctr"/>
+        <c:noMultiLvlLbl val="1"/>
+      </c:catAx>
+      <c:valAx>
+        <c:axId val="2094734552"/>
+        <c:scaling>
+          <c:orientation val="minMax"/>
+          <c:max val="20"/>
+          <c:min val="0"/>
+        </c:scaling>
+        <c:delete val="0"/>
+        <c:axPos val="l"/>
+        <c:majorGridlines>
+          <c:spPr>
+            <a:ln w="9525" cap="flat">
+              <a:solidFill>
+                <a:srgbClr val="DCE3EA"/>
+              </a:solidFill>
+              <a:prstDash val="solid"/>
+              <a:round/>
+            </a:ln>
+          </c:spPr>
+        </c:majorGridlines>
+        <c:numFmt formatCode="General" sourceLinked="0"/>
+        <c:majorTickMark val="out"/>
+        <c:minorTickMark val="none"/>
+        <c:tickLblPos val="nextTo"/>
+        <c:spPr>
+          <a:ln w="12700" cap="flat">
+            <a:solidFill>
+              <a:srgbClr val="888888"/>
+            </a:solidFill>
+            <a:prstDash val="solid"/>
+            <a:round/>
+          </a:ln>
+        </c:spPr>
+        <c:txPr>
+          <a:bodyPr/>
+          <a:lstStyle/>
+          <a:p>
+            <a:pPr>
+              <a:defRPr sz="900" b="0" i="0" u="none" strike="noStrike">
+                <a:solidFill>
+                  <a:srgbClr val="5B6B7A"/>
+                </a:solidFill>
+                <a:latin typeface="Arial"/>
+              </a:defRPr>
+            </a:pPr>
+            <a:endParaRPr lang="en-US"/>
+          </a:p>
+        </c:txPr>
+        <c:crossAx val="2094734554"/>
+        <c:crosses val="autoZero"/>
+        <c:crossBetween val="between"/>
+      </c:valAx>
+      <c:spPr>
+        <a:noFill/>
+        <a:ln>
+          <a:noFill/>
+        </a:ln>
+        <a:effectLst/>
+      </c:spPr>
+    </c:plotArea>
+    <c:legend>
+      <c:legendPos val="t"/>
+      <c:overlay val="0"/>
+      <c:txPr>
+        <a:bodyPr/>
+        <a:lstStyle/>
+        <a:p>
+          <a:pPr>
+            <a:defRPr sz="900">
+              <a:solidFill>
+                <a:srgbClr val="5B6B7A"/>
+              </a:solidFill>
+            </a:defRPr>
+          </a:pPr>
+          <a:endParaRPr lang="en-US"/>
+        </a:p>
+      </c:txPr>
+    </c:legend>
     <c:plotVisOnly val="1"/>
     <c:dispBlanksAs val="span"/>
   </c:chart>
@@ -3072,7 +3552,7 @@
                 <a:ea typeface="맑은 고딕" pitchFamily="34" charset="-122"/>
                 <a:cs typeface="맑은 고딕" pitchFamily="34" charset="-120"/>
               </a:rPr>
-              <a:t>수복치과재료학실험 · A2조</a:t>
+              <a:t>2026-2 〈수복치과재료학실험〉 A2조</a:t>
             </a:r>
             <a:endParaRPr lang="en-US" sz="1400" dirty="0"/>
           </a:p>
@@ -3411,7 +3891,7 @@
                 <a:ea typeface="맑은 고딕" pitchFamily="34" charset="-122"/>
                 <a:cs typeface="맑은 고딕" pitchFamily="34" charset="-120"/>
               </a:rPr>
-              <a:t>조건별 경화시간(setting time) 및 유리판 측정값</a:t>
+              <a:t>조건별 경화 시간(setting time) 및 유리판 측정값</a:t>
             </a:r>
             <a:endParaRPr lang="en-US" sz="2400" dirty="0"/>
           </a:p>
@@ -8211,7 +8691,27 @@
                 <a:ea typeface="맑은 고딕" pitchFamily="34" charset="-122"/>
                 <a:cs typeface="맑은 고딕" pitchFamily="34" charset="-120"/>
               </a:rPr>
-              <a:t>※ Setting time(경화시간) = Total time − Mixing time. ZPC는 mixing time 1:30(수업 노트의 "1분에서 +30초까지" 구간 기준), RMGI는 auto-mixing으로 0:00으로 보고 계산. 유리판 측정값·피막도 모두 mm 단위(예: 9.480−9.464=0.016mm) — 원본 raw data 수정본(9.27) 반영.</a:t>
+              <a:t>※ Setting time(경화 시간) = Total time − Mixing time.</a:t>
+            </a:r>
+            <a:endParaRPr lang="en-US" sz="1100" dirty="0"/>
+          </a:p>
+          <a:p>
+            <a:pPr indent="0" marL="0">
+              <a:lnSpc>
+                <a:spcPct val="120000"/>
+              </a:lnSpc>
+              <a:buNone/>
+            </a:pPr>
+            <a:r>
+              <a:rPr lang="en-US" sz="1100" i="1" dirty="0">
+                <a:solidFill>
+                  <a:srgbClr val="5B6B7A"/>
+                </a:solidFill>
+                <a:latin typeface="맑은 고딕" pitchFamily="34" charset="0"/>
+                <a:ea typeface="맑은 고딕" pitchFamily="34" charset="-122"/>
+                <a:cs typeface="맑은 고딕" pitchFamily="34" charset="-120"/>
+              </a:rPr>
+              <a:t>ZPC, PC, GIC는 표준 혼합 시간으로 간주. RMGI는 auto-mixing으로 0으로 간주.</a:t>
             </a:r>
             <a:endParaRPr lang="en-US" sz="1100" dirty="0"/>
           </a:p>
@@ -8421,7 +8921,7 @@
                 <a:ea typeface="맑은 고딕" pitchFamily="34" charset="-122"/>
                 <a:cs typeface="맑은 고딕" pitchFamily="34" charset="-120"/>
               </a:rPr>
-              <a:t>조별 데이터 종합 비교 — 6개 조 평균(A반 취합)</a:t>
+              <a:t>조별 데이터 종합 비교 — A분반</a:t>
             </a:r>
             <a:endParaRPr lang="en-US" sz="2400" dirty="0"/>
           </a:p>
@@ -8755,7 +9255,7 @@
         </p:nvSpPr>
         <p:spPr>
           <a:xfrm>
-            <a:off x="640080" y="1463040"/>
+            <a:off x="640080" y="1417320"/>
             <a:ext cx="10908792" cy="347472"/>
           </a:xfrm>
           <a:prstGeom prst="rect">
@@ -8794,8 +9294,8 @@
         </p:nvSpPr>
         <p:spPr>
           <a:xfrm>
-            <a:off x="640080" y="1810512"/>
-            <a:ext cx="10908792" cy="1143000"/>
+            <a:off x="640080" y="1737360"/>
+            <a:ext cx="10908792" cy="960120"/>
           </a:xfrm>
           <a:prstGeom prst="rect">
             <a:avLst/>
@@ -8809,12 +9309,12 @@
           <a:p>
             <a:pPr indent="0" marL="0">
               <a:lnSpc>
-                <a:spcPct val="140000"/>
+                <a:spcPct val="130000"/>
               </a:lnSpc>
               <a:buNone/>
             </a:pPr>
             <a:r>
-              <a:rPr lang="en-US" sz="1250" dirty="0">
+              <a:rPr lang="en-US" sz="1200" dirty="0">
                 <a:solidFill>
                   <a:srgbClr val="1C2733"/>
                 </a:solidFill>
@@ -8824,17 +9324,17 @@
               </a:rPr>
               <a:t>•  분액비(P/L ratio)가 높을수록(15%↑) 평균 7:40으로 가장 빠르고, 낮을수록(15%↓) 13:13으로 가장 느림 — high &lt; normal &lt; low 순으로 느려질 것이라는 이론적 예측이 반 전체 데이터에서도 일관되게 확인됨</a:t>
             </a:r>
-            <a:endParaRPr lang="en-US" sz="1250" dirty="0"/>
+            <a:endParaRPr lang="en-US" sz="1200" dirty="0"/>
           </a:p>
           <a:p>
             <a:pPr indent="0" marL="0">
               <a:lnSpc>
-                <a:spcPct val="140000"/>
+                <a:spcPct val="130000"/>
               </a:lnSpc>
               <a:buNone/>
             </a:pPr>
             <a:r>
-              <a:rPr lang="en-US" sz="1250" dirty="0">
+              <a:rPr lang="en-US" sz="1200" dirty="0">
                 <a:solidFill>
                   <a:srgbClr val="1C2733"/>
                 </a:solidFill>
@@ -8844,7 +9344,7 @@
               </a:rPr>
               <a:t>•  재료 간 경향도 일관됨: GIC(6:05)·RMGI(6:24)가 가장 빠르고, ZPC 계열이 전반적으로 가장 느림 — 재료 자체의 반응 속도 차이가 조건 차이보다 더 크게 작용</a:t>
             </a:r>
-            <a:endParaRPr lang="en-US" sz="1250" dirty="0"/>
+            <a:endParaRPr lang="en-US" sz="1200" dirty="0"/>
           </a:p>
         </p:txBody>
       </p:sp>
@@ -8856,7 +9356,7 @@
         </p:nvSpPr>
         <p:spPr>
           <a:xfrm>
-            <a:off x="640080" y="3017520"/>
+            <a:off x="640080" y="2788920"/>
             <a:ext cx="10908792" cy="347472"/>
           </a:xfrm>
           <a:prstGeom prst="rect">
@@ -8895,8 +9395,8 @@
         </p:nvSpPr>
         <p:spPr>
           <a:xfrm>
-            <a:off x="640080" y="3364992"/>
-            <a:ext cx="10908792" cy="1005840"/>
+            <a:off x="640080" y="3108960"/>
+            <a:ext cx="10908792" cy="914400"/>
           </a:xfrm>
           <a:prstGeom prst="rect">
             <a:avLst/>
@@ -8910,12 +9410,12 @@
           <a:p>
             <a:pPr indent="0" marL="0">
               <a:lnSpc>
-                <a:spcPct val="140000"/>
+                <a:spcPct val="130000"/>
               </a:lnSpc>
               <a:buNone/>
             </a:pPr>
             <a:r>
-              <a:rPr lang="en-US" sz="1250" dirty="0">
+              <a:rPr lang="en-US" sz="1200" dirty="0">
                 <a:solidFill>
                   <a:srgbClr val="1C2733"/>
                 </a:solidFill>
@@ -8925,17 +9425,17 @@
               </a:rPr>
               <a:t>•  6개 조건 중 5개에서 전체 평균보다 느리게 경화 — 유일하게 PC 정상 조건만 평균과 거의 같음(평균 대비 −0.2 SD)</a:t>
             </a:r>
-            <a:endParaRPr lang="en-US" sz="1250" dirty="0"/>
+            <a:endParaRPr lang="en-US" sz="1200" dirty="0"/>
           </a:p>
           <a:p>
             <a:pPr indent="0" marL="0">
               <a:lnSpc>
-                <a:spcPct val="140000"/>
+                <a:spcPct val="130000"/>
               </a:lnSpc>
               <a:buNone/>
             </a:pPr>
             <a:r>
-              <a:rPr lang="en-US" sz="1250" dirty="0">
+              <a:rPr lang="en-US" sz="1200" dirty="0">
                 <a:solidFill>
                   <a:srgbClr val="1C2733"/>
                 </a:solidFill>
@@ -8945,1891 +9445,100 @@
               </a:rPr>
               <a:t>•  편차가 가장 큰 조건은 ZPC 15%↑(+1.9 SD)와 GIC(+1.7 SD) — 우리 조가 indentor 판정 기준을 다른 조보다 보수적으로(늦게 경화로 판단) 적용했거나, 혼합 속도가 상대적으로 느렸을 가능성을 시사</a:t>
             </a:r>
-            <a:endParaRPr lang="en-US" sz="1250" dirty="0"/>
+            <a:endParaRPr lang="en-US" sz="1200" dirty="0"/>
           </a:p>
         </p:txBody>
+      </p:sp>
+      <p:sp>
+        <p:nvSpPr>
+          <p:cNvPr id="8" name="Shape 6"/>
+          <p:cNvSpPr/>
+          <p:nvPr/>
+        </p:nvSpPr>
+        <p:spPr>
+          <a:xfrm>
+            <a:off x="640080" y="4114800"/>
+            <a:ext cx="10908792" cy="2240280"/>
+          </a:xfrm>
+          <a:prstGeom prst="roundRect">
+            <a:avLst>
+              <a:gd name="adj" fmla="val 4082"/>
+            </a:avLst>
+          </a:prstGeom>
+          <a:solidFill>
+            <a:srgbClr val="FFFFFF"/>
+          </a:solidFill>
+          <a:ln/>
+          <a:effectLst>
+            <a:outerShdw sx="100000" sy="100000" kx="0" ky="0" algn="bl" rotWithShape="0" blurRad="76200" dist="25400" dir="5400000">
+              <a:srgbClr val="1C2321">
+                <a:alpha val="10000"/>
+              </a:srgbClr>
+            </a:outerShdw>
+          </a:effectLst>
+        </p:spPr>
       </p:sp>
       <p:graphicFrame>
         <p:nvGraphicFramePr>
-          <p:cNvPr id="13" name="Table 0"/>
-          <p:cNvGraphicFramePr>
-            <a:graphicFrameLocks noGrp="1"/>
-          </p:cNvGraphicFramePr>
-          <p:nvPr>
-            <p:extLst>
-              <p:ext uri="{D42A27DB-BD31-4B8C-83A1-F6EECF244321}">
-                <p14:modId xmlns:p14="http://schemas.microsoft.com/office/powerpoint/2010/main" val="1579011935"/>
-              </p:ext>
-            </p:extLst>
-          </p:nvPr>
+          <p:cNvPr id="9" name="Chart 0" descr=""/>
+          <p:cNvGraphicFramePr/>
+          <p:nvPr/>
         </p:nvGraphicFramePr>
         <p:xfrm>
-          <a:off x="640080" y="4526280"/>
-          <a:ext cx="10908792" cy="1828800"/>
+          <a:off x="822960" y="4224528"/>
+          <a:ext cx="10543032" cy="1600200"/>
         </p:xfrm>
-        <a:graphic>
-          <a:graphicData uri="http://schemas.openxmlformats.org/drawingml/2006/table">
-            <a:tbl>
-              <a:tblPr/>
-              <a:tblGrid>
-                <a:gridCol w="3200400"/>
-                <a:gridCol w="2569464"/>
-                <a:gridCol w="2569464"/>
-                <a:gridCol w="2569464"/>
-              </a:tblGrid>
-              <a:tr h="292608">
-                <a:tc>
-                  <a:txBody>
-                    <a:bodyPr/>
-                    <a:lstStyle/>
-                    <a:p>
-                      <a:pPr algn="ctr" indent="0" marL="0">
-                        <a:buNone/>
-                      </a:pPr>
-                      <a:r>
-                        <a:rPr lang="en-US" sz="1100" b="1" dirty="0">
-                          <a:solidFill>
-                            <a:srgbClr val="FFFFFF"/>
-                          </a:solidFill>
-                          <a:latin typeface="맑은 고딕" pitchFamily="34" charset="0"/>
-                          <a:ea typeface="맑은 고딕" pitchFamily="34" charset="-122"/>
-                          <a:cs typeface="맑은 고딕" pitchFamily="34" charset="-120"/>
-                        </a:rPr>
-                        <a:t>조건</a:t>
-                      </a:r>
-                      <a:endParaRPr lang="en-US" sz="1100" dirty="0">
-                        <a:latin typeface="맑은 고딕" charset="0"/>
-                        <a:ea typeface="맑은 고딕" charset="0"/>
-                        <a:cs typeface="맑은 고딕" charset="0"/>
-                      </a:endParaRPr>
-                    </a:p>
-                  </a:txBody>
-                  <a:tcPr marL="82296" marR="82296" marT="54864" marB="54864" anchor="ctr">
-                    <a:lnL w="6350" cap="flat" cmpd="sng" algn="ctr">
-                      <a:solidFill>
-                        <a:srgbClr val="DCE3EA"/>
-                      </a:solidFill>
-                      <a:prstDash val="solid"/>
-                      <a:round/>
-                      <a:headEnd type="none" w="med" len="med"/>
-                      <a:tailEnd type="none" w="med" len="med"/>
-                    </a:lnL>
-                    <a:lnR w="6350" cap="flat" cmpd="sng" algn="ctr">
-                      <a:solidFill>
-                        <a:srgbClr val="DCE3EA"/>
-                      </a:solidFill>
-                      <a:prstDash val="solid"/>
-                      <a:round/>
-                      <a:headEnd type="none" w="med" len="med"/>
-                      <a:tailEnd type="none" w="med" len="med"/>
-                    </a:lnR>
-                    <a:lnT w="6350" cap="flat" cmpd="sng" algn="ctr">
-                      <a:solidFill>
-                        <a:srgbClr val="DCE3EA"/>
-                      </a:solidFill>
-                      <a:prstDash val="solid"/>
-                      <a:round/>
-                      <a:headEnd type="none" w="med" len="med"/>
-                      <a:tailEnd type="none" w="med" len="med"/>
-                    </a:lnT>
-                    <a:lnB w="6350" cap="flat" cmpd="sng" algn="ctr">
-                      <a:solidFill>
-                        <a:srgbClr val="DCE3EA"/>
-                      </a:solidFill>
-                      <a:prstDash val="solid"/>
-                      <a:round/>
-                      <a:headEnd type="none" w="med" len="med"/>
-                      <a:tailEnd type="none" w="med" len="med"/>
-                    </a:lnB>
-                    <a:solidFill>
-                      <a:srgbClr val="1B3A5C"/>
-                    </a:solidFill>
-                  </a:tcPr>
-                </a:tc>
-                <a:tc>
-                  <a:txBody>
-                    <a:bodyPr/>
-                    <a:lstStyle/>
-                    <a:p>
-                      <a:pPr algn="ctr" indent="0" marL="0">
-                        <a:buNone/>
-                      </a:pPr>
-                      <a:r>
-                        <a:rPr lang="en-US" sz="1100" b="1" dirty="0">
-                          <a:solidFill>
-                            <a:srgbClr val="FFFFFF"/>
-                          </a:solidFill>
-                          <a:latin typeface="맑은 고딕" pitchFamily="34" charset="0"/>
-                          <a:ea typeface="맑은 고딕" pitchFamily="34" charset="-122"/>
-                          <a:cs typeface="맑은 고딕" pitchFamily="34" charset="-120"/>
-                        </a:rPr>
-                        <a:t>전체 평균</a:t>
-                      </a:r>
-                      <a:endParaRPr lang="en-US" sz="1100" dirty="0">
-                        <a:latin typeface="맑은 고딕" charset="0"/>
-                        <a:ea typeface="맑은 고딕" charset="0"/>
-                        <a:cs typeface="맑은 고딕" charset="0"/>
-                      </a:endParaRPr>
-                    </a:p>
-                  </a:txBody>
-                  <a:tcPr marL="82296" marR="82296" marT="54864" marB="54864" anchor="ctr">
-                    <a:lnL w="6350" cap="flat" cmpd="sng" algn="ctr">
-                      <a:solidFill>
-                        <a:srgbClr val="DCE3EA"/>
-                      </a:solidFill>
-                      <a:prstDash val="solid"/>
-                      <a:round/>
-                      <a:headEnd type="none" w="med" len="med"/>
-                      <a:tailEnd type="none" w="med" len="med"/>
-                    </a:lnL>
-                    <a:lnR w="6350" cap="flat" cmpd="sng" algn="ctr">
-                      <a:solidFill>
-                        <a:srgbClr val="DCE3EA"/>
-                      </a:solidFill>
-                      <a:prstDash val="solid"/>
-                      <a:round/>
-                      <a:headEnd type="none" w="med" len="med"/>
-                      <a:tailEnd type="none" w="med" len="med"/>
-                    </a:lnR>
-                    <a:lnT w="6350" cap="flat" cmpd="sng" algn="ctr">
-                      <a:solidFill>
-                        <a:srgbClr val="DCE3EA"/>
-                      </a:solidFill>
-                      <a:prstDash val="solid"/>
-                      <a:round/>
-                      <a:headEnd type="none" w="med" len="med"/>
-                      <a:tailEnd type="none" w="med" len="med"/>
-                    </a:lnT>
-                    <a:lnB w="6350" cap="flat" cmpd="sng" algn="ctr">
-                      <a:solidFill>
-                        <a:srgbClr val="DCE3EA"/>
-                      </a:solidFill>
-                      <a:prstDash val="solid"/>
-                      <a:round/>
-                      <a:headEnd type="none" w="med" len="med"/>
-                      <a:tailEnd type="none" w="med" len="med"/>
-                    </a:lnB>
-                    <a:solidFill>
-                      <a:srgbClr val="1B3A5C"/>
-                    </a:solidFill>
-                  </a:tcPr>
-                </a:tc>
-                <a:tc>
-                  <a:txBody>
-                    <a:bodyPr/>
-                    <a:lstStyle/>
-                    <a:p>
-                      <a:pPr algn="ctr" indent="0" marL="0">
-                        <a:buNone/>
-                      </a:pPr>
-                      <a:r>
-                        <a:rPr lang="en-US" sz="1100" b="1" dirty="0">
-                          <a:solidFill>
-                            <a:srgbClr val="FFFFFF"/>
-                          </a:solidFill>
-                          <a:latin typeface="맑은 고딕" pitchFamily="34" charset="0"/>
-                          <a:ea typeface="맑은 고딕" pitchFamily="34" charset="-122"/>
-                          <a:cs typeface="맑은 고딕" pitchFamily="34" charset="-120"/>
-                        </a:rPr>
-                        <a:t>우리 조(A2)</a:t>
-                      </a:r>
-                      <a:endParaRPr lang="en-US" sz="1100" dirty="0">
-                        <a:latin typeface="맑은 고딕" charset="0"/>
-                        <a:ea typeface="맑은 고딕" charset="0"/>
-                        <a:cs typeface="맑은 고딕" charset="0"/>
-                      </a:endParaRPr>
-                    </a:p>
-                  </a:txBody>
-                  <a:tcPr marL="82296" marR="82296" marT="54864" marB="54864" anchor="ctr">
-                    <a:lnL w="6350" cap="flat" cmpd="sng" algn="ctr">
-                      <a:solidFill>
-                        <a:srgbClr val="DCE3EA"/>
-                      </a:solidFill>
-                      <a:prstDash val="solid"/>
-                      <a:round/>
-                      <a:headEnd type="none" w="med" len="med"/>
-                      <a:tailEnd type="none" w="med" len="med"/>
-                    </a:lnL>
-                    <a:lnR w="6350" cap="flat" cmpd="sng" algn="ctr">
-                      <a:solidFill>
-                        <a:srgbClr val="DCE3EA"/>
-                      </a:solidFill>
-                      <a:prstDash val="solid"/>
-                      <a:round/>
-                      <a:headEnd type="none" w="med" len="med"/>
-                      <a:tailEnd type="none" w="med" len="med"/>
-                    </a:lnR>
-                    <a:lnT w="6350" cap="flat" cmpd="sng" algn="ctr">
-                      <a:solidFill>
-                        <a:srgbClr val="DCE3EA"/>
-                      </a:solidFill>
-                      <a:prstDash val="solid"/>
-                      <a:round/>
-                      <a:headEnd type="none" w="med" len="med"/>
-                      <a:tailEnd type="none" w="med" len="med"/>
-                    </a:lnT>
-                    <a:lnB w="6350" cap="flat" cmpd="sng" algn="ctr">
-                      <a:solidFill>
-                        <a:srgbClr val="DCE3EA"/>
-                      </a:solidFill>
-                      <a:prstDash val="solid"/>
-                      <a:round/>
-                      <a:headEnd type="none" w="med" len="med"/>
-                      <a:tailEnd type="none" w="med" len="med"/>
-                    </a:lnB>
-                    <a:solidFill>
-                      <a:srgbClr val="1B3A5C"/>
-                    </a:solidFill>
-                  </a:tcPr>
-                </a:tc>
-                <a:tc>
-                  <a:txBody>
-                    <a:bodyPr/>
-                    <a:lstStyle/>
-                    <a:p>
-                      <a:pPr algn="ctr" indent="0" marL="0">
-                        <a:buNone/>
-                      </a:pPr>
-                      <a:r>
-                        <a:rPr lang="en-US" sz="1100" b="1" dirty="0">
-                          <a:solidFill>
-                            <a:srgbClr val="FFFFFF"/>
-                          </a:solidFill>
-                          <a:latin typeface="맑은 고딕" pitchFamily="34" charset="0"/>
-                          <a:ea typeface="맑은 고딕" pitchFamily="34" charset="-122"/>
-                          <a:cs typeface="맑은 고딕" pitchFamily="34" charset="-120"/>
-                        </a:rPr>
-                        <a:t>차이(SD 배수)</a:t>
-                      </a:r>
-                      <a:endParaRPr lang="en-US" sz="1100" dirty="0">
-                        <a:latin typeface="맑은 고딕" charset="0"/>
-                        <a:ea typeface="맑은 고딕" charset="0"/>
-                        <a:cs typeface="맑은 고딕" charset="0"/>
-                      </a:endParaRPr>
-                    </a:p>
-                  </a:txBody>
-                  <a:tcPr marL="82296" marR="82296" marT="54864" marB="54864" anchor="ctr">
-                    <a:lnL w="6350" cap="flat" cmpd="sng" algn="ctr">
-                      <a:solidFill>
-                        <a:srgbClr val="DCE3EA"/>
-                      </a:solidFill>
-                      <a:prstDash val="solid"/>
-                      <a:round/>
-                      <a:headEnd type="none" w="med" len="med"/>
-                      <a:tailEnd type="none" w="med" len="med"/>
-                    </a:lnL>
-                    <a:lnR w="6350" cap="flat" cmpd="sng" algn="ctr">
-                      <a:solidFill>
-                        <a:srgbClr val="DCE3EA"/>
-                      </a:solidFill>
-                      <a:prstDash val="solid"/>
-                      <a:round/>
-                      <a:headEnd type="none" w="med" len="med"/>
-                      <a:tailEnd type="none" w="med" len="med"/>
-                    </a:lnR>
-                    <a:lnT w="6350" cap="flat" cmpd="sng" algn="ctr">
-                      <a:solidFill>
-                        <a:srgbClr val="DCE3EA"/>
-                      </a:solidFill>
-                      <a:prstDash val="solid"/>
-                      <a:round/>
-                      <a:headEnd type="none" w="med" len="med"/>
-                      <a:tailEnd type="none" w="med" len="med"/>
-                    </a:lnT>
-                    <a:lnB w="6350" cap="flat" cmpd="sng" algn="ctr">
-                      <a:solidFill>
-                        <a:srgbClr val="DCE3EA"/>
-                      </a:solidFill>
-                      <a:prstDash val="solid"/>
-                      <a:round/>
-                      <a:headEnd type="none" w="med" len="med"/>
-                      <a:tailEnd type="none" w="med" len="med"/>
-                    </a:lnB>
-                    <a:solidFill>
-                      <a:srgbClr val="1B3A5C"/>
-                    </a:solidFill>
-                  </a:tcPr>
-                </a:tc>
-              </a:tr>
-              <a:tr h="256032">
-                <a:tc>
-                  <a:txBody>
-                    <a:bodyPr/>
-                    <a:lstStyle/>
-                    <a:p>
-                      <a:pPr algn="ctr" indent="0" marL="0">
-                        <a:buNone/>
-                      </a:pPr>
-                      <a:r>
-                        <a:rPr lang="en-US" sz="1100" dirty="0">
-                          <a:solidFill>
-                            <a:srgbClr val="1C2733"/>
-                          </a:solidFill>
-                          <a:latin typeface="맑은 고딕" pitchFamily="34" charset="0"/>
-                          <a:ea typeface="맑은 고딕" pitchFamily="34" charset="-122"/>
-                          <a:cs typeface="맑은 고딕" pitchFamily="34" charset="-120"/>
-                        </a:rPr>
-                        <a:t>ZPC 15%↓</a:t>
-                      </a:r>
-                      <a:endParaRPr lang="en-US" sz="1100" dirty="0">
-                        <a:latin typeface="맑은 고딕" charset="0"/>
-                        <a:ea typeface="맑은 고딕" charset="0"/>
-                        <a:cs typeface="맑은 고딕" charset="0"/>
-                      </a:endParaRPr>
-                    </a:p>
-                  </a:txBody>
-                  <a:tcPr marL="82296" marR="82296" marT="54864" marB="54864" anchor="ctr">
-                    <a:lnL w="6350" cap="flat" cmpd="sng" algn="ctr">
-                      <a:solidFill>
-                        <a:srgbClr val="DCE3EA"/>
-                      </a:solidFill>
-                      <a:prstDash val="solid"/>
-                      <a:round/>
-                      <a:headEnd type="none" w="med" len="med"/>
-                      <a:tailEnd type="none" w="med" len="med"/>
-                    </a:lnL>
-                    <a:lnR w="6350" cap="flat" cmpd="sng" algn="ctr">
-                      <a:solidFill>
-                        <a:srgbClr val="DCE3EA"/>
-                      </a:solidFill>
-                      <a:prstDash val="solid"/>
-                      <a:round/>
-                      <a:headEnd type="none" w="med" len="med"/>
-                      <a:tailEnd type="none" w="med" len="med"/>
-                    </a:lnR>
-                    <a:lnT w="6350" cap="flat" cmpd="sng" algn="ctr">
-                      <a:solidFill>
-                        <a:srgbClr val="DCE3EA"/>
-                      </a:solidFill>
-                      <a:prstDash val="solid"/>
-                      <a:round/>
-                      <a:headEnd type="none" w="med" len="med"/>
-                      <a:tailEnd type="none" w="med" len="med"/>
-                    </a:lnT>
-                    <a:lnB w="6350" cap="flat" cmpd="sng" algn="ctr">
-                      <a:solidFill>
-                        <a:srgbClr val="DCE3EA"/>
-                      </a:solidFill>
-                      <a:prstDash val="solid"/>
-                      <a:round/>
-                      <a:headEnd type="none" w="med" len="med"/>
-                      <a:tailEnd type="none" w="med" len="med"/>
-                    </a:lnB>
-                  </a:tcPr>
-                </a:tc>
-                <a:tc>
-                  <a:txBody>
-                    <a:bodyPr/>
-                    <a:lstStyle/>
-                    <a:p>
-                      <a:pPr algn="ctr" indent="0" marL="0">
-                        <a:buNone/>
-                      </a:pPr>
-                      <a:r>
-                        <a:rPr lang="en-US" sz="1100" dirty="0">
-                          <a:solidFill>
-                            <a:srgbClr val="1C2733"/>
-                          </a:solidFill>
-                          <a:latin typeface="맑은 고딕" pitchFamily="34" charset="0"/>
-                          <a:ea typeface="맑은 고딕" pitchFamily="34" charset="-122"/>
-                          <a:cs typeface="맑은 고딕" pitchFamily="34" charset="-120"/>
-                        </a:rPr>
-                        <a:t>13:13</a:t>
-                      </a:r>
-                      <a:endParaRPr lang="en-US" sz="1100" dirty="0">
-                        <a:latin typeface="맑은 고딕" charset="0"/>
-                        <a:ea typeface="맑은 고딕" charset="0"/>
-                        <a:cs typeface="맑은 고딕" charset="0"/>
-                      </a:endParaRPr>
-                    </a:p>
-                  </a:txBody>
-                  <a:tcPr marL="82296" marR="82296" marT="54864" marB="54864" anchor="ctr">
-                    <a:lnL w="6350" cap="flat" cmpd="sng" algn="ctr">
-                      <a:solidFill>
-                        <a:srgbClr val="DCE3EA"/>
-                      </a:solidFill>
-                      <a:prstDash val="solid"/>
-                      <a:round/>
-                      <a:headEnd type="none" w="med" len="med"/>
-                      <a:tailEnd type="none" w="med" len="med"/>
-                    </a:lnL>
-                    <a:lnR w="6350" cap="flat" cmpd="sng" algn="ctr">
-                      <a:solidFill>
-                        <a:srgbClr val="DCE3EA"/>
-                      </a:solidFill>
-                      <a:prstDash val="solid"/>
-                      <a:round/>
-                      <a:headEnd type="none" w="med" len="med"/>
-                      <a:tailEnd type="none" w="med" len="med"/>
-                    </a:lnR>
-                    <a:lnT w="6350" cap="flat" cmpd="sng" algn="ctr">
-                      <a:solidFill>
-                        <a:srgbClr val="DCE3EA"/>
-                      </a:solidFill>
-                      <a:prstDash val="solid"/>
-                      <a:round/>
-                      <a:headEnd type="none" w="med" len="med"/>
-                      <a:tailEnd type="none" w="med" len="med"/>
-                    </a:lnT>
-                    <a:lnB w="6350" cap="flat" cmpd="sng" algn="ctr">
-                      <a:solidFill>
-                        <a:srgbClr val="DCE3EA"/>
-                      </a:solidFill>
-                      <a:prstDash val="solid"/>
-                      <a:round/>
-                      <a:headEnd type="none" w="med" len="med"/>
-                      <a:tailEnd type="none" w="med" len="med"/>
-                    </a:lnB>
-                  </a:tcPr>
-                </a:tc>
-                <a:tc>
-                  <a:txBody>
-                    <a:bodyPr/>
-                    <a:lstStyle/>
-                    <a:p>
-                      <a:pPr algn="ctr" indent="0" marL="0">
-                        <a:buNone/>
-                      </a:pPr>
-                      <a:r>
-                        <a:rPr lang="en-US" sz="1100" dirty="0">
-                          <a:solidFill>
-                            <a:srgbClr val="1C2733"/>
-                          </a:solidFill>
-                          <a:latin typeface="맑은 고딕" pitchFamily="34" charset="0"/>
-                          <a:ea typeface="맑은 고딕" pitchFamily="34" charset="-122"/>
-                          <a:cs typeface="맑은 고딕" pitchFamily="34" charset="-120"/>
-                        </a:rPr>
-                        <a:t>16:46</a:t>
-                      </a:r>
-                      <a:endParaRPr lang="en-US" sz="1100" dirty="0">
-                        <a:latin typeface="맑은 고딕" charset="0"/>
-                        <a:ea typeface="맑은 고딕" charset="0"/>
-                        <a:cs typeface="맑은 고딕" charset="0"/>
-                      </a:endParaRPr>
-                    </a:p>
-                  </a:txBody>
-                  <a:tcPr marL="82296" marR="82296" marT="54864" marB="54864" anchor="ctr">
-                    <a:lnL w="6350" cap="flat" cmpd="sng" algn="ctr">
-                      <a:solidFill>
-                        <a:srgbClr val="DCE3EA"/>
-                      </a:solidFill>
-                      <a:prstDash val="solid"/>
-                      <a:round/>
-                      <a:headEnd type="none" w="med" len="med"/>
-                      <a:tailEnd type="none" w="med" len="med"/>
-                    </a:lnL>
-                    <a:lnR w="6350" cap="flat" cmpd="sng" algn="ctr">
-                      <a:solidFill>
-                        <a:srgbClr val="DCE3EA"/>
-                      </a:solidFill>
-                      <a:prstDash val="solid"/>
-                      <a:round/>
-                      <a:headEnd type="none" w="med" len="med"/>
-                      <a:tailEnd type="none" w="med" len="med"/>
-                    </a:lnR>
-                    <a:lnT w="6350" cap="flat" cmpd="sng" algn="ctr">
-                      <a:solidFill>
-                        <a:srgbClr val="DCE3EA"/>
-                      </a:solidFill>
-                      <a:prstDash val="solid"/>
-                      <a:round/>
-                      <a:headEnd type="none" w="med" len="med"/>
-                      <a:tailEnd type="none" w="med" len="med"/>
-                    </a:lnT>
-                    <a:lnB w="6350" cap="flat" cmpd="sng" algn="ctr">
-                      <a:solidFill>
-                        <a:srgbClr val="DCE3EA"/>
-                      </a:solidFill>
-                      <a:prstDash val="solid"/>
-                      <a:round/>
-                      <a:headEnd type="none" w="med" len="med"/>
-                      <a:tailEnd type="none" w="med" len="med"/>
-                    </a:lnB>
-                  </a:tcPr>
-                </a:tc>
-                <a:tc>
-                  <a:txBody>
-                    <a:bodyPr/>
-                    <a:lstStyle/>
-                    <a:p>
-                      <a:pPr algn="ctr" indent="0" marL="0">
-                        <a:buNone/>
-                      </a:pPr>
-                      <a:r>
-                        <a:rPr lang="en-US" sz="1100" dirty="0">
-                          <a:solidFill>
-                            <a:srgbClr val="1C2733"/>
-                          </a:solidFill>
-                          <a:latin typeface="맑은 고딕" pitchFamily="34" charset="0"/>
-                          <a:ea typeface="맑은 고딕" pitchFamily="34" charset="-122"/>
-                          <a:cs typeface="맑은 고딕" pitchFamily="34" charset="-120"/>
-                        </a:rPr>
-                        <a:t>+0.9 SD</a:t>
-                      </a:r>
-                      <a:endParaRPr lang="en-US" sz="1100" dirty="0">
-                        <a:latin typeface="맑은 고딕" charset="0"/>
-                        <a:ea typeface="맑은 고딕" charset="0"/>
-                        <a:cs typeface="맑은 고딕" charset="0"/>
-                      </a:endParaRPr>
-                    </a:p>
-                  </a:txBody>
-                  <a:tcPr marL="82296" marR="82296" marT="54864" marB="54864" anchor="ctr">
-                    <a:lnL w="6350" cap="flat" cmpd="sng" algn="ctr">
-                      <a:solidFill>
-                        <a:srgbClr val="DCE3EA"/>
-                      </a:solidFill>
-                      <a:prstDash val="solid"/>
-                      <a:round/>
-                      <a:headEnd type="none" w="med" len="med"/>
-                      <a:tailEnd type="none" w="med" len="med"/>
-                    </a:lnL>
-                    <a:lnR w="6350" cap="flat" cmpd="sng" algn="ctr">
-                      <a:solidFill>
-                        <a:srgbClr val="DCE3EA"/>
-                      </a:solidFill>
-                      <a:prstDash val="solid"/>
-                      <a:round/>
-                      <a:headEnd type="none" w="med" len="med"/>
-                      <a:tailEnd type="none" w="med" len="med"/>
-                    </a:lnR>
-                    <a:lnT w="6350" cap="flat" cmpd="sng" algn="ctr">
-                      <a:solidFill>
-                        <a:srgbClr val="DCE3EA"/>
-                      </a:solidFill>
-                      <a:prstDash val="solid"/>
-                      <a:round/>
-                      <a:headEnd type="none" w="med" len="med"/>
-                      <a:tailEnd type="none" w="med" len="med"/>
-                    </a:lnT>
-                    <a:lnB w="6350" cap="flat" cmpd="sng" algn="ctr">
-                      <a:solidFill>
-                        <a:srgbClr val="DCE3EA"/>
-                      </a:solidFill>
-                      <a:prstDash val="solid"/>
-                      <a:round/>
-                      <a:headEnd type="none" w="med" len="med"/>
-                      <a:tailEnd type="none" w="med" len="med"/>
-                    </a:lnB>
-                  </a:tcPr>
-                </a:tc>
-              </a:tr>
-              <a:tr h="256032">
-                <a:tc>
-                  <a:txBody>
-                    <a:bodyPr/>
-                    <a:lstStyle/>
-                    <a:p>
-                      <a:pPr algn="ctr" indent="0" marL="0">
-                        <a:buNone/>
-                      </a:pPr>
-                      <a:r>
-                        <a:rPr lang="en-US" sz="1100" dirty="0">
-                          <a:solidFill>
-                            <a:srgbClr val="1C2733"/>
-                          </a:solidFill>
-                          <a:latin typeface="맑은 고딕" pitchFamily="34" charset="0"/>
-                          <a:ea typeface="맑은 고딕" pitchFamily="34" charset="-122"/>
-                          <a:cs typeface="맑은 고딕" pitchFamily="34" charset="-120"/>
-                        </a:rPr>
-                        <a:t>ZPC 정상</a:t>
-                      </a:r>
-                      <a:endParaRPr lang="en-US" sz="1100" dirty="0">
-                        <a:latin typeface="맑은 고딕" charset="0"/>
-                        <a:ea typeface="맑은 고딕" charset="0"/>
-                        <a:cs typeface="맑은 고딕" charset="0"/>
-                      </a:endParaRPr>
-                    </a:p>
-                  </a:txBody>
-                  <a:tcPr marL="82296" marR="82296" marT="54864" marB="54864" anchor="ctr">
-                    <a:lnL w="6350" cap="flat" cmpd="sng" algn="ctr">
-                      <a:solidFill>
-                        <a:srgbClr val="DCE3EA"/>
-                      </a:solidFill>
-                      <a:prstDash val="solid"/>
-                      <a:round/>
-                      <a:headEnd type="none" w="med" len="med"/>
-                      <a:tailEnd type="none" w="med" len="med"/>
-                    </a:lnL>
-                    <a:lnR w="6350" cap="flat" cmpd="sng" algn="ctr">
-                      <a:solidFill>
-                        <a:srgbClr val="DCE3EA"/>
-                      </a:solidFill>
-                      <a:prstDash val="solid"/>
-                      <a:round/>
-                      <a:headEnd type="none" w="med" len="med"/>
-                      <a:tailEnd type="none" w="med" len="med"/>
-                    </a:lnR>
-                    <a:lnT w="6350" cap="flat" cmpd="sng" algn="ctr">
-                      <a:solidFill>
-                        <a:srgbClr val="DCE3EA"/>
-                      </a:solidFill>
-                      <a:prstDash val="solid"/>
-                      <a:round/>
-                      <a:headEnd type="none" w="med" len="med"/>
-                      <a:tailEnd type="none" w="med" len="med"/>
-                    </a:lnT>
-                    <a:lnB w="6350" cap="flat" cmpd="sng" algn="ctr">
-                      <a:solidFill>
-                        <a:srgbClr val="DCE3EA"/>
-                      </a:solidFill>
-                      <a:prstDash val="solid"/>
-                      <a:round/>
-                      <a:headEnd type="none" w="med" len="med"/>
-                      <a:tailEnd type="none" w="med" len="med"/>
-                    </a:lnB>
-                  </a:tcPr>
-                </a:tc>
-                <a:tc>
-                  <a:txBody>
-                    <a:bodyPr/>
-                    <a:lstStyle/>
-                    <a:p>
-                      <a:pPr algn="ctr" indent="0" marL="0">
-                        <a:buNone/>
-                      </a:pPr>
-                      <a:r>
-                        <a:rPr lang="en-US" sz="1100" dirty="0">
-                          <a:solidFill>
-                            <a:srgbClr val="1C2733"/>
-                          </a:solidFill>
-                          <a:latin typeface="맑은 고딕" pitchFamily="34" charset="0"/>
-                          <a:ea typeface="맑은 고딕" pitchFamily="34" charset="-122"/>
-                          <a:cs typeface="맑은 고딕" pitchFamily="34" charset="-120"/>
-                        </a:rPr>
-                        <a:t>11:13</a:t>
-                      </a:r>
-                      <a:endParaRPr lang="en-US" sz="1100" dirty="0">
-                        <a:latin typeface="맑은 고딕" charset="0"/>
-                        <a:ea typeface="맑은 고딕" charset="0"/>
-                        <a:cs typeface="맑은 고딕" charset="0"/>
-                      </a:endParaRPr>
-                    </a:p>
-                  </a:txBody>
-                  <a:tcPr marL="82296" marR="82296" marT="54864" marB="54864" anchor="ctr">
-                    <a:lnL w="6350" cap="flat" cmpd="sng" algn="ctr">
-                      <a:solidFill>
-                        <a:srgbClr val="DCE3EA"/>
-                      </a:solidFill>
-                      <a:prstDash val="solid"/>
-                      <a:round/>
-                      <a:headEnd type="none" w="med" len="med"/>
-                      <a:tailEnd type="none" w="med" len="med"/>
-                    </a:lnL>
-                    <a:lnR w="6350" cap="flat" cmpd="sng" algn="ctr">
-                      <a:solidFill>
-                        <a:srgbClr val="DCE3EA"/>
-                      </a:solidFill>
-                      <a:prstDash val="solid"/>
-                      <a:round/>
-                      <a:headEnd type="none" w="med" len="med"/>
-                      <a:tailEnd type="none" w="med" len="med"/>
-                    </a:lnR>
-                    <a:lnT w="6350" cap="flat" cmpd="sng" algn="ctr">
-                      <a:solidFill>
-                        <a:srgbClr val="DCE3EA"/>
-                      </a:solidFill>
-                      <a:prstDash val="solid"/>
-                      <a:round/>
-                      <a:headEnd type="none" w="med" len="med"/>
-                      <a:tailEnd type="none" w="med" len="med"/>
-                    </a:lnT>
-                    <a:lnB w="6350" cap="flat" cmpd="sng" algn="ctr">
-                      <a:solidFill>
-                        <a:srgbClr val="DCE3EA"/>
-                      </a:solidFill>
-                      <a:prstDash val="solid"/>
-                      <a:round/>
-                      <a:headEnd type="none" w="med" len="med"/>
-                      <a:tailEnd type="none" w="med" len="med"/>
-                    </a:lnB>
-                  </a:tcPr>
-                </a:tc>
-                <a:tc>
-                  <a:txBody>
-                    <a:bodyPr/>
-                    <a:lstStyle/>
-                    <a:p>
-                      <a:pPr algn="ctr" indent="0" marL="0">
-                        <a:buNone/>
-                      </a:pPr>
-                      <a:r>
-                        <a:rPr lang="en-US" sz="1100" dirty="0">
-                          <a:solidFill>
-                            <a:srgbClr val="1C2733"/>
-                          </a:solidFill>
-                          <a:latin typeface="맑은 고딕" pitchFamily="34" charset="0"/>
-                          <a:ea typeface="맑은 고딕" pitchFamily="34" charset="-122"/>
-                          <a:cs typeface="맑은 고딕" pitchFamily="34" charset="-120"/>
-                        </a:rPr>
-                        <a:t>16:20</a:t>
-                      </a:r>
-                      <a:endParaRPr lang="en-US" sz="1100" dirty="0">
-                        <a:latin typeface="맑은 고딕" charset="0"/>
-                        <a:ea typeface="맑은 고딕" charset="0"/>
-                        <a:cs typeface="맑은 고딕" charset="0"/>
-                      </a:endParaRPr>
-                    </a:p>
-                  </a:txBody>
-                  <a:tcPr marL="82296" marR="82296" marT="54864" marB="54864" anchor="ctr">
-                    <a:lnL w="6350" cap="flat" cmpd="sng" algn="ctr">
-                      <a:solidFill>
-                        <a:srgbClr val="DCE3EA"/>
-                      </a:solidFill>
-                      <a:prstDash val="solid"/>
-                      <a:round/>
-                      <a:headEnd type="none" w="med" len="med"/>
-                      <a:tailEnd type="none" w="med" len="med"/>
-                    </a:lnL>
-                    <a:lnR w="6350" cap="flat" cmpd="sng" algn="ctr">
-                      <a:solidFill>
-                        <a:srgbClr val="DCE3EA"/>
-                      </a:solidFill>
-                      <a:prstDash val="solid"/>
-                      <a:round/>
-                      <a:headEnd type="none" w="med" len="med"/>
-                      <a:tailEnd type="none" w="med" len="med"/>
-                    </a:lnR>
-                    <a:lnT w="6350" cap="flat" cmpd="sng" algn="ctr">
-                      <a:solidFill>
-                        <a:srgbClr val="DCE3EA"/>
-                      </a:solidFill>
-                      <a:prstDash val="solid"/>
-                      <a:round/>
-                      <a:headEnd type="none" w="med" len="med"/>
-                      <a:tailEnd type="none" w="med" len="med"/>
-                    </a:lnT>
-                    <a:lnB w="6350" cap="flat" cmpd="sng" algn="ctr">
-                      <a:solidFill>
-                        <a:srgbClr val="DCE3EA"/>
-                      </a:solidFill>
-                      <a:prstDash val="solid"/>
-                      <a:round/>
-                      <a:headEnd type="none" w="med" len="med"/>
-                      <a:tailEnd type="none" w="med" len="med"/>
-                    </a:lnB>
-                  </a:tcPr>
-                </a:tc>
-                <a:tc>
-                  <a:txBody>
-                    <a:bodyPr/>
-                    <a:lstStyle/>
-                    <a:p>
-                      <a:pPr algn="ctr" indent="0" marL="0">
-                        <a:buNone/>
-                      </a:pPr>
-                      <a:r>
-                        <a:rPr lang="en-US" sz="1100" dirty="0">
-                          <a:solidFill>
-                            <a:srgbClr val="1C2733"/>
-                          </a:solidFill>
-                          <a:latin typeface="맑은 고딕" pitchFamily="34" charset="0"/>
-                          <a:ea typeface="맑은 고딕" pitchFamily="34" charset="-122"/>
-                          <a:cs typeface="맑은 고딕" pitchFamily="34" charset="-120"/>
-                        </a:rPr>
-                        <a:t>+1.3 SD</a:t>
-                      </a:r>
-                      <a:endParaRPr lang="en-US" sz="1100" dirty="0">
-                        <a:latin typeface="맑은 고딕" charset="0"/>
-                        <a:ea typeface="맑은 고딕" charset="0"/>
-                        <a:cs typeface="맑은 고딕" charset="0"/>
-                      </a:endParaRPr>
-                    </a:p>
-                  </a:txBody>
-                  <a:tcPr marL="82296" marR="82296" marT="54864" marB="54864" anchor="ctr">
-                    <a:lnL w="6350" cap="flat" cmpd="sng" algn="ctr">
-                      <a:solidFill>
-                        <a:srgbClr val="DCE3EA"/>
-                      </a:solidFill>
-                      <a:prstDash val="solid"/>
-                      <a:round/>
-                      <a:headEnd type="none" w="med" len="med"/>
-                      <a:tailEnd type="none" w="med" len="med"/>
-                    </a:lnL>
-                    <a:lnR w="6350" cap="flat" cmpd="sng" algn="ctr">
-                      <a:solidFill>
-                        <a:srgbClr val="DCE3EA"/>
-                      </a:solidFill>
-                      <a:prstDash val="solid"/>
-                      <a:round/>
-                      <a:headEnd type="none" w="med" len="med"/>
-                      <a:tailEnd type="none" w="med" len="med"/>
-                    </a:lnR>
-                    <a:lnT w="6350" cap="flat" cmpd="sng" algn="ctr">
-                      <a:solidFill>
-                        <a:srgbClr val="DCE3EA"/>
-                      </a:solidFill>
-                      <a:prstDash val="solid"/>
-                      <a:round/>
-                      <a:headEnd type="none" w="med" len="med"/>
-                      <a:tailEnd type="none" w="med" len="med"/>
-                    </a:lnT>
-                    <a:lnB w="6350" cap="flat" cmpd="sng" algn="ctr">
-                      <a:solidFill>
-                        <a:srgbClr val="DCE3EA"/>
-                      </a:solidFill>
-                      <a:prstDash val="solid"/>
-                      <a:round/>
-                      <a:headEnd type="none" w="med" len="med"/>
-                      <a:tailEnd type="none" w="med" len="med"/>
-                    </a:lnB>
-                  </a:tcPr>
-                </a:tc>
-              </a:tr>
-              <a:tr h="256032">
-                <a:tc>
-                  <a:txBody>
-                    <a:bodyPr/>
-                    <a:lstStyle/>
-                    <a:p>
-                      <a:pPr algn="ctr" indent="0" marL="0">
-                        <a:buNone/>
-                      </a:pPr>
-                      <a:r>
-                        <a:rPr lang="en-US" sz="1100" dirty="0">
-                          <a:solidFill>
-                            <a:srgbClr val="1C2733"/>
-                          </a:solidFill>
-                          <a:latin typeface="맑은 고딕" pitchFamily="34" charset="0"/>
-                          <a:ea typeface="맑은 고딕" pitchFamily="34" charset="-122"/>
-                          <a:cs typeface="맑은 고딕" pitchFamily="34" charset="-120"/>
-                        </a:rPr>
-                        <a:t>ZPC 15%↑</a:t>
-                      </a:r>
-                      <a:endParaRPr lang="en-US" sz="1100" dirty="0">
-                        <a:latin typeface="맑은 고딕" charset="0"/>
-                        <a:ea typeface="맑은 고딕" charset="0"/>
-                        <a:cs typeface="맑은 고딕" charset="0"/>
-                      </a:endParaRPr>
-                    </a:p>
-                  </a:txBody>
-                  <a:tcPr marL="82296" marR="82296" marT="54864" marB="54864" anchor="ctr">
-                    <a:lnL w="6350" cap="flat" cmpd="sng" algn="ctr">
-                      <a:solidFill>
-                        <a:srgbClr val="DCE3EA"/>
-                      </a:solidFill>
-                      <a:prstDash val="solid"/>
-                      <a:round/>
-                      <a:headEnd type="none" w="med" len="med"/>
-                      <a:tailEnd type="none" w="med" len="med"/>
-                    </a:lnL>
-                    <a:lnR w="6350" cap="flat" cmpd="sng" algn="ctr">
-                      <a:solidFill>
-                        <a:srgbClr val="DCE3EA"/>
-                      </a:solidFill>
-                      <a:prstDash val="solid"/>
-                      <a:round/>
-                      <a:headEnd type="none" w="med" len="med"/>
-                      <a:tailEnd type="none" w="med" len="med"/>
-                    </a:lnR>
-                    <a:lnT w="6350" cap="flat" cmpd="sng" algn="ctr">
-                      <a:solidFill>
-                        <a:srgbClr val="DCE3EA"/>
-                      </a:solidFill>
-                      <a:prstDash val="solid"/>
-                      <a:round/>
-                      <a:headEnd type="none" w="med" len="med"/>
-                      <a:tailEnd type="none" w="med" len="med"/>
-                    </a:lnT>
-                    <a:lnB w="6350" cap="flat" cmpd="sng" algn="ctr">
-                      <a:solidFill>
-                        <a:srgbClr val="DCE3EA"/>
-                      </a:solidFill>
-                      <a:prstDash val="solid"/>
-                      <a:round/>
-                      <a:headEnd type="none" w="med" len="med"/>
-                      <a:tailEnd type="none" w="med" len="med"/>
-                    </a:lnB>
-                  </a:tcPr>
-                </a:tc>
-                <a:tc>
-                  <a:txBody>
-                    <a:bodyPr/>
-                    <a:lstStyle/>
-                    <a:p>
-                      <a:pPr algn="ctr" indent="0" marL="0">
-                        <a:buNone/>
-                      </a:pPr>
-                      <a:r>
-                        <a:rPr lang="en-US" sz="1100" dirty="0">
-                          <a:solidFill>
-                            <a:srgbClr val="1C2733"/>
-                          </a:solidFill>
-                          <a:latin typeface="맑은 고딕" pitchFamily="34" charset="0"/>
-                          <a:ea typeface="맑은 고딕" pitchFamily="34" charset="-122"/>
-                          <a:cs typeface="맑은 고딕" pitchFamily="34" charset="-120"/>
-                        </a:rPr>
-                        <a:t>7:40</a:t>
-                      </a:r>
-                      <a:endParaRPr lang="en-US" sz="1100" dirty="0">
-                        <a:latin typeface="맑은 고딕" charset="0"/>
-                        <a:ea typeface="맑은 고딕" charset="0"/>
-                        <a:cs typeface="맑은 고딕" charset="0"/>
-                      </a:endParaRPr>
-                    </a:p>
-                  </a:txBody>
-                  <a:tcPr marL="82296" marR="82296" marT="54864" marB="54864" anchor="ctr">
-                    <a:lnL w="6350" cap="flat" cmpd="sng" algn="ctr">
-                      <a:solidFill>
-                        <a:srgbClr val="DCE3EA"/>
-                      </a:solidFill>
-                      <a:prstDash val="solid"/>
-                      <a:round/>
-                      <a:headEnd type="none" w="med" len="med"/>
-                      <a:tailEnd type="none" w="med" len="med"/>
-                    </a:lnL>
-                    <a:lnR w="6350" cap="flat" cmpd="sng" algn="ctr">
-                      <a:solidFill>
-                        <a:srgbClr val="DCE3EA"/>
-                      </a:solidFill>
-                      <a:prstDash val="solid"/>
-                      <a:round/>
-                      <a:headEnd type="none" w="med" len="med"/>
-                      <a:tailEnd type="none" w="med" len="med"/>
-                    </a:lnR>
-                    <a:lnT w="6350" cap="flat" cmpd="sng" algn="ctr">
-                      <a:solidFill>
-                        <a:srgbClr val="DCE3EA"/>
-                      </a:solidFill>
-                      <a:prstDash val="solid"/>
-                      <a:round/>
-                      <a:headEnd type="none" w="med" len="med"/>
-                      <a:tailEnd type="none" w="med" len="med"/>
-                    </a:lnT>
-                    <a:lnB w="6350" cap="flat" cmpd="sng" algn="ctr">
-                      <a:solidFill>
-                        <a:srgbClr val="DCE3EA"/>
-                      </a:solidFill>
-                      <a:prstDash val="solid"/>
-                      <a:round/>
-                      <a:headEnd type="none" w="med" len="med"/>
-                      <a:tailEnd type="none" w="med" len="med"/>
-                    </a:lnB>
-                  </a:tcPr>
-                </a:tc>
-                <a:tc>
-                  <a:txBody>
-                    <a:bodyPr/>
-                    <a:lstStyle/>
-                    <a:p>
-                      <a:pPr algn="ctr" indent="0" marL="0">
-                        <a:buNone/>
-                      </a:pPr>
-                      <a:r>
-                        <a:rPr lang="en-US" sz="1100" dirty="0">
-                          <a:solidFill>
-                            <a:srgbClr val="1C2733"/>
-                          </a:solidFill>
-                          <a:latin typeface="맑은 고딕" pitchFamily="34" charset="0"/>
-                          <a:ea typeface="맑은 고딕" pitchFamily="34" charset="-122"/>
-                          <a:cs typeface="맑은 고딕" pitchFamily="34" charset="-120"/>
-                        </a:rPr>
-                        <a:t>12:45</a:t>
-                      </a:r>
-                      <a:endParaRPr lang="en-US" sz="1100" dirty="0">
-                        <a:latin typeface="맑은 고딕" charset="0"/>
-                        <a:ea typeface="맑은 고딕" charset="0"/>
-                        <a:cs typeface="맑은 고딕" charset="0"/>
-                      </a:endParaRPr>
-                    </a:p>
-                  </a:txBody>
-                  <a:tcPr marL="82296" marR="82296" marT="54864" marB="54864" anchor="ctr">
-                    <a:lnL w="6350" cap="flat" cmpd="sng" algn="ctr">
-                      <a:solidFill>
-                        <a:srgbClr val="DCE3EA"/>
-                      </a:solidFill>
-                      <a:prstDash val="solid"/>
-                      <a:round/>
-                      <a:headEnd type="none" w="med" len="med"/>
-                      <a:tailEnd type="none" w="med" len="med"/>
-                    </a:lnL>
-                    <a:lnR w="6350" cap="flat" cmpd="sng" algn="ctr">
-                      <a:solidFill>
-                        <a:srgbClr val="DCE3EA"/>
-                      </a:solidFill>
-                      <a:prstDash val="solid"/>
-                      <a:round/>
-                      <a:headEnd type="none" w="med" len="med"/>
-                      <a:tailEnd type="none" w="med" len="med"/>
-                    </a:lnR>
-                    <a:lnT w="6350" cap="flat" cmpd="sng" algn="ctr">
-                      <a:solidFill>
-                        <a:srgbClr val="DCE3EA"/>
-                      </a:solidFill>
-                      <a:prstDash val="solid"/>
-                      <a:round/>
-                      <a:headEnd type="none" w="med" len="med"/>
-                      <a:tailEnd type="none" w="med" len="med"/>
-                    </a:lnT>
-                    <a:lnB w="6350" cap="flat" cmpd="sng" algn="ctr">
-                      <a:solidFill>
-                        <a:srgbClr val="DCE3EA"/>
-                      </a:solidFill>
-                      <a:prstDash val="solid"/>
-                      <a:round/>
-                      <a:headEnd type="none" w="med" len="med"/>
-                      <a:tailEnd type="none" w="med" len="med"/>
-                    </a:lnB>
-                  </a:tcPr>
-                </a:tc>
-                <a:tc>
-                  <a:txBody>
-                    <a:bodyPr/>
-                    <a:lstStyle/>
-                    <a:p>
-                      <a:pPr algn="ctr" indent="0" marL="0">
-                        <a:buNone/>
-                      </a:pPr>
-                      <a:r>
-                        <a:rPr lang="en-US" sz="1100" dirty="0">
-                          <a:solidFill>
-                            <a:srgbClr val="1C2733"/>
-                          </a:solidFill>
-                          <a:latin typeface="맑은 고딕" pitchFamily="34" charset="0"/>
-                          <a:ea typeface="맑은 고딕" pitchFamily="34" charset="-122"/>
-                          <a:cs typeface="맑은 고딕" pitchFamily="34" charset="-120"/>
-                        </a:rPr>
-                        <a:t>+1.9 SD</a:t>
-                      </a:r>
-                      <a:endParaRPr lang="en-US" sz="1100" dirty="0">
-                        <a:latin typeface="맑은 고딕" charset="0"/>
-                        <a:ea typeface="맑은 고딕" charset="0"/>
-                        <a:cs typeface="맑은 고딕" charset="0"/>
-                      </a:endParaRPr>
-                    </a:p>
-                  </a:txBody>
-                  <a:tcPr marL="82296" marR="82296" marT="54864" marB="54864" anchor="ctr">
-                    <a:lnL w="6350" cap="flat" cmpd="sng" algn="ctr">
-                      <a:solidFill>
-                        <a:srgbClr val="DCE3EA"/>
-                      </a:solidFill>
-                      <a:prstDash val="solid"/>
-                      <a:round/>
-                      <a:headEnd type="none" w="med" len="med"/>
-                      <a:tailEnd type="none" w="med" len="med"/>
-                    </a:lnL>
-                    <a:lnR w="6350" cap="flat" cmpd="sng" algn="ctr">
-                      <a:solidFill>
-                        <a:srgbClr val="DCE3EA"/>
-                      </a:solidFill>
-                      <a:prstDash val="solid"/>
-                      <a:round/>
-                      <a:headEnd type="none" w="med" len="med"/>
-                      <a:tailEnd type="none" w="med" len="med"/>
-                    </a:lnR>
-                    <a:lnT w="6350" cap="flat" cmpd="sng" algn="ctr">
-                      <a:solidFill>
-                        <a:srgbClr val="DCE3EA"/>
-                      </a:solidFill>
-                      <a:prstDash val="solid"/>
-                      <a:round/>
-                      <a:headEnd type="none" w="med" len="med"/>
-                      <a:tailEnd type="none" w="med" len="med"/>
-                    </a:lnT>
-                    <a:lnB w="6350" cap="flat" cmpd="sng" algn="ctr">
-                      <a:solidFill>
-                        <a:srgbClr val="DCE3EA"/>
-                      </a:solidFill>
-                      <a:prstDash val="solid"/>
-                      <a:round/>
-                      <a:headEnd type="none" w="med" len="med"/>
-                      <a:tailEnd type="none" w="med" len="med"/>
-                    </a:lnB>
-                  </a:tcPr>
-                </a:tc>
-              </a:tr>
-              <a:tr h="256032">
-                <a:tc>
-                  <a:txBody>
-                    <a:bodyPr/>
-                    <a:lstStyle/>
-                    <a:p>
-                      <a:pPr algn="ctr" indent="0" marL="0">
-                        <a:buNone/>
-                      </a:pPr>
-                      <a:r>
-                        <a:rPr lang="en-US" sz="1100" dirty="0">
-                          <a:solidFill>
-                            <a:srgbClr val="1C2733"/>
-                          </a:solidFill>
-                          <a:latin typeface="맑은 고딕" pitchFamily="34" charset="0"/>
-                          <a:ea typeface="맑은 고딕" pitchFamily="34" charset="-122"/>
-                          <a:cs typeface="맑은 고딕" pitchFamily="34" charset="-120"/>
-                        </a:rPr>
-                        <a:t>ZPC 15%↑+냉각판</a:t>
-                      </a:r>
-                      <a:endParaRPr lang="en-US" sz="1100" dirty="0">
-                        <a:latin typeface="맑은 고딕" charset="0"/>
-                        <a:ea typeface="맑은 고딕" charset="0"/>
-                        <a:cs typeface="맑은 고딕" charset="0"/>
-                      </a:endParaRPr>
-                    </a:p>
-                  </a:txBody>
-                  <a:tcPr marL="82296" marR="82296" marT="54864" marB="54864" anchor="ctr">
-                    <a:lnL w="6350" cap="flat" cmpd="sng" algn="ctr">
-                      <a:solidFill>
-                        <a:srgbClr val="DCE3EA"/>
-                      </a:solidFill>
-                      <a:prstDash val="solid"/>
-                      <a:round/>
-                      <a:headEnd type="none" w="med" len="med"/>
-                      <a:tailEnd type="none" w="med" len="med"/>
-                    </a:lnL>
-                    <a:lnR w="6350" cap="flat" cmpd="sng" algn="ctr">
-                      <a:solidFill>
-                        <a:srgbClr val="DCE3EA"/>
-                      </a:solidFill>
-                      <a:prstDash val="solid"/>
-                      <a:round/>
-                      <a:headEnd type="none" w="med" len="med"/>
-                      <a:tailEnd type="none" w="med" len="med"/>
-                    </a:lnR>
-                    <a:lnT w="6350" cap="flat" cmpd="sng" algn="ctr">
-                      <a:solidFill>
-                        <a:srgbClr val="DCE3EA"/>
-                      </a:solidFill>
-                      <a:prstDash val="solid"/>
-                      <a:round/>
-                      <a:headEnd type="none" w="med" len="med"/>
-                      <a:tailEnd type="none" w="med" len="med"/>
-                    </a:lnT>
-                    <a:lnB w="6350" cap="flat" cmpd="sng" algn="ctr">
-                      <a:solidFill>
-                        <a:srgbClr val="DCE3EA"/>
-                      </a:solidFill>
-                      <a:prstDash val="solid"/>
-                      <a:round/>
-                      <a:headEnd type="none" w="med" len="med"/>
-                      <a:tailEnd type="none" w="med" len="med"/>
-                    </a:lnB>
-                  </a:tcPr>
-                </a:tc>
-                <a:tc>
-                  <a:txBody>
-                    <a:bodyPr/>
-                    <a:lstStyle/>
-                    <a:p>
-                      <a:pPr algn="ctr" indent="0" marL="0">
-                        <a:buNone/>
-                      </a:pPr>
-                      <a:r>
-                        <a:rPr lang="en-US" sz="1100" dirty="0">
-                          <a:solidFill>
-                            <a:srgbClr val="1C2733"/>
-                          </a:solidFill>
-                          <a:latin typeface="맑은 고딕" pitchFamily="34" charset="0"/>
-                          <a:ea typeface="맑은 고딕" pitchFamily="34" charset="-122"/>
-                          <a:cs typeface="맑은 고딕" pitchFamily="34" charset="-120"/>
-                        </a:rPr>
-                        <a:t>10:07</a:t>
-                      </a:r>
-                      <a:endParaRPr lang="en-US" sz="1100" dirty="0">
-                        <a:latin typeface="맑은 고딕" charset="0"/>
-                        <a:ea typeface="맑은 고딕" charset="0"/>
-                        <a:cs typeface="맑은 고딕" charset="0"/>
-                      </a:endParaRPr>
-                    </a:p>
-                  </a:txBody>
-                  <a:tcPr marL="82296" marR="82296" marT="54864" marB="54864" anchor="ctr">
-                    <a:lnL w="6350" cap="flat" cmpd="sng" algn="ctr">
-                      <a:solidFill>
-                        <a:srgbClr val="DCE3EA"/>
-                      </a:solidFill>
-                      <a:prstDash val="solid"/>
-                      <a:round/>
-                      <a:headEnd type="none" w="med" len="med"/>
-                      <a:tailEnd type="none" w="med" len="med"/>
-                    </a:lnL>
-                    <a:lnR w="6350" cap="flat" cmpd="sng" algn="ctr">
-                      <a:solidFill>
-                        <a:srgbClr val="DCE3EA"/>
-                      </a:solidFill>
-                      <a:prstDash val="solid"/>
-                      <a:round/>
-                      <a:headEnd type="none" w="med" len="med"/>
-                      <a:tailEnd type="none" w="med" len="med"/>
-                    </a:lnR>
-                    <a:lnT w="6350" cap="flat" cmpd="sng" algn="ctr">
-                      <a:solidFill>
-                        <a:srgbClr val="DCE3EA"/>
-                      </a:solidFill>
-                      <a:prstDash val="solid"/>
-                      <a:round/>
-                      <a:headEnd type="none" w="med" len="med"/>
-                      <a:tailEnd type="none" w="med" len="med"/>
-                    </a:lnT>
-                    <a:lnB w="6350" cap="flat" cmpd="sng" algn="ctr">
-                      <a:solidFill>
-                        <a:srgbClr val="DCE3EA"/>
-                      </a:solidFill>
-                      <a:prstDash val="solid"/>
-                      <a:round/>
-                      <a:headEnd type="none" w="med" len="med"/>
-                      <a:tailEnd type="none" w="med" len="med"/>
-                    </a:lnB>
-                  </a:tcPr>
-                </a:tc>
-                <a:tc>
-                  <a:txBody>
-                    <a:bodyPr/>
-                    <a:lstStyle/>
-                    <a:p>
-                      <a:pPr algn="ctr" indent="0" marL="0">
-                        <a:buNone/>
-                      </a:pPr>
-                      <a:r>
-                        <a:rPr lang="en-US" sz="1100" dirty="0">
-                          <a:solidFill>
-                            <a:srgbClr val="1C2733"/>
-                          </a:solidFill>
-                          <a:latin typeface="맑은 고딕" pitchFamily="34" charset="0"/>
-                          <a:ea typeface="맑은 고딕" pitchFamily="34" charset="-122"/>
-                          <a:cs typeface="맑은 고딕" pitchFamily="34" charset="-120"/>
-                        </a:rPr>
-                        <a:t>12:03</a:t>
-                      </a:r>
-                      <a:endParaRPr lang="en-US" sz="1100" dirty="0">
-                        <a:latin typeface="맑은 고딕" charset="0"/>
-                        <a:ea typeface="맑은 고딕" charset="0"/>
-                        <a:cs typeface="맑은 고딕" charset="0"/>
-                      </a:endParaRPr>
-                    </a:p>
-                  </a:txBody>
-                  <a:tcPr marL="82296" marR="82296" marT="54864" marB="54864" anchor="ctr">
-                    <a:lnL w="6350" cap="flat" cmpd="sng" algn="ctr">
-                      <a:solidFill>
-                        <a:srgbClr val="DCE3EA"/>
-                      </a:solidFill>
-                      <a:prstDash val="solid"/>
-                      <a:round/>
-                      <a:headEnd type="none" w="med" len="med"/>
-                      <a:tailEnd type="none" w="med" len="med"/>
-                    </a:lnL>
-                    <a:lnR w="6350" cap="flat" cmpd="sng" algn="ctr">
-                      <a:solidFill>
-                        <a:srgbClr val="DCE3EA"/>
-                      </a:solidFill>
-                      <a:prstDash val="solid"/>
-                      <a:round/>
-                      <a:headEnd type="none" w="med" len="med"/>
-                      <a:tailEnd type="none" w="med" len="med"/>
-                    </a:lnR>
-                    <a:lnT w="6350" cap="flat" cmpd="sng" algn="ctr">
-                      <a:solidFill>
-                        <a:srgbClr val="DCE3EA"/>
-                      </a:solidFill>
-                      <a:prstDash val="solid"/>
-                      <a:round/>
-                      <a:headEnd type="none" w="med" len="med"/>
-                      <a:tailEnd type="none" w="med" len="med"/>
-                    </a:lnT>
-                    <a:lnB w="6350" cap="flat" cmpd="sng" algn="ctr">
-                      <a:solidFill>
-                        <a:srgbClr val="DCE3EA"/>
-                      </a:solidFill>
-                      <a:prstDash val="solid"/>
-                      <a:round/>
-                      <a:headEnd type="none" w="med" len="med"/>
-                      <a:tailEnd type="none" w="med" len="med"/>
-                    </a:lnB>
-                  </a:tcPr>
-                </a:tc>
-                <a:tc>
-                  <a:txBody>
-                    <a:bodyPr/>
-                    <a:lstStyle/>
-                    <a:p>
-                      <a:pPr algn="ctr" indent="0" marL="0">
-                        <a:buNone/>
-                      </a:pPr>
-                      <a:r>
-                        <a:rPr lang="en-US" sz="1100" dirty="0">
-                          <a:solidFill>
-                            <a:srgbClr val="1C2733"/>
-                          </a:solidFill>
-                          <a:latin typeface="맑은 고딕" pitchFamily="34" charset="0"/>
-                          <a:ea typeface="맑은 고딕" pitchFamily="34" charset="-122"/>
-                          <a:cs typeface="맑은 고딕" pitchFamily="34" charset="-120"/>
-                        </a:rPr>
-                        <a:t>+0.9 SD</a:t>
-                      </a:r>
-                      <a:endParaRPr lang="en-US" sz="1100" dirty="0">
-                        <a:latin typeface="맑은 고딕" charset="0"/>
-                        <a:ea typeface="맑은 고딕" charset="0"/>
-                        <a:cs typeface="맑은 고딕" charset="0"/>
-                      </a:endParaRPr>
-                    </a:p>
-                  </a:txBody>
-                  <a:tcPr marL="82296" marR="82296" marT="54864" marB="54864" anchor="ctr">
-                    <a:lnL w="6350" cap="flat" cmpd="sng" algn="ctr">
-                      <a:solidFill>
-                        <a:srgbClr val="DCE3EA"/>
-                      </a:solidFill>
-                      <a:prstDash val="solid"/>
-                      <a:round/>
-                      <a:headEnd type="none" w="med" len="med"/>
-                      <a:tailEnd type="none" w="med" len="med"/>
-                    </a:lnL>
-                    <a:lnR w="6350" cap="flat" cmpd="sng" algn="ctr">
-                      <a:solidFill>
-                        <a:srgbClr val="DCE3EA"/>
-                      </a:solidFill>
-                      <a:prstDash val="solid"/>
-                      <a:round/>
-                      <a:headEnd type="none" w="med" len="med"/>
-                      <a:tailEnd type="none" w="med" len="med"/>
-                    </a:lnR>
-                    <a:lnT w="6350" cap="flat" cmpd="sng" algn="ctr">
-                      <a:solidFill>
-                        <a:srgbClr val="DCE3EA"/>
-                      </a:solidFill>
-                      <a:prstDash val="solid"/>
-                      <a:round/>
-                      <a:headEnd type="none" w="med" len="med"/>
-                      <a:tailEnd type="none" w="med" len="med"/>
-                    </a:lnT>
-                    <a:lnB w="6350" cap="flat" cmpd="sng" algn="ctr">
-                      <a:solidFill>
-                        <a:srgbClr val="DCE3EA"/>
-                      </a:solidFill>
-                      <a:prstDash val="solid"/>
-                      <a:round/>
-                      <a:headEnd type="none" w="med" len="med"/>
-                      <a:tailEnd type="none" w="med" len="med"/>
-                    </a:lnB>
-                  </a:tcPr>
-                </a:tc>
-              </a:tr>
-              <a:tr h="256032">
-                <a:tc>
-                  <a:txBody>
-                    <a:bodyPr/>
-                    <a:lstStyle/>
-                    <a:p>
-                      <a:pPr algn="ctr" indent="0" marL="0">
-                        <a:buNone/>
-                      </a:pPr>
-                      <a:r>
-                        <a:rPr lang="en-US" sz="1100" dirty="0">
-                          <a:solidFill>
-                            <a:srgbClr val="1C2733"/>
-                          </a:solidFill>
-                          <a:latin typeface="맑은 고딕" pitchFamily="34" charset="0"/>
-                          <a:ea typeface="맑은 고딕" pitchFamily="34" charset="-122"/>
-                          <a:cs typeface="맑은 고딕" pitchFamily="34" charset="-120"/>
-                        </a:rPr>
-                        <a:t>PC 정상</a:t>
-                      </a:r>
-                      <a:endParaRPr lang="en-US" sz="1100" dirty="0">
-                        <a:latin typeface="맑은 고딕" charset="0"/>
-                        <a:ea typeface="맑은 고딕" charset="0"/>
-                        <a:cs typeface="맑은 고딕" charset="0"/>
-                      </a:endParaRPr>
-                    </a:p>
-                  </a:txBody>
-                  <a:tcPr marL="82296" marR="82296" marT="54864" marB="54864" anchor="ctr">
-                    <a:lnL w="6350" cap="flat" cmpd="sng" algn="ctr">
-                      <a:solidFill>
-                        <a:srgbClr val="DCE3EA"/>
-                      </a:solidFill>
-                      <a:prstDash val="solid"/>
-                      <a:round/>
-                      <a:headEnd type="none" w="med" len="med"/>
-                      <a:tailEnd type="none" w="med" len="med"/>
-                    </a:lnL>
-                    <a:lnR w="6350" cap="flat" cmpd="sng" algn="ctr">
-                      <a:solidFill>
-                        <a:srgbClr val="DCE3EA"/>
-                      </a:solidFill>
-                      <a:prstDash val="solid"/>
-                      <a:round/>
-                      <a:headEnd type="none" w="med" len="med"/>
-                      <a:tailEnd type="none" w="med" len="med"/>
-                    </a:lnR>
-                    <a:lnT w="6350" cap="flat" cmpd="sng" algn="ctr">
-                      <a:solidFill>
-                        <a:srgbClr val="DCE3EA"/>
-                      </a:solidFill>
-                      <a:prstDash val="solid"/>
-                      <a:round/>
-                      <a:headEnd type="none" w="med" len="med"/>
-                      <a:tailEnd type="none" w="med" len="med"/>
-                    </a:lnT>
-                    <a:lnB w="6350" cap="flat" cmpd="sng" algn="ctr">
-                      <a:solidFill>
-                        <a:srgbClr val="DCE3EA"/>
-                      </a:solidFill>
-                      <a:prstDash val="solid"/>
-                      <a:round/>
-                      <a:headEnd type="none" w="med" len="med"/>
-                      <a:tailEnd type="none" w="med" len="med"/>
-                    </a:lnB>
-                  </a:tcPr>
-                </a:tc>
-                <a:tc>
-                  <a:txBody>
-                    <a:bodyPr/>
-                    <a:lstStyle/>
-                    <a:p>
-                      <a:pPr algn="ctr" indent="0" marL="0">
-                        <a:buNone/>
-                      </a:pPr>
-                      <a:r>
-                        <a:rPr lang="en-US" sz="1100" dirty="0">
-                          <a:solidFill>
-                            <a:srgbClr val="1C2733"/>
-                          </a:solidFill>
-                          <a:latin typeface="맑은 고딕" pitchFamily="34" charset="0"/>
-                          <a:ea typeface="맑은 고딕" pitchFamily="34" charset="-122"/>
-                          <a:cs typeface="맑은 고딕" pitchFamily="34" charset="-120"/>
-                        </a:rPr>
-                        <a:t>10:17</a:t>
-                      </a:r>
-                      <a:endParaRPr lang="en-US" sz="1100" dirty="0">
-                        <a:latin typeface="맑은 고딕" charset="0"/>
-                        <a:ea typeface="맑은 고딕" charset="0"/>
-                        <a:cs typeface="맑은 고딕" charset="0"/>
-                      </a:endParaRPr>
-                    </a:p>
-                  </a:txBody>
-                  <a:tcPr marL="82296" marR="82296" marT="54864" marB="54864" anchor="ctr">
-                    <a:lnL w="6350" cap="flat" cmpd="sng" algn="ctr">
-                      <a:solidFill>
-                        <a:srgbClr val="DCE3EA"/>
-                      </a:solidFill>
-                      <a:prstDash val="solid"/>
-                      <a:round/>
-                      <a:headEnd type="none" w="med" len="med"/>
-                      <a:tailEnd type="none" w="med" len="med"/>
-                    </a:lnL>
-                    <a:lnR w="6350" cap="flat" cmpd="sng" algn="ctr">
-                      <a:solidFill>
-                        <a:srgbClr val="DCE3EA"/>
-                      </a:solidFill>
-                      <a:prstDash val="solid"/>
-                      <a:round/>
-                      <a:headEnd type="none" w="med" len="med"/>
-                      <a:tailEnd type="none" w="med" len="med"/>
-                    </a:lnR>
-                    <a:lnT w="6350" cap="flat" cmpd="sng" algn="ctr">
-                      <a:solidFill>
-                        <a:srgbClr val="DCE3EA"/>
-                      </a:solidFill>
-                      <a:prstDash val="solid"/>
-                      <a:round/>
-                      <a:headEnd type="none" w="med" len="med"/>
-                      <a:tailEnd type="none" w="med" len="med"/>
-                    </a:lnT>
-                    <a:lnB w="6350" cap="flat" cmpd="sng" algn="ctr">
-                      <a:solidFill>
-                        <a:srgbClr val="DCE3EA"/>
-                      </a:solidFill>
-                      <a:prstDash val="solid"/>
-                      <a:round/>
-                      <a:headEnd type="none" w="med" len="med"/>
-                      <a:tailEnd type="none" w="med" len="med"/>
-                    </a:lnB>
-                  </a:tcPr>
-                </a:tc>
-                <a:tc>
-                  <a:txBody>
-                    <a:bodyPr/>
-                    <a:lstStyle/>
-                    <a:p>
-                      <a:pPr algn="ctr" indent="0" marL="0">
-                        <a:buNone/>
-                      </a:pPr>
-                      <a:r>
-                        <a:rPr lang="en-US" sz="1100" dirty="0">
-                          <a:solidFill>
-                            <a:srgbClr val="1C2733"/>
-                          </a:solidFill>
-                          <a:latin typeface="맑은 고딕" pitchFamily="34" charset="0"/>
-                          <a:ea typeface="맑은 고딕" pitchFamily="34" charset="-122"/>
-                          <a:cs typeface="맑은 고딕" pitchFamily="34" charset="-120"/>
-                        </a:rPr>
-                        <a:t>9:41</a:t>
-                      </a:r>
-                      <a:endParaRPr lang="en-US" sz="1100" dirty="0">
-                        <a:latin typeface="맑은 고딕" charset="0"/>
-                        <a:ea typeface="맑은 고딕" charset="0"/>
-                        <a:cs typeface="맑은 고딕" charset="0"/>
-                      </a:endParaRPr>
-                    </a:p>
-                  </a:txBody>
-                  <a:tcPr marL="82296" marR="82296" marT="54864" marB="54864" anchor="ctr">
-                    <a:lnL w="6350" cap="flat" cmpd="sng" algn="ctr">
-                      <a:solidFill>
-                        <a:srgbClr val="DCE3EA"/>
-                      </a:solidFill>
-                      <a:prstDash val="solid"/>
-                      <a:round/>
-                      <a:headEnd type="none" w="med" len="med"/>
-                      <a:tailEnd type="none" w="med" len="med"/>
-                    </a:lnL>
-                    <a:lnR w="6350" cap="flat" cmpd="sng" algn="ctr">
-                      <a:solidFill>
-                        <a:srgbClr val="DCE3EA"/>
-                      </a:solidFill>
-                      <a:prstDash val="solid"/>
-                      <a:round/>
-                      <a:headEnd type="none" w="med" len="med"/>
-                      <a:tailEnd type="none" w="med" len="med"/>
-                    </a:lnR>
-                    <a:lnT w="6350" cap="flat" cmpd="sng" algn="ctr">
-                      <a:solidFill>
-                        <a:srgbClr val="DCE3EA"/>
-                      </a:solidFill>
-                      <a:prstDash val="solid"/>
-                      <a:round/>
-                      <a:headEnd type="none" w="med" len="med"/>
-                      <a:tailEnd type="none" w="med" len="med"/>
-                    </a:lnT>
-                    <a:lnB w="6350" cap="flat" cmpd="sng" algn="ctr">
-                      <a:solidFill>
-                        <a:srgbClr val="DCE3EA"/>
-                      </a:solidFill>
-                      <a:prstDash val="solid"/>
-                      <a:round/>
-                      <a:headEnd type="none" w="med" len="med"/>
-                      <a:tailEnd type="none" w="med" len="med"/>
-                    </a:lnB>
-                  </a:tcPr>
-                </a:tc>
-                <a:tc>
-                  <a:txBody>
-                    <a:bodyPr/>
-                    <a:lstStyle/>
-                    <a:p>
-                      <a:pPr algn="ctr" indent="0" marL="0">
-                        <a:buNone/>
-                      </a:pPr>
-                      <a:r>
-                        <a:rPr lang="en-US" sz="1100" dirty="0">
-                          <a:solidFill>
-                            <a:srgbClr val="1C2733"/>
-                          </a:solidFill>
-                          <a:latin typeface="맑은 고딕" pitchFamily="34" charset="0"/>
-                          <a:ea typeface="맑은 고딕" pitchFamily="34" charset="-122"/>
-                          <a:cs typeface="맑은 고딕" pitchFamily="34" charset="-120"/>
-                        </a:rPr>
-                        <a:t>−0.2 SD</a:t>
-                      </a:r>
-                      <a:endParaRPr lang="en-US" sz="1100" dirty="0">
-                        <a:latin typeface="맑은 고딕" charset="0"/>
-                        <a:ea typeface="맑은 고딕" charset="0"/>
-                        <a:cs typeface="맑은 고딕" charset="0"/>
-                      </a:endParaRPr>
-                    </a:p>
-                  </a:txBody>
-                  <a:tcPr marL="82296" marR="82296" marT="54864" marB="54864" anchor="ctr">
-                    <a:lnL w="6350" cap="flat" cmpd="sng" algn="ctr">
-                      <a:solidFill>
-                        <a:srgbClr val="DCE3EA"/>
-                      </a:solidFill>
-                      <a:prstDash val="solid"/>
-                      <a:round/>
-                      <a:headEnd type="none" w="med" len="med"/>
-                      <a:tailEnd type="none" w="med" len="med"/>
-                    </a:lnL>
-                    <a:lnR w="6350" cap="flat" cmpd="sng" algn="ctr">
-                      <a:solidFill>
-                        <a:srgbClr val="DCE3EA"/>
-                      </a:solidFill>
-                      <a:prstDash val="solid"/>
-                      <a:round/>
-                      <a:headEnd type="none" w="med" len="med"/>
-                      <a:tailEnd type="none" w="med" len="med"/>
-                    </a:lnR>
-                    <a:lnT w="6350" cap="flat" cmpd="sng" algn="ctr">
-                      <a:solidFill>
-                        <a:srgbClr val="DCE3EA"/>
-                      </a:solidFill>
-                      <a:prstDash val="solid"/>
-                      <a:round/>
-                      <a:headEnd type="none" w="med" len="med"/>
-                      <a:tailEnd type="none" w="med" len="med"/>
-                    </a:lnT>
-                    <a:lnB w="6350" cap="flat" cmpd="sng" algn="ctr">
-                      <a:solidFill>
-                        <a:srgbClr val="DCE3EA"/>
-                      </a:solidFill>
-                      <a:prstDash val="solid"/>
-                      <a:round/>
-                      <a:headEnd type="none" w="med" len="med"/>
-                      <a:tailEnd type="none" w="med" len="med"/>
-                    </a:lnB>
-                  </a:tcPr>
-                </a:tc>
-              </a:tr>
-              <a:tr h="256032">
-                <a:tc>
-                  <a:txBody>
-                    <a:bodyPr/>
-                    <a:lstStyle/>
-                    <a:p>
-                      <a:pPr algn="ctr" indent="0" marL="0">
-                        <a:buNone/>
-                      </a:pPr>
-                      <a:r>
-                        <a:rPr lang="en-US" sz="1100" dirty="0">
-                          <a:solidFill>
-                            <a:srgbClr val="1C2733"/>
-                          </a:solidFill>
-                          <a:latin typeface="맑은 고딕" pitchFamily="34" charset="0"/>
-                          <a:ea typeface="맑은 고딕" pitchFamily="34" charset="-122"/>
-                          <a:cs typeface="맑은 고딕" pitchFamily="34" charset="-120"/>
-                        </a:rPr>
-                        <a:t>GIC 정상</a:t>
-                      </a:r>
-                      <a:endParaRPr lang="en-US" sz="1100" dirty="0">
-                        <a:latin typeface="맑은 고딕" charset="0"/>
-                        <a:ea typeface="맑은 고딕" charset="0"/>
-                        <a:cs typeface="맑은 고딕" charset="0"/>
-                      </a:endParaRPr>
-                    </a:p>
-                  </a:txBody>
-                  <a:tcPr marL="82296" marR="82296" marT="54864" marB="54864" anchor="ctr">
-                    <a:lnL w="6350" cap="flat" cmpd="sng" algn="ctr">
-                      <a:solidFill>
-                        <a:srgbClr val="DCE3EA"/>
-                      </a:solidFill>
-                      <a:prstDash val="solid"/>
-                      <a:round/>
-                      <a:headEnd type="none" w="med" len="med"/>
-                      <a:tailEnd type="none" w="med" len="med"/>
-                    </a:lnL>
-                    <a:lnR w="6350" cap="flat" cmpd="sng" algn="ctr">
-                      <a:solidFill>
-                        <a:srgbClr val="DCE3EA"/>
-                      </a:solidFill>
-                      <a:prstDash val="solid"/>
-                      <a:round/>
-                      <a:headEnd type="none" w="med" len="med"/>
-                      <a:tailEnd type="none" w="med" len="med"/>
-                    </a:lnR>
-                    <a:lnT w="6350" cap="flat" cmpd="sng" algn="ctr">
-                      <a:solidFill>
-                        <a:srgbClr val="DCE3EA"/>
-                      </a:solidFill>
-                      <a:prstDash val="solid"/>
-                      <a:round/>
-                      <a:headEnd type="none" w="med" len="med"/>
-                      <a:tailEnd type="none" w="med" len="med"/>
-                    </a:lnT>
-                    <a:lnB w="6350" cap="flat" cmpd="sng" algn="ctr">
-                      <a:solidFill>
-                        <a:srgbClr val="DCE3EA"/>
-                      </a:solidFill>
-                      <a:prstDash val="solid"/>
-                      <a:round/>
-                      <a:headEnd type="none" w="med" len="med"/>
-                      <a:tailEnd type="none" w="med" len="med"/>
-                    </a:lnB>
-                  </a:tcPr>
-                </a:tc>
-                <a:tc>
-                  <a:txBody>
-                    <a:bodyPr/>
-                    <a:lstStyle/>
-                    <a:p>
-                      <a:pPr algn="ctr" indent="0" marL="0">
-                        <a:buNone/>
-                      </a:pPr>
-                      <a:r>
-                        <a:rPr lang="en-US" sz="1100" dirty="0">
-                          <a:solidFill>
-                            <a:srgbClr val="1C2733"/>
-                          </a:solidFill>
-                          <a:latin typeface="맑은 고딕" pitchFamily="34" charset="0"/>
-                          <a:ea typeface="맑은 고딕" pitchFamily="34" charset="-122"/>
-                          <a:cs typeface="맑은 고딕" pitchFamily="34" charset="-120"/>
-                        </a:rPr>
-                        <a:t>6:05</a:t>
-                      </a:r>
-                      <a:endParaRPr lang="en-US" sz="1100" dirty="0">
-                        <a:latin typeface="맑은 고딕" charset="0"/>
-                        <a:ea typeface="맑은 고딕" charset="0"/>
-                        <a:cs typeface="맑은 고딕" charset="0"/>
-                      </a:endParaRPr>
-                    </a:p>
-                  </a:txBody>
-                  <a:tcPr marL="82296" marR="82296" marT="54864" marB="54864" anchor="ctr">
-                    <a:lnL w="6350" cap="flat" cmpd="sng" algn="ctr">
-                      <a:solidFill>
-                        <a:srgbClr val="DCE3EA"/>
-                      </a:solidFill>
-                      <a:prstDash val="solid"/>
-                      <a:round/>
-                      <a:headEnd type="none" w="med" len="med"/>
-                      <a:tailEnd type="none" w="med" len="med"/>
-                    </a:lnL>
-                    <a:lnR w="6350" cap="flat" cmpd="sng" algn="ctr">
-                      <a:solidFill>
-                        <a:srgbClr val="DCE3EA"/>
-                      </a:solidFill>
-                      <a:prstDash val="solid"/>
-                      <a:round/>
-                      <a:headEnd type="none" w="med" len="med"/>
-                      <a:tailEnd type="none" w="med" len="med"/>
-                    </a:lnR>
-                    <a:lnT w="6350" cap="flat" cmpd="sng" algn="ctr">
-                      <a:solidFill>
-                        <a:srgbClr val="DCE3EA"/>
-                      </a:solidFill>
-                      <a:prstDash val="solid"/>
-                      <a:round/>
-                      <a:headEnd type="none" w="med" len="med"/>
-                      <a:tailEnd type="none" w="med" len="med"/>
-                    </a:lnT>
-                    <a:lnB w="6350" cap="flat" cmpd="sng" algn="ctr">
-                      <a:solidFill>
-                        <a:srgbClr val="DCE3EA"/>
-                      </a:solidFill>
-                      <a:prstDash val="solid"/>
-                      <a:round/>
-                      <a:headEnd type="none" w="med" len="med"/>
-                      <a:tailEnd type="none" w="med" len="med"/>
-                    </a:lnB>
-                  </a:tcPr>
-                </a:tc>
-                <a:tc>
-                  <a:txBody>
-                    <a:bodyPr/>
-                    <a:lstStyle/>
-                    <a:p>
-                      <a:pPr algn="ctr" indent="0" marL="0">
-                        <a:buNone/>
-                      </a:pPr>
-                      <a:r>
-                        <a:rPr lang="en-US" sz="1100" dirty="0">
-                          <a:solidFill>
-                            <a:srgbClr val="1C2733"/>
-                          </a:solidFill>
-                          <a:latin typeface="맑은 고딕" pitchFamily="34" charset="0"/>
-                          <a:ea typeface="맑은 고딕" pitchFamily="34" charset="-122"/>
-                          <a:cs typeface="맑은 고딕" pitchFamily="34" charset="-120"/>
-                        </a:rPr>
-                        <a:t>8:43</a:t>
-                      </a:r>
-                      <a:endParaRPr lang="en-US" sz="1100" dirty="0">
-                        <a:latin typeface="맑은 고딕" charset="0"/>
-                        <a:ea typeface="맑은 고딕" charset="0"/>
-                        <a:cs typeface="맑은 고딕" charset="0"/>
-                      </a:endParaRPr>
-                    </a:p>
-                  </a:txBody>
-                  <a:tcPr marL="82296" marR="82296" marT="54864" marB="54864" anchor="ctr">
-                    <a:lnL w="6350" cap="flat" cmpd="sng" algn="ctr">
-                      <a:solidFill>
-                        <a:srgbClr val="DCE3EA"/>
-                      </a:solidFill>
-                      <a:prstDash val="solid"/>
-                      <a:round/>
-                      <a:headEnd type="none" w="med" len="med"/>
-                      <a:tailEnd type="none" w="med" len="med"/>
-                    </a:lnL>
-                    <a:lnR w="6350" cap="flat" cmpd="sng" algn="ctr">
-                      <a:solidFill>
-                        <a:srgbClr val="DCE3EA"/>
-                      </a:solidFill>
-                      <a:prstDash val="solid"/>
-                      <a:round/>
-                      <a:headEnd type="none" w="med" len="med"/>
-                      <a:tailEnd type="none" w="med" len="med"/>
-                    </a:lnR>
-                    <a:lnT w="6350" cap="flat" cmpd="sng" algn="ctr">
-                      <a:solidFill>
-                        <a:srgbClr val="DCE3EA"/>
-                      </a:solidFill>
-                      <a:prstDash val="solid"/>
-                      <a:round/>
-                      <a:headEnd type="none" w="med" len="med"/>
-                      <a:tailEnd type="none" w="med" len="med"/>
-                    </a:lnT>
-                    <a:lnB w="6350" cap="flat" cmpd="sng" algn="ctr">
-                      <a:solidFill>
-                        <a:srgbClr val="DCE3EA"/>
-                      </a:solidFill>
-                      <a:prstDash val="solid"/>
-                      <a:round/>
-                      <a:headEnd type="none" w="med" len="med"/>
-                      <a:tailEnd type="none" w="med" len="med"/>
-                    </a:lnB>
-                  </a:tcPr>
-                </a:tc>
-                <a:tc>
-                  <a:txBody>
-                    <a:bodyPr/>
-                    <a:lstStyle/>
-                    <a:p>
-                      <a:pPr algn="ctr" indent="0" marL="0">
-                        <a:buNone/>
-                      </a:pPr>
-                      <a:r>
-                        <a:rPr lang="en-US" sz="1100" dirty="0">
-                          <a:solidFill>
-                            <a:srgbClr val="1C2733"/>
-                          </a:solidFill>
-                          <a:latin typeface="맑은 고딕" pitchFamily="34" charset="0"/>
-                          <a:ea typeface="맑은 고딕" pitchFamily="34" charset="-122"/>
-                          <a:cs typeface="맑은 고딕" pitchFamily="34" charset="-120"/>
-                        </a:rPr>
-                        <a:t>+1.7 SD</a:t>
-                      </a:r>
-                      <a:endParaRPr lang="en-US" sz="1100" dirty="0">
-                        <a:latin typeface="맑은 고딕" charset="0"/>
-                        <a:ea typeface="맑은 고딕" charset="0"/>
-                        <a:cs typeface="맑은 고딕" charset="0"/>
-                      </a:endParaRPr>
-                    </a:p>
-                  </a:txBody>
-                  <a:tcPr marL="82296" marR="82296" marT="54864" marB="54864" anchor="ctr">
-                    <a:lnL w="6350" cap="flat" cmpd="sng" algn="ctr">
-                      <a:solidFill>
-                        <a:srgbClr val="DCE3EA"/>
-                      </a:solidFill>
-                      <a:prstDash val="solid"/>
-                      <a:round/>
-                      <a:headEnd type="none" w="med" len="med"/>
-                      <a:tailEnd type="none" w="med" len="med"/>
-                    </a:lnL>
-                    <a:lnR w="6350" cap="flat" cmpd="sng" algn="ctr">
-                      <a:solidFill>
-                        <a:srgbClr val="DCE3EA"/>
-                      </a:solidFill>
-                      <a:prstDash val="solid"/>
-                      <a:round/>
-                      <a:headEnd type="none" w="med" len="med"/>
-                      <a:tailEnd type="none" w="med" len="med"/>
-                    </a:lnR>
-                    <a:lnT w="6350" cap="flat" cmpd="sng" algn="ctr">
-                      <a:solidFill>
-                        <a:srgbClr val="DCE3EA"/>
-                      </a:solidFill>
-                      <a:prstDash val="solid"/>
-                      <a:round/>
-                      <a:headEnd type="none" w="med" len="med"/>
-                      <a:tailEnd type="none" w="med" len="med"/>
-                    </a:lnT>
-                    <a:lnB w="6350" cap="flat" cmpd="sng" algn="ctr">
-                      <a:solidFill>
-                        <a:srgbClr val="DCE3EA"/>
-                      </a:solidFill>
-                      <a:prstDash val="solid"/>
-                      <a:round/>
-                      <a:headEnd type="none" w="med" len="med"/>
-                      <a:tailEnd type="none" w="med" len="med"/>
-                    </a:lnB>
-                  </a:tcPr>
-                </a:tc>
-              </a:tr>
-            </a:tbl>
+        <a:graphic xmlns:a="http://schemas.openxmlformats.org/drawingml/2006/main">
+          <a:graphicData uri="http://schemas.openxmlformats.org/drawingml/2006/chart">
+            <c:chart xmlns:c="http://schemas.openxmlformats.org/drawingml/2006/chart" r:id="rId1"/>
           </a:graphicData>
         </a:graphic>
       </p:graphicFrame>
       <p:sp>
         <p:nvSpPr>
-          <p:cNvPr id="9" name="Text 6"/>
+          <p:cNvPr id="10" name="Text 7"/>
+          <p:cNvSpPr txBox="1"/>
+          <p:nvPr/>
+        </p:nvSpPr>
+        <p:spPr>
+          <a:xfrm>
+            <a:off x="822960" y="5888736"/>
+            <a:ext cx="10543032" cy="411480"/>
+          </a:xfrm>
+          <a:prstGeom prst="rect">
+            <a:avLst/>
+          </a:prstGeom>
+          <a:noFill/>
+          <a:ln/>
+        </p:spPr>
+        <p:txBody>
+          <a:bodyPr wrap="square" lIns="0" tIns="0" rIns="0" bIns="0" rtlCol="0" anchor="ctr"/>
+          <a:lstStyle/>
+          <a:p>
+            <a:pPr indent="0" marL="0">
+              <a:lnSpc>
+                <a:spcPct val="115000"/>
+              </a:lnSpc>
+              <a:buNone/>
+            </a:pPr>
+            <a:r>
+              <a:rPr lang="en-US" sz="750" i="1" dirty="0">
+                <a:solidFill>
+                  <a:srgbClr val="5B6B7A"/>
+                </a:solidFill>
+                <a:latin typeface="맑은 고딕" pitchFamily="34" charset="0"/>
+                <a:ea typeface="맑은 고딕" pitchFamily="34" charset="-122"/>
+                <a:cs typeface="맑은 고딕" pitchFamily="34" charset="-120"/>
+              </a:rPr>
+              <a:t>※ 오차 막대는 전체 평균의 표준편차(SD) 1개. ZPC 15%↓ 13:13→16:46(+0.9 SD)  ·  ZPC 정상 11:13→16:20(+1.3 SD)  ·  ZPC 15%↑ 7:40→12:45(+1.9 SD)  ·  ZPC 15%↑+냉각판 10:07→12:03(+0.9 SD)  ·  PC 정상 10:17→9:41(−0.2 SD)  ·  GIC 정상 6:05→8:43(+1.7 SD)</a:t>
+            </a:r>
+            <a:endParaRPr lang="en-US" sz="750" dirty="0"/>
+          </a:p>
+        </p:txBody>
+      </p:sp>
+      <p:sp>
+        <p:nvSpPr>
+          <p:cNvPr id="11" name="Text 8"/>
           <p:cNvSpPr txBox="1"/>
           <p:nvPr/>
         </p:nvSpPr>
@@ -11009,7 +9718,7 @@
                 <a:ea typeface="맑은 고딕" pitchFamily="34" charset="-122"/>
                 <a:cs typeface="맑은 고딕" pitchFamily="34" charset="-120"/>
               </a:rPr>
-              <a:t>① P/L ratio와 경화시간</a:t>
+              <a:t>① P/L ratio와 경화 시간</a:t>
             </a:r>
             <a:endParaRPr lang="en-US" sz="1450" dirty="0"/>
           </a:p>
@@ -11152,7 +9861,7 @@
                 <a:ea typeface="맑은 고딕" pitchFamily="34" charset="-122"/>
                 <a:cs typeface="맑은 고딕" pitchFamily="34" charset="-120"/>
               </a:rPr>
-              <a:t>•  이론: 온도가 낮을수록 분자 운동성·반응성이 저하되어 작업시간은 길어지고 경화시간도 길어질 것으로 예상됨</a:t>
+              <a:t>•  이론: 온도가 낮을수록 분자 운동성·반응성이 저하되어 작업시간은 길어지고 경화 시간도 길어질 것으로 예상됨</a:t>
             </a:r>
             <a:endParaRPr lang="en-US" sz="1300" dirty="0"/>
           </a:p>
@@ -11172,7 +9881,7 @@
                 <a:ea typeface="맑은 고딕" pitchFamily="34" charset="-122"/>
                 <a:cs typeface="맑은 고딕" pitchFamily="34" charset="-120"/>
               </a:rPr>
-              <a:t>•  실측: 냉각판(setting 12:03)이 동일 조건 상온(setting 12:45)보다 오히려 짧게 나옴 — 예상과 반대 방향. 다만 작업시간(working time) 자체는 별도로 측정하지 못해 직접 비교는 어려움, 경화시간만으로 임의 추정한 결과</a:t>
+              <a:t>•  실측: 냉각판(setting 12:03)이 동일 조건 상온(setting 12:45)보다 오히려 짧게 나옴 — 예상과 반대 방향. 다만 작업시간(working time) 자체는 별도로 측정하지 못해 직접 비교는 어려움, 경화 시간만으로 임의 추정한 결과</a:t>
             </a:r>
             <a:endParaRPr lang="en-US" sz="1300" dirty="0"/>
           </a:p>
@@ -11507,7 +10216,7 @@
                 <a:ea typeface="맑은 고딕" pitchFamily="34" charset="-122"/>
                 <a:cs typeface="맑은 고딕" pitchFamily="34" charset="-120"/>
               </a:rPr>
-              <a:t>•  분액비가 높을수록 경화시간이 짧아지는 경향이 대체로 확인됨(일부 예외 존재 — 혼합·측정 오차 가능성)</a:t>
+              <a:t>•  분액비가 높을수록 경화 시간이 짧아지는 경향이 대체로 확인됨(일부 예외 존재 — 혼합·측정 오차 가능성)</a:t>
             </a:r>
             <a:endParaRPr lang="en-US" sz="1400" dirty="0"/>
           </a:p>
@@ -11527,7 +10236,7 @@
                 <a:ea typeface="맑은 고딕" pitchFamily="34" charset="-122"/>
                 <a:cs typeface="맑은 고딕" pitchFamily="34" charset="-120"/>
               </a:rPr>
-              <a:t>•  냉각판(저온) 조건은 이론상 경화 지연을 예상했으나 실측은 반대 — 작업시간·경화시간을 분리 측정하지 못한 한계</a:t>
+              <a:t>•  냉각판(저온) 조건은 이론상 경화 지연을 예상했으나 실측은 반대 — 작업시간·경화 시간을 분리 측정하지 못한 한계</a:t>
             </a:r>
             <a:endParaRPr lang="en-US" sz="1400" dirty="0"/>
           </a:p>
@@ -14850,7 +13559,7 @@
       </p:sp>
       <p:pic>
         <p:nvPicPr>
-          <p:cNvPr id="13" name="Image 0" descr="/home/user/-/.claude/worktrees/agent-a33c37b000189e92f/수복치과재료학실험/dental_photos/insert/photo_09.jpg">    </p:cNvPr>
+          <p:cNvPr id="13" name="Image 0" descr="/home/user/-/수복치과재료학실험/dental_photos/insert/photo_09.jpg">    </p:cNvPr>
           <p:cNvPicPr>
             <a:picLocks noChangeAspect="1"/>
           </p:cNvPicPr>
@@ -15197,7 +13906,7 @@
       </p:sp>
       <p:pic>
         <p:nvPicPr>
-          <p:cNvPr id="21" name="Image 1" descr="/home/user/-/.claude/worktrees/agent-a33c37b000189e92f/수복치과재료학실험/dental_photos/insert/photo_10.jpg">    </p:cNvPr>
+          <p:cNvPr id="21" name="Image 1" descr="/home/user/-/수복치과재료학실험/dental_photos/insert/photo_10.jpg">    </p:cNvPr>
           <p:cNvPicPr>
             <a:picLocks noChangeAspect="1"/>
           </p:cNvPicPr>
@@ -15488,7 +14197,7 @@
                 <a:ea typeface="맑은 고딕" pitchFamily="34" charset="-122"/>
                 <a:cs typeface="맑은 고딕" pitchFamily="34" charset="-120"/>
               </a:rPr>
-              <a:t>냉동고에 보관해 둔 유리판. 15% 높은 분액비 조건에서 사용 — 작업시간은 길고 경화시간은 짧음, 필요 분말량은 보통보다 50~70% 많으나 결로는 분액비로 보상. 압축·인장강도·용해도는 상온 혼합과 큰 차이 없음.
+              <a:t>냉동고에 보관해 둔 유리판. 15% 높은 분액비 조건에서 사용 — 작업시간은 길고 경화 시간은 짧음, 필요 분말량은 보통보다 50~70% 많으나 결로는 분액비로 보상. 압축·인장강도·용해도는 상온 혼합과 큰 차이 없음.
 </a:t>
             </a:r>
             <a:pPr indent="0" marL="0">
@@ -15793,7 +14502,7 @@
                 <a:ea typeface="맑은 고딕" pitchFamily="34" charset="-122"/>
                 <a:cs typeface="맑은 고딕" pitchFamily="34" charset="-120"/>
               </a:rPr>
-              <a:t>•  Net setting time(순경화시간) = mixing 종료 시점부터 indentor가 완전한 원형 압흔을 남기지 못하는 시점까지</a:t>
+              <a:t>•  Net setting time(순경화 시간) = mixing 종료 시점부터 indentor가 완전한 원형 압흔을 남기지 못하는 시점까지</a:t>
             </a:r>
             <a:endParaRPr lang="en-US" sz="1200" dirty="0"/>
           </a:p>
@@ -17664,7 +16373,27 @@
                 <a:ea typeface="맑은 고딕" pitchFamily="34" charset="-122"/>
                 <a:cs typeface="맑은 고딕" pitchFamily="34" charset="-120"/>
               </a:rPr>
-              <a:t>* mixing 종료(합착) 기준  † mixing 시작 기준  ‡ 수복물 장착 이후 최종 마무리 가능 시점 — 제품마다 기준 시점이 달라 직접 비교 시 유의.</a:t>
+              <a:t>* mixing 종료(합착) 기준  † mixing 시작 기준  ‡ 수복물 장착 이후 최종 마무리 가능 시점</a:t>
+            </a:r>
+            <a:endParaRPr lang="en-US" sz="900" dirty="0"/>
+          </a:p>
+          <a:p>
+            <a:pPr indent="0" marL="0">
+              <a:lnSpc>
+                <a:spcPct val="120000"/>
+              </a:lnSpc>
+              <a:buNone/>
+            </a:pPr>
+            <a:r>
+              <a:rPr lang="en-US" sz="900" i="1" dirty="0">
+                <a:solidFill>
+                  <a:srgbClr val="5B6B7A"/>
+                </a:solidFill>
+                <a:latin typeface="맑은 고딕" pitchFamily="34" charset="0"/>
+                <a:ea typeface="맑은 고딕" pitchFamily="34" charset="-122"/>
+                <a:cs typeface="맑은 고딕" pitchFamily="34" charset="-120"/>
+              </a:rPr>
+              <a:t>— 제품마다 기준 시점이 다르므로 직접 비교 시 유의.</a:t>
             </a:r>
             <a:endParaRPr lang="en-US" sz="900" dirty="0"/>
           </a:p>
@@ -17933,7 +16662,7 @@
                 <a:ea typeface="맑은 고딕" pitchFamily="34" charset="-122"/>
                 <a:cs typeface="맑은 고딕" pitchFamily="34" charset="-120"/>
               </a:rPr>
-              <a:t>9/22 수업일지 요약</a:t>
+              <a:t>9월 22일 A분반 실험</a:t>
             </a:r>
             <a:endParaRPr lang="en-US" sz="1450" dirty="0"/>
           </a:p>
@@ -19318,7 +18047,7 @@
                 <a:ea typeface="맑은 고딕" pitchFamily="34" charset="-122"/>
                 <a:cs typeface="맑은 고딕" pitchFamily="34" charset="-120"/>
               </a:rPr>
-              <a:t>•  분액비의 차이가 경화시간에 미치는 영향</a:t>
+              <a:t>•  분액비의 차이가 경화 시간에 미치는 영향</a:t>
             </a:r>
             <a:endParaRPr lang="en-US" sz="1200" dirty="0"/>
           </a:p>
@@ -19828,7 +18557,7 @@
       </p:sp>
       <p:pic>
         <p:nvPicPr>
-          <p:cNvPr id="7" name="Image 0" descr="/home/user/-/.claude/worktrees/agent-a33c37b000189e92f/수복치과재료학실험/dental_photos/insert/photo_06.jpg">    </p:cNvPr>
+          <p:cNvPr id="7" name="Image 0" descr="/home/user/-/수복치과재료학실험/dental_photos/insert/photo_06.jpg">    </p:cNvPr>
           <p:cNvPicPr>
             <a:picLocks noChangeAspect="1"/>
           </p:cNvPicPr>
@@ -19915,7 +18644,7 @@
       </p:sp>
       <p:pic>
         <p:nvPicPr>
-          <p:cNvPr id="10" name="Image 1" descr="/home/user/-/.claude/worktrees/agent-a33c37b000189e92f/수복치과재료학실험/dental_photos/insert/photo_07.jpg">    </p:cNvPr>
+          <p:cNvPr id="10" name="Image 1" descr="/home/user/-/수복치과재료학실험/dental_photos/insert/photo_07.jpg">    </p:cNvPr>
           <p:cNvPicPr>
             <a:picLocks noChangeAspect="1"/>
           </p:cNvPicPr>
@@ -20104,7 +18833,7 @@
                 <a:ea typeface="맑은 고딕" pitchFamily="34" charset="-122"/>
                 <a:cs typeface="맑은 고딕" pitchFamily="34" charset="-120"/>
               </a:rPr>
-              <a:t>•  ZPC(정상/±15%/냉각판 조건)</a:t>
+              <a:t>•  Slide glass 2매 × 2 set</a:t>
             </a:r>
             <a:endParaRPr lang="en-US" sz="1250" dirty="0"/>
           </a:p>
@@ -20124,7 +18853,7 @@
                 <a:ea typeface="맑은 고딕" pitchFamily="34" charset="-122"/>
                 <a:cs typeface="맑은 고딕" pitchFamily="34" charset="-120"/>
               </a:rPr>
-              <a:t>•  Slide glass 2매</a:t>
+              <a:t>•  Metal spatula, cotton swab</a:t>
             </a:r>
             <a:endParaRPr lang="en-US" sz="1250" dirty="0"/>
           </a:p>
@@ -20144,7 +18873,7 @@
                 <a:ea typeface="맑은 고딕" pitchFamily="34" charset="-122"/>
                 <a:cs typeface="맑은 고딕" pitchFamily="34" charset="-120"/>
               </a:rPr>
-              <a:t>•  Metal spatula, cotton swab</a:t>
+              <a:t>•  Micrometer(두께 측정기)</a:t>
             </a:r>
             <a:endParaRPr lang="en-US" sz="1250" dirty="0"/>
           </a:p>
@@ -20164,26 +18893,6 @@
                 <a:ea typeface="맑은 고딕" pitchFamily="34" charset="-122"/>
                 <a:cs typeface="맑은 고딕" pitchFamily="34" charset="-120"/>
               </a:rPr>
-              <a:t>•  Micrometer(두께 측정기)</a:t>
-            </a:r>
-            <a:endParaRPr lang="en-US" sz="1250" dirty="0"/>
-          </a:p>
-          <a:p>
-            <a:pPr indent="0" marL="0">
-              <a:lnSpc>
-                <a:spcPct val="140000"/>
-              </a:lnSpc>
-              <a:buNone/>
-            </a:pPr>
-            <a:r>
-              <a:rPr lang="en-US" sz="1250" dirty="0">
-                <a:solidFill>
-                  <a:srgbClr val="1C2733"/>
-                </a:solidFill>
-                <a:latin typeface="맑은 고딕" pitchFamily="34" charset="0"/>
-                <a:ea typeface="맑은 고딕" pitchFamily="34" charset="-122"/>
-                <a:cs typeface="맑은 고딕" pitchFamily="34" charset="-120"/>
-              </a:rPr>
               <a:t>•  하중장치(150N, load compressor)</a:t>
             </a:r>
             <a:endParaRPr lang="en-US" sz="1250" dirty="0"/>
@@ -20192,7 +18901,7 @@
       </p:sp>
       <p:pic>
         <p:nvPicPr>
-          <p:cNvPr id="16" name="Image 2" descr="/home/user/-/.claude/worktrees/agent-a33c37b000189e92f/수복치과재료학실험/dental_photos/insert/photo_05.jpg">    </p:cNvPr>
+          <p:cNvPr id="16" name="Image 2" descr="/home/user/-/수복치과재료학실험/dental_photos/insert/photo_05.jpg">    </p:cNvPr>
           <p:cNvPicPr>
             <a:picLocks noChangeAspect="1"/>
           </p:cNvPicPr>
@@ -20271,7 +18980,7 @@
                 <a:ea typeface="맑은 고딕" pitchFamily="34" charset="-122"/>
                 <a:cs typeface="맑은 고딕" pitchFamily="34" charset="-120"/>
               </a:rPr>
-              <a:t>필름두께 측정기 (하중장치)</a:t>
+              <a:t>피막도 측정 장치 (하중장치, 조립 전)</a:t>
             </a:r>
             <a:endParaRPr lang="en-US" sz="1100" dirty="0"/>
           </a:p>
@@ -21437,7 +20146,7 @@
                           <a:ea typeface="맑은 고딕" pitchFamily="34" charset="-122"/>
                           <a:cs typeface="맑은 고딕" pitchFamily="34" charset="-120"/>
                         </a:rPr>
-                        <a:t>-</a:t>
+                        <a:t>3 / 13</a:t>
                       </a:r>
                       <a:endParaRPr lang="en-US" sz="1350" dirty="0">
                         <a:latin typeface="맑은 고딕" charset="0"/>
@@ -22244,7 +20953,7 @@
       </p:sp>
       <p:pic>
         <p:nvPicPr>
-          <p:cNvPr id="8" name="Image 0" descr="/home/user/-/.claude/worktrees/agent-a33c37b000189e92f/수복치과재료학실험/dental_photos/insert/photo_04.jpg">    </p:cNvPr>
+          <p:cNvPr id="8" name="Image 0" descr="/home/user/-/수복치과재료학실험/dental_photos/insert/photo_04.jpg">    </p:cNvPr>
           <p:cNvPicPr>
             <a:picLocks noChangeAspect="1"/>
           </p:cNvPicPr>
@@ -22323,7 +21032,7 @@
                 <a:ea typeface="맑은 고딕" pitchFamily="34" charset="-122"/>
                 <a:cs typeface="맑은 고딕" pitchFamily="34" charset="-120"/>
               </a:rPr>
-              <a:t>Mixing 과정 (spatula)</a:t>
+              <a:t>Molding after Mixing</a:t>
             </a:r>
             <a:endParaRPr lang="en-US" sz="1100" dirty="0"/>
           </a:p>
@@ -22553,7 +21262,7 @@
                 <a:ea typeface="맑은 고딕" pitchFamily="34" charset="-122"/>
                 <a:cs typeface="맑은 고딕" pitchFamily="34" charset="-120"/>
               </a:rPr>
-              <a:t>검정 사각 금속 주형을 Al foil로 덮은 metal block에 올리고 mix 완료 재료를 채움 → 혼합 종료 90초 후부터 indentor를 수직으로 5초간 압입, 30초 간격 반복 → 예상 경화시점 30초 전부터 10초 간격으로 전환 → 완전한 원형 압흔이 안 남는 시점 기록</a:t>
+              <a:t>검정 사각 금속 주형을 Al foil로 덮은 metal block에 올리고 mix 완료 재료를 채움 → 표준 혼합 시간 종료 후부터 indentor를 수직으로 5초간 압입, 30초 간격 반복 → 예상 경화 시점 30초 전부터 10초 간격으로 전환 → 완전한 원형 압흔이 안 남는 시점을 기록</a:t>
             </a:r>
             <a:endParaRPr lang="en-US" sz="1500" dirty="0"/>
           </a:p>
@@ -22634,7 +21343,7 @@
                 <a:ea typeface="맑은 고딕" pitchFamily="34" charset="-122"/>
                 <a:cs typeface="맑은 고딕" pitchFamily="34" charset="-120"/>
               </a:rPr>
-              <a:t>유리판 2매를 포개어 접촉 상태 두께 선측정(A) → 혼합 종료 cement 0.10mL을 유리판 사이 중앙에 위치 → 작업시간 10초 전부터 하중장치로 150N을 10분간 적용 → 재측정(B) → 피막도 = B − A</a:t>
+              <a:t>유리판 2매를 포개어 접촉 상태 두께 선측정(A) → 혼합 종료 cement 0.10mL을 유리판 사이 중앙에 위치 → 작업 시간 10초 전부터 하중 장치로 150N을 1분간 적용 → 재측정(B) → 피막도 = B − A</a:t>
             </a:r>
             <a:endParaRPr lang="en-US" sz="1500" dirty="0"/>
           </a:p>
@@ -22642,7 +21351,7 @@
       </p:sp>
       <p:pic>
         <p:nvPicPr>
-          <p:cNvPr id="8" name="Image 0" descr="/home/user/-/.claude/worktrees/agent-a33c37b000189e92f/수복치과재료학실험/dental_photos/insert/photo_02.jpg">    </p:cNvPr>
+          <p:cNvPr id="8" name="Image 0" descr="/home/user/-/수복치과재료학실험/dental_photos/insert/photo_02.jpg">    </p:cNvPr>
           <p:cNvPicPr>
             <a:picLocks noChangeAspect="1"/>
           </p:cNvPicPr>
@@ -22721,7 +21430,7 @@
                 <a:ea typeface="맑은 고딕" pitchFamily="34" charset="-122"/>
                 <a:cs typeface="맑은 고딕" pitchFamily="34" charset="-120"/>
               </a:rPr>
-              <a:t>Setting time — 금속 몰드</a:t>
+              <a:t>Scene applying cement for measuring film thickness</a:t>
             </a:r>
             <a:endParaRPr lang="en-US" sz="1100" dirty="0"/>
           </a:p>
@@ -22763,7 +21472,7 @@
                 <a:ea typeface="맑은 고딕" pitchFamily="34" charset="-122"/>
                 <a:cs typeface="맑은 고딕" pitchFamily="34" charset="-120"/>
               </a:rPr>
-              <a:t>※ ISO 9917-1 규격 문서는 시멘트량을 0.1g으로 표기하나, 실제 강의 프로토콜은 0.10mL 기준 — 단위 표기 차이이며 비중 차로 실질량은 유사.</a:t>
+              <a:t>※ ISO 9917-1 규격 문서는 시멘트량을 0.1g으로 표기하나, 실제 강의 프로토콜은 0.10mL 기준 — 실질량은 유사한 것으로 간주한다.</a:t>
             </a:r>
             <a:endParaRPr lang="en-US" sz="1050" dirty="0"/>
           </a:p>

</xml_diff>

<commit_message>
Add missing Film Thickness interpretation slide
결과 해석 slide only discussed Setting time (P/L ratio, cooling-slab
effect, manufacturer comparison) — Film Thickness results from slide
11's chart were never interpreted anywhere in the deck. Split the old
single 결과 해석 slide into two:
  - Slide 13: 결과 해석 ① — Setting Time (unchanged content)
  - Slide 14: 결과 해석 ② — Film Thickness (new): P/L ratio vs film
    thickness trend (matches theory, but flags the A3 outlier's effect
    on SD), cooling-slab/RMGI effect, and how our group's raw values
    compare to the class average (mirrors the SD-multiple framing used
    for setting time on slide 12).

Renumbered slides 14→15 (결론) and 15→16 (참고문헌), updated pageNum
calls and the 결론 slide's notes timestamp. 발표대본.md and README.md
updated to match (16 slides, ~10:25 runtime, rehearsal checklist
note). Verified all 15 narrated slides' notes match the script
word-for-word via python-pptx.
</commit_message>
<xml_diff>
--- a/수복치과재료학실험/수복치과재료학실험_DentalCements_20260922.pptx
+++ b/수복치과재료학실험/수복치과재료학실험_DentalCements_20260922.pptx
@@ -20,9 +20,10 @@
     <p:sldId id="268" r:id="rId14"/>
     <p:sldId id="269" r:id="rId15"/>
     <p:sldId id="270" r:id="rId16"/>
+    <p:sldId id="271" r:id="rId17"/>
   </p:sldIdLst>
   <p:notesMasterIdLst>
-    <p:notesMasterId r:id="rId17"/>
+    <p:notesMasterId r:id="rId18"/>
   </p:notesMasterIdLst>
   <p:sldSz cx="12192000" cy="6858000"/>
   <p:notesSz cx="6858000" cy="12192000"/>
@@ -2196,7 +2197,7 @@
           <a:p>
             <a:r>
               <a:rPr lang="en-US" dirty="0"/>
-              <a:t>[대본 8:50~9:45]
+              <a:t>[대본 8:50~9:35]
 먼저 분액비와 경화시간 관계를 보면, 이론상으로는 분액비가 높을수록 반응할 산화아연이 많아져서 빨리 굳어야 하는데, 저희 실측도 15% 높음이 정상보다 빠르게 나와서 이론과 대체로 맞았습니다. 다만 정상 조건 자체가 예상보다 오래 걸린 건, 혼합 균질도나 실험실 온습도, indentor 판정 시점의 주관성 같은 요인이 작용했을 것으로 봅니다.
 냉각판 효과는 저희 예상과 반대로 나왔는데요, 온도가 낮으면 반응이 느려져서 경화도 늦어질 거라 생각했지만, 실측은 오히려 상온보다 짧게 나왔습니다. 다만 저희가 작업시간을 따로 측정하지 못해서 경화시간만으로 비교한 한계가 있습니다.
 마지막으로 제조사 공식 값과 비교하면 전반적으로 실측이 1.9배에서 2.4배 정도 느린데, 이건 ISO 표준 조건인 37도가 아니라 상온에서 실습했기 때문으로 보입니다.
@@ -2288,9 +2289,10 @@
           <a:p>
             <a:r>
               <a:rPr lang="en-US" dirty="0"/>
-              <a:t>[대본 9:45~10:00]
-정리하면, 분액비와 혼합 온도, 재료 종류 모두 dental cement의 경화시간과 피막도에 유의한 영향을 줍니다. 임상에서는 이 특성을 이용해서, 빠른 경화가 필요하면 분액비를 높게, 여유 있는 작업시간이 필요하면 낮은 분액비나 냉각판을 활용하는 식으로 조절해서 쓸 수 있겠습니다.
-이상으로 발표를 마치겠습니다. 감사합니다.</a:t>
+              <a:t>[대본 9:35~10:10]
+피막도 결과도 짚고 가겠습니다. 이론상으로는 분액비가 높을수록 반죽이 되직해져서 압착할 때 잘 안 퍼지니까 피막도가 두꺼워질 거라 예상했는데, 반 평균을 보면 실제로 15% 낮음이 가장 얇고 15% 높음이 가장 두꺼워서 이론과 맞았습니다. 다만 세 조건 모두 표준편차가 워낙 커서, 이건 한 조의 이상치 영향이 크다는 걸 슬라이드 11에서 이미 말씀드렸으니 경향성만 참고해 주시면 됩니다.
+냉각판 조건은 반 평균이 오히려 가장 얇게 나왔고, RMGI도 ZPC보다 얇은 편이었습니다. 저희 조 실측은 ZPC 세 조건에서는 반 평균보다 얇게, 냉각판에서는 오히려 평균보다 두껍게 나왔는데, 이것도 setting time 때와 비슷하게 저희가 측정하는 과정에서 판정 기준이 다른 조와 조금 달랐을 가능성이 있다고 봅니다.
+[발표 팁] 슬라이드 11의 Film thickness 차트·각주(A3 이상치)를 화면에 띄워두고 같이 설명하면 좋음. SD가 커서 통계적으로 단정짓기 어렵다는 점을 솔직히 인정하고 넘어갈 것.</a:t>
             </a:r>
             <a:endParaRPr lang="en-US" dirty="0"/>
           </a:p>
@@ -2378,6 +2380,96 @@
           <a:p>
             <a:r>
               <a:rPr lang="en-US" dirty="0"/>
+              <a:t>[대본 10:10~10:25]
+정리하면, 분액비와 혼합 온도, 재료 종류 모두 dental cement의 경화시간과 피막도에 유의한 영향을 줍니다. 임상에서는 이 특성을 이용해서, 빠른 경화가 필요하면 분액비를 높게, 여유 있는 작업시간이 필요하면 낮은 분액비나 냉각판을 활용하는 식으로 조절해서 쓸 수 있겠습니다.
+이상으로 발표를 마치겠습니다. 감사합니다.</a:t>
+            </a:r>
+            <a:endParaRPr lang="en-US" dirty="0"/>
+          </a:p>
+        </p:txBody>
+      </p:sp>
+      <p:sp>
+        <p:nvSpPr>
+          <p:cNvPr id="4" name="Slide Number Placeholder 3"/>
+          <p:cNvSpPr>
+            <a:spLocks noGrp="1"/>
+          </p:cNvSpPr>
+          <p:nvPr>
+            <p:ph type="sldNum" sz="quarter" idx="10"/>
+          </p:nvPr>
+        </p:nvSpPr>
+        <p:spPr/>
+        <p:txBody>
+          <a:bodyPr/>
+          <a:lstStyle/>
+          <a:p>
+            <a:fld id="{F7021451-1387-4CA6-816F-3879F97B5CBC}" type="slidenum">
+              <a:rPr lang="en-US"/>
+              <a:t>15</a:t>
+            </a:fld>
+            <a:endParaRPr lang="en-US"/>
+          </a:p>
+        </p:txBody>
+      </p:sp>
+    </p:spTree>
+    <p:extLst>
+      <p:ext uri="{BB962C8B-B14F-4D97-AF65-F5344CB8AC3E}">
+        <p14:creationId xmlns:p14="http://schemas.microsoft.com/office/powerpoint/2010/main" val="1024086991"/>
+      </p:ext>
+    </p:extLst>
+  </p:cSld>
+  <p:clrMapOvr>
+    <a:masterClrMapping/>
+  </p:clrMapOvr>
+</p:notes>
+</file>
+
+<file path=ppt/notesSlides/notesSlide16.xml><?xml version="1.0" encoding="utf-8"?>
+<p:notes xmlns:a="http://schemas.openxmlformats.org/drawingml/2006/main" xmlns:r="http://schemas.openxmlformats.org/officeDocument/2006/relationships" xmlns:p="http://schemas.openxmlformats.org/presentationml/2006/main">
+  <p:cSld>
+    <p:spTree>
+      <p:nvGrpSpPr>
+        <p:cNvPr id="1" name=""/>
+        <p:cNvGrpSpPr/>
+        <p:nvPr/>
+      </p:nvGrpSpPr>
+      <p:grpSpPr>
+        <a:xfrm>
+          <a:off x="0" y="0"/>
+          <a:ext cx="0" cy="0"/>
+          <a:chOff x="0" y="0"/>
+          <a:chExt cx="0" cy="0"/>
+        </a:xfrm>
+      </p:grpSpPr>
+      <p:sp>
+        <p:nvSpPr>
+          <p:cNvPr id="2" name="Slide Image Placeholder 1"/>
+          <p:cNvSpPr>
+            <a:spLocks noGrp="1" noRot="1" noChangeAspect="1"/>
+          </p:cNvSpPr>
+          <p:nvPr>
+            <p:ph type="sldImg"/>
+          </p:nvPr>
+        </p:nvSpPr>
+        <p:spPr/>
+      </p:sp>
+      <p:sp>
+        <p:nvSpPr>
+          <p:cNvPr id="3" name="Notes Placeholder 2"/>
+          <p:cNvSpPr>
+            <a:spLocks noGrp="1"/>
+          </p:cNvSpPr>
+          <p:nvPr>
+            <p:ph type="body" idx="1"/>
+          </p:nvPr>
+        </p:nvSpPr>
+        <p:spPr/>
+        <p:txBody>
+          <a:bodyPr/>
+          <a:lstStyle/>
+          <a:p>
+            <a:r>
+              <a:rPr lang="en-US" dirty="0"/>
               <a:t>[예상 질문 메모]
 Q. 조별 취합 데이터에서 film thickness 값이 이상하게 튄 조(A3)는 어떻게 처리했나?
 → 평균에는 그대로 반영했지만, 슬라이드 11에 측정·단위 오류 가능성이 있다고 명시해뒀다고 답하면 됩니다. 발표 전 실제로 해당 조에 값을 한 번 더 확인해두면 더 좋습니다.
@@ -2409,7 +2501,7 @@
           <a:p>
             <a:fld id="{F7021451-1387-4CA6-816F-3879F97B5CBC}" type="slidenum">
               <a:rPr lang="en-US"/>
-              <a:t>15</a:t>
+              <a:t>16</a:t>
             </a:fld>
             <a:endParaRPr lang="en-US"/>
           </a:p>
@@ -9640,7 +9732,7 @@
                 <a:ea typeface="맑은 고딕" pitchFamily="34" charset="-122"/>
                 <a:cs typeface="맑은 고딕" pitchFamily="34" charset="-120"/>
               </a:rPr>
-              <a:t>고찰</a:t>
+              <a:t>고찰 · 01</a:t>
             </a:r>
             <a:endParaRPr lang="en-US" sz="1200" dirty="0"/>
           </a:p>
@@ -9679,7 +9771,7 @@
                 <a:ea typeface="맑은 고딕" pitchFamily="34" charset="-122"/>
                 <a:cs typeface="맑은 고딕" pitchFamily="34" charset="-120"/>
               </a:rPr>
-              <a:t>결과 해석 및 고찰</a:t>
+              <a:t>결과 해석 ① — Setting Time</a:t>
             </a:r>
             <a:endParaRPr lang="en-US" sz="2400" dirty="0"/>
           </a:p>
@@ -10061,54 +10153,14 @@
       </p:grpSpPr>
       <p:sp>
         <p:nvSpPr>
-          <p:cNvPr id="2" name="Shape 0"/>
-          <p:cNvSpPr/>
+          <p:cNvPr id="2" name="Text 0"/>
+          <p:cNvSpPr txBox="1"/>
           <p:nvPr/>
         </p:nvSpPr>
         <p:spPr>
           <a:xfrm>
-            <a:off x="0" y="0"/>
-            <a:ext cx="12188952" cy="6858000"/>
-          </a:xfrm>
-          <a:prstGeom prst="rect">
-            <a:avLst/>
-          </a:prstGeom>
-          <a:solidFill>
-            <a:srgbClr val="1B3A5C"/>
-          </a:solidFill>
-          <a:ln/>
-        </p:spPr>
-      </p:sp>
-      <p:sp>
-        <p:nvSpPr>
-          <p:cNvPr id="3" name="Shape 1"/>
-          <p:cNvSpPr/>
-          <p:nvPr/>
-        </p:nvSpPr>
-        <p:spPr>
-          <a:xfrm>
-            <a:off x="-2286000" y="3657600"/>
-            <a:ext cx="5486400" cy="5486400"/>
-          </a:xfrm>
-          <a:prstGeom prst="ellipse">
-            <a:avLst/>
-          </a:prstGeom>
-          <a:solidFill>
-            <a:srgbClr val="10253D"/>
-          </a:solidFill>
-          <a:ln/>
-        </p:spPr>
-      </p:sp>
-      <p:sp>
-        <p:nvSpPr>
-          <p:cNvPr id="4" name="Text 2"/>
-          <p:cNvSpPr txBox="1"/>
-          <p:nvPr/>
-        </p:nvSpPr>
-        <p:spPr>
-          <a:xfrm>
-            <a:off x="822960" y="640080"/>
-            <a:ext cx="5486400" cy="457200"/>
+            <a:off x="640080" y="365760"/>
+            <a:ext cx="10908792" cy="292608"/>
           </a:xfrm>
           <a:prstGeom prst="rect">
             <a:avLst/>
@@ -10124,7 +10176,7 @@
               <a:buNone/>
             </a:pPr>
             <a:r>
-              <a:rPr lang="en-US" sz="1400" b="1" spc="100" kern="0" dirty="0">
+              <a:rPr lang="en-US" sz="1200" b="1" spc="100" kern="0" dirty="0">
                 <a:solidFill>
                   <a:srgbClr val="4A90C2"/>
                 </a:solidFill>
@@ -10132,22 +10184,22 @@
                 <a:ea typeface="맑은 고딕" pitchFamily="34" charset="-122"/>
                 <a:cs typeface="맑은 고딕" pitchFamily="34" charset="-120"/>
               </a:rPr>
-              <a:t>결론</a:t>
-            </a:r>
-            <a:endParaRPr lang="en-US" sz="1400" dirty="0"/>
+              <a:t>고찰 · 02</a:t>
+            </a:r>
+            <a:endParaRPr lang="en-US" sz="1200" dirty="0"/>
           </a:p>
         </p:txBody>
       </p:sp>
       <p:sp>
         <p:nvSpPr>
-          <p:cNvPr id="5" name="Text 3"/>
+          <p:cNvPr id="3" name="Text 1"/>
           <p:cNvSpPr txBox="1"/>
           <p:nvPr/>
         </p:nvSpPr>
         <p:spPr>
           <a:xfrm>
-            <a:off x="822960" y="1143000"/>
-            <a:ext cx="10332720" cy="1188720"/>
+            <a:off x="640080" y="640080"/>
+            <a:ext cx="10908792" cy="548640"/>
           </a:xfrm>
           <a:prstGeom prst="rect">
             <a:avLst/>
@@ -10160,36 +10212,72 @@
           <a:lstStyle/>
           <a:p>
             <a:pPr indent="0" marL="0">
-              <a:lnSpc>
-                <a:spcPct val="130000"/>
-              </a:lnSpc>
               <a:buNone/>
             </a:pPr>
             <a:r>
-              <a:rPr lang="en-US" sz="2600" b="1" dirty="0">
-                <a:solidFill>
-                  <a:srgbClr val="FFFFFF"/>
+              <a:rPr lang="en-US" sz="2400" b="1" dirty="0">
+                <a:solidFill>
+                  <a:srgbClr val="1B3A5C"/>
                 </a:solidFill>
                 <a:latin typeface="맑은 고딕" pitchFamily="34" charset="0"/>
                 <a:ea typeface="맑은 고딕" pitchFamily="34" charset="-122"/>
                 <a:cs typeface="맑은 고딕" pitchFamily="34" charset="-120"/>
               </a:rPr>
-              <a:t>분액비·혼합 온도·재료 종류 모두 dental cement의 경화 시간과 피막도에 유의한 영향이 있다.</a:t>
-            </a:r>
-            <a:endParaRPr lang="en-US" sz="2600" dirty="0"/>
+              <a:t>결과 해석 ② — Film Thickness</a:t>
+            </a:r>
+            <a:endParaRPr lang="en-US" sz="2400" dirty="0"/>
           </a:p>
         </p:txBody>
       </p:sp>
       <p:sp>
         <p:nvSpPr>
-          <p:cNvPr id="6" name="Text 4"/>
+          <p:cNvPr id="4" name="Text 2"/>
           <p:cNvSpPr txBox="1"/>
           <p:nvPr/>
         </p:nvSpPr>
         <p:spPr>
           <a:xfrm>
-            <a:off x="822960" y="2606040"/>
-            <a:ext cx="10332720" cy="2377440"/>
+            <a:off x="640080" y="1554480"/>
+            <a:ext cx="10908792" cy="347472"/>
+          </a:xfrm>
+          <a:prstGeom prst="rect">
+            <a:avLst/>
+          </a:prstGeom>
+          <a:noFill/>
+          <a:ln/>
+        </p:spPr>
+        <p:txBody>
+          <a:bodyPr wrap="square" lIns="0" tIns="0" rIns="0" bIns="0" rtlCol="0" anchor="ctr"/>
+          <a:lstStyle/>
+          <a:p>
+            <a:pPr indent="0" marL="0">
+              <a:buNone/>
+            </a:pPr>
+            <a:r>
+              <a:rPr lang="en-US" sz="1450" b="1" dirty="0">
+                <a:solidFill>
+                  <a:srgbClr val="1B3A5C"/>
+                </a:solidFill>
+                <a:latin typeface="맑은 고딕" pitchFamily="34" charset="0"/>
+                <a:ea typeface="맑은 고딕" pitchFamily="34" charset="-122"/>
+                <a:cs typeface="맑은 고딕" pitchFamily="34" charset="-120"/>
+              </a:rPr>
+              <a:t>① P/L ratio와 피막도</a:t>
+            </a:r>
+            <a:endParaRPr lang="en-US" sz="1450" dirty="0"/>
+          </a:p>
+        </p:txBody>
+      </p:sp>
+      <p:sp>
+        <p:nvSpPr>
+          <p:cNvPr id="5" name="Text 3"/>
+          <p:cNvSpPr txBox="1"/>
+          <p:nvPr/>
+        </p:nvSpPr>
+        <p:spPr>
+          <a:xfrm>
+            <a:off x="640080" y="1920240"/>
+            <a:ext cx="10908792" cy="1417320"/>
           </a:xfrm>
           <a:prstGeom prst="rect">
             <a:avLst/>
@@ -10208,17 +10296,17 @@
               <a:buNone/>
             </a:pPr>
             <a:r>
-              <a:rPr lang="en-US" sz="1400" dirty="0">
-                <a:solidFill>
-                  <a:srgbClr val="FFFFFF"/>
+              <a:rPr lang="en-US" sz="1300" dirty="0">
+                <a:solidFill>
+                  <a:srgbClr val="1C2733"/>
                 </a:solidFill>
                 <a:latin typeface="맑은 고딕" pitchFamily="34" charset="0"/>
                 <a:ea typeface="맑은 고딕" pitchFamily="34" charset="-122"/>
                 <a:cs typeface="맑은 고딕" pitchFamily="34" charset="-120"/>
               </a:rPr>
-              <a:t>•  분액비가 높을수록 경화 시간이 짧아지는 경향이 대체로 확인됨(일부 예외 존재 — 혼합·측정 오차 가능성)</a:t>
-            </a:r>
-            <a:endParaRPr lang="en-US" sz="1400" dirty="0"/>
+              <a:t>•  이론: 분액비(P/L)가 높을수록 반죽의 점도가 증가해 압착 시 유동성이 떨어지고, 그만큼 얇게 눌리지 못해 피막도가 커질 것으로 예상됨</a:t>
+            </a:r>
+            <a:endParaRPr lang="en-US" sz="1300" dirty="0"/>
           </a:p>
           <a:p>
             <a:pPr indent="0" marL="0">
@@ -10228,18 +10316,79 @@
               <a:buNone/>
             </a:pPr>
             <a:r>
-              <a:rPr lang="en-US" sz="1400" dirty="0">
-                <a:solidFill>
-                  <a:srgbClr val="FFFFFF"/>
+              <a:rPr lang="en-US" sz="1300" dirty="0">
+                <a:solidFill>
+                  <a:srgbClr val="1C2733"/>
                 </a:solidFill>
                 <a:latin typeface="맑은 고딕" pitchFamily="34" charset="0"/>
                 <a:ea typeface="맑은 고딕" pitchFamily="34" charset="-122"/>
                 <a:cs typeface="맑은 고딕" pitchFamily="34" charset="-120"/>
               </a:rPr>
-              <a:t>•  냉각판(저온) 조건은 이론상 경화 지연을 예상했으나 실측은 반대 — 작업시간·경화 시간을 분리 측정하지 못한 한계</a:t>
-            </a:r>
-            <a:endParaRPr lang="en-US" sz="1400" dirty="0"/>
-          </a:p>
+              <a:t>•  실측(반 평균): 이론과 부합 — 15%↓(0.035mm) &lt; 정상(0.047mm) &lt; 15%↑(0.049mm) 순으로 분액비가 높을수록 피막도 증가. 다만 세 조건 모두 표준편차가 매우 커서(한 조(A3)의 이상치 영향, 슬라이드 11 참고) 경향성 해석에는 주의가 필요함</a:t>
+            </a:r>
+            <a:endParaRPr lang="en-US" sz="1300" dirty="0"/>
+          </a:p>
+        </p:txBody>
+      </p:sp>
+      <p:sp>
+        <p:nvSpPr>
+          <p:cNvPr id="6" name="Text 4"/>
+          <p:cNvSpPr txBox="1"/>
+          <p:nvPr/>
+        </p:nvSpPr>
+        <p:spPr>
+          <a:xfrm>
+            <a:off x="640080" y="3520440"/>
+            <a:ext cx="10908792" cy="347472"/>
+          </a:xfrm>
+          <a:prstGeom prst="rect">
+            <a:avLst/>
+          </a:prstGeom>
+          <a:noFill/>
+          <a:ln/>
+        </p:spPr>
+        <p:txBody>
+          <a:bodyPr wrap="square" lIns="0" tIns="0" rIns="0" bIns="0" rtlCol="0" anchor="ctr"/>
+          <a:lstStyle/>
+          <a:p>
+            <a:pPr indent="0" marL="0">
+              <a:buNone/>
+            </a:pPr>
+            <a:r>
+              <a:rPr lang="en-US" sz="1450" b="1" dirty="0">
+                <a:solidFill>
+                  <a:srgbClr val="1B3A5C"/>
+                </a:solidFill>
+                <a:latin typeface="맑은 고딕" pitchFamily="34" charset="0"/>
+                <a:ea typeface="맑은 고딕" pitchFamily="34" charset="-122"/>
+                <a:cs typeface="맑은 고딕" pitchFamily="34" charset="-120"/>
+              </a:rPr>
+              <a:t>② 냉각판·RMGI 효과, 그리고 우리 조(A2)의 위치</a:t>
+            </a:r>
+            <a:endParaRPr lang="en-US" sz="1450" dirty="0"/>
+          </a:p>
+        </p:txBody>
+      </p:sp>
+      <p:sp>
+        <p:nvSpPr>
+          <p:cNvPr id="7" name="Text 5"/>
+          <p:cNvSpPr txBox="1"/>
+          <p:nvPr/>
+        </p:nvSpPr>
+        <p:spPr>
+          <a:xfrm>
+            <a:off x="640080" y="3867912"/>
+            <a:ext cx="10908792" cy="1828800"/>
+          </a:xfrm>
+          <a:prstGeom prst="rect">
+            <a:avLst/>
+          </a:prstGeom>
+          <a:noFill/>
+          <a:ln/>
+        </p:spPr>
+        <p:txBody>
+          <a:bodyPr wrap="square" lIns="0" tIns="0" rIns="0" bIns="0" rtlCol="0" anchor="t"/>
+          <a:lstStyle/>
           <a:p>
             <a:pPr indent="0" marL="0">
               <a:lnSpc>
@@ -10248,23 +10397,124 @@
               <a:buNone/>
             </a:pPr>
             <a:r>
-              <a:rPr lang="en-US" sz="1400" dirty="0">
-                <a:solidFill>
-                  <a:srgbClr val="FFFFFF"/>
+              <a:rPr lang="en-US" sz="1300" dirty="0">
+                <a:solidFill>
+                  <a:srgbClr val="1C2733"/>
                 </a:solidFill>
                 <a:latin typeface="맑은 고딕" pitchFamily="34" charset="0"/>
                 <a:ea typeface="맑은 고딕" pitchFamily="34" charset="-122"/>
                 <a:cs typeface="맑은 고딕" pitchFamily="34" charset="-120"/>
               </a:rPr>
-              <a:t>•  임상에서는 합착 목적·필요 작업시간에 따라 재료와 분액비를 조절해 사용해야 함 — 예: 빠른 경화가 필요하면 high P/L, 여유 있는 작업시간이 필요하면 low P/L 또는 냉각판 활용</a:t>
-            </a:r>
-            <a:endParaRPr lang="en-US" sz="1400" dirty="0"/>
+              <a:t>•  냉각판 조건은 반 평균 피막도(0.012mm)가 나머지 ZPC 조건보다 훨씬 얇게 나옴 — 낮은 온도가 압착 시 유동성을 오히려 개선했을 가능성(표본이 적어 단정하기는 어려움). RMGI(0.015mm)도 ZPC 대비 얇은 편 — 레진 개량형 특유의 낮은 초기 점도 영향으로 추정</a:t>
+            </a:r>
+            <a:endParaRPr lang="en-US" sz="1300" dirty="0"/>
+          </a:p>
+          <a:p>
+            <a:pPr indent="0" marL="0">
+              <a:lnSpc>
+                <a:spcPct val="140000"/>
+              </a:lnSpc>
+              <a:buNone/>
+            </a:pPr>
+            <a:r>
+              <a:rPr lang="en-US" sz="1300" dirty="0">
+                <a:solidFill>
+                  <a:srgbClr val="1C2733"/>
+                </a:solidFill>
+                <a:latin typeface="맑은 고딕" pitchFamily="34" charset="0"/>
+                <a:ea typeface="맑은 고딕" pitchFamily="34" charset="-122"/>
+                <a:cs typeface="맑은 고딕" pitchFamily="34" charset="-120"/>
+              </a:rPr>
+              <a:t>•  우리 조 실측은 ZPC 세 조건(정상·15%↑·15%↓) 모두 반 평균보다 얇게 나왔고(−0.5~−0.7 SD), 냉각판만 평균보다 두껍게 나옴(+1.1 SD) — Setting time과 마찬가지로 개인별 측정 판정 차이(글라스판 접촉 상태 확인, 하중 적용 타이밍 등)가 영향을 줬을 가능성을 고려할 수 있음</a:t>
+            </a:r>
+            <a:endParaRPr lang="en-US" sz="1300" dirty="0"/>
           </a:p>
         </p:txBody>
       </p:sp>
       <p:sp>
         <p:nvSpPr>
-          <p:cNvPr id="7" name="Text 5"/>
+          <p:cNvPr id="8" name="Shape 6"/>
+          <p:cNvSpPr/>
+          <p:nvPr/>
+        </p:nvSpPr>
+        <p:spPr>
+          <a:xfrm>
+            <a:off x="640080" y="5897880"/>
+            <a:ext cx="10908792" cy="731520"/>
+          </a:xfrm>
+          <a:prstGeom prst="roundRect">
+            <a:avLst>
+              <a:gd name="adj" fmla="val 10000"/>
+            </a:avLst>
+          </a:prstGeom>
+          <a:solidFill>
+            <a:srgbClr val="EAF2EE"/>
+          </a:solidFill>
+          <a:ln/>
+        </p:spPr>
+      </p:sp>
+      <p:sp>
+        <p:nvSpPr>
+          <p:cNvPr id="9" name="Text 7"/>
+          <p:cNvSpPr txBox="1"/>
+          <p:nvPr/>
+        </p:nvSpPr>
+        <p:spPr>
+          <a:xfrm>
+            <a:off x="868680" y="6016752"/>
+            <a:ext cx="10451592" cy="502920"/>
+          </a:xfrm>
+          <a:prstGeom prst="rect">
+            <a:avLst/>
+          </a:prstGeom>
+          <a:noFill/>
+          <a:ln/>
+        </p:spPr>
+        <p:txBody>
+          <a:bodyPr wrap="square" lIns="0" tIns="0" rIns="0" bIns="0" rtlCol="0" anchor="ctr"/>
+          <a:lstStyle/>
+          <a:p>
+            <a:pPr indent="0" marL="0">
+              <a:lnSpc>
+                <a:spcPct val="125000"/>
+              </a:lnSpc>
+              <a:buNone/>
+            </a:pPr>
+            <a:r>
+              <a:rPr lang="en-US" sz="1100" b="1" dirty="0">
+                <a:solidFill>
+                  <a:srgbClr val="1B3A5C"/>
+                </a:solidFill>
+                <a:latin typeface="맑은 고딕" pitchFamily="34" charset="0"/>
+                <a:ea typeface="맑은 고딕" pitchFamily="34" charset="-122"/>
+                <a:cs typeface="맑은 고딕" pitchFamily="34" charset="-120"/>
+              </a:rPr>
+              <a:t>정리: </a:t>
+            </a:r>
+            <a:pPr indent="0" marL="0">
+              <a:lnSpc>
+                <a:spcPct val="125000"/>
+              </a:lnSpc>
+              <a:buNone/>
+            </a:pPr>
+            <a:r>
+              <a:rPr lang="en-US" sz="1100" dirty="0">
+                <a:solidFill>
+                  <a:srgbClr val="1C2733"/>
+                </a:solidFill>
+                <a:latin typeface="맑은 고딕" pitchFamily="34" charset="0"/>
+                <a:ea typeface="맑은 고딕" pitchFamily="34" charset="-122"/>
+                <a:cs typeface="맑은 고딕" pitchFamily="34" charset="-120"/>
+              </a:rPr>
+              <a:t>Setting time과 마찬가지로 피막도도 분액비·냉각판 조건에 따라 유의한 차이를 보이며, 개별 조의 측정·판정 방식 차이가 재료 자체의 특성만큼이나 결과에 영향을 줄 수 있음을 시사함.</a:t>
+            </a:r>
+            <a:endParaRPr lang="en-US" sz="1100" dirty="0"/>
+          </a:p>
+        </p:txBody>
+      </p:sp>
+      <p:sp>
+        <p:nvSpPr>
+          <p:cNvPr id="10" name="Text 8"/>
           <p:cNvSpPr txBox="1"/>
           <p:nvPr/>
         </p:nvSpPr>
@@ -10335,6 +10585,280 @@
       </p:grpSpPr>
       <p:sp>
         <p:nvSpPr>
+          <p:cNvPr id="2" name="Shape 0"/>
+          <p:cNvSpPr/>
+          <p:nvPr/>
+        </p:nvSpPr>
+        <p:spPr>
+          <a:xfrm>
+            <a:off x="0" y="0"/>
+            <a:ext cx="12188952" cy="6858000"/>
+          </a:xfrm>
+          <a:prstGeom prst="rect">
+            <a:avLst/>
+          </a:prstGeom>
+          <a:solidFill>
+            <a:srgbClr val="1B3A5C"/>
+          </a:solidFill>
+          <a:ln/>
+        </p:spPr>
+      </p:sp>
+      <p:sp>
+        <p:nvSpPr>
+          <p:cNvPr id="3" name="Shape 1"/>
+          <p:cNvSpPr/>
+          <p:nvPr/>
+        </p:nvSpPr>
+        <p:spPr>
+          <a:xfrm>
+            <a:off x="-2286000" y="3657600"/>
+            <a:ext cx="5486400" cy="5486400"/>
+          </a:xfrm>
+          <a:prstGeom prst="ellipse">
+            <a:avLst/>
+          </a:prstGeom>
+          <a:solidFill>
+            <a:srgbClr val="10253D"/>
+          </a:solidFill>
+          <a:ln/>
+        </p:spPr>
+      </p:sp>
+      <p:sp>
+        <p:nvSpPr>
+          <p:cNvPr id="4" name="Text 2"/>
+          <p:cNvSpPr txBox="1"/>
+          <p:nvPr/>
+        </p:nvSpPr>
+        <p:spPr>
+          <a:xfrm>
+            <a:off x="822960" y="640080"/>
+            <a:ext cx="5486400" cy="457200"/>
+          </a:xfrm>
+          <a:prstGeom prst="rect">
+            <a:avLst/>
+          </a:prstGeom>
+          <a:noFill/>
+          <a:ln/>
+        </p:spPr>
+        <p:txBody>
+          <a:bodyPr wrap="square" lIns="0" tIns="0" rIns="0" bIns="0" rtlCol="0" anchor="ctr"/>
+          <a:lstStyle/>
+          <a:p>
+            <a:pPr indent="0" marL="0">
+              <a:buNone/>
+            </a:pPr>
+            <a:r>
+              <a:rPr lang="en-US" sz="1400" b="1" spc="100" kern="0" dirty="0">
+                <a:solidFill>
+                  <a:srgbClr val="4A90C2"/>
+                </a:solidFill>
+                <a:latin typeface="맑은 고딕" pitchFamily="34" charset="0"/>
+                <a:ea typeface="맑은 고딕" pitchFamily="34" charset="-122"/>
+                <a:cs typeface="맑은 고딕" pitchFamily="34" charset="-120"/>
+              </a:rPr>
+              <a:t>결론</a:t>
+            </a:r>
+            <a:endParaRPr lang="en-US" sz="1400" dirty="0"/>
+          </a:p>
+        </p:txBody>
+      </p:sp>
+      <p:sp>
+        <p:nvSpPr>
+          <p:cNvPr id="5" name="Text 3"/>
+          <p:cNvSpPr txBox="1"/>
+          <p:nvPr/>
+        </p:nvSpPr>
+        <p:spPr>
+          <a:xfrm>
+            <a:off x="822960" y="1143000"/>
+            <a:ext cx="10332720" cy="1188720"/>
+          </a:xfrm>
+          <a:prstGeom prst="rect">
+            <a:avLst/>
+          </a:prstGeom>
+          <a:noFill/>
+          <a:ln/>
+        </p:spPr>
+        <p:txBody>
+          <a:bodyPr wrap="square" lIns="0" tIns="0" rIns="0" bIns="0" rtlCol="0" anchor="ctr"/>
+          <a:lstStyle/>
+          <a:p>
+            <a:pPr indent="0" marL="0">
+              <a:lnSpc>
+                <a:spcPct val="130000"/>
+              </a:lnSpc>
+              <a:buNone/>
+            </a:pPr>
+            <a:r>
+              <a:rPr lang="en-US" sz="2600" b="1" dirty="0">
+                <a:solidFill>
+                  <a:srgbClr val="FFFFFF"/>
+                </a:solidFill>
+                <a:latin typeface="맑은 고딕" pitchFamily="34" charset="0"/>
+                <a:ea typeface="맑은 고딕" pitchFamily="34" charset="-122"/>
+                <a:cs typeface="맑은 고딕" pitchFamily="34" charset="-120"/>
+              </a:rPr>
+              <a:t>분액비·혼합 온도·재료 종류 모두 dental cement의 경화 시간과 피막도에 유의한 영향이 있다.</a:t>
+            </a:r>
+            <a:endParaRPr lang="en-US" sz="2600" dirty="0"/>
+          </a:p>
+        </p:txBody>
+      </p:sp>
+      <p:sp>
+        <p:nvSpPr>
+          <p:cNvPr id="6" name="Text 4"/>
+          <p:cNvSpPr txBox="1"/>
+          <p:nvPr/>
+        </p:nvSpPr>
+        <p:spPr>
+          <a:xfrm>
+            <a:off x="822960" y="2606040"/>
+            <a:ext cx="10332720" cy="2377440"/>
+          </a:xfrm>
+          <a:prstGeom prst="rect">
+            <a:avLst/>
+          </a:prstGeom>
+          <a:noFill/>
+          <a:ln/>
+        </p:spPr>
+        <p:txBody>
+          <a:bodyPr wrap="square" lIns="0" tIns="0" rIns="0" bIns="0" rtlCol="0" anchor="t"/>
+          <a:lstStyle/>
+          <a:p>
+            <a:pPr indent="0" marL="0">
+              <a:lnSpc>
+                <a:spcPct val="140000"/>
+              </a:lnSpc>
+              <a:buNone/>
+            </a:pPr>
+            <a:r>
+              <a:rPr lang="en-US" sz="1400" dirty="0">
+                <a:solidFill>
+                  <a:srgbClr val="FFFFFF"/>
+                </a:solidFill>
+                <a:latin typeface="맑은 고딕" pitchFamily="34" charset="0"/>
+                <a:ea typeface="맑은 고딕" pitchFamily="34" charset="-122"/>
+                <a:cs typeface="맑은 고딕" pitchFamily="34" charset="-120"/>
+              </a:rPr>
+              <a:t>•  분액비가 높을수록 경화 시간이 짧아지는 경향이 대체로 확인됨(일부 예외 존재 — 혼합·측정 오차 가능성)</a:t>
+            </a:r>
+            <a:endParaRPr lang="en-US" sz="1400" dirty="0"/>
+          </a:p>
+          <a:p>
+            <a:pPr indent="0" marL="0">
+              <a:lnSpc>
+                <a:spcPct val="140000"/>
+              </a:lnSpc>
+              <a:buNone/>
+            </a:pPr>
+            <a:r>
+              <a:rPr lang="en-US" sz="1400" dirty="0">
+                <a:solidFill>
+                  <a:srgbClr val="FFFFFF"/>
+                </a:solidFill>
+                <a:latin typeface="맑은 고딕" pitchFamily="34" charset="0"/>
+                <a:ea typeface="맑은 고딕" pitchFamily="34" charset="-122"/>
+                <a:cs typeface="맑은 고딕" pitchFamily="34" charset="-120"/>
+              </a:rPr>
+              <a:t>•  냉각판(저온) 조건은 이론상 경화 지연을 예상했으나 실측은 반대 — 작업시간·경화 시간을 분리 측정하지 못한 한계</a:t>
+            </a:r>
+            <a:endParaRPr lang="en-US" sz="1400" dirty="0"/>
+          </a:p>
+          <a:p>
+            <a:pPr indent="0" marL="0">
+              <a:lnSpc>
+                <a:spcPct val="140000"/>
+              </a:lnSpc>
+              <a:buNone/>
+            </a:pPr>
+            <a:r>
+              <a:rPr lang="en-US" sz="1400" dirty="0">
+                <a:solidFill>
+                  <a:srgbClr val="FFFFFF"/>
+                </a:solidFill>
+                <a:latin typeface="맑은 고딕" pitchFamily="34" charset="0"/>
+                <a:ea typeface="맑은 고딕" pitchFamily="34" charset="-122"/>
+                <a:cs typeface="맑은 고딕" pitchFamily="34" charset="-120"/>
+              </a:rPr>
+              <a:t>•  임상에서는 합착 목적·필요 작업시간에 따라 재료와 분액비를 조절해 사용해야 함 — 예: 빠른 경화가 필요하면 high P/L, 여유 있는 작업시간이 필요하면 low P/L 또는 냉각판 활용</a:t>
+            </a:r>
+            <a:endParaRPr lang="en-US" sz="1400" dirty="0"/>
+          </a:p>
+        </p:txBody>
+      </p:sp>
+      <p:sp>
+        <p:nvSpPr>
+          <p:cNvPr id="7" name="Text 5"/>
+          <p:cNvSpPr txBox="1"/>
+          <p:nvPr/>
+        </p:nvSpPr>
+        <p:spPr>
+          <a:xfrm>
+            <a:off x="11365992" y="6400800"/>
+            <a:ext cx="457200" cy="320040"/>
+          </a:xfrm>
+          <a:prstGeom prst="rect">
+            <a:avLst/>
+          </a:prstGeom>
+          <a:noFill/>
+          <a:ln/>
+        </p:spPr>
+        <p:txBody>
+          <a:bodyPr wrap="square" lIns="0" tIns="0" rIns="0" bIns="0" rtlCol="0" anchor="ctr"/>
+          <a:lstStyle/>
+          <a:p>
+            <a:pPr algn="r" indent="0" marL="0">
+              <a:buNone/>
+            </a:pPr>
+            <a:r>
+              <a:rPr lang="en-US" sz="1100" dirty="0">
+                <a:solidFill>
+                  <a:srgbClr val="5B6B7A"/>
+                </a:solidFill>
+                <a:latin typeface="Cambria" pitchFamily="34" charset="0"/>
+                <a:ea typeface="Cambria" pitchFamily="34" charset="-122"/>
+                <a:cs typeface="Cambria" pitchFamily="34" charset="-120"/>
+              </a:rPr>
+              <a:t>15</a:t>
+            </a:r>
+            <a:endParaRPr lang="en-US" sz="1100" dirty="0"/>
+          </a:p>
+        </p:txBody>
+      </p:sp>
+    </p:spTree>
+  </p:cSld>
+  <p:clrMapOvr>
+    <a:masterClrMapping/>
+  </p:clrMapOvr>
+</p:sld>
+</file>
+
+<file path=ppt/slides/slide16.xml><?xml version="1.0" encoding="utf-8"?>
+<p:sld xmlns:a="http://schemas.openxmlformats.org/drawingml/2006/main" xmlns:r="http://schemas.openxmlformats.org/officeDocument/2006/relationships" xmlns:p="http://schemas.openxmlformats.org/presentationml/2006/main">
+  <p:cSld name="Slide 16">
+    <p:bg>
+      <p:bgPr>
+        <a:solidFill>
+          <a:srgbClr val="F5F6F8"/>
+        </a:solidFill>
+      </p:bgPr>
+    </p:bg>
+    <p:spTree>
+      <p:nvGrpSpPr>
+        <p:cNvPr id="1" name=""/>
+        <p:cNvGrpSpPr/>
+        <p:nvPr/>
+      </p:nvGrpSpPr>
+      <p:grpSpPr>
+        <a:xfrm>
+          <a:off x="0" y="0"/>
+          <a:ext cx="0" cy="0"/>
+          <a:chOff x="0" y="0"/>
+          <a:chExt cx="0" cy="0"/>
+        </a:xfrm>
+      </p:grpSpPr>
+      <p:sp>
+        <p:nvSpPr>
           <p:cNvPr id="2" name="Text 0"/>
           <p:cNvSpPr txBox="1"/>
           <p:nvPr/>
@@ -10546,7 +11070,7 @@
                 <a:ea typeface="Cambria" pitchFamily="34" charset="-122"/>
                 <a:cs typeface="Cambria" pitchFamily="34" charset="-120"/>
               </a:rPr>
-              <a:t>15</a:t>
+              <a:t>16</a:t>
             </a:r>
             <a:endParaRPr lang="en-US" sz="1100" dirty="0"/>
           </a:p>

</xml_diff>

<commit_message>
Add Film thickness comparison chart to slide 14 (matches slide 12)
Same clustered-bar + error-bar format as slide 12's Setting time
chart: 전체 평균 (with SD error bars) vs 우리 조(A2), for the five
Film thickness conditions. Replaces the prose-only comparison
sentence with a chart + compact caption (same pattern as slide 12).
scripts/add_errorbars.py updated to inject into the new chart4.xml,
error bars on the "전체 평균" series only.
</commit_message>
<xml_diff>
--- a/수복치과재료학실험/수복치과재료학실험_DentalCements_20260922.pptx
+++ b/수복치과재료학실험/수복치과재료학실험_DentalCements_20260922.pptx
@@ -1353,6 +1353,464 @@
         <c:scaling>
           <c:orientation val="minMax"/>
           <c:max val="20"/>
+          <c:min val="0"/>
+        </c:scaling>
+        <c:delete val="0"/>
+        <c:axPos val="l"/>
+        <c:majorGridlines>
+          <c:spPr>
+            <a:ln w="9525" cap="flat">
+              <a:solidFill>
+                <a:srgbClr val="DCE3EA"/>
+              </a:solidFill>
+              <a:prstDash val="solid"/>
+              <a:round/>
+            </a:ln>
+          </c:spPr>
+        </c:majorGridlines>
+        <c:numFmt formatCode="General" sourceLinked="0"/>
+        <c:majorTickMark val="out"/>
+        <c:minorTickMark val="none"/>
+        <c:tickLblPos val="nextTo"/>
+        <c:spPr>
+          <a:ln w="12700" cap="flat">
+            <a:solidFill>
+              <a:srgbClr val="888888"/>
+            </a:solidFill>
+            <a:prstDash val="solid"/>
+            <a:round/>
+          </a:ln>
+        </c:spPr>
+        <c:txPr>
+          <a:bodyPr/>
+          <a:lstStyle/>
+          <a:p>
+            <a:pPr>
+              <a:defRPr sz="900" b="0" i="0" u="none" strike="noStrike">
+                <a:solidFill>
+                  <a:srgbClr val="5B6B7A"/>
+                </a:solidFill>
+                <a:latin typeface="Arial"/>
+              </a:defRPr>
+            </a:pPr>
+            <a:endParaRPr lang="en-US"/>
+          </a:p>
+        </c:txPr>
+        <c:crossAx val="2094734554"/>
+        <c:crosses val="autoZero"/>
+        <c:crossBetween val="between"/>
+      </c:valAx>
+      <c:spPr>
+        <a:noFill/>
+        <a:ln>
+          <a:noFill/>
+        </a:ln>
+        <a:effectLst/>
+      </c:spPr>
+    </c:plotArea>
+    <c:legend>
+      <c:legendPos val="t"/>
+      <c:overlay val="0"/>
+      <c:txPr>
+        <a:bodyPr/>
+        <a:lstStyle/>
+        <a:p>
+          <a:pPr>
+            <a:defRPr sz="900">
+              <a:solidFill>
+                <a:srgbClr val="5B6B7A"/>
+              </a:solidFill>
+            </a:defRPr>
+          </a:pPr>
+          <a:endParaRPr lang="en-US"/>
+        </a:p>
+      </c:txPr>
+    </c:legend>
+    <c:plotVisOnly val="1"/>
+    <c:dispBlanksAs val="span"/>
+  </c:chart>
+  <c:spPr>
+    <a:noFill/>
+    <a:ln>
+      <a:noFill/>
+    </a:ln>
+    <a:effectLst/>
+  </c:spPr>
+  <c:externalData r:id="rId1">
+    <c:autoUpdate val="0"/>
+  </c:externalData>
+</c:chartSpace>
+</file>
+
+<file path=ppt/charts/chart4.xml><?xml version="1.0" encoding="utf-8"?>
+<c:chartSpace xmlns:c="http://schemas.openxmlformats.org/drawingml/2006/chart" xmlns:a="http://schemas.openxmlformats.org/drawingml/2006/main" xmlns:r="http://schemas.openxmlformats.org/officeDocument/2006/relationships">
+  <c:date1904 val="0"/>
+  <c:roundedCorners val="1"/>
+  <c:chart>
+    <c:title>
+      <c:tx>
+        <c:rich>
+          <a:bodyPr/>
+          <a:lstStyle/>
+          <a:p>
+            <a:pPr>
+              <a:defRPr sz="1200" b="0" i="0" u="none" strike="noStrike">
+                <a:solidFill>
+                  <a:srgbClr val="1B3A5C"/>
+                </a:solidFill>
+                <a:latin typeface="맑은 고딕"/>
+              </a:defRPr>
+            </a:pPr>
+            <a:r>
+              <a:rPr sz="1200" b="0" i="0" u="none" strike="noStrike">
+                <a:solidFill>
+                  <a:srgbClr val="1B3A5C"/>
+                </a:solidFill>
+                <a:latin typeface="맑은 고딕"/>
+              </a:rPr>
+              <a:t>Film thickness — 전체 평균 vs 우리 조(A2)</a:t>
+            </a:r>
+          </a:p>
+        </c:rich>
+      </c:tx>
+      <c:layout/>
+      <c:overlay val="0"/>
+    </c:title>
+    <c:autoTitleDeleted val="0"/>
+    <c:plotArea>
+      <c:layout/>
+      <c:barChart>
+        <c:barDir val="col"/>
+        <c:grouping val="clustered"/>
+        <c:varyColors val="0"/>
+        <c:ser>
+          <c:idx val="0"/>
+          <c:order val="0"/>
+          <c:tx>
+            <c:strRef>
+              <c:f>Sheet1!$B$1</c:f>
+              <c:strCache>
+                <c:ptCount val="1"/>
+                <c:pt idx="0">
+                  <c:v>전체 평균</c:v>
+                </c:pt>
+              </c:strCache>
+            </c:strRef>
+          </c:tx>
+          <c:spPr>
+            <a:solidFill>
+              <a:srgbClr val="1B3A5C"/>
+            </a:solidFill>
+            <a:effectLst/>
+          </c:spPr>
+          <c:invertIfNegative val="0"/>
+          <c:dLbls>
+            <c:numFmt formatCode="0.000" sourceLinked="0"/>
+            <c:txPr>
+              <a:bodyPr/>
+              <a:lstStyle/>
+              <a:p>
+                <a:pPr>
+                  <a:defRPr b="0" i="0" strike="noStrike" sz="800" u="none">
+                    <a:solidFill>
+                      <a:srgbClr val="1C2733"/>
+                    </a:solidFill>
+                    <a:latin typeface="Arial"/>
+                  </a:defRPr>
+                </a:pPr>
+              </a:p>
+            </c:txPr>
+            <c:showLegendKey val="0"/>
+            <c:showVal val="1"/>
+            <c:showCatName val="0"/>
+            <c:showSerName val="0"/>
+            <c:showPercent val="0"/>
+            <c:showBubbleSize val="0"/>
+            <c:showLeaderLines val="0"/>
+          </c:dLbls>
+          <c:errBars>
+            <c:errBarType val="both"/>
+            <c:errValType val="cust"/>
+            <c:noEndCap val="0"/>
+            <c:plus>
+              <c:numLit>
+                <c:formatCode>General</c:formatCode>
+                <c:ptCount val="5"/>
+                <c:pt idx="0">
+                  <c:v>0.0433</c:v>
+                </c:pt>
+                <c:pt idx="1">
+                  <c:v>0.0531</c:v>
+                </c:pt>
+                <c:pt idx="2">
+                  <c:v>0.0727</c:v>
+                </c:pt>
+                <c:pt idx="3">
+                  <c:v>0.0072</c:v>
+                </c:pt>
+                <c:pt idx="4">
+                  <c:v>0.004</c:v>
+                </c:pt>
+              </c:numLit>
+            </c:plus>
+            <c:minus>
+              <c:numLit>
+                <c:formatCode>General</c:formatCode>
+                <c:ptCount val="5"/>
+                <c:pt idx="0">
+                  <c:v>0.0433</c:v>
+                </c:pt>
+                <c:pt idx="1">
+                  <c:v>0.0531</c:v>
+                </c:pt>
+                <c:pt idx="2">
+                  <c:v>0.0727</c:v>
+                </c:pt>
+                <c:pt idx="3">
+                  <c:v>0.0072</c:v>
+                </c:pt>
+                <c:pt idx="4">
+                  <c:v>0.004</c:v>
+                </c:pt>
+              </c:numLit>
+            </c:minus>
+            <c:spPr>
+              <a:ln w="9525">
+                <a:solidFill>
+                  <a:srgbClr val="5B6B7A"/>
+                </a:solidFill>
+              </a:ln>
+            </c:spPr>
+          </c:errBars>
+          <c:cat>
+            <c:multiLvlStrRef>
+              <c:f>Sheet1!$A$2:$A$6</c:f>
+              <c:multiLvlStrCache>
+                <c:ptCount val="5"/>
+                <c:lvl>
+                  <c:pt idx="0">
+                    <c:v>ZPC
+15%↓</c:v>
+                  </c:pt>
+                  <c:pt idx="1">
+                    <c:v>ZPC
+정상</c:v>
+                  </c:pt>
+                  <c:pt idx="2">
+                    <c:v>ZPC
+15%↑</c:v>
+                  </c:pt>
+                  <c:pt idx="3">
+                    <c:v>ZPC
+15%↑+냉각판</c:v>
+                  </c:pt>
+                  <c:pt idx="4">
+                    <c:v>RMGI</c:v>
+                  </c:pt>
+                </c:lvl>
+              </c:multiLvlStrCache>
+            </c:multiLvlStrRef>
+          </c:cat>
+          <c:val>
+            <c:numRef>
+              <c:f>Sheet1!$B$2:$B$6</c:f>
+              <c:numCache>
+                <c:formatCode>General</c:formatCode>
+                <c:ptCount val="5"/>
+                <c:pt idx="0">
+                  <c:v>0.0352</c:v>
+                </c:pt>
+                <c:pt idx="1">
+                  <c:v>0.047</c:v>
+                </c:pt>
+                <c:pt idx="2">
+                  <c:v>0.0492</c:v>
+                </c:pt>
+                <c:pt idx="3">
+                  <c:v>0.0123</c:v>
+                </c:pt>
+                <c:pt idx="4">
+                  <c:v>0.0152</c:v>
+                </c:pt>
+              </c:numCache>
+            </c:numRef>
+          </c:val>
+        </c:ser>
+        <c:ser>
+          <c:idx val="1"/>
+          <c:order val="1"/>
+          <c:tx>
+            <c:strRef>
+              <c:f>Sheet1!$C$1</c:f>
+              <c:strCache>
+                <c:ptCount val="1"/>
+                <c:pt idx="0">
+                  <c:v>우리 조(A2)</c:v>
+                </c:pt>
+              </c:strCache>
+            </c:strRef>
+          </c:tx>
+          <c:spPr>
+            <a:solidFill>
+              <a:srgbClr val="4A90C2"/>
+            </a:solidFill>
+            <a:effectLst/>
+          </c:spPr>
+          <c:invertIfNegative val="0"/>
+          <c:dLbls>
+            <c:numFmt formatCode="0.000" sourceLinked="0"/>
+            <c:txPr>
+              <a:bodyPr/>
+              <a:lstStyle/>
+              <a:p>
+                <a:pPr>
+                  <a:defRPr b="0" i="0" strike="noStrike" sz="800" u="none">
+                    <a:solidFill>
+                      <a:srgbClr val="1C2733"/>
+                    </a:solidFill>
+                    <a:latin typeface="Arial"/>
+                  </a:defRPr>
+                </a:pPr>
+              </a:p>
+            </c:txPr>
+            <c:showLegendKey val="0"/>
+            <c:showVal val="1"/>
+            <c:showCatName val="0"/>
+            <c:showSerName val="0"/>
+            <c:showPercent val="0"/>
+            <c:showBubbleSize val="0"/>
+            <c:showLeaderLines val="0"/>
+          </c:dLbls>
+          <c:cat>
+            <c:multiLvlStrRef>
+              <c:f>Sheet1!$A$2:$A$6</c:f>
+              <c:multiLvlStrCache>
+                <c:ptCount val="5"/>
+                <c:lvl>
+                  <c:pt idx="0">
+                    <c:v>ZPC
+15%↓</c:v>
+                  </c:pt>
+                  <c:pt idx="1">
+                    <c:v>ZPC
+정상</c:v>
+                  </c:pt>
+                  <c:pt idx="2">
+                    <c:v>ZPC
+15%↑</c:v>
+                  </c:pt>
+                  <c:pt idx="3">
+                    <c:v>ZPC
+15%↑+냉각판</c:v>
+                  </c:pt>
+                  <c:pt idx="4">
+                    <c:v>RMGI</c:v>
+                  </c:pt>
+                </c:lvl>
+              </c:multiLvlStrCache>
+            </c:multiLvlStrRef>
+          </c:cat>
+          <c:val>
+            <c:numRef>
+              <c:f>Sheet1!$C$2:$C$6</c:f>
+              <c:numCache>
+                <c:formatCode>General</c:formatCode>
+                <c:ptCount val="5"/>
+                <c:pt idx="0">
+                  <c:v>0.004</c:v>
+                </c:pt>
+                <c:pt idx="1">
+                  <c:v>0.016</c:v>
+                </c:pt>
+                <c:pt idx="2">
+                  <c:v>0.01</c:v>
+                </c:pt>
+                <c:pt idx="3">
+                  <c:v>0.02</c:v>
+                </c:pt>
+                <c:pt idx="4">
+                  <c:v>0.014</c:v>
+                </c:pt>
+              </c:numCache>
+            </c:numRef>
+          </c:val>
+        </c:ser>
+        <c:dLbls>
+          <c:numFmt formatCode="0.000" sourceLinked="0"/>
+          <c:txPr>
+            <a:bodyPr/>
+            <a:lstStyle/>
+            <a:p>
+              <a:pPr>
+                <a:defRPr b="0" i="0" strike="noStrike" sz="800" u="none">
+                  <a:solidFill>
+                    <a:srgbClr val="1C2733"/>
+                  </a:solidFill>
+                  <a:latin typeface="Arial"/>
+                </a:defRPr>
+              </a:pPr>
+            </a:p>
+          </c:txPr>
+          <c:showLegendKey val="0"/>
+          <c:showVal val="1"/>
+          <c:showCatName val="0"/>
+          <c:showSerName val="0"/>
+          <c:showPercent val="0"/>
+          <c:showBubbleSize val="0"/>
+          <c:showLeaderLines val="0"/>
+        </c:dLbls>
+        <c:gapWidth val="35"/>
+        <c:overlap val="0"/>
+        <c:axId val="2094734554"/>
+        <c:axId val="2094734552"/>
+        <c:axId val="2094734556"/>
+      </c:barChart>
+      <c:catAx>
+        <c:axId val="2094734554"/>
+        <c:scaling>
+          <c:orientation val="minMax"/>
+        </c:scaling>
+        <c:delete val="0"/>
+        <c:axPos val="b"/>
+        <c:numFmt formatCode="General" sourceLinked="1"/>
+        <c:majorTickMark val="out"/>
+        <c:minorTickMark val="none"/>
+        <c:tickLblPos val="low"/>
+        <c:spPr>
+          <a:ln w="12700" cap="flat">
+            <a:solidFill>
+              <a:srgbClr val="888888"/>
+            </a:solidFill>
+            <a:prstDash val="solid"/>
+            <a:round/>
+          </a:ln>
+        </c:spPr>
+        <c:txPr>
+          <a:bodyPr/>
+          <a:lstStyle/>
+          <a:p>
+            <a:pPr>
+              <a:defRPr sz="900" b="0" i="0" u="none" strike="noStrike">
+                <a:solidFill>
+                  <a:srgbClr val="5B6B7A"/>
+                </a:solidFill>
+                <a:latin typeface="맑은 고딕"/>
+              </a:defRPr>
+            </a:pPr>
+            <a:endParaRPr lang="en-US"/>
+          </a:p>
+        </c:txPr>
+        <c:crossAx val="2094734552"/>
+        <c:crosses val="autoZero"/>
+        <c:auto val="1"/>
+        <c:lblAlgn val="ctr"/>
+        <c:noMultiLvlLbl val="1"/>
+      </c:catAx>
+      <c:valAx>
+        <c:axId val="2094734552"/>
+        <c:scaling>
+          <c:orientation val="minMax"/>
+          <c:max val="0.14"/>
           <c:min val="0"/>
         </c:scaling>
         <c:delete val="0"/>
@@ -10237,7 +10695,7 @@
         </p:nvSpPr>
         <p:spPr>
           <a:xfrm>
-            <a:off x="640080" y="1554480"/>
+            <a:off x="640080" y="1417320"/>
             <a:ext cx="10908792" cy="347472"/>
           </a:xfrm>
           <a:prstGeom prst="rect">
@@ -10276,8 +10734,8 @@
         </p:nvSpPr>
         <p:spPr>
           <a:xfrm>
-            <a:off x="640080" y="1920240"/>
-            <a:ext cx="10908792" cy="1417320"/>
+            <a:off x="640080" y="1737360"/>
+            <a:ext cx="10908792" cy="1005840"/>
           </a:xfrm>
           <a:prstGeom prst="rect">
             <a:avLst/>
@@ -10291,12 +10749,12 @@
           <a:p>
             <a:pPr indent="0" marL="0">
               <a:lnSpc>
-                <a:spcPct val="140000"/>
+                <a:spcPct val="130000"/>
               </a:lnSpc>
               <a:buNone/>
             </a:pPr>
             <a:r>
-              <a:rPr lang="en-US" sz="1300" dirty="0">
+              <a:rPr lang="en-US" sz="1200" dirty="0">
                 <a:solidFill>
                   <a:srgbClr val="1C2733"/>
                 </a:solidFill>
@@ -10306,17 +10764,17 @@
               </a:rPr>
               <a:t>•  이론: 분액비(P/L)가 높을수록 반죽의 점도가 증가해 압착 시 유동성이 떨어지고, 그만큼 얇게 눌리지 못해 피막도가 커질 것으로 예상됨</a:t>
             </a:r>
-            <a:endParaRPr lang="en-US" sz="1300" dirty="0"/>
+            <a:endParaRPr lang="en-US" sz="1200" dirty="0"/>
           </a:p>
           <a:p>
             <a:pPr indent="0" marL="0">
               <a:lnSpc>
-                <a:spcPct val="140000"/>
+                <a:spcPct val="130000"/>
               </a:lnSpc>
               <a:buNone/>
             </a:pPr>
             <a:r>
-              <a:rPr lang="en-US" sz="1300" dirty="0">
+              <a:rPr lang="en-US" sz="1200" dirty="0">
                 <a:solidFill>
                   <a:srgbClr val="1C2733"/>
                 </a:solidFill>
@@ -10326,7 +10784,7 @@
               </a:rPr>
               <a:t>•  실측(반 평균): 이론과 부합 — 15%↓(0.035mm) &lt; 정상(0.047mm) &lt; 15%↑(0.049mm) 순으로 분액비가 높을수록 피막도 증가. 다만 세 조건 모두 표준편차가 매우 커서(한 조(A3)의 이상치 영향, 슬라이드 11 참고) 경향성 해석에는 주의가 필요함</a:t>
             </a:r>
-            <a:endParaRPr lang="en-US" sz="1300" dirty="0"/>
+            <a:endParaRPr lang="en-US" sz="1200" dirty="0"/>
           </a:p>
         </p:txBody>
       </p:sp>
@@ -10338,7 +10796,7 @@
         </p:nvSpPr>
         <p:spPr>
           <a:xfrm>
-            <a:off x="640080" y="3520440"/>
+            <a:off x="640080" y="2834640"/>
             <a:ext cx="10908792" cy="347472"/>
           </a:xfrm>
           <a:prstGeom prst="rect">
@@ -10363,7 +10821,7 @@
                 <a:ea typeface="맑은 고딕" pitchFamily="34" charset="-122"/>
                 <a:cs typeface="맑은 고딕" pitchFamily="34" charset="-120"/>
               </a:rPr>
-              <a:t>② 냉각판·RMGI 효과, 그리고 우리 조(A2)의 위치</a:t>
+              <a:t>② 냉각판·RMGI 효과</a:t>
             </a:r>
             <a:endParaRPr lang="en-US" sz="1450" dirty="0"/>
           </a:p>
@@ -10377,8 +10835,8 @@
         </p:nvSpPr>
         <p:spPr>
           <a:xfrm>
-            <a:off x="640080" y="3867912"/>
-            <a:ext cx="10908792" cy="1828800"/>
+            <a:off x="640080" y="3154680"/>
+            <a:ext cx="10908792" cy="685800"/>
           </a:xfrm>
           <a:prstGeom prst="rect">
             <a:avLst/>
@@ -10392,12 +10850,12 @@
           <a:p>
             <a:pPr indent="0" marL="0">
               <a:lnSpc>
-                <a:spcPct val="140000"/>
+                <a:spcPct val="130000"/>
               </a:lnSpc>
               <a:buNone/>
             </a:pPr>
             <a:r>
-              <a:rPr lang="en-US" sz="1300" dirty="0">
+              <a:rPr lang="en-US" sz="1200" dirty="0">
                 <a:solidFill>
                   <a:srgbClr val="1C2733"/>
                 </a:solidFill>
@@ -10407,27 +10865,7 @@
               </a:rPr>
               <a:t>•  냉각판 조건은 반 평균 피막도(0.012mm)가 나머지 ZPC 조건보다 훨씬 얇게 나옴 — 낮은 온도가 압착 시 유동성을 오히려 개선했을 가능성(표본이 적어 단정하기는 어려움). RMGI(0.015mm)도 ZPC 대비 얇은 편 — 레진 개량형 특유의 낮은 초기 점도 영향으로 추정</a:t>
             </a:r>
-            <a:endParaRPr lang="en-US" sz="1300" dirty="0"/>
-          </a:p>
-          <a:p>
-            <a:pPr indent="0" marL="0">
-              <a:lnSpc>
-                <a:spcPct val="140000"/>
-              </a:lnSpc>
-              <a:buNone/>
-            </a:pPr>
-            <a:r>
-              <a:rPr lang="en-US" sz="1300" dirty="0">
-                <a:solidFill>
-                  <a:srgbClr val="1C2733"/>
-                </a:solidFill>
-                <a:latin typeface="맑은 고딕" pitchFamily="34" charset="0"/>
-                <a:ea typeface="맑은 고딕" pitchFamily="34" charset="-122"/>
-                <a:cs typeface="맑은 고딕" pitchFamily="34" charset="-120"/>
-              </a:rPr>
-              <a:t>•  우리 조 실측은 ZPC 세 조건(정상·15%↑·15%↓) 모두 반 평균보다 얇게 나왔고(−0.5~−0.7 SD), 냉각판만 평균보다 두껍게 나옴(+1.1 SD) — Setting time과 마찬가지로 개인별 측정 판정 차이(글라스판 접촉 상태 확인, 하중 적용 타이밍 등)가 영향을 줬을 가능성을 고려할 수 있음</a:t>
-            </a:r>
-            <a:endParaRPr lang="en-US" sz="1300" dirty="0"/>
+            <a:endParaRPr lang="en-US" sz="1200" dirty="0"/>
           </a:p>
         </p:txBody>
       </p:sp>
@@ -10439,30 +10877,53 @@
         </p:nvSpPr>
         <p:spPr>
           <a:xfrm>
-            <a:off x="640080" y="5897880"/>
-            <a:ext cx="10908792" cy="731520"/>
+            <a:off x="640080" y="3886200"/>
+            <a:ext cx="10908792" cy="2148840"/>
           </a:xfrm>
           <a:prstGeom prst="roundRect">
             <a:avLst>
-              <a:gd name="adj" fmla="val 10000"/>
+              <a:gd name="adj" fmla="val 4255"/>
             </a:avLst>
           </a:prstGeom>
           <a:solidFill>
-            <a:srgbClr val="EAF2EE"/>
+            <a:srgbClr val="FFFFFF"/>
           </a:solidFill>
           <a:ln/>
+          <a:effectLst>
+            <a:outerShdw sx="100000" sy="100000" kx="0" ky="0" algn="bl" rotWithShape="0" blurRad="76200" dist="25400" dir="5400000">
+              <a:srgbClr val="1C2321">
+                <a:alpha val="10000"/>
+              </a:srgbClr>
+            </a:outerShdw>
+          </a:effectLst>
         </p:spPr>
       </p:sp>
-      <p:sp>
-        <p:nvSpPr>
-          <p:cNvPr id="9" name="Text 7"/>
+      <p:graphicFrame>
+        <p:nvGraphicFramePr>
+          <p:cNvPr id="9" name="Chart 0" descr=""/>
+          <p:cNvGraphicFramePr/>
+          <p:nvPr/>
+        </p:nvGraphicFramePr>
+        <p:xfrm>
+          <a:off x="822960" y="3995928"/>
+          <a:ext cx="10543032" cy="1508760"/>
+        </p:xfrm>
+        <a:graphic xmlns:a="http://schemas.openxmlformats.org/drawingml/2006/main">
+          <a:graphicData uri="http://schemas.openxmlformats.org/drawingml/2006/chart">
+            <c:chart xmlns:c="http://schemas.openxmlformats.org/drawingml/2006/chart" r:id="rId1"/>
+          </a:graphicData>
+        </a:graphic>
+      </p:graphicFrame>
+      <p:sp>
+        <p:nvSpPr>
+          <p:cNvPr id="10" name="Text 7"/>
           <p:cNvSpPr txBox="1"/>
           <p:nvPr/>
         </p:nvSpPr>
         <p:spPr>
           <a:xfrm>
-            <a:off x="868680" y="6016752"/>
-            <a:ext cx="10451592" cy="502920"/>
+            <a:off x="822960" y="5650992"/>
+            <a:ext cx="10543032" cy="365760"/>
           </a:xfrm>
           <a:prstGeom prst="rect">
             <a:avLst/>
@@ -10476,45 +10937,28 @@
           <a:p>
             <a:pPr indent="0" marL="0">
               <a:lnSpc>
-                <a:spcPct val="125000"/>
+                <a:spcPct val="115000"/>
               </a:lnSpc>
               <a:buNone/>
             </a:pPr>
             <a:r>
-              <a:rPr lang="en-US" sz="1100" b="1" dirty="0">
-                <a:solidFill>
-                  <a:srgbClr val="1B3A5C"/>
+              <a:rPr lang="en-US" sz="750" i="1" dirty="0">
+                <a:solidFill>
+                  <a:srgbClr val="5B6B7A"/>
                 </a:solidFill>
                 <a:latin typeface="맑은 고딕" pitchFamily="34" charset="0"/>
                 <a:ea typeface="맑은 고딕" pitchFamily="34" charset="-122"/>
                 <a:cs typeface="맑은 고딕" pitchFamily="34" charset="-120"/>
               </a:rPr>
-              <a:t>정리: </a:t>
-            </a:r>
-            <a:pPr indent="0" marL="0">
-              <a:lnSpc>
-                <a:spcPct val="125000"/>
-              </a:lnSpc>
-              <a:buNone/>
-            </a:pPr>
-            <a:r>
-              <a:rPr lang="en-US" sz="1100" dirty="0">
-                <a:solidFill>
-                  <a:srgbClr val="1C2733"/>
-                </a:solidFill>
-                <a:latin typeface="맑은 고딕" pitchFamily="34" charset="0"/>
-                <a:ea typeface="맑은 고딕" pitchFamily="34" charset="-122"/>
-                <a:cs typeface="맑은 고딕" pitchFamily="34" charset="-120"/>
-              </a:rPr>
-              <a:t>Setting time과 마찬가지로 피막도도 분액비·냉각판 조건에 따라 유의한 차이를 보이며, 개별 조의 측정·판정 방식 차이가 재료 자체의 특성만큼이나 결과에 영향을 줄 수 있음을 시사함.</a:t>
-            </a:r>
-            <a:endParaRPr lang="en-US" sz="1100" dirty="0"/>
+              <a:t>※ 오차 막대는 전체 평균의 표준편차(SD) 1개. ZPC 15%↓ 0.035→0.004(−0.7 SD)  ·  ZPC 정상 0.047→0.016(−0.6 SD)  ·  ZPC 15%↑ 0.049→0.010(−0.5 SD)  ·  ZPC 15%↑+냉각판 0.012→0.020(+1.1 SD)  ·  RMGI 0.015→0.014(−0.3 SD)</a:t>
+            </a:r>
+            <a:endParaRPr lang="en-US" sz="750" dirty="0"/>
           </a:p>
         </p:txBody>
       </p:sp>
       <p:sp>
         <p:nvSpPr>
-          <p:cNvPr id="10" name="Text 8"/>
+          <p:cNvPr id="11" name="Text 8"/>
           <p:cNvSpPr txBox="1"/>
           <p:nvPr/>
         </p:nvSpPr>

</xml_diff>

<commit_message>
Add 1-minute load rationale (vs ISO 10 min) to slide 9 notes and Q&A
Co-Authored-By: Claude Sonnet 5.5 <noreply@anthropic.com>
Claude-Session: https://claude.ai/code/session_014ok8p4xZCZLzhCuM2RAuEa
</commit_message>
<xml_diff>
--- a/수복치과재료학실험/수복치과재료학실험_DentalCements_20260922.pptx
+++ b/수복치과재료학실험/수복치과재료학실험_DentalCements_20260922.pptx
@@ -3027,6 +3027,8 @@
 → 온도(37°C vs 23°C)가 가장 크지만, 습도(90% vs 통제 없음)도 함께 작용했을 가능성이 있고, indentor 판정 시점의 주관성, 개인별 혼합 속도 차이도 오차 요인으로 볼 수 있다고 답하면 됩니다.
 Q. 냉각판 조건이 이론과 반대로 나온 것을 어떻게 설명할 것인가?
 → 작업시간(working time)을 따로 측정하지 못해 경화 시간만으로 판단한 한계라고 솔직히 인정하는 게 가장 무난합니다. 냉각판은 분액비를 높게 쓰면서도 여유 있는 작업시간을 확보하기 위한 방법이라, 경화 시간 자체보다 작업시간 지표로 봐야 더 정확한 비교가 될 것 같다고 덧붙이면 좋습니다.
+Q. ISO 규격은 하중을 10분 가하는데 왜 1분만 적용했는가? 피막도에 영향은 없는가?
+→ 조가 6개인데 하중 장치는 하나라, 조마다 10분씩 적용하면 수업 시간 안에 끝낼 수 없어서 1분으로 줄였다고 솔직히 답하면 됩니다. 압착 시간이 짧으면 시멘트가 덜 빠져나가 ISO 방식보다 피막도가 두껍게 측정됐을 가능성이 있어서, 절대값을 규격 기준과 직접 비교하기는 어렵습니다. 다만 반 전체가 같은 장치와 시간으로 측정했기 때문에 조건 간·조 간 상대 비교에는 영향이 작다고 덧붙이면 좋습니다.
 Q. 우리 조만 유독 느리게 나온 이유가 뭐라고 생각하는가?
 → 가장 그럴듯한 설명은 indentor 판정 기준입니다. "완전한 원형 압흔이 안 남는 시점"이라는 기준 자체가 다소 주관적이라, 저희 조가 다른 조보다 조금 더 보수적으로(늦게) 판단했을 가능성이 있습니다. 혼합 속도나 실험실 내 위치별 온도 차이도 부차적 요인으로 들 수 있습니다.</a:t>
             </a:r>
@@ -3748,7 +3750,7 @@
             <a:r>
               <a:rPr lang="en-US" dirty="0"/>
               <a:t>[대본 5:20~6:00]
-측정은, setting time의 경우 표준 혼합 시간이 끝난 뒤부터 indentor로 30초 간격으로 눌러보다가 경화가 임박하면 10초 간격으로 좁혀서 완전한 원형 압흔이 안 남는 시점을 기록했고, film thickness는 유리판 두께를 먼저 재고(A) 시멘트를 끼운 뒤 작업 시간 10초 전부터 150N을 1분간 가한 상태에서 다시 재서(B) 그 차이를 피막도로 계산했습니다.</a:t>
+측정은, setting time의 경우 표준 혼합 시간이 끝난 뒤부터 indentor로 30초 간격으로 눌러보다가 경화가 임박하면 10초 간격으로 좁혀서 완전한 원형 압흔이 안 남는 시점을 기록했고, film thickness는 유리판 두께를 먼저 재고(A) 시멘트를 끼운 뒤 작업 시간 10초 전부터 150N을 1분간 가한 상태에서 다시 재서(B) 그 차이를 피막도로 계산했습니다. 참고로 film thickness의 하중 시간은 ISO 규격이 10분이지만, 조가 여섯 개인데 하중 장치는 하나라 시간상 1분만 적용했습니다.</a:t>
             </a:r>
             <a:endParaRPr lang="en-US" dirty="0"/>
           </a:p>

</xml_diff>